<commit_message>
Synchronize corrected A1 poster PDF PPTX and previews
</commit_message>
<xml_diff>
--- a/FINALDOCS/POSTER/A1_FINAL_TITLE_CONFIRMED_20261010/M_RAG_A1_FINAL_EDITABLE.pptx
+++ b/FINALDOCS/POSTER/A1_FINAL_TITLE_CONFIRMED_20261010/M_RAG_A1_FINAL_EDITABLE.pptx
@@ -4278,7 +4278,7 @@
                 <ns1:ea typeface="Malgun Gothic"/>
                 <ns1:cs typeface="Malgun Gothic"/>
               </ns1:rPr>
-              <ns1:t>영어 논문에 한국어로 질문할 때 생기는 문제</ns1:t>
+              <ns1:t>한국어 질문으로 영어 문서를 검색할 때의 쟁점</ns1:t>
             </ns1:r>
           </ns1:p>
         </ns0:txBody>
@@ -4350,7 +4350,7 @@
                 <ns1:ea typeface="Malgun Gothic"/>
                 <ns1:cs typeface="Malgun Gothic"/>
               </ns1:rPr>
-              <ns1:t>한국어 질문과 영어 원문의 표현 차이가 검색에 미치는 영향 확인</ns1:t>
+              <ns1:t>한국어 질문과 영어 원문의 표현 차이에 따른 검색 결과 비교</ns1:t>
             </ns1:r>
           </ns1:p>
         </ns0:txBody>
@@ -4422,7 +4422,7 @@
                 <ns1:ea typeface="Malgun Gothic"/>
                 <ns1:cs typeface="Malgun Gothic"/>
               </ns1:rPr>
-              <ns1:t>검색한 근거를 답변에 얼마나 반영하는지, 한국어 출력을 유지하는지 확인</ns1:t>
+              <ns1:t>근거 충실도와 한국어 문자 비율을 각각 측정</ns1:t>
             </ns1:r>
           </ns1:p>
         </ns0:txBody>
@@ -4494,7 +4494,7 @@
                 <ns1:ea typeface="Malgun Gothic"/>
                 <ns1:cs typeface="Malgun Gothic"/>
               </ns1:rPr>
-              <ns1:t>검색, 답변 생성과 출력 언어에서 세 기법의 적용 전후 비교</ns1:t>
+              <ns1:t>HyDE의 검색 결과, CAD의 답변 품질, SCD의 출력 언어 비교</ns1:t>
             </ns1:r>
           </ns1:p>
         </ns0:txBody>
@@ -4681,7 +4681,7 @@
                           <ns1:ea typeface="Malgun Gothic"/>
                           <ns1:cs typeface="Malgun Gothic"/>
                         </ns1:rPr>
-                        <ns1:t>같은 문맥에서 CAD 적용 전후 품질과 시간은 어떻게 달라지는가</ns1:t>
+                        <ns1:t>같은 문맥에서 CAD 적용 전후 답변 품질과 실행 시간은 어떻게 달라지는가</ns1:t>
                       </ns1:r>
                     </ns1:p>
                   </ns1:txBody>
@@ -4865,7 +4865,7 @@
                           <ns1:ea typeface="Malgun Gothic"/>
                           <ns1:cs typeface="Malgun Gothic"/>
                         </ns1:rPr>
-                        <ns1:t>관련성, 충실도, 한국어 비율과 실행 시간에 따라 어떤 조건을 고르는가</ns1:t>
+                        <ns1:t>관련성, 충실도, 한국어 비율과 실행 시간에 따라 어떤 조건을 선택하는가</ns1:t>
                       </ns1:r>
                     </ns1:p>
                   </ns1:txBody>
@@ -4985,7 +4985,7 @@
                           <ns1:ea typeface="Malgun Gothic"/>
                           <ns1:cs typeface="Malgun Gothic"/>
                         </ns1:rPr>
-                        <ns1:t>검색 증강 생성: 관련 문서를 검색해 답변 생성에 활용</ns1:t>
+                        <ns1:t>관련 문서를 검색해 생성 모델의 입력으로 제공하고 답변 생성</ns1:t>
                       </ns1:r>
                     </ns1:p>
                     <ns1:p>
@@ -5096,7 +5096,7 @@
                           <ns1:ea typeface="Malgun Gothic"/>
                           <ns1:cs typeface="Malgun Gothic"/>
                         </ns1:rPr>
-                        <ns1:t>한국어 질문을 영어로 바꾸고 가상 문서를 생성해 벡터로 변환</ns1:t>
+                        <ns1:t>한국어 질의를 영어로 번역해 가상 문서를 생성하고 벡터화</ns1:t>
                       </ns1:r>
                     </ns1:p>
                     <ns1:p>
@@ -5115,7 +5115,7 @@
                           <ns1:ea typeface="Malgun Gothic"/>
                           <ns1:cs typeface="Malgun Gothic"/>
                         </ns1:rPr>
-                        <ns1:t>벡터는 밀집 검색에 사용, BM25와 재정렬은 원래 질문 사용</ns1:t>
+                        <ns1:t>가상 문서 벡터로 밀집 검색, BM25와 재정렬은 한국어 질의 사용</ns1:t>
                       </ns1:r>
                     </ns1:p>
                   </ns1:txBody>
@@ -5337,7 +5337,7 @@
                           <ns1:ea typeface="Malgun Gothic"/>
                           <ns1:cs typeface="Malgun Gothic"/>
                         </ns1:rPr>
-                        <ns1:t>CAD 후 한국어1.1, 비목표0.9 적용; 중립과 초기5생성단계 유지</ns1:t>
+                        <ns1:t>CAD 후 한국어×1.1, 다른 언어×0.9; 중립 토큰과 첫 5토큰 유지</ns1:t>
                       </ns1:r>
                     </ns1:p>
                   </ns1:txBody>
@@ -5434,7 +5434,7 @@
                 <ns1:ea typeface="Malgun Gothic"/>
                 <ns1:cs typeface="Malgun Gothic"/>
               </ns1:rPr>
-              <ns1:t>관련 연구: DPR[11], FiD[12], 긴 문맥[9], 자기검증[15,16]</ns1:t>
+              <ns1:t>관련 연구: DPR[11], FiD[12], 긴 문맥[9], Self-RAG와 CRAG[15,16]</ns1:t>
             </ns1:r>
           </ns1:p>
         </ns0:txBody>
@@ -5888,7 +5888,7 @@
                 <ns1:ea typeface="Malgun Gothic"/>
                 <ns1:cs typeface="Malgun Gothic"/>
               </ns1:rPr>
-              <ns1:t>ON: 영어 질문으로 변환</ns1:t>
+              <ns1:t>ON: 질의를 영어로 번역</ns1:t>
             </ns1:r>
           </ns1:p>
         </ns0:txBody>
@@ -9256,7 +9256,7 @@
                 <ns1:ea typeface="Malgun Gothic"/>
                 <ns1:cs typeface="Malgun Gothic"/>
               </ns1:rPr>
-              <ns1:t>문맥 포함/제외 대조</ns1:t>
+              <ns1:t>두 로짓 가중 결합</ns1:t>
             </ns1:r>
           </ns1:p>
         </ns0:txBody>
@@ -10744,7 +10744,7 @@
                 <ns1:ea typeface="Malgun Gothic"/>
                 <ns1:cs typeface="Malgun Gothic"/>
               </ns1:rPr>
-              <ns1:t>HyDE는 밀집 검색 전에 적용하며, CAD와 SCD는 생성 중 매 토큰의 점수를 조절</ns1:t>
+              <ns1:t>HyDE는 밀집 검색 입력을 바꾸며, CAD와 SCD는 생성 중 토큰 점수를 조정</ns1:t>
             </ns1:r>
           </ns1:p>
         </ns0:txBody>
@@ -10816,7 +10816,7 @@
                 <ns1:ea typeface="Malgun Gothic"/>
                 <ns1:cs typeface="Malgun Gothic"/>
               </ns1:rPr>
-              <ns1:t>함께 쓰면 CAD(α=0.5) 다음 SCD 적용; 백본을 고정한 8조건의 답변을 같은 질의끼리 비교</ns1:t>
+              <ns1:t>CAD와 SCD 동시 적용 시 CAD(α=0.5) 후 SCD 적용; 같은 질의의 8조건 비교</ns1:t>
             </ns1:r>
           </ns1:p>
         </ns0:txBody>
@@ -12689,7 +12689,7 @@
                           <ns1:ea typeface="Malgun Gothic"/>
                           <ns1:cs typeface="Malgun Gothic"/>
                         </ns1:rPr>
-                        <ns1:t>연구자가 초기 질문 3개로 표현과 범위 설정 → LLM 문서 요약을 15개 내용 단위로 구분</ns1:t>
+                        <ns1:t>초기 질문 3개로 질문 형식과 범위 설정 → LLM으로 문서 주요 내용 요약</ns1:t>
                       </ns1:r>
                     </ns1:p>
                     <ns1:p>
@@ -12708,7 +12708,7 @@
                           <ns1:ea typeface="Malgun Gothic"/>
                           <ns1:cs typeface="Malgun Gothic"/>
                         </ns1:rPr>
-                        <ns1:t>단위별 한국어 질의 1개 작성 → 문서별 15질의의 원문 페이지와 근거 확인</ns1:t>
+                        <ns1:t>요약을 15개 단위로 나눠 질의 작성 → 각 질의의 원문 페이지와 근거 확인</ns1:t>
                       </ns1:r>
                     </ns1:p>
                   </ns1:txBody>
@@ -12984,7 +12984,7 @@
                           <ns1:ea typeface="Malgun Gothic"/>
                           <ns1:cs typeface="Malgun Gothic"/>
                         </ns1:rPr>
-                        <ns1:t>검색8 → 재정렬8 → 문맥5 / 청크 최대512단어, 중첩64, 최소50</ns1:t>
+                        <ns1:t>검색 8개, 재정렬 8개, 문맥 5개; 청크 최대 512, 중첩 64, 최소 50단어</ns1:t>
                       </ns1:r>
                     </ns1:p>
                   </ns1:txBody>
@@ -13076,7 +13076,7 @@
                           <ns1:ea typeface="Malgun Gothic"/>
                           <ns1:cs typeface="Malgun Gothic"/>
                         </ns1:rPr>
-                        <ns1:t>문맥 한도3072단어, 초과 시 압축(비율0.5); argmax, 최대512토큰</ns1:t>
+                        <ns1:t>문맥 3,072단어 초과 시 압축(0.5); 탐욕적 디코딩, 최대 512토큰</ns1:t>
                       </ns1:r>
                     </ns1:p>
                   </ns1:txBody>
@@ -13173,7 +13173,7 @@
                 <ns1:ea typeface="Malgun Gothic"/>
                 <ns1:cs typeface="Malgun Gothic"/>
               </ns1:rPr>
-              <ns1:t>질문 유형: 사실/정의8, 방법/절차29, 결과/비교20, 목적/기여3</ns1:t>
+              <ns1:t>질의 유형: 사실/정의 8, 방법/절차 29, 결과/비교 20, 목적/기여 3</ns1:t>
             </ns1:r>
           </ns1:p>
         </ns0:txBody>
@@ -13347,7 +13347,7 @@
                 <ns1:ea typeface="Malgun Gothic"/>
                 <ns1:cs typeface="Malgun Gothic"/>
               </ns1:rPr>
-              <ns1:t>질의, 답변, 문맥과 정답으로 품질 평가; 한국어 문자 비율로 출력 언어 측정</ns1:t>
+              <ns1:t>질의, 답변, 검색 문맥과 참조 답변으로 품질 평가; 출력 언어는 한국어 문자 비율로 측정</ns1:t>
             </ns1:r>
           </ns1:p>
         </ns0:txBody>
@@ -14171,7 +14171,7 @@
                 <ns1:ea typeface="Malgun Gothic"/>
                 <ns1:cs typeface="Malgun Gothic"/>
               </ns1:rPr>
-              <ns1:t>SCD ON/OFF 품질 평균은 서로 다른 평가 문맥의 기술통계로 해석</ns1:t>
+              <ns1:t>SCD ON/OFF의 RAGAS 평균은 평가 문맥 언어가 달라 각각 제시</ns1:t>
             </ns1:r>
           </ns1:p>
         </ns0:txBody>
@@ -14541,7 +14541,7 @@
                           <ns1:ea typeface="Malgun Gothic"/>
                           <ns1:cs typeface="Malgun Gothic"/>
                         </ns1:rPr>
-                        <ns1:t>검색/재정렬 ID와 최종 문맥이 동일</ns1:t>
+                        <ns1:t>검색과 재정렬 청크 ID, 최종 문맥 동일</ns1:t>
                       </ns1:r>
                     </ns1:p>
                   </ns1:txBody>
@@ -14586,7 +14586,7 @@
                           <ns1:ea typeface="Malgun Gothic"/>
                           <ns1:cs typeface="Malgun Gothic"/>
                         </ns1:rPr>
-                        <ns1:t>60 / 충실도58</ns1:t>
+                        <ns1:t>60쌍, 충실도 58쌍</ns1:t>
                       </ns1:r>
                     </ns1:p>
                   </ns1:txBody>
@@ -14678,7 +14678,7 @@
                           <ns1:ea typeface="Malgun Gothic"/>
                           <ns1:cs typeface="Malgun Gothic"/>
                         </ns1:rPr>
-                        <ns1:t>HyDE OFF 동일 문맥 / HyDE와 CAD 상태 일치</ns1:t>
+                        <ns1:t>주 비교 H0 동일 문맥 / 전체 H/C 상태 일치</ns1:t>
                       </ns1:r>
                     </ns1:p>
                   </ns1:txBody>
@@ -14964,7 +14964,7 @@
                 <ns1:ea typeface="Malgun Gothic"/>
                 <ns1:cs typeface="Malgun Gothic"/>
               </ns1:rPr>
-              <ns1:t>숫자와 기호는 제외하며, 논문 제목과 모델명의 혼합 표기는 포함</ns1:t>
+              <ns1:t>한글과 ASCII 영문자만 계산; 논문명과 모델명의 영어 표기도 반영</ns1:t>
             </ns1:r>
           </ns1:p>
         </ns0:txBody>
@@ -15036,7 +15036,7 @@
                 <ns1:ea typeface="Malgun Gothic"/>
                 <ns1:cs typeface="Malgun Gothic"/>
               </ns1:rPr>
-              <ns1:t>평가값 1,920개 중 1,915개 유효, 충실도 결측5개는 결측 유지</ns1:t>
+              <ns1:t>RAGAS 평가값 1,920개 중 1,915개 유효; 근거 충실도 5개 결측</ns1:t>
             </ns1:r>
           </ns1:p>
         </ns0:txBody>
@@ -15180,7 +15180,7 @@
                 <ns1:ea typeface="Malgun Gothic"/>
                 <ns1:cs typeface="Malgun Gothic"/>
               </ns1:rPr>
-              <ns1:t>문서4종 고정, seed=20260713; 질의 수준의 95% 신뢰구간</ns1:t>
+              <ns1:t>문서 4종 고정, seed=20260713; 질의 단위 95% 신뢰구간</ns1:t>
             </ns1:r>
           </ns1:p>
         </ns0:txBody>
@@ -16410,7 +16410,7 @@
                 <ns1:ea typeface="Malgun Gothic"/>
                 <ns1:cs typeface="Malgun Gothic"/>
               </ns1:rPr>
-              <ns1:t>CAD 충실도와 관련성 구간은 0 포함; 관련성 -0.0073 [-0.0855, +0.0719]</ns1:t>
+              <ns1:t>CAD 두 지표의 95% 구간은 0 포함; 관련성 -0.0073 [-0.0855, +0.0719]</ns1:t>
             </ns1:r>
           </ns1:p>
         </ns0:txBody>
@@ -16696,7 +16696,7 @@
                 <ns1:ea typeface="Malgun Gothic"/>
                 <ns1:cs typeface="Malgun Gothic"/>
               </ns1:rPr>
-              <ns1:t>한국어 멀티턴 대화의 설계 기준 3가지</ns1:t>
+              <ns1:t>한국어 멀티턴 대화 데이터의 설계 차원 3가지</ns1:t>
             </ns1:r>
           </ns1:p>
         </ns0:txBody>
@@ -17384,7 +17384,7 @@
                 <ns1:ea typeface="Malgun Gothic"/>
                 <ns1:cs typeface="Malgun Gothic"/>
               </ns1:rPr>
-              <ns1:t>독점, 공개와 자체 합성의 세 경로 제시</ns1:t>
+              <ns1:t>라이선스 자료, 상업 이용 가능 공개 자료, 자체 합성 자료</ns1:t>
             </ns1:r>
           </ns1:p>
         </ns0:txBody>
@@ -17640,7 +17640,7 @@
                 <ns1:ea typeface="Malgun Gothic"/>
                 <ns1:cs typeface="Malgun Gothic"/>
               </ns1:rPr>
-              <ns1:t>RAG의 지식 집약적 작업 관련 장점</ns1:t>
+              <ns1:t>RAG가 지식 집약적 작업에 유리한 이유</ns1:t>
             </ns1:r>
           </ns1:p>
         </ns0:txBody>
@@ -18112,7 +18112,7 @@
                 <ns1:ea typeface="Malgun Gothic"/>
                 <ns1:cs typeface="Malgun Gothic"/>
               </ns1:rPr>
-              <ns1:t>Fusion SFT의 non-reasoning 목적</ns1:t>
+              <ns1:t>Fusion SFT의 비추론(non-reasoning) 학습 목적</ns1:t>
             </ns1:r>
           </ns1:p>
         </ns0:txBody>
@@ -18472,7 +18472,7 @@
                 <ns1:ea typeface="Malgun Gothic"/>
                 <ns1:cs typeface="Malgun Gothic"/>
               </ns1:rPr>
-              <ns1:t>CAD는 동일 문맥 비교; SCD의 언어 비율 증가와 내용 정확성은 구분</ns1:t>
+              <ns1:t>CAD는 동일 문맥 비교; SCD의 언어 비율과 답변 정확성은 별개로 해석</ns1:t>
             </ns1:r>
           </ns1:p>
         </ns0:txBody>
@@ -18544,7 +18544,7 @@
                 <ns1:ea typeface="Malgun Gothic"/>
                 <ns1:cs typeface="Malgun Gothic"/>
               </ns1:rPr>
-              <ns1:t>SCD 사례는 HyDE ON으로 전체240쌍에만 포함, OFF 주 비교120쌍에는 미포함</ns1:t>
+              <ns1:t>SCD 사례(HyDE ON)는 전체 240쌍에 포함, 주 비교 120쌍에서는 제외</ns1:t>
             </ns1:r>
           </ns1:p>
         </ns0:txBody>
@@ -18790,7 +18790,7 @@
                 <ns1:ea typeface="Malgun Gothic"/>
                 <ns1:cs typeface="Malgun Gothic"/>
               </ns1:rPr>
-              <ns1:t>CAD 충실도는 평균 +0.0288 변화했으며 95% 구간에 0 포함</ns1:t>
+              <ns1:t>CAD 근거 충실도 변화 +0.0288; 95% 신뢰구간은 0 포함</ns1:t>
             </ns1:r>
           </ns1:p>
         </ns0:txBody>
@@ -18862,7 +18862,7 @@
                 <ns1:ea typeface="Malgun Gothic"/>
                 <ns1:cs typeface="Malgun Gothic"/>
               </ns1:rPr>
-              <ns1:t>CAD 주 비교의 조건 실행 시간은 20.792초에서 63.867초로 증가</ns1:t>
+              <ns1:t>CAD 조건 실행 시간은 20.792초에서 63.867초로 증가</ns1:t>
             </ns1:r>
           </ns1:p>
         </ns0:txBody>
@@ -19006,7 +19006,7 @@
                 <ns1:ea typeface="Malgun Gothic"/>
                 <ns1:cs typeface="Malgun Gothic"/>
               </ns1:rPr>
-              <ns1:t>관련성, 충실도, 한국어 문자 비율과 실행 시간을 기준으로 조건 선택</ns1:t>
+              <ns1:t>답변 관련성, 근거 충실도, 한국어 문자 비율과 실행 시간으로 조건 선택</ns1:t>
             </ns1:r>
           </ns1:p>
         </ns0:txBody>
@@ -19078,7 +19078,7 @@
                 <ns1:ea typeface="Malgun Gothic"/>
                 <ns1:cs typeface="Malgun Gothic"/>
               </ns1:rPr>
-              <ns1:t>평가 범위: 영어 문서4종, 한국어 질의60개, 단일 생성 모델과 자동 평가</ns1:t>
+              <ns1:t>평가 범위: 영어 문서 4종, 한국어 질의 60개, 생성 모델 1종과 자동 평가</ns1:t>
             </ns1:r>
           </ns1:p>
         </ns0:txBody>

</xml_diff>

<commit_message>
Polish final thesis and poster prose and verify actual Hancom exports
</commit_message>
<xml_diff>
--- a/FINALDOCS/POSTER/A1_FINAL_TITLE_CONFIRMED_20261010/M_RAG_A1_FINAL_EDITABLE.pptx
+++ b/FINALDOCS/POSTER/A1_FINAL_TITLE_CONFIRMED_20261010/M_RAG_A1_FINAL_EDITABLE.pptx
@@ -4589,7 +4589,7 @@
                           <ns1:ea typeface="Malgun Gothic"/>
                           <ns1:cs typeface="Malgun Gothic"/>
                         </ns1:rPr>
-                        <ns1:t>HyDE 적용 전후 답변 관련성은 어떻게 달라지는가</ns1:t>
+                        <ns1:t>HyDE 적용 전후 검색 결과와 답변 품질은 어떻게 달라지는가</ns1:t>
                       </ns1:r>
                     </ns1:p>
                   </ns1:txBody>
@@ -4865,7 +4865,7 @@
                           <ns1:ea typeface="Malgun Gothic"/>
                           <ns1:cs typeface="Malgun Gothic"/>
                         </ns1:rPr>
-                        <ns1:t>관련성, 충실도, 한국어 비율과 실행 시간에 따라 어떤 조건을 선택하는가</ns1:t>
+                        <ns1:t>답변 품질, 한국어 문자 비율과 실행 시간으로 어떤 조건을 선택하는가</ns1:t>
                       </ns1:r>
                     </ns1:p>
                   </ns1:txBody>
@@ -4985,7 +4985,7 @@
                           <ns1:ea typeface="Malgun Gothic"/>
                           <ns1:cs typeface="Malgun Gothic"/>
                         </ns1:rPr>
-                        <ns1:t>관련 문서를 검색해 생성 모델의 입력으로 제공하고 답변 생성</ns1:t>
+                        <ns1:t>관련 문맥을 검색하고 생성 모델에 입력하여 답변 생성</ns1:t>
                       </ns1:r>
                     </ns1:p>
                     <ns1:p>
@@ -5207,7 +5207,7 @@
                           <ns1:ea typeface="Malgun Gothic"/>
                           <ns1:cs typeface="Malgun Gothic"/>
                         </ns1:rPr>
-                        <ns1:t>같은 모델의 문맥 포함 분포와 문맥 제외 분포를 비교</ns1:t>
+                        <ns1:t>같은 모델에서 문맥을 포함한 입력과 제외한 입력의 로짓 계산</ns1:t>
                       </ns1:r>
                     </ns1:p>
                     <ns1:p>
@@ -5226,7 +5226,7 @@
                           <ns1:ea typeface="Malgun Gothic"/>
                           <ns1:cs typeface="Malgun Gothic"/>
                         </ns1:rPr>
-                        <ns1:t>토큰 점수를 (1+α)z_ctx - αz_noctx로 조절</ns1:t>
+                        <ns1:t>로짓을 (1+α)z_ctx - αz_noctx로 가중 결합</ns1:t>
                       </ns1:r>
                     </ns1:p>
                   </ns1:txBody>
@@ -5318,7 +5318,7 @@
                           <ns1:ea typeface="Malgun Gothic"/>
                           <ns1:cs typeface="Malgun Gothic"/>
                         </ns1:rPr>
-                        <ns1:t>토큰의 언어에 따라 생성 점수를 조절해 한국어 출력을 유도</ns1:t>
+                        <ns1:t>한국어와 다른 언어 토큰의 로짓에 각각 계수를 곱함</ns1:t>
                       </ns1:r>
                     </ns1:p>
                     <ns1:p>
@@ -5337,7 +5337,7 @@
                           <ns1:ea typeface="Malgun Gothic"/>
                           <ns1:cs typeface="Malgun Gothic"/>
                         </ns1:rPr>
-                        <ns1:t>CAD 후 한국어×1.1, 다른 언어×0.9; 중립 토큰과 첫 5토큰 유지</ns1:t>
+                        <ns1:t>한국어 로짓×1.1, 다른 언어×0.9. 중립 토큰과 첫 5토큰 유지</ns1:t>
                       </ns1:r>
                     </ns1:p>
                   </ns1:txBody>
@@ -7128,7 +7128,7 @@
                 <ns1:ea typeface="Malgun Gothic"/>
                 <ns1:cs typeface="Malgun Gothic"/>
               </ns1:rPr>
-              <ns1:t>3072단어 초과 시 압축</ns1:t>
+              <ns1:t>3,072단어 초과 시 압축</ns1:t>
             </ns1:r>
           </ns1:p>
         </ns0:txBody>
@@ -8520,7 +8520,7 @@
                 <ns1:ea typeface="Malgun Gothic"/>
                 <ns1:cs typeface="Malgun Gothic"/>
               </ns1:rPr>
-              <ns1:t>생성: CAD로 문맥 기반 토큰 점수 조절 → SCD로 출력 언어 조절</ns1:t>
+              <ns1:t>생성: CAD ON에서 로짓 가중 결합 → SCD ON에서 언어별 로짓 조정</ns1:t>
             </ns1:r>
           </ns1:p>
         </ns0:txBody>
@@ -8696,7 +8696,7 @@
                 <ns1:ea typeface="Malgun Gothic"/>
                 <ns1:cs typeface="Malgun Gothic"/>
               </ns1:rPr>
-              <ns1:t>최종 5개</ns1:t>
+              <ns1:t>선택 청크 5개</ns1:t>
             </ns1:r>
           </ns1:p>
         </ns0:txBody>
@@ -9432,7 +9432,7 @@
                 <ns1:ea typeface="Malgun Gothic"/>
                 <ns1:cs typeface="Malgun Gothic"/>
               </ns1:rPr>
-              <ns1:t>언어별 토큰 점수 조절</ns1:t>
+              <ns1:t>언어별 로짓 조정</ns1:t>
             </ns1:r>
           </ns1:p>
         </ns0:txBody>
@@ -10744,7 +10744,7 @@
                 <ns1:ea typeface="Malgun Gothic"/>
                 <ns1:cs typeface="Malgun Gothic"/>
               </ns1:rPr>
-              <ns1:t>HyDE는 밀집 검색 입력을 바꾸며, CAD와 SCD는 생성 중 토큰 점수를 조정</ns1:t>
+              <ns1:t>최종 평가와 분리한 튜닝 질의 5개로 검색 폭 선정</ns1:t>
             </ns1:r>
           </ns1:p>
         </ns0:txBody>
@@ -10816,7 +10816,7 @@
                 <ns1:ea typeface="Malgun Gothic"/>
                 <ns1:cs typeface="Malgun Gothic"/>
               </ns1:rPr>
-              <ns1:t>CAD와 SCD 동시 적용 시 CAD(α=0.5) 후 SCD 적용; 같은 질의의 8조건 비교</ns1:t>
+              <ns1:t>두 기법을 함께 적용하면 CAD(α=0.5) 계산 후 SCD 적용</ns1:t>
             </ns1:r>
           </ns1:p>
         </ns0:txBody>
@@ -12689,7 +12689,7 @@
                           <ns1:ea typeface="Malgun Gothic"/>
                           <ns1:cs typeface="Malgun Gothic"/>
                         </ns1:rPr>
-                        <ns1:t>초기 질문 3개로 질문 형식과 범위 설정 → LLM으로 문서 주요 내용 요약</ns1:t>
+                        <ns1:t>초기 질문 3개로 표현과 범위 설정 → LLM으로 각 문서 주요 내용 요약</ns1:t>
                       </ns1:r>
                     </ns1:p>
                     <ns1:p>
@@ -12708,7 +12708,7 @@
                           <ns1:ea typeface="Malgun Gothic"/>
                           <ns1:cs typeface="Malgun Gothic"/>
                         </ns1:rPr>
-                        <ns1:t>요약을 15개 단위로 나눠 질의 작성 → 각 질의의 원문 페이지와 근거 확인</ns1:t>
+                        <ns1:t>요약 15개 단위에서 질의 작성 → 문서별 15개, 총 60개 근거 확인</ns1:t>
                       </ns1:r>
                     </ns1:p>
                   </ns1:txBody>
@@ -13173,7 +13173,7 @@
                 <ns1:ea typeface="Malgun Gothic"/>
                 <ns1:cs typeface="Malgun Gothic"/>
               </ns1:rPr>
-              <ns1:t>질의 유형: 사실/정의 8, 방법/절차 29, 결과/비교 20, 목적/기여 3</ns1:t>
+              <ns1:t>질의 유형: 사실 및 정의 8, 방법 및 절차 29, 결과 및 비교 20, 목적 및 기여 3</ns1:t>
             </ns1:r>
           </ns1:p>
         </ns0:txBody>
@@ -13347,7 +13347,7 @@
                 <ns1:ea typeface="Malgun Gothic"/>
                 <ns1:cs typeface="Malgun Gothic"/>
               </ns1:rPr>
-              <ns1:t>질의, 답변, 검색 문맥과 참조 답변으로 품질 평가; 출력 언어는 한국어 문자 비율로 측정</ns1:t>
+              <ns1:t>질의, 답변, 검색 문맥과 참조 답변으로 품질 평가. 한국어 문자 비율 별도 측정</ns1:t>
             </ns1:r>
           </ns1:p>
         </ns0:txBody>
@@ -13514,7 +13514,7 @@
                           <ns1:ea typeface="Malgun Gothic"/>
                           <ns1:cs typeface="Malgun Gothic"/>
                         </ns1:rPr>
-                        <ns1:t>답변의 주장이 검색 문맥으로 지지되는 정도</ns1:t>
+                        <ns1:t>검색 문맥이 답변의 주장을 뒷받침하는 정도</ns1:t>
                       </ns1:r>
                     </ns1:p>
                   </ns1:txBody>
@@ -14002,7 +14002,7 @@
                           <ns1:ea typeface="Malgun Gothic"/>
                           <ns1:cs typeface="Malgun Gothic"/>
                         </ns1:rPr>
-                        <ns1:t>gpt-4o로 한국어 변환한 문맥으로 RAGAS 평가</ns1:t>
+                        <ns1:t>영어 문맥을 gpt-4o로 한국어 번역한 뒤 RAGAS 평가</ns1:t>
                       </ns1:r>
                     </ns1:p>
                   </ns1:txBody>
@@ -14678,7 +14678,7 @@
                           <ns1:ea typeface="Malgun Gothic"/>
                           <ns1:cs typeface="Malgun Gothic"/>
                         </ns1:rPr>
-                        <ns1:t>주 비교 H0 동일 문맥 / 전체 H/C 상태 일치</ns1:t>
+                        <ns1:t>주 비교 HyDE OFF 동일 문맥 / 전체 H/C 상태 일치</ns1:t>
                       </ns1:r>
                     </ns1:p>
                   </ns1:txBody>
@@ -14820,7 +14820,7 @@
                 <ns1:ea typeface="Malgun Gothic"/>
                 <ns1:cs typeface="Malgun Gothic"/>
               </ns1:rPr>
-              <ns1:t>HyDE ON은 가상 문서 재생성으로 문맥이 달라질 수 있어, OFF 120쌍을 주 비교로 사용</ns1:t>
+              <ns1:t>HyDE OFF의 동일 문맥 120쌍을 주 비교로 사용. 전체 240쌍도 집계</ns1:t>
             </ns1:r>
           </ns1:p>
         </ns0:txBody>
@@ -14964,7 +14964,7 @@
                 <ns1:ea typeface="Malgun Gothic"/>
                 <ns1:cs typeface="Malgun Gothic"/>
               </ns1:rPr>
-              <ns1:t>한글과 ASCII 영문자만 계산; 논문명과 모델명의 영어 표기도 반영</ns1:t>
+              <ns1:t>한글과 ASCII 영문자 수로 계산. 논문명과 모델명의 영어 표기도 포함</ns1:t>
             </ns1:r>
           </ns1:p>
         </ns0:txBody>
@@ -15036,7 +15036,7 @@
                 <ns1:ea typeface="Malgun Gothic"/>
                 <ns1:cs typeface="Malgun Gothic"/>
               </ns1:rPr>
-              <ns1:t>RAGAS 평가값 1,920개 중 1,915개 유효; 근거 충실도 5개 결측</ns1:t>
+              <ns1:t>RAGAS 평가값 1,920개 중 1,915개 유효. 근거 충실도 5개 결측</ns1:t>
             </ns1:r>
           </ns1:p>
         </ns0:txBody>
@@ -15180,7 +15180,7 @@
                 <ns1:ea typeface="Malgun Gothic"/>
                 <ns1:cs typeface="Malgun Gothic"/>
               </ns1:rPr>
-              <ns1:t>문서 4종 고정, seed=20260713; 질의 단위 95% 신뢰구간</ns1:t>
+              <ns1:t>문서 4종 고정, seed=20260713. 질의 단위 95% 신뢰구간</ns1:t>
             </ns1:r>
           </ns1:p>
         </ns0:txBody>
@@ -16410,7 +16410,7 @@
                 <ns1:ea typeface="Malgun Gothic"/>
                 <ns1:cs typeface="Malgun Gothic"/>
               </ns1:rPr>
-              <ns1:t>CAD 두 지표의 95% 구간은 0 포함; 관련성 -0.0073 [-0.0855, +0.0719]</ns1:t>
+              <ns1:t>CAD 두 지표의 95% 구간은 0 포함. 관련성 -0.0073 [-0.0855, +0.0719]</ns1:t>
             </ns1:r>
           </ns1:p>
         </ns0:txBody>
@@ -18472,7 +18472,7 @@
                 <ns1:ea typeface="Malgun Gothic"/>
                 <ns1:cs typeface="Malgun Gothic"/>
               </ns1:rPr>
-              <ns1:t>CAD는 동일 문맥 비교; SCD의 언어 비율과 답변 정확성은 별개로 해석</ns1:t>
+              <ns1:t>CAD 사례는 동일 문맥 비교. SCD 사례는 답변 언어의 변화 비교</ns1:t>
             </ns1:r>
           </ns1:p>
         </ns0:txBody>
@@ -18544,7 +18544,7 @@
                 <ns1:ea typeface="Malgun Gothic"/>
                 <ns1:cs typeface="Malgun Gothic"/>
               </ns1:rPr>
-              <ns1:t>SCD 사례(HyDE ON)는 전체 240쌍에 포함, 주 비교 120쌍에서는 제외</ns1:t>
+              <ns1:t>HyDE ON의 SCD 사례는 전체 240쌍에 포함. 주 비교는 HyDE OFF 120쌍</ns1:t>
             </ns1:r>
           </ns1:p>
         </ns0:txBody>
@@ -18790,7 +18790,7 @@
                 <ns1:ea typeface="Malgun Gothic"/>
                 <ns1:cs typeface="Malgun Gothic"/>
               </ns1:rPr>
-              <ns1:t>CAD 근거 충실도 변화 +0.0288; 95% 신뢰구간은 0 포함</ns1:t>
+              <ns1:t>CAD 근거 충실도 평균 대응 차이 +0.0288. 95% 신뢰구간은 0 포함</ns1:t>
             </ns1:r>
           </ns1:p>
         </ns0:txBody>
@@ -18862,7 +18862,7 @@
                 <ns1:ea typeface="Malgun Gothic"/>
                 <ns1:cs typeface="Malgun Gothic"/>
               </ns1:rPr>
-              <ns1:t>CAD 조건 실행 시간은 20.792초에서 63.867초로 증가</ns1:t>
+              <ns1:t>H0S0에서 CAD 조건 실행 시간은 20.792초에서 63.867초로 증가</ns1:t>
             </ns1:r>
           </ns1:p>
         </ns0:txBody>
@@ -18934,7 +18934,7 @@
                 <ns1:ea typeface="Malgun Gothic"/>
                 <ns1:cs typeface="Malgun Gothic"/>
               </ns1:rPr>
-              <ns1:t>SCD 한국어 문자 비율은 동일 문맥120쌍에서 평균 +0.2182 증가</ns1:t>
+              <ns1:t>SCD 한국어 문자 비율은 HyDE OFF 동일 문맥 120쌍에서 평균 +0.2182 증가</ns1:t>
             </ns1:r>
           </ns1:p>
         </ns0:txBody>

</xml_diff>

<commit_message>
Correct final thesis prose and poster numeric alignment
</commit_message>
<xml_diff>
--- a/FINALDOCS/POSTER/A1_FINAL_TITLE_CONFIRMED_20261010/M_RAG_A1_FINAL_EDITABLE.pptx
+++ b/FINALDOCS/POSTER/A1_FINAL_TITLE_CONFIRMED_20261010/M_RAG_A1_FINAL_EDITABLE.pptx
@@ -2,13 +2,13 @@
 <file path=ppt/presentation.xml><?xml version="1.0" encoding="utf-8"?>
 <p:presentation xmlns:p="http://schemas.openxmlformats.org/presentationml/2006/main">
   <p:sldMasterIdLst>
-    <p:sldMasterId xmlns:r="http://schemas.openxmlformats.org/officeDocument/2006/relationships" id="2147483648" r:id="Rb6e19347b8354970"/>
+    <p:sldMasterId xmlns:r="http://schemas.openxmlformats.org/officeDocument/2006/relationships" id="2147483648" r:id="R25cdf025835b4cc7"/>
   </p:sldMasterIdLst>
   <p:notesMasterIdLst>
-    <p:notesMasterId xmlns:r="http://schemas.openxmlformats.org/officeDocument/2006/relationships" r:id="R5759b30b39154fce"/>
+    <p:notesMasterId xmlns:r="http://schemas.openxmlformats.org/officeDocument/2006/relationships" r:id="R1a10d38d154247d3"/>
   </p:notesMasterIdLst>
   <p:sldIdLst>
-    <p:sldId xmlns:r="http://schemas.openxmlformats.org/officeDocument/2006/relationships" id="256" r:id="R02a32982260041c1"/>
+    <p:sldId xmlns:r="http://schemas.openxmlformats.org/officeDocument/2006/relationships" id="256" r:id="R311e838784fc4b00"/>
   </p:sldIdLst>
   <p:sldSz cx="21384000" cy="30276000"/>
   <p:notesSz cx="6858000" cy="9144000"/>
@@ -442,7 +442,7 @@
           <a:lstStyle xmlns:a="http://schemas.openxmlformats.org/drawingml/2006/main"/>
           <a:p xmlns:a="http://schemas.openxmlformats.org/drawingml/2006/main">
             <a:r>
-              <a:t>Research sources and full statistics: FINALDOCS/DATA/FACTORIAL_STATISTICS_60Q.json; FINALDOCS/MANUSCRIPT/GRADUATION_REPORT_TRANSFER_KO_60Q.md. Existing retained records only. Holm families declared at revision time. Native editable diagrams and tables. No confidence-interval charts or cube. Reference [4] https://arxiv.org/abs/2511.09984; references follow manuscript numbering.</a:t>
+              <a:t>Research sources and full statistics: FINALDOCS/DATA/FACTORIAL_STATISTICS_60Q.json; FINALDOCS/MANUSCRIPT/GRADUATION_REPORT_TRANSFER_KO_60Q.md. The exploratory analysis uses query-level repeated measures and Holm-adjusted hypothesis families. Editable tables follow explicit data-type alignment. Reference [4] https://arxiv.org/abs/2511.09984; references follow manuscript numbering.</a:t>
             </a:r>
           </a:p>
         </p:txBody>
@@ -489,7 +489,7 @@
           <p:cNvPr id="3" name="Title">
             <a:extLst xmlns:a="http://schemas.openxmlformats.org/drawingml/2006/main">
               <a:ext uri="{FF2B5EF4-FFF2-40B4-BE49-F238E27FC236}">
-                <a16:creationId xmlns:a16="http://schemas.microsoft.com/office/drawing/2014/main" id="{3FE3A825-BF6F-49AF-ACDF-F7898CE8733B}"/>
+                <a16:creationId xmlns:a16="http://schemas.microsoft.com/office/drawing/2014/main" id="{3EF1CA28-601E-4D25-98C6-8FF66D38F999}"/>
               </a:ext>
             </a:extLst>
           </p:cNvPr>
@@ -646,7 +646,7 @@
           <p:cNvPr id="2" name="Subtitle">
             <a:extLst xmlns:a="http://schemas.openxmlformats.org/drawingml/2006/main">
               <a:ext uri="{FF2B5EF4-FFF2-40B4-BE49-F238E27FC236}">
-                <a16:creationId xmlns:a16="http://schemas.microsoft.com/office/drawing/2014/main" id="{EFC19271-8FF3-4763-B9E8-4D7C9E4AD0DB}"/>
+                <a16:creationId xmlns:a16="http://schemas.microsoft.com/office/drawing/2014/main" id="{297DE18A-30B9-4804-8197-E472CDEA4A7F}"/>
               </a:ext>
             </a:extLst>
           </p:cNvPr>
@@ -820,7 +820,7 @@
           <p:cNvPr id="2" name="Section title">
             <a:extLst xmlns:a="http://schemas.openxmlformats.org/drawingml/2006/main">
               <a:ext uri="{FF2B5EF4-FFF2-40B4-BE49-F238E27FC236}">
-                <a16:creationId xmlns:a16="http://schemas.microsoft.com/office/drawing/2014/main" id="{40DC9239-C8A9-4A85-8C4A-AF4B2D593298}"/>
+                <a16:creationId xmlns:a16="http://schemas.microsoft.com/office/drawing/2014/main" id="{423753AE-4691-41CA-A1F5-E3AEEAB94FA4}"/>
               </a:ext>
             </a:extLst>
           </p:cNvPr>
@@ -994,7 +994,7 @@
           <p:cNvPr id="3" name="Title">
             <a:extLst xmlns:a="http://schemas.openxmlformats.org/drawingml/2006/main">
               <a:ext uri="{FF2B5EF4-FFF2-40B4-BE49-F238E27FC236}">
-                <a16:creationId xmlns:a16="http://schemas.microsoft.com/office/drawing/2014/main" id="{E2448AB4-140B-479B-9C4D-4FEFB8B8522A}"/>
+                <a16:creationId xmlns:a16="http://schemas.microsoft.com/office/drawing/2014/main" id="{259D13B0-039E-4B8D-92D3-62731AAF799B}"/>
               </a:ext>
             </a:extLst>
           </p:cNvPr>
@@ -1151,7 +1151,7 @@
           <p:cNvPr id="2" name="Body">
             <a:extLst xmlns:a="http://schemas.openxmlformats.org/drawingml/2006/main">
               <a:ext uri="{FF2B5EF4-FFF2-40B4-BE49-F238E27FC236}">
-                <a16:creationId xmlns:a16="http://schemas.microsoft.com/office/drawing/2014/main" id="{7AB5F2BB-3B52-463F-9B6D-B0D5AED22C9C}"/>
+                <a16:creationId xmlns:a16="http://schemas.microsoft.com/office/drawing/2014/main" id="{070B5E39-825F-4FB8-85B8-CDF8E33E3E40}"/>
               </a:ext>
             </a:extLst>
           </p:cNvPr>
@@ -1325,7 +1325,7 @@
           <p:cNvPr id="4" name="Title">
             <a:extLst xmlns:a="http://schemas.openxmlformats.org/drawingml/2006/main">
               <a:ext uri="{FF2B5EF4-FFF2-40B4-BE49-F238E27FC236}">
-                <a16:creationId xmlns:a16="http://schemas.microsoft.com/office/drawing/2014/main" id="{D87C62FE-9FDE-490F-98A5-717D2CA41563}"/>
+                <a16:creationId xmlns:a16="http://schemas.microsoft.com/office/drawing/2014/main" id="{A05C5A84-E02D-4899-B073-7349CA25A10B}"/>
               </a:ext>
             </a:extLst>
           </p:cNvPr>
@@ -1482,7 +1482,7 @@
           <p:cNvPr id="2" name="Left column">
             <a:extLst xmlns:a="http://schemas.openxmlformats.org/drawingml/2006/main">
               <a:ext uri="{FF2B5EF4-FFF2-40B4-BE49-F238E27FC236}">
-                <a16:creationId xmlns:a16="http://schemas.microsoft.com/office/drawing/2014/main" id="{E8AEFD8A-0BE2-4655-94E2-3C32698AF264}"/>
+                <a16:creationId xmlns:a16="http://schemas.microsoft.com/office/drawing/2014/main" id="{C56BC174-9CCD-4251-AE15-6AB6B7BB6ECE}"/>
               </a:ext>
             </a:extLst>
           </p:cNvPr>
@@ -1639,7 +1639,7 @@
           <p:cNvPr id="3" name="Right column">
             <a:extLst xmlns:a="http://schemas.openxmlformats.org/drawingml/2006/main">
               <a:ext uri="{FF2B5EF4-FFF2-40B4-BE49-F238E27FC236}">
-                <a16:creationId xmlns:a16="http://schemas.microsoft.com/office/drawing/2014/main" id="{B1DFA414-EEDE-42A2-BD14-72A993FEA27C}"/>
+                <a16:creationId xmlns:a16="http://schemas.microsoft.com/office/drawing/2014/main" id="{BA3EBC97-C82E-42F7-8F90-6BA5FE89BDAB}"/>
               </a:ext>
             </a:extLst>
           </p:cNvPr>
@@ -1813,7 +1813,7 @@
           <p:cNvPr id="3" name="Title">
             <a:extLst xmlns:a="http://schemas.openxmlformats.org/drawingml/2006/main">
               <a:ext uri="{FF2B5EF4-FFF2-40B4-BE49-F238E27FC236}">
-                <a16:creationId xmlns:a16="http://schemas.microsoft.com/office/drawing/2014/main" id="{A08A9EFD-E1B8-4B54-A788-88DB96D68113}"/>
+                <a16:creationId xmlns:a16="http://schemas.microsoft.com/office/drawing/2014/main" id="{222EA17B-ACC9-4B1D-9FFA-AC1C094FF760}"/>
               </a:ext>
             </a:extLst>
           </p:cNvPr>
@@ -1970,7 +1970,7 @@
           <p:cNvPr id="2" name="Left column">
             <a:extLst xmlns:a="http://schemas.openxmlformats.org/drawingml/2006/main">
               <a:ext uri="{FF2B5EF4-FFF2-40B4-BE49-F238E27FC236}">
-                <a16:creationId xmlns:a16="http://schemas.microsoft.com/office/drawing/2014/main" id="{40F7B7FF-25A5-42DC-9077-E58858C18D6D}"/>
+                <a16:creationId xmlns:a16="http://schemas.microsoft.com/office/drawing/2014/main" id="{4F449F82-FF4A-4DDA-8202-2A38B4F4FFE8}"/>
               </a:ext>
             </a:extLst>
           </p:cNvPr>
@@ -2165,12 +2165,12 @@
   </p:cSld>
   <p:clrMap bg1="lt1" tx1="dk1" bg2="lt2" tx2="dk2" accent1="accent1" accent2="accent2" accent3="accent3" accent4="accent4" accent5="accent5" accent6="accent6" hlink="hlink" folHlink="folHlink"/>
   <p:sldLayoutIdLst>
-    <p:sldLayoutId xmlns:r="http://schemas.openxmlformats.org/officeDocument/2006/relationships" id="2147483649" r:id="Re58fd566ece84e1c"/>
-    <p:sldLayoutId xmlns:r="http://schemas.openxmlformats.org/officeDocument/2006/relationships" id="2147483650" r:id="R2dc1470f541a4cf4"/>
-    <p:sldLayoutId xmlns:r="http://schemas.openxmlformats.org/officeDocument/2006/relationships" id="2147483651" r:id="Rf0e42d1068644cef"/>
-    <p:sldLayoutId xmlns:r="http://schemas.openxmlformats.org/officeDocument/2006/relationships" id="2147483652" r:id="Ra6ffd3d64356416a"/>
-    <p:sldLayoutId xmlns:r="http://schemas.openxmlformats.org/officeDocument/2006/relationships" id="2147483653" r:id="R447f418f2f3a4ee3"/>
-    <p:sldLayoutId xmlns:r="http://schemas.openxmlformats.org/officeDocument/2006/relationships" id="2147483654" r:id="R15137b3534ff476d"/>
+    <p:sldLayoutId xmlns:r="http://schemas.openxmlformats.org/officeDocument/2006/relationships" id="2147483649" r:id="R4dda2c8629464ceb"/>
+    <p:sldLayoutId xmlns:r="http://schemas.openxmlformats.org/officeDocument/2006/relationships" id="2147483650" r:id="Rc74016f17898430f"/>
+    <p:sldLayoutId xmlns:r="http://schemas.openxmlformats.org/officeDocument/2006/relationships" id="2147483651" r:id="R59a69b171cb249d6"/>
+    <p:sldLayoutId xmlns:r="http://schemas.openxmlformats.org/officeDocument/2006/relationships" id="2147483652" r:id="R3b4877f22e024747"/>
+    <p:sldLayoutId xmlns:r="http://schemas.openxmlformats.org/officeDocument/2006/relationships" id="2147483653" r:id="Rb034b9c1f4d7491b"/>
+    <p:sldLayoutId xmlns:r="http://schemas.openxmlformats.org/officeDocument/2006/relationships" id="2147483654" r:id="R6cf200f9030741e4"/>
   </p:sldLayoutIdLst>
   <p:txStyles>
     <p:titleStyle>
@@ -2721,7 +2721,7 @@
           <p:cNvPr id="70" name="">
             <a:extLst xmlns:a="http://schemas.openxmlformats.org/drawingml/2006/main">
               <a:ext uri="{FF2B5EF4-FFF2-40B4-BE49-F238E27FC236}">
-                <a16:creationId xmlns:a16="http://schemas.microsoft.com/office/drawing/2014/main" id="{0C2ED282-F120-41FC-BCF6-C4E9EB5ABD1B}"/>
+                <a16:creationId xmlns:a16="http://schemas.microsoft.com/office/drawing/2014/main" id="{D35823C3-23EA-486F-A14C-FF18F9FC54E0}"/>
               </a:ext>
             </a:extLst>
           </p:cNvPr>
@@ -2752,7 +2752,7 @@
           <p:cNvPr id="2" name="한국어 질의로 영어 학술·기술 문서를 검색하는">
             <a:extLst xmlns:a="http://schemas.openxmlformats.org/drawingml/2006/main">
               <a:ext uri="{FF2B5EF4-FFF2-40B4-BE49-F238E27FC236}">
-                <a16:creationId xmlns:a16="http://schemas.microsoft.com/office/drawing/2014/main" id="{7C4DFB6C-958D-451D-972E-9FE81F63227B}"/>
+                <a16:creationId xmlns:a16="http://schemas.microsoft.com/office/drawing/2014/main" id="{EC04968A-A661-41B5-97E0-DBC56404D650}"/>
               </a:ext>
             </a:extLst>
           </p:cNvPr>
@@ -2820,7 +2820,7 @@
           <p:cNvPr id="3" name="RAG에서의 HyDE·CAD·SCD 조합 실험">
             <a:extLst xmlns:a="http://schemas.openxmlformats.org/drawingml/2006/main">
               <a:ext uri="{FF2B5EF4-FFF2-40B4-BE49-F238E27FC236}">
-                <a16:creationId xmlns:a16="http://schemas.microsoft.com/office/drawing/2014/main" id="{98605256-6ED2-4646-AB9C-B0B77D0B102E}"/>
+                <a16:creationId xmlns:a16="http://schemas.microsoft.com/office/drawing/2014/main" id="{F446C877-BCE2-41A9-A986-BC8E96DCDA61}"/>
               </a:ext>
             </a:extLst>
           </p:cNvPr>
@@ -2888,7 +2888,7 @@
           <p:cNvPr id="4" name="문종건 · 동국대학교 WISE캠퍼스 컴퓨터공학과 · 지도교수 김진석 · 2026.10.15">
             <a:extLst xmlns:a="http://schemas.openxmlformats.org/drawingml/2006/main">
               <a:ext uri="{FF2B5EF4-FFF2-40B4-BE49-F238E27FC236}">
-                <a16:creationId xmlns:a16="http://schemas.microsoft.com/office/drawing/2014/main" id="{8121F4B6-01DB-4BED-A833-FAFB43BBAF37}"/>
+                <a16:creationId xmlns:a16="http://schemas.microsoft.com/office/drawing/2014/main" id="{4DCDC5CB-A832-4692-8720-66DA532565B7}"/>
               </a:ext>
             </a:extLst>
           </p:cNvPr>
@@ -2956,7 +2956,7 @@
           <p:cNvPr id="5" name="">
             <a:extLst xmlns:a="http://schemas.openxmlformats.org/drawingml/2006/main">
               <a:ext uri="{FF2B5EF4-FFF2-40B4-BE49-F238E27FC236}">
-                <a16:creationId xmlns:a16="http://schemas.microsoft.com/office/drawing/2014/main" id="{E871D863-6D29-4FF3-9D7F-4B21C25D987E}"/>
+                <a16:creationId xmlns:a16="http://schemas.microsoft.com/office/drawing/2014/main" id="{C91C276D-D979-4B92-B732-77454A6CDC01}"/>
               </a:ext>
             </a:extLst>
           </p:cNvPr>
@@ -2987,7 +2987,7 @@
           <p:cNvPr id="6" name="01 연구 배경과 목적">
             <a:extLst xmlns:a="http://schemas.openxmlformats.org/drawingml/2006/main">
               <a:ext uri="{FF2B5EF4-FFF2-40B4-BE49-F238E27FC236}">
-                <a16:creationId xmlns:a16="http://schemas.microsoft.com/office/drawing/2014/main" id="{D0B477FC-83D2-4F14-8B7C-A46F2BE34E18}"/>
+                <a16:creationId xmlns:a16="http://schemas.microsoft.com/office/drawing/2014/main" id="{3FB551B7-90E5-49FC-A63E-81C6C6F5E81A}"/>
               </a:ext>
             </a:extLst>
           </p:cNvPr>
@@ -3055,7 +3055,7 @@
           <p:cNvPr id="7" name="RAG는 질문과 관련된 문서 구간을 검색하고, 그 텍스트를 생성 모델에 제공해 답변을 만든다[1].">
             <a:extLst xmlns:a="http://schemas.openxmlformats.org/drawingml/2006/main">
               <a:ext uri="{FF2B5EF4-FFF2-40B4-BE49-F238E27FC236}">
-                <a16:creationId xmlns:a16="http://schemas.microsoft.com/office/drawing/2014/main" id="{120A4F1F-32C1-4ACA-BC00-FE21F5661B60}"/>
+                <a16:creationId xmlns:a16="http://schemas.microsoft.com/office/drawing/2014/main" id="{517D2337-F1C6-4E16-9927-400AE51A10F9}"/>
               </a:ext>
             </a:extLst>
           </p:cNvPr>
@@ -3146,7 +3146,7 @@
           <p:cNvPr id="8" name="HyDE: Hypothetical Document Embeddings[2] CAD: Context-Aware Deco">
             <a:extLst xmlns:a="http://schemas.openxmlformats.org/drawingml/2006/main">
               <a:ext uri="{FF2B5EF4-FFF2-40B4-BE49-F238E27FC236}">
-                <a16:creationId xmlns:a16="http://schemas.microsoft.com/office/drawing/2014/main" id="{E44A3529-7AD0-4D40-9ACB-D05B445482E7}"/>
+                <a16:creationId xmlns:a16="http://schemas.microsoft.com/office/drawing/2014/main" id="{DECE8374-0FED-430E-95AB-2AD96C09C731}"/>
               </a:ext>
             </a:extLst>
           </p:cNvPr>
@@ -3257,10 +3257,10 @@
       </p:sp>
       <p:sp>
         <p:nvSpPr>
-          <p:cNvPr id="9" name="한국어 질문으로 영어 문서를 이용할 때 검색 근거, 답변의 근거 충실도와 출력 언어를 함께 살펴본다. 동일 파이프라인">
+          <p:cNvPr id="9" name="본 연구는 한국어 질의로 영어 문서를 검색하는 RAG에서 검색 결과, 답변의 근거 충실도 및 출력 언어를 평가한다. ">
             <a:extLst xmlns:a="http://schemas.openxmlformats.org/drawingml/2006/main">
               <a:ext uri="{FF2B5EF4-FFF2-40B4-BE49-F238E27FC236}">
-                <a16:creationId xmlns:a16="http://schemas.microsoft.com/office/drawing/2014/main" id="{E69F7A23-42E7-49A7-A5D9-077453734575}"/>
+                <a16:creationId xmlns:a16="http://schemas.microsoft.com/office/drawing/2014/main" id="{60ECDB5A-7CE7-4515-BF78-448231C7F4EC}"/>
               </a:ext>
             </a:extLst>
           </p:cNvPr>
@@ -3318,7 +3318,7 @@
                 <a:ea typeface="Malgun Gothic"/>
                 <a:cs typeface="Malgun Gothic"/>
               </a:rPr>
-              <a:t>한국어 질문으로 영어 문서를 이용할 때 검색 근거,</a:t>
+              <a:t>본 연구는 한국어 질의로 영어 문서를 검색하는 RAG에서</a:t>
             </a:r>
           </a:p>
           <a:p xmlns:a="http://schemas.openxmlformats.org/drawingml/2006/main">
@@ -3341,7 +3341,7 @@
                 <a:ea typeface="Malgun Gothic"/>
                 <a:cs typeface="Malgun Gothic"/>
               </a:rPr>
-              <a:t>답변의 근거 충실도와 출력 언어를 함께 살펴본다.</a:t>
+              <a:t>검색 결과, 답변의 근거 충실도 및 출력 언어를 평가한다.</a:t>
             </a:r>
           </a:p>
           <a:p xmlns:a="http://schemas.openxmlformats.org/drawingml/2006/main">
@@ -3364,7 +3364,7 @@
                 <a:ea typeface="Malgun Gothic"/>
                 <a:cs typeface="Malgun Gothic"/>
               </a:rPr>
-              <a:t>동일 파이프라인에서 세 기법의 8개 조합을 비교한다.</a:t>
+              <a:t>같은 파이프라인에서 세 기법의 8개 조합을 비교한다.</a:t>
             </a:r>
           </a:p>
         </p:txBody>
@@ -3374,7 +3374,7 @@
           <p:cNvPr id="10" name="">
             <a:extLst xmlns:a="http://schemas.openxmlformats.org/drawingml/2006/main">
               <a:ext uri="{FF2B5EF4-FFF2-40B4-BE49-F238E27FC236}">
-                <a16:creationId xmlns:a16="http://schemas.microsoft.com/office/drawing/2014/main" id="{6A81FF77-E18E-4F0D-A1DB-C2654B8D2F57}"/>
+                <a16:creationId xmlns:a16="http://schemas.microsoft.com/office/drawing/2014/main" id="{2C9F2623-5C6A-47A8-A02A-5852CA938A1A}"/>
               </a:ext>
             </a:extLst>
           </p:cNvPr>
@@ -3405,7 +3405,7 @@
           <p:cNvPr id="11" name="02 Paper-RAG 구조와 기법 적용 위치">
             <a:extLst xmlns:a="http://schemas.openxmlformats.org/drawingml/2006/main">
               <a:ext uri="{FF2B5EF4-FFF2-40B4-BE49-F238E27FC236}">
-                <a16:creationId xmlns:a16="http://schemas.microsoft.com/office/drawing/2014/main" id="{CDA6676A-2EA7-4C79-8D3D-C614CB401E8C}"/>
+                <a16:creationId xmlns:a16="http://schemas.microsoft.com/office/drawing/2014/main" id="{831A511A-EBAF-4552-8060-1250B8897B84}"/>
               </a:ext>
             </a:extLst>
           </p:cNvPr>
@@ -3473,7 +3473,7 @@
           <p:cNvPr id="12" name="Paper-RAG는 본 연구의 고정 검색·생성 파이프라인이다.">
             <a:extLst xmlns:a="http://schemas.openxmlformats.org/drawingml/2006/main">
               <a:ext uri="{FF2B5EF4-FFF2-40B4-BE49-F238E27FC236}">
-                <a16:creationId xmlns:a16="http://schemas.microsoft.com/office/drawing/2014/main" id="{AC425FBD-3671-4218-B02C-2D2CAFF0AA97}"/>
+                <a16:creationId xmlns:a16="http://schemas.microsoft.com/office/drawing/2014/main" id="{3E012770-4A2F-4642-A875-47E36DBFA26E}"/>
               </a:ext>
             </a:extLst>
           </p:cNvPr>
@@ -3541,7 +3541,7 @@
           <p:cNvPr id="13" name="">
             <a:extLst xmlns:a="http://schemas.openxmlformats.org/drawingml/2006/main">
               <a:ext uri="{FF2B5EF4-FFF2-40B4-BE49-F238E27FC236}">
-                <a16:creationId xmlns:a16="http://schemas.microsoft.com/office/drawing/2014/main" id="{2F2880B9-3B47-4F15-873F-FE8853FAE1C9}"/>
+                <a16:creationId xmlns:a16="http://schemas.microsoft.com/office/drawing/2014/main" id="{633824F8-68EE-479D-AFCE-1BD54F4C00BA}"/>
               </a:ext>
             </a:extLst>
           </p:cNvPr>
@@ -3574,7 +3574,7 @@
           <p:cNvPr id="14" name="한국어 질의 HyDE OFF: 원질의 HyDE ON: 영어 번역·가상 문서">
             <a:extLst xmlns:a="http://schemas.openxmlformats.org/drawingml/2006/main">
               <a:ext uri="{FF2B5EF4-FFF2-40B4-BE49-F238E27FC236}">
-                <a16:creationId xmlns:a16="http://schemas.microsoft.com/office/drawing/2014/main" id="{FBFBDFA2-D9EF-4C28-B748-1630F09C72E0}"/>
+                <a16:creationId xmlns:a16="http://schemas.microsoft.com/office/drawing/2014/main" id="{C543CEB6-22AE-4AB7-8E39-E239E36A5BB5}"/>
               </a:ext>
             </a:extLst>
           </p:cNvPr>
@@ -3688,7 +3688,7 @@
           <p:cNvPr id="15" name="">
             <a:extLst xmlns:a="http://schemas.openxmlformats.org/drawingml/2006/main">
               <a:ext uri="{FF2B5EF4-FFF2-40B4-BE49-F238E27FC236}">
-                <a16:creationId xmlns:a16="http://schemas.microsoft.com/office/drawing/2014/main" id="{FEBC3303-7DD3-4F47-8573-4262DD9DD632}"/>
+                <a16:creationId xmlns:a16="http://schemas.microsoft.com/office/drawing/2014/main" id="{88A59CB5-7758-4951-A4CA-8D2264BB2C9C}"/>
               </a:ext>
             </a:extLst>
           </p:cNvPr>
@@ -3721,7 +3721,7 @@
           <p:cNvPr id="16" name="BM25 희소 검색[6] 한국어 원질의 사용">
             <a:extLst xmlns:a="http://schemas.openxmlformats.org/drawingml/2006/main">
               <a:ext uri="{FF2B5EF4-FFF2-40B4-BE49-F238E27FC236}">
-                <a16:creationId xmlns:a16="http://schemas.microsoft.com/office/drawing/2014/main" id="{23524070-1BB5-44DC-84DA-63DC193C100F}"/>
+                <a16:creationId xmlns:a16="http://schemas.microsoft.com/office/drawing/2014/main" id="{A77C4F8B-7DA6-49F3-8FAC-00F5273300E2}"/>
               </a:ext>
             </a:extLst>
           </p:cNvPr>
@@ -3812,7 +3812,7 @@
           <p:cNvPr id="17" name="">
             <a:extLst xmlns:a="http://schemas.openxmlformats.org/drawingml/2006/main">
               <a:ext uri="{FF2B5EF4-FFF2-40B4-BE49-F238E27FC236}">
-                <a16:creationId xmlns:a16="http://schemas.microsoft.com/office/drawing/2014/main" id="{F692E1CA-0C5D-42D0-963B-D524065BB6F3}"/>
+                <a16:creationId xmlns:a16="http://schemas.microsoft.com/office/drawing/2014/main" id="{7ADEDB0E-41D7-449B-83C9-78C45206F615}"/>
               </a:ext>
             </a:extLst>
           </p:cNvPr>
@@ -3845,7 +3845,7 @@
           <p:cNvPr id="18" name="BGE-M3 밀집 검색[5]">
             <a:extLst xmlns:a="http://schemas.openxmlformats.org/drawingml/2006/main">
               <a:ext uri="{FF2B5EF4-FFF2-40B4-BE49-F238E27FC236}">
-                <a16:creationId xmlns:a16="http://schemas.microsoft.com/office/drawing/2014/main" id="{C0BE9C95-EE4F-44D9-ABF6-DE356F0BCD19}"/>
+                <a16:creationId xmlns:a16="http://schemas.microsoft.com/office/drawing/2014/main" id="{5D1E9E6D-5626-4A39-97D8-29CF6003D2A7}"/>
               </a:ext>
             </a:extLst>
           </p:cNvPr>
@@ -3913,7 +3913,7 @@
           <p:cNvPr id="19" name="">
             <a:extLst xmlns:a="http://schemas.openxmlformats.org/drawingml/2006/main">
               <a:ext uri="{FF2B5EF4-FFF2-40B4-BE49-F238E27FC236}">
-                <a16:creationId xmlns:a16="http://schemas.microsoft.com/office/drawing/2014/main" id="{CC047C55-3E17-404C-9444-0E6E2A047927}"/>
+                <a16:creationId xmlns:a16="http://schemas.microsoft.com/office/drawing/2014/main" id="{5266FDBD-685C-4542-928C-F6787244D3EE}"/>
               </a:ext>
             </a:extLst>
           </p:cNvPr>
@@ -3946,7 +3946,7 @@
           <p:cNvPr id="20" name="가중 RRF[7] 0.6 / 0.4, k=60">
             <a:extLst xmlns:a="http://schemas.openxmlformats.org/drawingml/2006/main">
               <a:ext uri="{FF2B5EF4-FFF2-40B4-BE49-F238E27FC236}">
-                <a16:creationId xmlns:a16="http://schemas.microsoft.com/office/drawing/2014/main" id="{B743A9A4-4770-4AF9-91FF-3FFCC007D0B8}"/>
+                <a16:creationId xmlns:a16="http://schemas.microsoft.com/office/drawing/2014/main" id="{D0421307-ED85-4229-9A2D-3D7C4663E28D}"/>
               </a:ext>
             </a:extLst>
           </p:cNvPr>
@@ -4037,7 +4037,7 @@
           <p:cNvPr id="21" name="">
             <a:extLst xmlns:a="http://schemas.openxmlformats.org/drawingml/2006/main">
               <a:ext uri="{FF2B5EF4-FFF2-40B4-BE49-F238E27FC236}">
-                <a16:creationId xmlns:a16="http://schemas.microsoft.com/office/drawing/2014/main" id="{27DF294C-ED85-4940-B70C-9C32FAE15F71}"/>
+                <a16:creationId xmlns:a16="http://schemas.microsoft.com/office/drawing/2014/main" id="{D6415A48-CEDF-403D-B838-4D6EEE983967}"/>
               </a:ext>
             </a:extLst>
           </p:cNvPr>
@@ -4069,7 +4069,7 @@
           <p:cNvPr id="22" name="">
             <a:extLst xmlns:a="http://schemas.openxmlformats.org/drawingml/2006/main">
               <a:ext uri="{FF2B5EF4-FFF2-40B4-BE49-F238E27FC236}">
-                <a16:creationId xmlns:a16="http://schemas.microsoft.com/office/drawing/2014/main" id="{C2BA48DA-6FEE-40FA-A722-4D0FE6D4355F}"/>
+                <a16:creationId xmlns:a16="http://schemas.microsoft.com/office/drawing/2014/main" id="{0D8872F7-8A69-483B-8C90-0E2720D8E609}"/>
               </a:ext>
             </a:extLst>
           </p:cNvPr>
@@ -4101,7 +4101,7 @@
           <p:cNvPr id="23" name="">
             <a:extLst xmlns:a="http://schemas.openxmlformats.org/drawingml/2006/main">
               <a:ext uri="{FF2B5EF4-FFF2-40B4-BE49-F238E27FC236}">
-                <a16:creationId xmlns:a16="http://schemas.microsoft.com/office/drawing/2014/main" id="{223FD28B-D439-42C8-B831-F233A9B91666}"/>
+                <a16:creationId xmlns:a16="http://schemas.microsoft.com/office/drawing/2014/main" id="{2A77BF00-3B43-4235-85DA-6EC1DA68E662}"/>
               </a:ext>
             </a:extLst>
           </p:cNvPr>
@@ -4133,7 +4133,7 @@
           <p:cNvPr id="24" name="">
             <a:extLst xmlns:a="http://schemas.openxmlformats.org/drawingml/2006/main">
               <a:ext uri="{FF2B5EF4-FFF2-40B4-BE49-F238E27FC236}">
-                <a16:creationId xmlns:a16="http://schemas.microsoft.com/office/drawing/2014/main" id="{54C9E954-8788-46B5-9873-BFB535ECFDB9}"/>
+                <a16:creationId xmlns:a16="http://schemas.microsoft.com/office/drawing/2014/main" id="{13CCD39A-D53C-4D2B-89B2-53B8563B12CC}"/>
               </a:ext>
             </a:extLst>
           </p:cNvPr>
@@ -4166,7 +4166,7 @@
           <p:cNvPr id="25" name="원질의 기반 CrossEncoder 재정렬[8] 상위 5개 구간 선택·문맥 길이 관리">
             <a:extLst xmlns:a="http://schemas.openxmlformats.org/drawingml/2006/main">
               <a:ext uri="{FF2B5EF4-FFF2-40B4-BE49-F238E27FC236}">
-                <a16:creationId xmlns:a16="http://schemas.microsoft.com/office/drawing/2014/main" id="{FF43DD35-4048-4D54-B01E-A3776B151F2B}"/>
+                <a16:creationId xmlns:a16="http://schemas.microsoft.com/office/drawing/2014/main" id="{20D7C720-0DBA-4A27-B83E-5DDC97C39D4C}"/>
               </a:ext>
             </a:extLst>
           </p:cNvPr>
@@ -4257,7 +4257,7 @@
           <p:cNvPr id="26" name="">
             <a:extLst xmlns:a="http://schemas.openxmlformats.org/drawingml/2006/main">
               <a:ext uri="{FF2B5EF4-FFF2-40B4-BE49-F238E27FC236}">
-                <a16:creationId xmlns:a16="http://schemas.microsoft.com/office/drawing/2014/main" id="{5FBE50A8-7EB2-4D83-AC17-2505AC74334E}"/>
+                <a16:creationId xmlns:a16="http://schemas.microsoft.com/office/drawing/2014/main" id="{BC0B20FC-CF7A-4558-8780-ABD3853C1490}"/>
               </a:ext>
             </a:extLst>
           </p:cNvPr>
@@ -4290,7 +4290,7 @@
           <p:cNvPr id="27" name="Mi:dm 2.0 Base Instruct[18] CAD 로짓 결합 후 SCD 언어별 조정, 최종 답변 생성">
             <a:extLst xmlns:a="http://schemas.openxmlformats.org/drawingml/2006/main">
               <a:ext uri="{FF2B5EF4-FFF2-40B4-BE49-F238E27FC236}">
-                <a16:creationId xmlns:a16="http://schemas.microsoft.com/office/drawing/2014/main" id="{87EDA566-3877-4BB8-B771-498124868DA4}"/>
+                <a16:creationId xmlns:a16="http://schemas.microsoft.com/office/drawing/2014/main" id="{4DD244D3-FFEC-4C11-9459-61E9AA1EC77D}"/>
               </a:ext>
             </a:extLst>
           </p:cNvPr>
@@ -4381,7 +4381,7 @@
           <p:cNvPr id="28" name="">
             <a:extLst xmlns:a="http://schemas.openxmlformats.org/drawingml/2006/main">
               <a:ext uri="{FF2B5EF4-FFF2-40B4-BE49-F238E27FC236}">
-                <a16:creationId xmlns:a16="http://schemas.microsoft.com/office/drawing/2014/main" id="{1ACE2156-0D94-4A90-8945-63D647F59ECC}"/>
+                <a16:creationId xmlns:a16="http://schemas.microsoft.com/office/drawing/2014/main" id="{5287C08F-CA51-4B67-84C1-DB65E881F735}"/>
               </a:ext>
             </a:extLst>
           </p:cNvPr>
@@ -4413,7 +4413,7 @@
           <p:cNvPr id="29" name="">
             <a:extLst xmlns:a="http://schemas.openxmlformats.org/drawingml/2006/main">
               <a:ext uri="{FF2B5EF4-FFF2-40B4-BE49-F238E27FC236}">
-                <a16:creationId xmlns:a16="http://schemas.microsoft.com/office/drawing/2014/main" id="{85E01F6A-4A32-413B-9521-7918DB4C96B7}"/>
+                <a16:creationId xmlns:a16="http://schemas.microsoft.com/office/drawing/2014/main" id="{05BA7CDF-A363-4422-838B-76BBF79D8CF9}"/>
               </a:ext>
             </a:extLst>
           </p:cNvPr>
@@ -4445,7 +4445,7 @@
           <p:cNvPr id="30" name="">
             <a:extLst xmlns:a="http://schemas.openxmlformats.org/drawingml/2006/main">
               <a:ext uri="{FF2B5EF4-FFF2-40B4-BE49-F238E27FC236}">
-                <a16:creationId xmlns:a16="http://schemas.microsoft.com/office/drawing/2014/main" id="{CB7D9FD6-FDBB-406A-925B-E58724AE1468}"/>
+                <a16:creationId xmlns:a16="http://schemas.microsoft.com/office/drawing/2014/main" id="{80C4BD57-677B-4F56-BE98-11E7AA069625}"/>
               </a:ext>
             </a:extLst>
           </p:cNvPr>
@@ -4476,7 +4476,7 @@
           <p:cNvPr id="31" name="03 3요인 완전요인 실험 설계">
             <a:extLst xmlns:a="http://schemas.openxmlformats.org/drawingml/2006/main">
               <a:ext uri="{FF2B5EF4-FFF2-40B4-BE49-F238E27FC236}">
-                <a16:creationId xmlns:a16="http://schemas.microsoft.com/office/drawing/2014/main" id="{2E9FFF74-D01F-477B-A0AE-DDF129C7DE06}"/>
+                <a16:creationId xmlns:a16="http://schemas.microsoft.com/office/drawing/2014/main" id="{F5ABF092-2403-4197-9FB5-53C7E38664DA}"/>
               </a:ext>
             </a:extLst>
           </p:cNvPr>
@@ -4544,7 +4544,7 @@
           <p:cNvPr id="32" name="H=HyDE, C=CAD, S=SCD   0=미적용, 1=적용">
             <a:extLst xmlns:a="http://schemas.openxmlformats.org/drawingml/2006/main">
               <a:ext uri="{FF2B5EF4-FFF2-40B4-BE49-F238E27FC236}">
-                <a16:creationId xmlns:a16="http://schemas.microsoft.com/office/drawing/2014/main" id="{34C524BD-CC4F-49EA-8EA5-DEA4BDC079EC}"/>
+                <a16:creationId xmlns:a16="http://schemas.microsoft.com/office/drawing/2014/main" id="{EE1A7A57-A219-4916-871B-09FCE10A1E62}"/>
               </a:ext>
             </a:extLst>
           </p:cNvPr>
@@ -4612,7 +4612,7 @@
           <p:cNvPr id="33" name="">
             <a:extLst xmlns:a="http://schemas.openxmlformats.org/drawingml/2006/main">
               <a:ext uri="{FF2B5EF4-FFF2-40B4-BE49-F238E27FC236}">
-                <a16:creationId xmlns:a16="http://schemas.microsoft.com/office/drawing/2014/main" id="{9D1F3B7E-7A3D-4239-AF37-EC0FEA24504C}"/>
+                <a16:creationId xmlns:a16="http://schemas.microsoft.com/office/drawing/2014/main" id="{5C5FDABF-B9E4-4A4C-B029-4FB99C8D78E7}"/>
               </a:ext>
             </a:extLst>
           </p:cNvPr>
@@ -4641,7 +4641,7 @@
                     </a:bodyPr>
                     <a:lstStyle/>
                     <a:p>
-                      <a:pPr algn="l"/>
+                      <a:pPr algn="ctr"/>
                       <a:r>
                         <a:rPr sz="1800" b="1">
                           <a:solidFill>
@@ -4829,7 +4829,7 @@
                     </a:bodyPr>
                     <a:lstStyle/>
                     <a:p>
-                      <a:pPr algn="l"/>
+                      <a:pPr algn="ctr"/>
                       <a:r>
                         <a:rPr sz="1800" b="0">
                           <a:solidFill>
@@ -4993,7 +4993,7 @@
                     </a:bodyPr>
                     <a:lstStyle/>
                     <a:p>
-                      <a:pPr algn="l"/>
+                      <a:pPr algn="ctr"/>
                       <a:r>
                         <a:rPr sz="1800" b="0">
                           <a:solidFill>
@@ -5157,7 +5157,7 @@
                     </a:bodyPr>
                     <a:lstStyle/>
                     <a:p>
-                      <a:pPr algn="l"/>
+                      <a:pPr algn="ctr"/>
                       <a:r>
                         <a:rPr sz="1800" b="0">
                           <a:solidFill>
@@ -5321,7 +5321,7 @@
                     </a:bodyPr>
                     <a:lstStyle/>
                     <a:p>
-                      <a:pPr algn="l"/>
+                      <a:pPr algn="ctr"/>
                       <a:r>
                         <a:rPr sz="1800" b="0">
                           <a:solidFill>
@@ -5485,7 +5485,7 @@
                     </a:bodyPr>
                     <a:lstStyle/>
                     <a:p>
-                      <a:pPr algn="l"/>
+                      <a:pPr algn="ctr"/>
                       <a:r>
                         <a:rPr sz="1800" b="0">
                           <a:solidFill>
@@ -5649,7 +5649,7 @@
                     </a:bodyPr>
                     <a:lstStyle/>
                     <a:p>
-                      <a:pPr algn="l"/>
+                      <a:pPr algn="ctr"/>
                       <a:r>
                         <a:rPr sz="1800" b="0">
                           <a:solidFill>
@@ -5813,7 +5813,7 @@
                     </a:bodyPr>
                     <a:lstStyle/>
                     <a:p>
-                      <a:pPr algn="l"/>
+                      <a:pPr algn="ctr"/>
                       <a:r>
                         <a:rPr sz="1800" b="0">
                           <a:solidFill>
@@ -5977,7 +5977,7 @@
                     </a:bodyPr>
                     <a:lstStyle/>
                     <a:p>
-                      <a:pPr algn="l"/>
+                      <a:pPr algn="ctr"/>
                       <a:r>
                         <a:rPr sz="1800" b="0">
                           <a:solidFill>
@@ -6142,7 +6142,7 @@
           <p:cNvPr id="34" name="영어 문서 4종 × 15개 질의 × 8조건 = 480개 생성 기록">
             <a:extLst xmlns:a="http://schemas.openxmlformats.org/drawingml/2006/main">
               <a:ext uri="{FF2B5EF4-FFF2-40B4-BE49-F238E27FC236}">
-                <a16:creationId xmlns:a16="http://schemas.microsoft.com/office/drawing/2014/main" id="{8ABD1371-57F2-4F0E-9515-12DDA86C4DC5}"/>
+                <a16:creationId xmlns:a16="http://schemas.microsoft.com/office/drawing/2014/main" id="{ADA00431-1B67-4234-898E-B051A2C40230}"/>
               </a:ext>
             </a:extLst>
           </p:cNvPr>
@@ -6210,7 +6210,7 @@
           <p:cNvPr id="35" name="생성 512토큰, CAD α=0.5, SCD α=1.1·β=0.9·Tstart=5">
             <a:extLst xmlns:a="http://schemas.openxmlformats.org/drawingml/2006/main">
               <a:ext uri="{FF2B5EF4-FFF2-40B4-BE49-F238E27FC236}">
-                <a16:creationId xmlns:a16="http://schemas.microsoft.com/office/drawing/2014/main" id="{DBDC9228-3F26-49C9-B3E2-9ACDABA4DBFD}"/>
+                <a16:creationId xmlns:a16="http://schemas.microsoft.com/office/drawing/2014/main" id="{0E202563-AE2E-45D3-AB83-16530D35904B}"/>
               </a:ext>
             </a:extLst>
           </p:cNvPr>
@@ -6278,7 +6278,7 @@
           <p:cNvPr id="36" name="문서 요약을 15개 내용 단위로 나누어 질의를 작성하고, 총 60개 질의의 원문 페이지·정답 근거·답변 가능성을 확인">
             <a:extLst xmlns:a="http://schemas.openxmlformats.org/drawingml/2006/main">
               <a:ext uri="{FF2B5EF4-FFF2-40B4-BE49-F238E27FC236}">
-                <a16:creationId xmlns:a16="http://schemas.microsoft.com/office/drawing/2014/main" id="{CD5B8F85-5A9F-4789-A3D3-96A2F05CD556}"/>
+                <a16:creationId xmlns:a16="http://schemas.microsoft.com/office/drawing/2014/main" id="{55883192-2574-4382-9758-16B83518587C}"/>
               </a:ext>
             </a:extLst>
           </p:cNvPr>
@@ -6369,7 +6369,7 @@
           <p:cNvPr id="37" name="">
             <a:extLst xmlns:a="http://schemas.openxmlformats.org/drawingml/2006/main">
               <a:ext uri="{FF2B5EF4-FFF2-40B4-BE49-F238E27FC236}">
-                <a16:creationId xmlns:a16="http://schemas.microsoft.com/office/drawing/2014/main" id="{16463A9F-CD10-4165-9E08-F07C3B0E1A44}"/>
+                <a16:creationId xmlns:a16="http://schemas.microsoft.com/office/drawing/2014/main" id="{FD95D328-7D77-48BC-8842-1081E15193B9}"/>
               </a:ext>
             </a:extLst>
           </p:cNvPr>
@@ -6400,7 +6400,7 @@
           <p:cNvPr id="38" name="04 평가 지표 및 실험·통계 방법">
             <a:extLst xmlns:a="http://schemas.openxmlformats.org/drawingml/2006/main">
               <a:ext uri="{FF2B5EF4-FFF2-40B4-BE49-F238E27FC236}">
-                <a16:creationId xmlns:a16="http://schemas.microsoft.com/office/drawing/2014/main" id="{870D92DD-FCF0-497E-995C-F7B732F97865}"/>
+                <a16:creationId xmlns:a16="http://schemas.microsoft.com/office/drawing/2014/main" id="{E16B6B89-9A2F-4293-ABBD-414E900A639F}"/>
               </a:ext>
             </a:extLst>
           </p:cNvPr>
@@ -6468,7 +6468,7 @@
           <p:cNvPr id="39" name="근거 충실도: 답변 주장 중 검색 근거가 뒷받침하는 비율 답변 관련성: 답변에서 만든 질문과 원질문의 의미 유사도 문">
             <a:extLst xmlns:a="http://schemas.openxmlformats.org/drawingml/2006/main">
               <a:ext uri="{FF2B5EF4-FFF2-40B4-BE49-F238E27FC236}">
-                <a16:creationId xmlns:a16="http://schemas.microsoft.com/office/drawing/2014/main" id="{5AACAF04-929D-417B-811C-3FC11AD39E2A}"/>
+                <a16:creationId xmlns:a16="http://schemas.microsoft.com/office/drawing/2014/main" id="{E56AA116-59F2-4752-AE9E-E61AB08CD624}"/>
               </a:ext>
             </a:extLst>
           </p:cNvPr>
@@ -6625,10 +6625,10 @@
       </p:sp>
       <p:sp>
         <p:nvSpPr>
-          <p:cNvPr id="40" name="품질 지표는 높을수록 해당 평가 항목의 점수가 높다. 한국어 비율 0.700은 계산 대상 문자 중 한글이 70.0%다">
+          <p:cNvPr id="40" name="높은 품질 점수는 근거 지지·질문 관련성·근거 활용을 뜻한다. 한국어 비율 0.700은 계산 대상 문자 중 한글이 7">
             <a:extLst xmlns:a="http://schemas.openxmlformats.org/drawingml/2006/main">
               <a:ext uri="{FF2B5EF4-FFF2-40B4-BE49-F238E27FC236}">
-                <a16:creationId xmlns:a16="http://schemas.microsoft.com/office/drawing/2014/main" id="{9F6F5B5D-90A2-46A2-9E8B-953C7D101EA0}"/>
+                <a16:creationId xmlns:a16="http://schemas.microsoft.com/office/drawing/2014/main" id="{2B4B41E3-B459-4201-BB43-4D4B2573C6A3}"/>
               </a:ext>
             </a:extLst>
           </p:cNvPr>
@@ -6686,7 +6686,7 @@
                 <a:ea typeface="Malgun Gothic"/>
                 <a:cs typeface="Malgun Gothic"/>
               </a:rPr>
-              <a:t>품질 지표는 높을수록 해당 평가 항목의 점수가 높다.</a:t>
+              <a:t>높은 품질 점수는 근거 지지·질문 관련성·근거 활용을 뜻한다.</a:t>
             </a:r>
           </a:p>
           <a:p xmlns:a="http://schemas.openxmlformats.org/drawingml/2006/main">
@@ -6719,7 +6719,7 @@
           <p:cNvPr id="41" name="평가 예시  ext_raptor_011, H0C0S0">
             <a:extLst xmlns:a="http://schemas.openxmlformats.org/drawingml/2006/main">
               <a:ext uri="{FF2B5EF4-FFF2-40B4-BE49-F238E27FC236}">
-                <a16:creationId xmlns:a16="http://schemas.microsoft.com/office/drawing/2014/main" id="{C214F9D5-C9F1-4726-8E58-7129DA8B179F}"/>
+                <a16:creationId xmlns:a16="http://schemas.microsoft.com/office/drawing/2014/main" id="{03A6C5BF-682E-4460-BCA0-11AB3C4F2C91}"/>
               </a:ext>
             </a:extLst>
           </p:cNvPr>
@@ -6787,7 +6787,7 @@
           <p:cNvPr id="42" name="질문: Cinderella 사례의 정성 분석에서 RAPTOR의 tree-based retrieval이 DPR보다 주제">
             <a:extLst xmlns:a="http://schemas.openxmlformats.org/drawingml/2006/main">
               <a:ext uri="{FF2B5EF4-FFF2-40B4-BE49-F238E27FC236}">
-                <a16:creationId xmlns:a16="http://schemas.microsoft.com/office/drawing/2014/main" id="{FCD1C6FC-64B9-4F50-BF51-2F678A6B44F2}"/>
+                <a16:creationId xmlns:a16="http://schemas.microsoft.com/office/drawing/2014/main" id="{ECC50F9D-90B1-493C-A108-3B3EB1BE735C}"/>
               </a:ext>
             </a:extLst>
           </p:cNvPr>
@@ -6901,7 +6901,7 @@
           <p:cNvPr id="43" name="검색 근거(발췌): “within higher-layer summaries” 참조답변(발췌): “The text re">
             <a:extLst xmlns:a="http://schemas.openxmlformats.org/drawingml/2006/main">
               <a:ext uri="{FF2B5EF4-FFF2-40B4-BE49-F238E27FC236}">
-                <a16:creationId xmlns:a16="http://schemas.microsoft.com/office/drawing/2014/main" id="{08711F5A-89B8-432E-9E4C-8D6D72EF2850}"/>
+                <a16:creationId xmlns:a16="http://schemas.microsoft.com/office/drawing/2014/main" id="{B9EBDAD6-A1BC-4CCC-9D44-13092DB44598}"/>
               </a:ext>
             </a:extLst>
           </p:cNvPr>
@@ -7038,7 +7038,7 @@
           <p:cNvPr id="44" name="평가: RAGAS 0.2.15[10], gpt-4o, BGE-M3 임베딩 S0: 영어 문맥 / S1: 한국어 번역 평">
             <a:extLst xmlns:a="http://schemas.openxmlformats.org/drawingml/2006/main">
               <a:ext uri="{FF2B5EF4-FFF2-40B4-BE49-F238E27FC236}">
-                <a16:creationId xmlns:a16="http://schemas.microsoft.com/office/drawing/2014/main" id="{6A543F83-BE8E-48E4-A422-BEB5E8BE93A4}"/>
+                <a16:creationId xmlns:a16="http://schemas.microsoft.com/office/drawing/2014/main" id="{D915AAFD-DCF6-4FC6-964D-55EEADC1A995}"/>
               </a:ext>
             </a:extLst>
           </p:cNvPr>
@@ -7152,7 +7152,7 @@
           <p:cNvPr id="45" name="질의 60개 반복측정, 양측 α=0.05와 Holm 보정 품질: S0·S1별 H×C / 문자 비율·시간: H×C×S ">
             <a:extLst xmlns:a="http://schemas.openxmlformats.org/drawingml/2006/main">
               <a:ext uri="{FF2B5EF4-FFF2-40B4-BE49-F238E27FC236}">
-                <a16:creationId xmlns:a16="http://schemas.microsoft.com/office/drawing/2014/main" id="{2E0962B1-7677-4BBC-A751-072443231D68}"/>
+                <a16:creationId xmlns:a16="http://schemas.microsoft.com/office/drawing/2014/main" id="{6BF1BC4B-B437-4A45-8C45-E8FC7F517435}"/>
               </a:ext>
             </a:extLst>
           </p:cNvPr>
@@ -7266,7 +7266,7 @@
           <p:cNvPr id="46" name="">
             <a:extLst xmlns:a="http://schemas.openxmlformats.org/drawingml/2006/main">
               <a:ext uri="{FF2B5EF4-FFF2-40B4-BE49-F238E27FC236}">
-                <a16:creationId xmlns:a16="http://schemas.microsoft.com/office/drawing/2014/main" id="{A5740A54-FC67-4064-B93A-1FDCAED5849F}"/>
+                <a16:creationId xmlns:a16="http://schemas.microsoft.com/office/drawing/2014/main" id="{CFFBF10B-3415-4B7C-AF38-DA36D7587279}"/>
               </a:ext>
             </a:extLst>
           </p:cNvPr>
@@ -7297,7 +7297,7 @@
           <p:cNvPr id="47" name="05 조합별 결과와 통계 검정">
             <a:extLst xmlns:a="http://schemas.openxmlformats.org/drawingml/2006/main">
               <a:ext uri="{FF2B5EF4-FFF2-40B4-BE49-F238E27FC236}">
-                <a16:creationId xmlns:a16="http://schemas.microsoft.com/office/drawing/2014/main" id="{E92846A7-2771-46E6-AB33-C13BAB85B78C}"/>
+                <a16:creationId xmlns:a16="http://schemas.microsoft.com/office/drawing/2014/main" id="{31AAFAA6-6349-4EE3-A1BB-23B8359C481E}"/>
               </a:ext>
             </a:extLst>
           </p:cNvPr>
@@ -7365,7 +7365,7 @@
           <p:cNvPr id="48" name="8조건 평균(SD)  ·  시간 단위: 초">
             <a:extLst xmlns:a="http://schemas.openxmlformats.org/drawingml/2006/main">
               <a:ext uri="{FF2B5EF4-FFF2-40B4-BE49-F238E27FC236}">
-                <a16:creationId xmlns:a16="http://schemas.microsoft.com/office/drawing/2014/main" id="{05EA8B5D-47F9-4A84-9E68-A2A1E993280B}"/>
+                <a16:creationId xmlns:a16="http://schemas.microsoft.com/office/drawing/2014/main" id="{9452CE0E-B064-48C6-A3EF-67ED8AEEC7E8}"/>
               </a:ext>
             </a:extLst>
           </p:cNvPr>
@@ -7433,7 +7433,7 @@
           <p:cNvPr id="49" name="">
             <a:extLst xmlns:a="http://schemas.openxmlformats.org/drawingml/2006/main">
               <a:ext uri="{FF2B5EF4-FFF2-40B4-BE49-F238E27FC236}">
-                <a16:creationId xmlns:a16="http://schemas.microsoft.com/office/drawing/2014/main" id="{AC39739E-DBAB-49BE-8896-35CFEB8B86C8}"/>
+                <a16:creationId xmlns:a16="http://schemas.microsoft.com/office/drawing/2014/main" id="{F091D218-7506-4DF4-802A-3B40A27C32E6}"/>
               </a:ext>
             </a:extLst>
           </p:cNvPr>
@@ -7465,7 +7465,7 @@
                     </a:bodyPr>
                     <a:lstStyle/>
                     <a:p>
-                      <a:pPr algn="l"/>
+                      <a:pPr algn="ctr"/>
                       <a:r>
                         <a:rPr sz="1800" b="1">
                           <a:solidFill>
@@ -7872,7 +7872,7 @@
                     </a:bodyPr>
                     <a:lstStyle/>
                     <a:p>
-                      <a:pPr algn="l"/>
+                      <a:pPr algn="ctr"/>
                       <a:r>
                         <a:rPr sz="1800" b="0">
                           <a:solidFill>
@@ -7917,7 +7917,7 @@
                     </a:bodyPr>
                     <a:lstStyle/>
                     <a:p>
-                      <a:pPr algn="ctr"/>
+                      <a:pPr algn="r"/>
                       <a:r>
                         <a:rPr sz="1800" b="0">
                           <a:solidFill>
@@ -7931,7 +7931,7 @@
                       </a:r>
                     </a:p>
                     <a:p>
-                      <a:pPr algn="ctr"/>
+                      <a:pPr algn="r"/>
                       <a:r>
                         <a:rPr sz="1800" b="0">
                           <a:solidFill>
@@ -7970,7 +7970,7 @@
                     </a:bodyPr>
                     <a:lstStyle/>
                     <a:p>
-                      <a:pPr algn="ctr"/>
+                      <a:pPr algn="r"/>
                       <a:r>
                         <a:rPr sz="1800" b="0">
                           <a:solidFill>
@@ -7984,7 +7984,7 @@
                       </a:r>
                     </a:p>
                     <a:p>
-                      <a:pPr algn="ctr"/>
+                      <a:pPr algn="r"/>
                       <a:r>
                         <a:rPr sz="1800" b="0">
                           <a:solidFill>
@@ -8023,7 +8023,7 @@
                     </a:bodyPr>
                     <a:lstStyle/>
                     <a:p>
-                      <a:pPr algn="ctr"/>
+                      <a:pPr algn="r"/>
                       <a:r>
                         <a:rPr sz="1800" b="0">
                           <a:solidFill>
@@ -8037,7 +8037,7 @@
                       </a:r>
                     </a:p>
                     <a:p>
-                      <a:pPr algn="ctr"/>
+                      <a:pPr algn="r"/>
                       <a:r>
                         <a:rPr sz="1800" b="0">
                           <a:solidFill>
@@ -8076,7 +8076,7 @@
                     </a:bodyPr>
                     <a:lstStyle/>
                     <a:p>
-                      <a:pPr algn="ctr"/>
+                      <a:pPr algn="r"/>
                       <a:r>
                         <a:rPr sz="1800" b="0">
                           <a:solidFill>
@@ -8090,7 +8090,7 @@
                       </a:r>
                     </a:p>
                     <a:p>
-                      <a:pPr algn="ctr"/>
+                      <a:pPr algn="r"/>
                       <a:r>
                         <a:rPr sz="1800" b="0">
                           <a:solidFill>
@@ -8129,7 +8129,7 @@
                     </a:bodyPr>
                     <a:lstStyle/>
                     <a:p>
-                      <a:pPr algn="ctr"/>
+                      <a:pPr algn="r"/>
                       <a:r>
                         <a:rPr sz="1800" b="0">
                           <a:solidFill>
@@ -8143,7 +8143,7 @@
                       </a:r>
                     </a:p>
                     <a:p>
-                      <a:pPr algn="ctr"/>
+                      <a:pPr algn="r"/>
                       <a:r>
                         <a:rPr sz="1800" b="0">
                           <a:solidFill>
@@ -8182,7 +8182,7 @@
                     </a:bodyPr>
                     <a:lstStyle/>
                     <a:p>
-                      <a:pPr algn="ctr"/>
+                      <a:pPr algn="r"/>
                       <a:r>
                         <a:rPr sz="1800" b="0">
                           <a:solidFill>
@@ -8196,7 +8196,7 @@
                       </a:r>
                     </a:p>
                     <a:p>
-                      <a:pPr algn="ctr"/>
+                      <a:pPr algn="r"/>
                       <a:r>
                         <a:rPr sz="1800" b="0">
                           <a:solidFill>
@@ -8237,7 +8237,7 @@
                     </a:bodyPr>
                     <a:lstStyle/>
                     <a:p>
-                      <a:pPr algn="l"/>
+                      <a:pPr algn="ctr"/>
                       <a:r>
                         <a:rPr sz="1800" b="0">
                           <a:solidFill>
@@ -8282,7 +8282,7 @@
                     </a:bodyPr>
                     <a:lstStyle/>
                     <a:p>
-                      <a:pPr algn="ctr"/>
+                      <a:pPr algn="r"/>
                       <a:r>
                         <a:rPr sz="1800" b="0">
                           <a:solidFill>
@@ -8296,7 +8296,7 @@
                       </a:r>
                     </a:p>
                     <a:p>
-                      <a:pPr algn="ctr"/>
+                      <a:pPr algn="r"/>
                       <a:r>
                         <a:rPr sz="1800" b="0">
                           <a:solidFill>
@@ -8335,7 +8335,7 @@
                     </a:bodyPr>
                     <a:lstStyle/>
                     <a:p>
-                      <a:pPr algn="ctr"/>
+                      <a:pPr algn="r"/>
                       <a:r>
                         <a:rPr sz="1800" b="0">
                           <a:solidFill>
@@ -8349,7 +8349,7 @@
                       </a:r>
                     </a:p>
                     <a:p>
-                      <a:pPr algn="ctr"/>
+                      <a:pPr algn="r"/>
                       <a:r>
                         <a:rPr sz="1800" b="0">
                           <a:solidFill>
@@ -8388,7 +8388,7 @@
                     </a:bodyPr>
                     <a:lstStyle/>
                     <a:p>
-                      <a:pPr algn="ctr"/>
+                      <a:pPr algn="r"/>
                       <a:r>
                         <a:rPr sz="1800" b="0">
                           <a:solidFill>
@@ -8402,7 +8402,7 @@
                       </a:r>
                     </a:p>
                     <a:p>
-                      <a:pPr algn="ctr"/>
+                      <a:pPr algn="r"/>
                       <a:r>
                         <a:rPr sz="1800" b="0">
                           <a:solidFill>
@@ -8441,7 +8441,7 @@
                     </a:bodyPr>
                     <a:lstStyle/>
                     <a:p>
-                      <a:pPr algn="ctr"/>
+                      <a:pPr algn="r"/>
                       <a:r>
                         <a:rPr sz="1800" b="0">
                           <a:solidFill>
@@ -8455,7 +8455,7 @@
                       </a:r>
                     </a:p>
                     <a:p>
-                      <a:pPr algn="ctr"/>
+                      <a:pPr algn="r"/>
                       <a:r>
                         <a:rPr sz="1800" b="0">
                           <a:solidFill>
@@ -8494,7 +8494,7 @@
                     </a:bodyPr>
                     <a:lstStyle/>
                     <a:p>
-                      <a:pPr algn="ctr"/>
+                      <a:pPr algn="r"/>
                       <a:r>
                         <a:rPr sz="1800" b="0">
                           <a:solidFill>
@@ -8508,7 +8508,7 @@
                       </a:r>
                     </a:p>
                     <a:p>
-                      <a:pPr algn="ctr"/>
+                      <a:pPr algn="r"/>
                       <a:r>
                         <a:rPr sz="1800" b="0">
                           <a:solidFill>
@@ -8547,7 +8547,7 @@
                     </a:bodyPr>
                     <a:lstStyle/>
                     <a:p>
-                      <a:pPr algn="ctr"/>
+                      <a:pPr algn="r"/>
                       <a:r>
                         <a:rPr sz="1800" b="0">
                           <a:solidFill>
@@ -8561,7 +8561,7 @@
                       </a:r>
                     </a:p>
                     <a:p>
-                      <a:pPr algn="ctr"/>
+                      <a:pPr algn="r"/>
                       <a:r>
                         <a:rPr sz="1800" b="0">
                           <a:solidFill>
@@ -8602,7 +8602,7 @@
                     </a:bodyPr>
                     <a:lstStyle/>
                     <a:p>
-                      <a:pPr algn="l"/>
+                      <a:pPr algn="ctr"/>
                       <a:r>
                         <a:rPr sz="1800" b="0">
                           <a:solidFill>
@@ -8647,7 +8647,7 @@
                     </a:bodyPr>
                     <a:lstStyle/>
                     <a:p>
-                      <a:pPr algn="ctr"/>
+                      <a:pPr algn="r"/>
                       <a:r>
                         <a:rPr sz="1800" b="0">
                           <a:solidFill>
@@ -8661,7 +8661,7 @@
                       </a:r>
                     </a:p>
                     <a:p>
-                      <a:pPr algn="ctr"/>
+                      <a:pPr algn="r"/>
                       <a:r>
                         <a:rPr sz="1800" b="0">
                           <a:solidFill>
@@ -8700,7 +8700,7 @@
                     </a:bodyPr>
                     <a:lstStyle/>
                     <a:p>
-                      <a:pPr algn="ctr"/>
+                      <a:pPr algn="r"/>
                       <a:r>
                         <a:rPr sz="1800" b="0">
                           <a:solidFill>
@@ -8714,7 +8714,7 @@
                       </a:r>
                     </a:p>
                     <a:p>
-                      <a:pPr algn="ctr"/>
+                      <a:pPr algn="r"/>
                       <a:r>
                         <a:rPr sz="1800" b="0">
                           <a:solidFill>
@@ -8753,7 +8753,7 @@
                     </a:bodyPr>
                     <a:lstStyle/>
                     <a:p>
-                      <a:pPr algn="ctr"/>
+                      <a:pPr algn="r"/>
                       <a:r>
                         <a:rPr sz="1800" b="0">
                           <a:solidFill>
@@ -8767,7 +8767,7 @@
                       </a:r>
                     </a:p>
                     <a:p>
-                      <a:pPr algn="ctr"/>
+                      <a:pPr algn="r"/>
                       <a:r>
                         <a:rPr sz="1800" b="0">
                           <a:solidFill>
@@ -8806,7 +8806,7 @@
                     </a:bodyPr>
                     <a:lstStyle/>
                     <a:p>
-                      <a:pPr algn="ctr"/>
+                      <a:pPr algn="r"/>
                       <a:r>
                         <a:rPr sz="1800" b="0">
                           <a:solidFill>
@@ -8820,7 +8820,7 @@
                       </a:r>
                     </a:p>
                     <a:p>
-                      <a:pPr algn="ctr"/>
+                      <a:pPr algn="r"/>
                       <a:r>
                         <a:rPr sz="1800" b="0">
                           <a:solidFill>
@@ -8859,7 +8859,7 @@
                     </a:bodyPr>
                     <a:lstStyle/>
                     <a:p>
-                      <a:pPr algn="ctr"/>
+                      <a:pPr algn="r"/>
                       <a:r>
                         <a:rPr sz="1800" b="0">
                           <a:solidFill>
@@ -8873,7 +8873,7 @@
                       </a:r>
                     </a:p>
                     <a:p>
-                      <a:pPr algn="ctr"/>
+                      <a:pPr algn="r"/>
                       <a:r>
                         <a:rPr sz="1800" b="0">
                           <a:solidFill>
@@ -8912,7 +8912,7 @@
                     </a:bodyPr>
                     <a:lstStyle/>
                     <a:p>
-                      <a:pPr algn="ctr"/>
+                      <a:pPr algn="r"/>
                       <a:r>
                         <a:rPr sz="1800" b="0">
                           <a:solidFill>
@@ -8926,7 +8926,7 @@
                       </a:r>
                     </a:p>
                     <a:p>
-                      <a:pPr algn="ctr"/>
+                      <a:pPr algn="r"/>
                       <a:r>
                         <a:rPr sz="1800" b="0">
                           <a:solidFill>
@@ -8967,7 +8967,7 @@
                     </a:bodyPr>
                     <a:lstStyle/>
                     <a:p>
-                      <a:pPr algn="l"/>
+                      <a:pPr algn="ctr"/>
                       <a:r>
                         <a:rPr sz="1800" b="0">
                           <a:solidFill>
@@ -9012,7 +9012,7 @@
                     </a:bodyPr>
                     <a:lstStyle/>
                     <a:p>
-                      <a:pPr algn="ctr"/>
+                      <a:pPr algn="r"/>
                       <a:r>
                         <a:rPr sz="1800" b="0">
                           <a:solidFill>
@@ -9026,7 +9026,7 @@
                       </a:r>
                     </a:p>
                     <a:p>
-                      <a:pPr algn="ctr"/>
+                      <a:pPr algn="r"/>
                       <a:r>
                         <a:rPr sz="1800" b="0">
                           <a:solidFill>
@@ -9065,7 +9065,7 @@
                     </a:bodyPr>
                     <a:lstStyle/>
                     <a:p>
-                      <a:pPr algn="ctr"/>
+                      <a:pPr algn="r"/>
                       <a:r>
                         <a:rPr sz="1800" b="0">
                           <a:solidFill>
@@ -9079,7 +9079,7 @@
                       </a:r>
                     </a:p>
                     <a:p>
-                      <a:pPr algn="ctr"/>
+                      <a:pPr algn="r"/>
                       <a:r>
                         <a:rPr sz="1800" b="0">
                           <a:solidFill>
@@ -9118,7 +9118,7 @@
                     </a:bodyPr>
                     <a:lstStyle/>
                     <a:p>
-                      <a:pPr algn="ctr"/>
+                      <a:pPr algn="r"/>
                       <a:r>
                         <a:rPr sz="1800" b="0">
                           <a:solidFill>
@@ -9132,7 +9132,7 @@
                       </a:r>
                     </a:p>
                     <a:p>
-                      <a:pPr algn="ctr"/>
+                      <a:pPr algn="r"/>
                       <a:r>
                         <a:rPr sz="1800" b="0">
                           <a:solidFill>
@@ -9171,7 +9171,7 @@
                     </a:bodyPr>
                     <a:lstStyle/>
                     <a:p>
-                      <a:pPr algn="ctr"/>
+                      <a:pPr algn="r"/>
                       <a:r>
                         <a:rPr sz="1800" b="0">
                           <a:solidFill>
@@ -9185,7 +9185,7 @@
                       </a:r>
                     </a:p>
                     <a:p>
-                      <a:pPr algn="ctr"/>
+                      <a:pPr algn="r"/>
                       <a:r>
                         <a:rPr sz="1800" b="0">
                           <a:solidFill>
@@ -9224,7 +9224,7 @@
                     </a:bodyPr>
                     <a:lstStyle/>
                     <a:p>
-                      <a:pPr algn="ctr"/>
+                      <a:pPr algn="r"/>
                       <a:r>
                         <a:rPr sz="1800" b="0">
                           <a:solidFill>
@@ -9238,7 +9238,7 @@
                       </a:r>
                     </a:p>
                     <a:p>
-                      <a:pPr algn="ctr"/>
+                      <a:pPr algn="r"/>
                       <a:r>
                         <a:rPr sz="1800" b="0">
                           <a:solidFill>
@@ -9277,7 +9277,7 @@
                     </a:bodyPr>
                     <a:lstStyle/>
                     <a:p>
-                      <a:pPr algn="ctr"/>
+                      <a:pPr algn="r"/>
                       <a:r>
                         <a:rPr sz="1800" b="0">
                           <a:solidFill>
@@ -9291,7 +9291,7 @@
                       </a:r>
                     </a:p>
                     <a:p>
-                      <a:pPr algn="ctr"/>
+                      <a:pPr algn="r"/>
                       <a:r>
                         <a:rPr sz="1800" b="0">
                           <a:solidFill>
@@ -9332,7 +9332,7 @@
                     </a:bodyPr>
                     <a:lstStyle/>
                     <a:p>
-                      <a:pPr algn="l"/>
+                      <a:pPr algn="ctr"/>
                       <a:r>
                         <a:rPr sz="1800" b="0">
                           <a:solidFill>
@@ -9377,7 +9377,7 @@
                     </a:bodyPr>
                     <a:lstStyle/>
                     <a:p>
-                      <a:pPr algn="ctr"/>
+                      <a:pPr algn="r"/>
                       <a:r>
                         <a:rPr sz="1800" b="0">
                           <a:solidFill>
@@ -9391,7 +9391,7 @@
                       </a:r>
                     </a:p>
                     <a:p>
-                      <a:pPr algn="ctr"/>
+                      <a:pPr algn="r"/>
                       <a:r>
                         <a:rPr sz="1800" b="0">
                           <a:solidFill>
@@ -9430,7 +9430,7 @@
                     </a:bodyPr>
                     <a:lstStyle/>
                     <a:p>
-                      <a:pPr algn="ctr"/>
+                      <a:pPr algn="r"/>
                       <a:r>
                         <a:rPr sz="1800" b="0">
                           <a:solidFill>
@@ -9444,7 +9444,7 @@
                       </a:r>
                     </a:p>
                     <a:p>
-                      <a:pPr algn="ctr"/>
+                      <a:pPr algn="r"/>
                       <a:r>
                         <a:rPr sz="1800" b="0">
                           <a:solidFill>
@@ -9483,7 +9483,7 @@
                     </a:bodyPr>
                     <a:lstStyle/>
                     <a:p>
-                      <a:pPr algn="ctr"/>
+                      <a:pPr algn="r"/>
                       <a:r>
                         <a:rPr sz="1800" b="0">
                           <a:solidFill>
@@ -9497,7 +9497,7 @@
                       </a:r>
                     </a:p>
                     <a:p>
-                      <a:pPr algn="ctr"/>
+                      <a:pPr algn="r"/>
                       <a:r>
                         <a:rPr sz="1800" b="0">
                           <a:solidFill>
@@ -9536,7 +9536,7 @@
                     </a:bodyPr>
                     <a:lstStyle/>
                     <a:p>
-                      <a:pPr algn="ctr"/>
+                      <a:pPr algn="r"/>
                       <a:r>
                         <a:rPr sz="1800" b="0">
                           <a:solidFill>
@@ -9550,7 +9550,7 @@
                       </a:r>
                     </a:p>
                     <a:p>
-                      <a:pPr algn="ctr"/>
+                      <a:pPr algn="r"/>
                       <a:r>
                         <a:rPr sz="1800" b="0">
                           <a:solidFill>
@@ -9589,7 +9589,7 @@
                     </a:bodyPr>
                     <a:lstStyle/>
                     <a:p>
-                      <a:pPr algn="ctr"/>
+                      <a:pPr algn="r"/>
                       <a:r>
                         <a:rPr sz="1800" b="0">
                           <a:solidFill>
@@ -9603,7 +9603,7 @@
                       </a:r>
                     </a:p>
                     <a:p>
-                      <a:pPr algn="ctr"/>
+                      <a:pPr algn="r"/>
                       <a:r>
                         <a:rPr sz="1800" b="0">
                           <a:solidFill>
@@ -9642,7 +9642,7 @@
                     </a:bodyPr>
                     <a:lstStyle/>
                     <a:p>
-                      <a:pPr algn="ctr"/>
+                      <a:pPr algn="r"/>
                       <a:r>
                         <a:rPr sz="1800" b="0">
                           <a:solidFill>
@@ -9656,7 +9656,7 @@
                       </a:r>
                     </a:p>
                     <a:p>
-                      <a:pPr algn="ctr"/>
+                      <a:pPr algn="r"/>
                       <a:r>
                         <a:rPr sz="1800" b="0">
                           <a:solidFill>
@@ -9697,7 +9697,7 @@
                     </a:bodyPr>
                     <a:lstStyle/>
                     <a:p>
-                      <a:pPr algn="l"/>
+                      <a:pPr algn="ctr"/>
                       <a:r>
                         <a:rPr sz="1800" b="0">
                           <a:solidFill>
@@ -9742,7 +9742,7 @@
                     </a:bodyPr>
                     <a:lstStyle/>
                     <a:p>
-                      <a:pPr algn="ctr"/>
+                      <a:pPr algn="r"/>
                       <a:r>
                         <a:rPr sz="1800" b="0">
                           <a:solidFill>
@@ -9756,7 +9756,7 @@
                       </a:r>
                     </a:p>
                     <a:p>
-                      <a:pPr algn="ctr"/>
+                      <a:pPr algn="r"/>
                       <a:r>
                         <a:rPr sz="1800" b="0">
                           <a:solidFill>
@@ -9795,7 +9795,7 @@
                     </a:bodyPr>
                     <a:lstStyle/>
                     <a:p>
-                      <a:pPr algn="ctr"/>
+                      <a:pPr algn="r"/>
                       <a:r>
                         <a:rPr sz="1800" b="0">
                           <a:solidFill>
@@ -9809,7 +9809,7 @@
                       </a:r>
                     </a:p>
                     <a:p>
-                      <a:pPr algn="ctr"/>
+                      <a:pPr algn="r"/>
                       <a:r>
                         <a:rPr sz="1800" b="0">
                           <a:solidFill>
@@ -9848,7 +9848,7 @@
                     </a:bodyPr>
                     <a:lstStyle/>
                     <a:p>
-                      <a:pPr algn="ctr"/>
+                      <a:pPr algn="r"/>
                       <a:r>
                         <a:rPr sz="1800" b="0">
                           <a:solidFill>
@@ -9862,7 +9862,7 @@
                       </a:r>
                     </a:p>
                     <a:p>
-                      <a:pPr algn="ctr"/>
+                      <a:pPr algn="r"/>
                       <a:r>
                         <a:rPr sz="1800" b="0">
                           <a:solidFill>
@@ -9901,7 +9901,7 @@
                     </a:bodyPr>
                     <a:lstStyle/>
                     <a:p>
-                      <a:pPr algn="ctr"/>
+                      <a:pPr algn="r"/>
                       <a:r>
                         <a:rPr sz="1800" b="0">
                           <a:solidFill>
@@ -9915,7 +9915,7 @@
                       </a:r>
                     </a:p>
                     <a:p>
-                      <a:pPr algn="ctr"/>
+                      <a:pPr algn="r"/>
                       <a:r>
                         <a:rPr sz="1800" b="0">
                           <a:solidFill>
@@ -9954,7 +9954,7 @@
                     </a:bodyPr>
                     <a:lstStyle/>
                     <a:p>
-                      <a:pPr algn="ctr"/>
+                      <a:pPr algn="r"/>
                       <a:r>
                         <a:rPr sz="1800" b="0">
                           <a:solidFill>
@@ -9968,7 +9968,7 @@
                       </a:r>
                     </a:p>
                     <a:p>
-                      <a:pPr algn="ctr"/>
+                      <a:pPr algn="r"/>
                       <a:r>
                         <a:rPr sz="1800" b="0">
                           <a:solidFill>
@@ -10007,7 +10007,7 @@
                     </a:bodyPr>
                     <a:lstStyle/>
                     <a:p>
-                      <a:pPr algn="ctr"/>
+                      <a:pPr algn="r"/>
                       <a:r>
                         <a:rPr sz="1800" b="0">
                           <a:solidFill>
@@ -10021,7 +10021,7 @@
                       </a:r>
                     </a:p>
                     <a:p>
-                      <a:pPr algn="ctr"/>
+                      <a:pPr algn="r"/>
                       <a:r>
                         <a:rPr sz="1800" b="0">
                           <a:solidFill>
@@ -10062,7 +10062,7 @@
                     </a:bodyPr>
                     <a:lstStyle/>
                     <a:p>
-                      <a:pPr algn="l"/>
+                      <a:pPr algn="ctr"/>
                       <a:r>
                         <a:rPr sz="1800" b="0">
                           <a:solidFill>
@@ -10107,7 +10107,7 @@
                     </a:bodyPr>
                     <a:lstStyle/>
                     <a:p>
-                      <a:pPr algn="ctr"/>
+                      <a:pPr algn="r"/>
                       <a:r>
                         <a:rPr sz="1800" b="0">
                           <a:solidFill>
@@ -10121,7 +10121,7 @@
                       </a:r>
                     </a:p>
                     <a:p>
-                      <a:pPr algn="ctr"/>
+                      <a:pPr algn="r"/>
                       <a:r>
                         <a:rPr sz="1800" b="0">
                           <a:solidFill>
@@ -10160,7 +10160,7 @@
                     </a:bodyPr>
                     <a:lstStyle/>
                     <a:p>
-                      <a:pPr algn="ctr"/>
+                      <a:pPr algn="r"/>
                       <a:r>
                         <a:rPr sz="1800" b="0">
                           <a:solidFill>
@@ -10174,7 +10174,7 @@
                       </a:r>
                     </a:p>
                     <a:p>
-                      <a:pPr algn="ctr"/>
+                      <a:pPr algn="r"/>
                       <a:r>
                         <a:rPr sz="1800" b="0">
                           <a:solidFill>
@@ -10213,7 +10213,7 @@
                     </a:bodyPr>
                     <a:lstStyle/>
                     <a:p>
-                      <a:pPr algn="ctr"/>
+                      <a:pPr algn="r"/>
                       <a:r>
                         <a:rPr sz="1800" b="0">
                           <a:solidFill>
@@ -10227,7 +10227,7 @@
                       </a:r>
                     </a:p>
                     <a:p>
-                      <a:pPr algn="ctr"/>
+                      <a:pPr algn="r"/>
                       <a:r>
                         <a:rPr sz="1800" b="0">
                           <a:solidFill>
@@ -10266,7 +10266,7 @@
                     </a:bodyPr>
                     <a:lstStyle/>
                     <a:p>
-                      <a:pPr algn="ctr"/>
+                      <a:pPr algn="r"/>
                       <a:r>
                         <a:rPr sz="1800" b="0">
                           <a:solidFill>
@@ -10280,7 +10280,7 @@
                       </a:r>
                     </a:p>
                     <a:p>
-                      <a:pPr algn="ctr"/>
+                      <a:pPr algn="r"/>
                       <a:r>
                         <a:rPr sz="1800" b="0">
                           <a:solidFill>
@@ -10319,7 +10319,7 @@
                     </a:bodyPr>
                     <a:lstStyle/>
                     <a:p>
-                      <a:pPr algn="ctr"/>
+                      <a:pPr algn="r"/>
                       <a:r>
                         <a:rPr sz="1800" b="0">
                           <a:solidFill>
@@ -10333,7 +10333,7 @@
                       </a:r>
                     </a:p>
                     <a:p>
-                      <a:pPr algn="ctr"/>
+                      <a:pPr algn="r"/>
                       <a:r>
                         <a:rPr sz="1800" b="0">
                           <a:solidFill>
@@ -10372,7 +10372,7 @@
                     </a:bodyPr>
                     <a:lstStyle/>
                     <a:p>
-                      <a:pPr algn="ctr"/>
+                      <a:pPr algn="r"/>
                       <a:r>
                         <a:rPr sz="1800" b="0">
                           <a:solidFill>
@@ -10386,7 +10386,7 @@
                       </a:r>
                     </a:p>
                     <a:p>
-                      <a:pPr algn="ctr"/>
+                      <a:pPr algn="r"/>
                       <a:r>
                         <a:rPr sz="1800" b="0">
                           <a:solidFill>
@@ -10427,7 +10427,7 @@
                     </a:bodyPr>
                     <a:lstStyle/>
                     <a:p>
-                      <a:pPr algn="l"/>
+                      <a:pPr algn="ctr"/>
                       <a:r>
                         <a:rPr sz="1800" b="0">
                           <a:solidFill>
@@ -10472,7 +10472,7 @@
                     </a:bodyPr>
                     <a:lstStyle/>
                     <a:p>
-                      <a:pPr algn="ctr"/>
+                      <a:pPr algn="r"/>
                       <a:r>
                         <a:rPr sz="1800" b="0">
                           <a:solidFill>
@@ -10486,7 +10486,7 @@
                       </a:r>
                     </a:p>
                     <a:p>
-                      <a:pPr algn="ctr"/>
+                      <a:pPr algn="r"/>
                       <a:r>
                         <a:rPr sz="1800" b="0">
                           <a:solidFill>
@@ -10525,7 +10525,7 @@
                     </a:bodyPr>
                     <a:lstStyle/>
                     <a:p>
-                      <a:pPr algn="ctr"/>
+                      <a:pPr algn="r"/>
                       <a:r>
                         <a:rPr sz="1800" b="0">
                           <a:solidFill>
@@ -10539,7 +10539,7 @@
                       </a:r>
                     </a:p>
                     <a:p>
-                      <a:pPr algn="ctr"/>
+                      <a:pPr algn="r"/>
                       <a:r>
                         <a:rPr sz="1800" b="0">
                           <a:solidFill>
@@ -10578,7 +10578,7 @@
                     </a:bodyPr>
                     <a:lstStyle/>
                     <a:p>
-                      <a:pPr algn="ctr"/>
+                      <a:pPr algn="r"/>
                       <a:r>
                         <a:rPr sz="1800" b="0">
                           <a:solidFill>
@@ -10592,7 +10592,7 @@
                       </a:r>
                     </a:p>
                     <a:p>
-                      <a:pPr algn="ctr"/>
+                      <a:pPr algn="r"/>
                       <a:r>
                         <a:rPr sz="1800" b="0">
                           <a:solidFill>
@@ -10631,7 +10631,7 @@
                     </a:bodyPr>
                     <a:lstStyle/>
                     <a:p>
-                      <a:pPr algn="ctr"/>
+                      <a:pPr algn="r"/>
                       <a:r>
                         <a:rPr sz="1800" b="0">
                           <a:solidFill>
@@ -10645,7 +10645,7 @@
                       </a:r>
                     </a:p>
                     <a:p>
-                      <a:pPr algn="ctr"/>
+                      <a:pPr algn="r"/>
                       <a:r>
                         <a:rPr sz="1800" b="0">
                           <a:solidFill>
@@ -10684,7 +10684,7 @@
                     </a:bodyPr>
                     <a:lstStyle/>
                     <a:p>
-                      <a:pPr algn="ctr"/>
+                      <a:pPr algn="r"/>
                       <a:r>
                         <a:rPr sz="1800" b="0">
                           <a:solidFill>
@@ -10698,7 +10698,7 @@
                       </a:r>
                     </a:p>
                     <a:p>
-                      <a:pPr algn="ctr"/>
+                      <a:pPr algn="r"/>
                       <a:r>
                         <a:rPr sz="1800" b="0">
                           <a:solidFill>
@@ -10737,7 +10737,7 @@
                     </a:bodyPr>
                     <a:lstStyle/>
                     <a:p>
-                      <a:pPr algn="ctr"/>
+                      <a:pPr algn="r"/>
                       <a:r>
                         <a:rPr sz="1800" b="0">
                           <a:solidFill>
@@ -10751,7 +10751,7 @@
                       </a:r>
                     </a:p>
                     <a:p>
-                      <a:pPr algn="ctr"/>
+                      <a:pPr algn="r"/>
                       <a:r>
                         <a:rPr sz="1800" b="0">
                           <a:solidFill>
@@ -10793,7 +10793,7 @@
           <p:cNvPr id="50" name="S0: 영어 평가 문맥 / S1: 한국어 번역 평가 문맥 충실도 H0C1S0 n=58, H0C0S1 n=57, 나머지">
             <a:extLst xmlns:a="http://schemas.openxmlformats.org/drawingml/2006/main">
               <a:ext uri="{FF2B5EF4-FFF2-40B4-BE49-F238E27FC236}">
-                <a16:creationId xmlns:a16="http://schemas.microsoft.com/office/drawing/2014/main" id="{90F47361-498C-4A6C-B013-BC1CA2DD6B3E}"/>
+                <a16:creationId xmlns:a16="http://schemas.microsoft.com/office/drawing/2014/main" id="{0D3B1E56-A283-4827-8783-317A3538BF5D}"/>
               </a:ext>
             </a:extLst>
           </p:cNvPr>
@@ -10907,7 +10907,7 @@
           <p:cNvPr id="51" name="3요인 반복측정 ANOVA  ·  각 효과 df=(1,59)">
             <a:extLst xmlns:a="http://schemas.openxmlformats.org/drawingml/2006/main">
               <a:ext uri="{FF2B5EF4-FFF2-40B4-BE49-F238E27FC236}">
-                <a16:creationId xmlns:a16="http://schemas.microsoft.com/office/drawing/2014/main" id="{83BB8F76-AA8F-42D8-B2B9-13C6CC65D5FA}"/>
+                <a16:creationId xmlns:a16="http://schemas.microsoft.com/office/drawing/2014/main" id="{B32BA9A8-429B-4407-9CF6-C975434942B2}"/>
               </a:ext>
             </a:extLst>
           </p:cNvPr>
@@ -10975,7 +10975,7 @@
           <p:cNvPr id="52" name="">
             <a:extLst xmlns:a="http://schemas.openxmlformats.org/drawingml/2006/main">
               <a:ext uri="{FF2B5EF4-FFF2-40B4-BE49-F238E27FC236}">
-                <a16:creationId xmlns:a16="http://schemas.microsoft.com/office/drawing/2014/main" id="{B43BD973-A8F2-4949-8BFA-9FECF1F89D13}"/>
+                <a16:creationId xmlns:a16="http://schemas.microsoft.com/office/drawing/2014/main" id="{6A7C8353-A6EA-4A12-92C9-43506A6C81DC}"/>
               </a:ext>
             </a:extLst>
           </p:cNvPr>
@@ -11005,7 +11005,7 @@
                     </a:bodyPr>
                     <a:lstStyle/>
                     <a:p>
-                      <a:pPr algn="l"/>
+                      <a:pPr algn="ctr"/>
                       <a:r>
                         <a:rPr sz="1800" b="1">
                           <a:solidFill>
@@ -11266,7 +11266,7 @@
                     </a:bodyPr>
                     <a:lstStyle/>
                     <a:p>
-                      <a:pPr algn="l"/>
+                      <a:pPr algn="ctr"/>
                       <a:r>
                         <a:rPr sz="1800" b="0">
                           <a:solidFill>
@@ -11311,7 +11311,7 @@
                     </a:bodyPr>
                     <a:lstStyle/>
                     <a:p>
-                      <a:pPr algn="ctr"/>
+                      <a:pPr algn="r"/>
                       <a:r>
                         <a:rPr sz="1800" b="0">
                           <a:solidFill>
@@ -11350,7 +11350,7 @@
                     </a:bodyPr>
                     <a:lstStyle/>
                     <a:p>
-                      <a:pPr algn="ctr"/>
+                      <a:pPr algn="r"/>
                       <a:r>
                         <a:rPr sz="1800" b="0">
                           <a:solidFill>
@@ -11389,7 +11389,7 @@
                     </a:bodyPr>
                     <a:lstStyle/>
                     <a:p>
-                      <a:pPr algn="ctr"/>
+                      <a:pPr algn="r"/>
                       <a:r>
                         <a:rPr sz="1800" b="0">
                           <a:solidFill>
@@ -11428,7 +11428,7 @@
                     </a:bodyPr>
                     <a:lstStyle/>
                     <a:p>
-                      <a:pPr algn="ctr"/>
+                      <a:pPr algn="r"/>
                       <a:r>
                         <a:rPr sz="1800" b="0">
                           <a:solidFill>
@@ -11469,7 +11469,7 @@
                     </a:bodyPr>
                     <a:lstStyle/>
                     <a:p>
-                      <a:pPr algn="l"/>
+                      <a:pPr algn="ctr"/>
                       <a:r>
                         <a:rPr sz="1800" b="0">
                           <a:solidFill>
@@ -11514,7 +11514,7 @@
                     </a:bodyPr>
                     <a:lstStyle/>
                     <a:p>
-                      <a:pPr algn="ctr"/>
+                      <a:pPr algn="r"/>
                       <a:r>
                         <a:rPr sz="1800" b="0">
                           <a:solidFill>
@@ -11553,7 +11553,7 @@
                     </a:bodyPr>
                     <a:lstStyle/>
                     <a:p>
-                      <a:pPr algn="ctr"/>
+                      <a:pPr algn="r"/>
                       <a:r>
                         <a:rPr sz="1800" b="0">
                           <a:solidFill>
@@ -11592,7 +11592,7 @@
                     </a:bodyPr>
                     <a:lstStyle/>
                     <a:p>
-                      <a:pPr algn="ctr"/>
+                      <a:pPr algn="r"/>
                       <a:r>
                         <a:rPr sz="1800" b="0">
                           <a:solidFill>
@@ -11631,7 +11631,7 @@
                     </a:bodyPr>
                     <a:lstStyle/>
                     <a:p>
-                      <a:pPr algn="ctr"/>
+                      <a:pPr algn="r"/>
                       <a:r>
                         <a:rPr sz="1800" b="0">
                           <a:solidFill>
@@ -11672,7 +11672,7 @@
                     </a:bodyPr>
                     <a:lstStyle/>
                     <a:p>
-                      <a:pPr algn="l"/>
+                      <a:pPr algn="ctr"/>
                       <a:r>
                         <a:rPr sz="1800" b="0">
                           <a:solidFill>
@@ -11717,7 +11717,7 @@
                     </a:bodyPr>
                     <a:lstStyle/>
                     <a:p>
-                      <a:pPr algn="ctr"/>
+                      <a:pPr algn="r"/>
                       <a:r>
                         <a:rPr sz="1800" b="0">
                           <a:solidFill>
@@ -11756,7 +11756,7 @@
                     </a:bodyPr>
                     <a:lstStyle/>
                     <a:p>
-                      <a:pPr algn="ctr"/>
+                      <a:pPr algn="r"/>
                       <a:r>
                         <a:rPr sz="1800" b="0">
                           <a:solidFill>
@@ -11795,7 +11795,7 @@
                     </a:bodyPr>
                     <a:lstStyle/>
                     <a:p>
-                      <a:pPr algn="ctr"/>
+                      <a:pPr algn="r"/>
                       <a:r>
                         <a:rPr sz="1800" b="0">
                           <a:solidFill>
@@ -11834,7 +11834,7 @@
                     </a:bodyPr>
                     <a:lstStyle/>
                     <a:p>
-                      <a:pPr algn="ctr"/>
+                      <a:pPr algn="r"/>
                       <a:r>
                         <a:rPr sz="1800" b="0">
                           <a:solidFill>
@@ -11875,7 +11875,7 @@
                     </a:bodyPr>
                     <a:lstStyle/>
                     <a:p>
-                      <a:pPr algn="l"/>
+                      <a:pPr algn="ctr"/>
                       <a:r>
                         <a:rPr sz="1800" b="0">
                           <a:solidFill>
@@ -11920,7 +11920,7 @@
                     </a:bodyPr>
                     <a:lstStyle/>
                     <a:p>
-                      <a:pPr algn="ctr"/>
+                      <a:pPr algn="r"/>
                       <a:r>
                         <a:rPr sz="1800" b="0">
                           <a:solidFill>
@@ -11959,7 +11959,7 @@
                     </a:bodyPr>
                     <a:lstStyle/>
                     <a:p>
-                      <a:pPr algn="ctr"/>
+                      <a:pPr algn="r"/>
                       <a:r>
                         <a:rPr sz="1800" b="0">
                           <a:solidFill>
@@ -11998,7 +11998,7 @@
                     </a:bodyPr>
                     <a:lstStyle/>
                     <a:p>
-                      <a:pPr algn="ctr"/>
+                      <a:pPr algn="r"/>
                       <a:r>
                         <a:rPr sz="1800" b="0">
                           <a:solidFill>
@@ -12037,7 +12037,7 @@
                     </a:bodyPr>
                     <a:lstStyle/>
                     <a:p>
-                      <a:pPr algn="ctr"/>
+                      <a:pPr algn="r"/>
                       <a:r>
                         <a:rPr sz="1800" b="0">
                           <a:solidFill>
@@ -12078,7 +12078,7 @@
                     </a:bodyPr>
                     <a:lstStyle/>
                     <a:p>
-                      <a:pPr algn="l"/>
+                      <a:pPr algn="ctr"/>
                       <a:r>
                         <a:rPr sz="1800" b="0">
                           <a:solidFill>
@@ -12123,7 +12123,7 @@
                     </a:bodyPr>
                     <a:lstStyle/>
                     <a:p>
-                      <a:pPr algn="ctr"/>
+                      <a:pPr algn="r"/>
                       <a:r>
                         <a:rPr sz="1800" b="0">
                           <a:solidFill>
@@ -12162,7 +12162,7 @@
                     </a:bodyPr>
                     <a:lstStyle/>
                     <a:p>
-                      <a:pPr algn="ctr"/>
+                      <a:pPr algn="r"/>
                       <a:r>
                         <a:rPr sz="1800" b="0">
                           <a:solidFill>
@@ -12201,7 +12201,7 @@
                     </a:bodyPr>
                     <a:lstStyle/>
                     <a:p>
-                      <a:pPr algn="ctr"/>
+                      <a:pPr algn="r"/>
                       <a:r>
                         <a:rPr sz="1800" b="0">
                           <a:solidFill>
@@ -12240,7 +12240,7 @@
                     </a:bodyPr>
                     <a:lstStyle/>
                     <a:p>
-                      <a:pPr algn="ctr"/>
+                      <a:pPr algn="r"/>
                       <a:r>
                         <a:rPr sz="1800" b="0">
                           <a:solidFill>
@@ -12281,7 +12281,7 @@
                     </a:bodyPr>
                     <a:lstStyle/>
                     <a:p>
-                      <a:pPr algn="l"/>
+                      <a:pPr algn="ctr"/>
                       <a:r>
                         <a:rPr sz="1800" b="0">
                           <a:solidFill>
@@ -12326,7 +12326,7 @@
                     </a:bodyPr>
                     <a:lstStyle/>
                     <a:p>
-                      <a:pPr algn="ctr"/>
+                      <a:pPr algn="r"/>
                       <a:r>
                         <a:rPr sz="1800" b="0">
                           <a:solidFill>
@@ -12365,7 +12365,7 @@
                     </a:bodyPr>
                     <a:lstStyle/>
                     <a:p>
-                      <a:pPr algn="ctr"/>
+                      <a:pPr algn="r"/>
                       <a:r>
                         <a:rPr sz="1800" b="0">
                           <a:solidFill>
@@ -12404,7 +12404,7 @@
                     </a:bodyPr>
                     <a:lstStyle/>
                     <a:p>
-                      <a:pPr algn="ctr"/>
+                      <a:pPr algn="r"/>
                       <a:r>
                         <a:rPr sz="1800" b="0">
                           <a:solidFill>
@@ -12443,7 +12443,7 @@
                     </a:bodyPr>
                     <a:lstStyle/>
                     <a:p>
-                      <a:pPr algn="ctr"/>
+                      <a:pPr algn="r"/>
                       <a:r>
                         <a:rPr sz="1800" b="0">
                           <a:solidFill>
@@ -12484,7 +12484,7 @@
                     </a:bodyPr>
                     <a:lstStyle/>
                     <a:p>
-                      <a:pPr algn="l"/>
+                      <a:pPr algn="ctr"/>
                       <a:r>
                         <a:rPr sz="1800" b="0">
                           <a:solidFill>
@@ -12529,7 +12529,7 @@
                     </a:bodyPr>
                     <a:lstStyle/>
                     <a:p>
-                      <a:pPr algn="ctr"/>
+                      <a:pPr algn="r"/>
                       <a:r>
                         <a:rPr sz="1800" b="0">
                           <a:solidFill>
@@ -12568,7 +12568,7 @@
                     </a:bodyPr>
                     <a:lstStyle/>
                     <a:p>
-                      <a:pPr algn="ctr"/>
+                      <a:pPr algn="r"/>
                       <a:r>
                         <a:rPr sz="1800" b="0">
                           <a:solidFill>
@@ -12607,7 +12607,7 @@
                     </a:bodyPr>
                     <a:lstStyle/>
                     <a:p>
-                      <a:pPr algn="ctr"/>
+                      <a:pPr algn="r"/>
                       <a:r>
                         <a:rPr sz="1800" b="0">
                           <a:solidFill>
@@ -12646,7 +12646,7 @@
                     </a:bodyPr>
                     <a:lstStyle/>
                     <a:p>
-                      <a:pPr algn="ctr"/>
+                      <a:pPr algn="r"/>
                       <a:r>
                         <a:rPr sz="1800" b="0">
                           <a:solidFill>
@@ -12688,7 +12688,7 @@
           <p:cNvPr id="53" name="문자 비율·시간은 각각 7검정에 Holm 보정. RAGAS H×C 검정은 평가 문맥 언어별로 수행했으며, 전체 24검">
             <a:extLst xmlns:a="http://schemas.openxmlformats.org/drawingml/2006/main">
               <a:ext uri="{FF2B5EF4-FFF2-40B4-BE49-F238E27FC236}">
-                <a16:creationId xmlns:a16="http://schemas.microsoft.com/office/drawing/2014/main" id="{C174F881-E4E6-457C-8F82-705414592196}"/>
+                <a16:creationId xmlns:a16="http://schemas.microsoft.com/office/drawing/2014/main" id="{4C383798-9742-444E-B2C6-2EC178B73E02}"/>
               </a:ext>
             </a:extLst>
           </p:cNvPr>
@@ -12802,7 +12802,7 @@
           <p:cNvPr id="54" name="기법별 대응 비교  ·  질의별 평균 차이, 양측 검정">
             <a:extLst xmlns:a="http://schemas.openxmlformats.org/drawingml/2006/main">
               <a:ext uri="{FF2B5EF4-FFF2-40B4-BE49-F238E27FC236}">
-                <a16:creationId xmlns:a16="http://schemas.microsoft.com/office/drawing/2014/main" id="{E1F10C66-E739-49DF-BEF6-FE12456ADE9F}"/>
+                <a16:creationId xmlns:a16="http://schemas.microsoft.com/office/drawing/2014/main" id="{D62BA19D-8821-4DF2-A62A-A925B121B95E}"/>
               </a:ext>
             </a:extLst>
           </p:cNvPr>
@@ -12870,7 +12870,7 @@
           <p:cNvPr id="55" name="">
             <a:extLst xmlns:a="http://schemas.openxmlformats.org/drawingml/2006/main">
               <a:ext uri="{FF2B5EF4-FFF2-40B4-BE49-F238E27FC236}">
-                <a16:creationId xmlns:a16="http://schemas.microsoft.com/office/drawing/2014/main" id="{738A0D3C-B710-4187-8F4E-F5B3E7B318AF}"/>
+                <a16:creationId xmlns:a16="http://schemas.microsoft.com/office/drawing/2014/main" id="{F34D4D0D-B46E-44B9-AB8D-A00EA92BB506}"/>
               </a:ext>
             </a:extLst>
           </p:cNvPr>
@@ -12900,7 +12900,7 @@
                     </a:bodyPr>
                     <a:lstStyle/>
                     <a:p>
-                      <a:pPr algn="l"/>
+                      <a:pPr algn="ctr"/>
                       <a:r>
                         <a:rPr sz="1800" b="1">
                           <a:solidFill>
@@ -13234,7 +13234,7 @@
                     </a:bodyPr>
                     <a:lstStyle/>
                     <a:p>
-                      <a:pPr algn="ctr"/>
+                      <a:pPr algn="r"/>
                       <a:r>
                         <a:rPr sz="1800" b="0">
                           <a:solidFill>
@@ -13248,7 +13248,7 @@
                       </a:r>
                     </a:p>
                     <a:p>
-                      <a:pPr algn="ctr"/>
+                      <a:pPr algn="r"/>
                       <a:r>
                         <a:rPr sz="1800" b="0">
                           <a:solidFill>
@@ -13287,7 +13287,7 @@
                     </a:bodyPr>
                     <a:lstStyle/>
                     <a:p>
-                      <a:pPr algn="ctr"/>
+                      <a:pPr algn="r"/>
                       <a:r>
                         <a:rPr sz="1800" b="0">
                           <a:solidFill>
@@ -13301,7 +13301,7 @@
                       </a:r>
                     </a:p>
                     <a:p>
-                      <a:pPr algn="ctr"/>
+                      <a:pPr algn="r"/>
                       <a:r>
                         <a:rPr sz="1800" b="0">
                           <a:solidFill>
@@ -13340,7 +13340,7 @@
                     </a:bodyPr>
                     <a:lstStyle/>
                     <a:p>
-                      <a:pPr algn="ctr"/>
+                      <a:pPr algn="r"/>
                       <a:r>
                         <a:rPr sz="1800" b="0">
                           <a:solidFill>
@@ -13379,7 +13379,7 @@
                     </a:bodyPr>
                     <a:lstStyle/>
                     <a:p>
-                      <a:pPr algn="ctr"/>
+                      <a:pPr algn="r"/>
                       <a:r>
                         <a:rPr sz="1800" b="0">
                           <a:solidFill>
@@ -13479,7 +13479,7 @@
                     </a:bodyPr>
                     <a:lstStyle/>
                     <a:p>
-                      <a:pPr algn="ctr"/>
+                      <a:pPr algn="r"/>
                       <a:r>
                         <a:rPr sz="1800" b="0">
                           <a:solidFill>
@@ -13493,7 +13493,7 @@
                       </a:r>
                     </a:p>
                     <a:p>
-                      <a:pPr algn="ctr"/>
+                      <a:pPr algn="r"/>
                       <a:r>
                         <a:rPr sz="1800" b="0">
                           <a:solidFill>
@@ -13532,7 +13532,7 @@
                     </a:bodyPr>
                     <a:lstStyle/>
                     <a:p>
-                      <a:pPr algn="ctr"/>
+                      <a:pPr algn="r"/>
                       <a:r>
                         <a:rPr sz="1800" b="0">
                           <a:solidFill>
@@ -13546,7 +13546,7 @@
                       </a:r>
                     </a:p>
                     <a:p>
-                      <a:pPr algn="ctr"/>
+                      <a:pPr algn="r"/>
                       <a:r>
                         <a:rPr sz="1800" b="0">
                           <a:solidFill>
@@ -13585,7 +13585,7 @@
                     </a:bodyPr>
                     <a:lstStyle/>
                     <a:p>
-                      <a:pPr algn="ctr"/>
+                      <a:pPr algn="r"/>
                       <a:r>
                         <a:rPr sz="1800" b="0">
                           <a:solidFill>
@@ -13624,7 +13624,7 @@
                     </a:bodyPr>
                     <a:lstStyle/>
                     <a:p>
-                      <a:pPr algn="ctr"/>
+                      <a:pPr algn="r"/>
                       <a:r>
                         <a:rPr sz="1800" b="0">
                           <a:solidFill>
@@ -13724,7 +13724,7 @@
                     </a:bodyPr>
                     <a:lstStyle/>
                     <a:p>
-                      <a:pPr algn="ctr"/>
+                      <a:pPr algn="r"/>
                       <a:r>
                         <a:rPr sz="1800" b="0">
                           <a:solidFill>
@@ -13738,7 +13738,7 @@
                       </a:r>
                     </a:p>
                     <a:p>
-                      <a:pPr algn="ctr"/>
+                      <a:pPr algn="r"/>
                       <a:r>
                         <a:rPr sz="1800" b="0">
                           <a:solidFill>
@@ -13777,7 +13777,7 @@
                     </a:bodyPr>
                     <a:lstStyle/>
                     <a:p>
-                      <a:pPr algn="ctr"/>
+                      <a:pPr algn="r"/>
                       <a:r>
                         <a:rPr sz="1800" b="0">
                           <a:solidFill>
@@ -13791,7 +13791,7 @@
                       </a:r>
                     </a:p>
                     <a:p>
-                      <a:pPr algn="ctr"/>
+                      <a:pPr algn="r"/>
                       <a:r>
                         <a:rPr sz="1800" b="0">
                           <a:solidFill>
@@ -13830,7 +13830,7 @@
                     </a:bodyPr>
                     <a:lstStyle/>
                     <a:p>
-                      <a:pPr algn="ctr"/>
+                      <a:pPr algn="r"/>
                       <a:r>
                         <a:rPr sz="1800" b="0">
                           <a:solidFill>
@@ -13869,7 +13869,7 @@
                     </a:bodyPr>
                     <a:lstStyle/>
                     <a:p>
-                      <a:pPr algn="ctr"/>
+                      <a:pPr algn="r"/>
                       <a:r>
                         <a:rPr sz="1800" b="0">
                           <a:solidFill>
@@ -13911,7 +13911,7 @@
           <p:cNvPr id="56" name="HyDE: C0S0, CAD: H0S0, SCD: H0의 CAD 상태 평균 보정: HyDE·CAD 각 4지표, SCD">
             <a:extLst xmlns:a="http://schemas.openxmlformats.org/drawingml/2006/main">
               <a:ext uri="{FF2B5EF4-FFF2-40B4-BE49-F238E27FC236}">
-                <a16:creationId xmlns:a16="http://schemas.microsoft.com/office/drawing/2014/main" id="{47A458AB-321E-41C9-97A7-D310CE511A95}"/>
+                <a16:creationId xmlns:a16="http://schemas.microsoft.com/office/drawing/2014/main" id="{D2BF6CEB-1CA8-467F-BC20-5A13D7AE7021}"/>
               </a:ext>
             </a:extLst>
           </p:cNvPr>
@@ -14025,7 +14025,7 @@
           <p:cNvPr id="57" name="">
             <a:extLst xmlns:a="http://schemas.openxmlformats.org/drawingml/2006/main">
               <a:ext uri="{FF2B5EF4-FFF2-40B4-BE49-F238E27FC236}">
-                <a16:creationId xmlns:a16="http://schemas.microsoft.com/office/drawing/2014/main" id="{EBDAFB7E-4142-4AD9-A0D2-D8075ED73F1E}"/>
+                <a16:creationId xmlns:a16="http://schemas.microsoft.com/office/drawing/2014/main" id="{78A781B1-22AE-4A8D-AF1F-6FDB4D1B0AA6}"/>
               </a:ext>
             </a:extLst>
           </p:cNvPr>
@@ -14056,7 +14056,7 @@
           <p:cNvPr id="58" name="06 결과 해석">
             <a:extLst xmlns:a="http://schemas.openxmlformats.org/drawingml/2006/main">
               <a:ext uri="{FF2B5EF4-FFF2-40B4-BE49-F238E27FC236}">
-                <a16:creationId xmlns:a16="http://schemas.microsoft.com/office/drawing/2014/main" id="{A0915C9A-CCAB-45C6-97C3-15F2B082FBF4}"/>
+                <a16:creationId xmlns:a16="http://schemas.microsoft.com/office/drawing/2014/main" id="{50A3C81F-B2E6-468C-8A13-707E231BCED7}"/>
               </a:ext>
             </a:extLst>
           </p:cNvPr>
@@ -14121,10 +14121,10 @@
       </p:sp>
       <p:sp>
         <p:nvSpPr>
-          <p:cNvPr id="59" name="HyDE 관련성은 양의 평균 차이, 보정 후 p=0.117. CAD 충실도는 질의별 증가와 감소가 함께 관찰됨. SC">
+          <p:cNvPr id="59" name="HyDE 관련성 차이는 +0.080점, Holm 보정 p=0.117이다. CAD 충실도 차이는 +0.029점(SD 0">
             <a:extLst xmlns:a="http://schemas.openxmlformats.org/drawingml/2006/main">
               <a:ext uri="{FF2B5EF4-FFF2-40B4-BE49-F238E27FC236}">
-                <a16:creationId xmlns:a16="http://schemas.microsoft.com/office/drawing/2014/main" id="{F09B36BA-163C-4AFF-8FC9-C97742F52C47}"/>
+                <a16:creationId xmlns:a16="http://schemas.microsoft.com/office/drawing/2014/main" id="{0FABEBDA-F489-410E-A20A-D1448022DB53}"/>
               </a:ext>
             </a:extLst>
           </p:cNvPr>
@@ -14182,7 +14182,7 @@
                 <a:ea typeface="Malgun Gothic"/>
                 <a:cs typeface="Malgun Gothic"/>
               </a:rPr>
-              <a:t>HyDE 관련성은 양의 평균 차이, 보정 후 p=0.117.</a:t>
+              <a:t>HyDE 관련성 차이는 +0.080점, Holm 보정 p=0.117이다.</a:t>
             </a:r>
           </a:p>
           <a:p xmlns:a="http://schemas.openxmlformats.org/drawingml/2006/main">
@@ -14205,7 +14205,7 @@
                 <a:ea typeface="Malgun Gothic"/>
                 <a:cs typeface="Malgun Gothic"/>
               </a:rPr>
-              <a:t>CAD 충실도는 질의별 증가와 감소가 함께 관찰됨.</a:t>
+              <a:t>CAD 충실도 차이는 +0.029점(SD 0.255), p=0.393이다.</a:t>
             </a:r>
           </a:p>
           <a:p xmlns:a="http://schemas.openxmlformats.org/drawingml/2006/main">
@@ -14228,7 +14228,7 @@
                 <a:ea typeface="Malgun Gothic"/>
                 <a:cs typeface="Malgun Gothic"/>
               </a:rPr>
-              <a:t>SCD 한글 비중은 주·전체 비교 모두 보정 p&lt;0.001.</a:t>
+              <a:t>SCD 문자 비율의 주·전체 비교는 모두 보정 p&lt;0.001이다.</a:t>
             </a:r>
           </a:p>
           <a:p xmlns:a="http://schemas.openxmlformats.org/drawingml/2006/main">
@@ -14251,7 +14251,7 @@
                 <a:ea typeface="Malgun Gothic"/>
                 <a:cs typeface="Malgun Gothic"/>
               </a:rPr>
-              <a:t>HyDE ON: T=0.1, top_p=0.9, 검색 문맥 차이 포함</a:t>
+              <a:t>HyDE 비교에는 번역·가상 문서 샘플링의 차이가 포함된다.</a:t>
             </a:r>
           </a:p>
         </p:txBody>
@@ -14261,7 +14261,7 @@
           <p:cNvPr id="60" name="">
             <a:extLst xmlns:a="http://schemas.openxmlformats.org/drawingml/2006/main">
               <a:ext uri="{FF2B5EF4-FFF2-40B4-BE49-F238E27FC236}">
-                <a16:creationId xmlns:a16="http://schemas.microsoft.com/office/drawing/2014/main" id="{A8E057C2-9478-4A8A-955E-8B1CBBA7D6CC}"/>
+                <a16:creationId xmlns:a16="http://schemas.microsoft.com/office/drawing/2014/main" id="{4A955602-12DA-44DC-A84D-3186E76932A4}"/>
               </a:ext>
             </a:extLst>
           </p:cNvPr>
@@ -14292,7 +14292,7 @@
           <p:cNvPr id="61" name="07 결론">
             <a:extLst xmlns:a="http://schemas.openxmlformats.org/drawingml/2006/main">
               <a:ext uri="{FF2B5EF4-FFF2-40B4-BE49-F238E27FC236}">
-                <a16:creationId xmlns:a16="http://schemas.microsoft.com/office/drawing/2014/main" id="{81656940-B69C-43F2-8EB9-3913A797D32E}"/>
+                <a16:creationId xmlns:a16="http://schemas.microsoft.com/office/drawing/2014/main" id="{F51BB986-9EB1-4E30-A92A-52FDA2D62D97}"/>
               </a:ext>
             </a:extLst>
           </p:cNvPr>
@@ -14357,10 +14357,10 @@
       </p:sp>
       <p:sp>
         <p:nvSpPr>
-          <p:cNvPr id="62" name="세 기법의 작동 단계에 따라 품질·언어·비용을 구분했다. SCD는 한국어 문자 비율을 높였고, 실행 시간에서는 HyD">
+          <p:cNvPr id="62" name="본 연구는 HyDE·CAD·SCD 조합별 답변 품질, 한국어 문자 비율 및 실행 시간을 평가하였다. SCD는 한국어 ">
             <a:extLst xmlns:a="http://schemas.openxmlformats.org/drawingml/2006/main">
               <a:ext uri="{FF2B5EF4-FFF2-40B4-BE49-F238E27FC236}">
-                <a16:creationId xmlns:a16="http://schemas.microsoft.com/office/drawing/2014/main" id="{E2F1D751-EDAE-4A91-9EA4-1D4000CB5461}"/>
+                <a16:creationId xmlns:a16="http://schemas.microsoft.com/office/drawing/2014/main" id="{10BFA70D-3412-40BB-9DDD-7E9BCC2DCD01}"/>
               </a:ext>
             </a:extLst>
           </p:cNvPr>
@@ -14372,7 +14372,7 @@
         <p:spPr>
           <a:xfrm xmlns:a="http://schemas.openxmlformats.org/drawingml/2006/main">
             <a:off x="10949175" y="25288875"/>
-            <a:ext cx="9729975" cy="1219200"/>
+            <a:ext cx="9729975" cy="1524000"/>
           </a:xfrm>
           <a:prstGeom xmlns:a="http://schemas.openxmlformats.org/drawingml/2006/main" prst="rect">
             <a:avLst/>
@@ -14418,7 +14418,7 @@
                 <a:ea typeface="Malgun Gothic"/>
                 <a:cs typeface="Malgun Gothic"/>
               </a:rPr>
-              <a:t>세 기법의 작동 단계에 따라 품질·언어·비용을 구분했다.</a:t>
+              <a:t>본 연구는 HyDE·CAD·SCD 조합별 답변 품질,</a:t>
             </a:r>
           </a:p>
           <a:p xmlns:a="http://schemas.openxmlformats.org/drawingml/2006/main">
@@ -14441,7 +14441,7 @@
                 <a:ea typeface="Malgun Gothic"/>
                 <a:cs typeface="Malgun Gothic"/>
               </a:rPr>
-              <a:t>SCD는 한국어 문자 비율을 높였고, 실행 시간에서는</a:t>
+              <a:t>한국어 문자 비율 및 실행 시간을 평가하였다.</a:t>
             </a:r>
           </a:p>
           <a:p xmlns:a="http://schemas.openxmlformats.org/drawingml/2006/main">
@@ -14464,7 +14464,30 @@
                 <a:ea typeface="Malgun Gothic"/>
                 <a:cs typeface="Malgun Gothic"/>
               </a:rPr>
-              <a:t>HyDE·CAD 주효과와 CAD×SCD 상호작용을 확인했다.</a:t>
+              <a:t>SCD는 한국어 문자 비율을 높였다(보정 p&lt;0.001).</a:t>
+            </a:r>
+          </a:p>
+          <a:p xmlns:a="http://schemas.openxmlformats.org/drawingml/2006/main">
+            <a:pPr algn="l">
+              <a:defRPr sz="1800" b="0">
+                <a:solidFill>
+                  <a:srgbClr val="24324A"/>
+                </a:solidFill>
+                <a:latin typeface="Malgun Gothic"/>
+                <a:ea typeface="Malgun Gothic"/>
+                <a:cs typeface="Malgun Gothic"/>
+              </a:defRPr>
+            </a:pPr>
+            <a:r>
+              <a:rPr sz="1800" b="0">
+                <a:solidFill>
+                  <a:srgbClr val="24324A"/>
+                </a:solidFill>
+                <a:latin typeface="Malgun Gothic"/>
+                <a:ea typeface="Malgun Gothic"/>
+                <a:cs typeface="Malgun Gothic"/>
+              </a:rPr>
+              <a:t>실행 시간의 H·C 주효과와 C×S 상호작용도 유의하였다.</a:t>
             </a:r>
           </a:p>
           <a:p xmlns:a="http://schemas.openxmlformats.org/drawingml/2006/main">
@@ -14497,7 +14520,7 @@
           <p:cNvPr id="63" name="">
             <a:extLst xmlns:a="http://schemas.openxmlformats.org/drawingml/2006/main">
               <a:ext uri="{FF2B5EF4-FFF2-40B4-BE49-F238E27FC236}">
-                <a16:creationId xmlns:a16="http://schemas.microsoft.com/office/drawing/2014/main" id="{5A264F1A-D0EB-4347-92B4-C70080C1ED08}"/>
+                <a16:creationId xmlns:a16="http://schemas.microsoft.com/office/drawing/2014/main" id="{A0D43F72-4EDF-43ED-9C58-F370A36175EE}"/>
               </a:ext>
             </a:extLst>
           </p:cNvPr>
@@ -14528,7 +14551,7 @@
           <p:cNvPr id="64" name="08 주요 참고문헌">
             <a:extLst xmlns:a="http://schemas.openxmlformats.org/drawingml/2006/main">
               <a:ext uri="{FF2B5EF4-FFF2-40B4-BE49-F238E27FC236}">
-                <a16:creationId xmlns:a16="http://schemas.microsoft.com/office/drawing/2014/main" id="{3B431690-7240-47DC-8B88-70F601179E50}"/>
+                <a16:creationId xmlns:a16="http://schemas.microsoft.com/office/drawing/2014/main" id="{73AFB703-F9C2-47C5-8A45-A19A38D34DDC}"/>
               </a:ext>
             </a:extLst>
           </p:cNvPr>
@@ -14596,7 +14619,7 @@
           <p:cNvPr id="65" name="[1] Lewis et al. RAG. NeurIPS, 2020. [2] Gao et al. HyDE. ACL, 20">
             <a:extLst xmlns:a="http://schemas.openxmlformats.org/drawingml/2006/main">
               <a:ext uri="{FF2B5EF4-FFF2-40B4-BE49-F238E27FC236}">
-                <a16:creationId xmlns:a16="http://schemas.microsoft.com/office/drawing/2014/main" id="{D90A6E35-5D8C-4370-9D84-F2298825C909}"/>
+                <a16:creationId xmlns:a16="http://schemas.microsoft.com/office/drawing/2014/main" id="{2B27162D-187F-4E38-AEB3-B3CE866B6835}"/>
               </a:ext>
             </a:extLst>
           </p:cNvPr>
@@ -14710,7 +14733,7 @@
           <p:cNvPr id="66" name="[4] Li et al. Language Drift and SCD. AAAI, 2026. [5] Chen et al.">
             <a:extLst xmlns:a="http://schemas.openxmlformats.org/drawingml/2006/main">
               <a:ext uri="{FF2B5EF4-FFF2-40B4-BE49-F238E27FC236}">
-                <a16:creationId xmlns:a16="http://schemas.microsoft.com/office/drawing/2014/main" id="{5B727E51-19D1-4AA4-8801-D16723CD6E4F}"/>
+                <a16:creationId xmlns:a16="http://schemas.microsoft.com/office/drawing/2014/main" id="{3DF0032D-802C-48C5-BA16-7DA4BC802D2C}"/>
               </a:ext>
             </a:extLst>
           </p:cNvPr>
@@ -14824,7 +14847,7 @@
           <p:cNvPr id="67" name="전체 22편과 통계 상세표·결측·민감도 분석은 동봉 자료에 수록">
             <a:extLst xmlns:a="http://schemas.openxmlformats.org/drawingml/2006/main">
               <a:ext uri="{FF2B5EF4-FFF2-40B4-BE49-F238E27FC236}">
-                <a16:creationId xmlns:a16="http://schemas.microsoft.com/office/drawing/2014/main" id="{F7B9696B-B411-40BE-BCD7-6B46350C85E5}"/>
+                <a16:creationId xmlns:a16="http://schemas.microsoft.com/office/drawing/2014/main" id="{B04FD7C5-9E6A-483A-BC80-6ED18BC1A9F4}"/>
               </a:ext>
             </a:extLst>
           </p:cNvPr>
@@ -14892,7 +14915,7 @@
           <p:cNvPr id="68" name="영어 문서 4종 · 질의 60개 · 생성 모델 1종 · 질의별 반복측정">
             <a:extLst xmlns:a="http://schemas.openxmlformats.org/drawingml/2006/main">
               <a:ext uri="{FF2B5EF4-FFF2-40B4-BE49-F238E27FC236}">
-                <a16:creationId xmlns:a16="http://schemas.microsoft.com/office/drawing/2014/main" id="{76112FBE-EF47-4F08-891D-65A50C2D5AE2}"/>
+                <a16:creationId xmlns:a16="http://schemas.microsoft.com/office/drawing/2014/main" id="{8CF0F5B7-1181-4D32-A78F-EE3315576E85}"/>
               </a:ext>
             </a:extLst>
           </p:cNvPr>
@@ -14960,7 +14983,7 @@
           <p:cNvPr id="69" name="A1 594 × 841 mm">
             <a:extLst xmlns:a="http://schemas.openxmlformats.org/drawingml/2006/main">
               <a:ext uri="{FF2B5EF4-FFF2-40B4-BE49-F238E27FC236}">
-                <a16:creationId xmlns:a16="http://schemas.microsoft.com/office/drawing/2014/main" id="{23C17327-8E6D-4FEE-A794-D4711E1F32F8}"/>
+                <a16:creationId xmlns:a16="http://schemas.microsoft.com/office/drawing/2014/main" id="{24D13A9D-62CE-4199-ABA1-F0203CA00441}"/>
               </a:ext>
             </a:extLst>
           </p:cNvPr>
@@ -15026,7 +15049,7 @@
     </p:spTree>
     <p:extLst>
       <p:ext uri="{BB962C8B-B14F-4D97-AF65-F5344CB8AC3E}">
-        <p14:creationId xmlns:p14="http://schemas.microsoft.com/office/powerpoint/2010/main" val="884406712"/>
+        <p14:creationId xmlns:p14="http://schemas.microsoft.com/office/powerpoint/2010/main" val="912304359"/>
       </p:ext>
     </p:extLst>
   </p:cSld>

</xml_diff>

<commit_message>
Apply professor acceptance audit to thesis and A1 poster
</commit_message>
<xml_diff>
--- a/FINALDOCS/POSTER/A1_FINAL_TITLE_CONFIRMED_20261010/M_RAG_A1_FINAL_EDITABLE.pptx
+++ b/FINALDOCS/POSTER/A1_FINAL_TITLE_CONFIRMED_20261010/M_RAG_A1_FINAL_EDITABLE.pptx
@@ -2,13 +2,13 @@
 <file path=ppt/presentation.xml><?xml version="1.0" encoding="utf-8"?>
 <p:presentation xmlns:p="http://schemas.openxmlformats.org/presentationml/2006/main">
   <p:sldMasterIdLst>
-    <p:sldMasterId xmlns:r="http://schemas.openxmlformats.org/officeDocument/2006/relationships" id="2147483648" r:id="R25cdf025835b4cc7"/>
+    <p:sldMasterId xmlns:r="http://schemas.openxmlformats.org/officeDocument/2006/relationships" id="2147483648" r:id="Rb58195702ba64367"/>
   </p:sldMasterIdLst>
   <p:notesMasterIdLst>
-    <p:notesMasterId xmlns:r="http://schemas.openxmlformats.org/officeDocument/2006/relationships" r:id="R1a10d38d154247d3"/>
+    <p:notesMasterId xmlns:r="http://schemas.openxmlformats.org/officeDocument/2006/relationships" r:id="R8355700b404142f7"/>
   </p:notesMasterIdLst>
   <p:sldIdLst>
-    <p:sldId xmlns:r="http://schemas.openxmlformats.org/officeDocument/2006/relationships" id="256" r:id="R311e838784fc4b00"/>
+    <p:sldId xmlns:r="http://schemas.openxmlformats.org/officeDocument/2006/relationships" id="256" r:id="Rb4fbd5e9c87042fd"/>
   </p:sldIdLst>
   <p:sldSz cx="21384000" cy="30276000"/>
   <p:notesSz cx="6858000" cy="9144000"/>
@@ -489,7 +489,7 @@
           <p:cNvPr id="3" name="Title">
             <a:extLst xmlns:a="http://schemas.openxmlformats.org/drawingml/2006/main">
               <a:ext uri="{FF2B5EF4-FFF2-40B4-BE49-F238E27FC236}">
-                <a16:creationId xmlns:a16="http://schemas.microsoft.com/office/drawing/2014/main" id="{3EF1CA28-601E-4D25-98C6-8FF66D38F999}"/>
+                <a16:creationId xmlns:a16="http://schemas.microsoft.com/office/drawing/2014/main" id="{5A91EE45-AEDF-480A-88C7-3C7272C2A7BA}"/>
               </a:ext>
             </a:extLst>
           </p:cNvPr>
@@ -646,7 +646,7 @@
           <p:cNvPr id="2" name="Subtitle">
             <a:extLst xmlns:a="http://schemas.openxmlformats.org/drawingml/2006/main">
               <a:ext uri="{FF2B5EF4-FFF2-40B4-BE49-F238E27FC236}">
-                <a16:creationId xmlns:a16="http://schemas.microsoft.com/office/drawing/2014/main" id="{297DE18A-30B9-4804-8197-E472CDEA4A7F}"/>
+                <a16:creationId xmlns:a16="http://schemas.microsoft.com/office/drawing/2014/main" id="{C2CD1A07-9918-4FF9-99C6-7D12E3803759}"/>
               </a:ext>
             </a:extLst>
           </p:cNvPr>
@@ -820,7 +820,7 @@
           <p:cNvPr id="2" name="Section title">
             <a:extLst xmlns:a="http://schemas.openxmlformats.org/drawingml/2006/main">
               <a:ext uri="{FF2B5EF4-FFF2-40B4-BE49-F238E27FC236}">
-                <a16:creationId xmlns:a16="http://schemas.microsoft.com/office/drawing/2014/main" id="{423753AE-4691-41CA-A1F5-E3AEEAB94FA4}"/>
+                <a16:creationId xmlns:a16="http://schemas.microsoft.com/office/drawing/2014/main" id="{9AC45DD9-BA39-4048-B4CE-6764F84D21EF}"/>
               </a:ext>
             </a:extLst>
           </p:cNvPr>
@@ -994,7 +994,7 @@
           <p:cNvPr id="3" name="Title">
             <a:extLst xmlns:a="http://schemas.openxmlformats.org/drawingml/2006/main">
               <a:ext uri="{FF2B5EF4-FFF2-40B4-BE49-F238E27FC236}">
-                <a16:creationId xmlns:a16="http://schemas.microsoft.com/office/drawing/2014/main" id="{259D13B0-039E-4B8D-92D3-62731AAF799B}"/>
+                <a16:creationId xmlns:a16="http://schemas.microsoft.com/office/drawing/2014/main" id="{EA2FC633-F36A-4EEA-90D5-68F57241DFF3}"/>
               </a:ext>
             </a:extLst>
           </p:cNvPr>
@@ -1151,7 +1151,7 @@
           <p:cNvPr id="2" name="Body">
             <a:extLst xmlns:a="http://schemas.openxmlformats.org/drawingml/2006/main">
               <a:ext uri="{FF2B5EF4-FFF2-40B4-BE49-F238E27FC236}">
-                <a16:creationId xmlns:a16="http://schemas.microsoft.com/office/drawing/2014/main" id="{070B5E39-825F-4FB8-85B8-CDF8E33E3E40}"/>
+                <a16:creationId xmlns:a16="http://schemas.microsoft.com/office/drawing/2014/main" id="{783B1D4C-AC93-4A3D-8A26-AFEE41E4C427}"/>
               </a:ext>
             </a:extLst>
           </p:cNvPr>
@@ -1325,7 +1325,7 @@
           <p:cNvPr id="4" name="Title">
             <a:extLst xmlns:a="http://schemas.openxmlformats.org/drawingml/2006/main">
               <a:ext uri="{FF2B5EF4-FFF2-40B4-BE49-F238E27FC236}">
-                <a16:creationId xmlns:a16="http://schemas.microsoft.com/office/drawing/2014/main" id="{A05C5A84-E02D-4899-B073-7349CA25A10B}"/>
+                <a16:creationId xmlns:a16="http://schemas.microsoft.com/office/drawing/2014/main" id="{A440D7EE-AFD1-4E82-9163-A560D9952CE9}"/>
               </a:ext>
             </a:extLst>
           </p:cNvPr>
@@ -1482,7 +1482,7 @@
           <p:cNvPr id="2" name="Left column">
             <a:extLst xmlns:a="http://schemas.openxmlformats.org/drawingml/2006/main">
               <a:ext uri="{FF2B5EF4-FFF2-40B4-BE49-F238E27FC236}">
-                <a16:creationId xmlns:a16="http://schemas.microsoft.com/office/drawing/2014/main" id="{C56BC174-9CCD-4251-AE15-6AB6B7BB6ECE}"/>
+                <a16:creationId xmlns:a16="http://schemas.microsoft.com/office/drawing/2014/main" id="{ACD2F858-2D47-4E29-8E4E-26103C1AAD9A}"/>
               </a:ext>
             </a:extLst>
           </p:cNvPr>
@@ -1639,7 +1639,7 @@
           <p:cNvPr id="3" name="Right column">
             <a:extLst xmlns:a="http://schemas.openxmlformats.org/drawingml/2006/main">
               <a:ext uri="{FF2B5EF4-FFF2-40B4-BE49-F238E27FC236}">
-                <a16:creationId xmlns:a16="http://schemas.microsoft.com/office/drawing/2014/main" id="{BA3EBC97-C82E-42F7-8F90-6BA5FE89BDAB}"/>
+                <a16:creationId xmlns:a16="http://schemas.microsoft.com/office/drawing/2014/main" id="{B61D93B1-80B0-49DF-9599-A0DB19857A1D}"/>
               </a:ext>
             </a:extLst>
           </p:cNvPr>
@@ -1813,7 +1813,7 @@
           <p:cNvPr id="3" name="Title">
             <a:extLst xmlns:a="http://schemas.openxmlformats.org/drawingml/2006/main">
               <a:ext uri="{FF2B5EF4-FFF2-40B4-BE49-F238E27FC236}">
-                <a16:creationId xmlns:a16="http://schemas.microsoft.com/office/drawing/2014/main" id="{222EA17B-ACC9-4B1D-9FFA-AC1C094FF760}"/>
+                <a16:creationId xmlns:a16="http://schemas.microsoft.com/office/drawing/2014/main" id="{7F44DFE3-DAF9-4DE6-9B54-B21F62016ABD}"/>
               </a:ext>
             </a:extLst>
           </p:cNvPr>
@@ -1970,7 +1970,7 @@
           <p:cNvPr id="2" name="Left column">
             <a:extLst xmlns:a="http://schemas.openxmlformats.org/drawingml/2006/main">
               <a:ext uri="{FF2B5EF4-FFF2-40B4-BE49-F238E27FC236}">
-                <a16:creationId xmlns:a16="http://schemas.microsoft.com/office/drawing/2014/main" id="{4F449F82-FF4A-4DDA-8202-2A38B4F4FFE8}"/>
+                <a16:creationId xmlns:a16="http://schemas.microsoft.com/office/drawing/2014/main" id="{90350097-BA1C-4BAA-A102-E2B244F84659}"/>
               </a:ext>
             </a:extLst>
           </p:cNvPr>
@@ -2165,12 +2165,12 @@
   </p:cSld>
   <p:clrMap bg1="lt1" tx1="dk1" bg2="lt2" tx2="dk2" accent1="accent1" accent2="accent2" accent3="accent3" accent4="accent4" accent5="accent5" accent6="accent6" hlink="hlink" folHlink="folHlink"/>
   <p:sldLayoutIdLst>
-    <p:sldLayoutId xmlns:r="http://schemas.openxmlformats.org/officeDocument/2006/relationships" id="2147483649" r:id="R4dda2c8629464ceb"/>
-    <p:sldLayoutId xmlns:r="http://schemas.openxmlformats.org/officeDocument/2006/relationships" id="2147483650" r:id="Rc74016f17898430f"/>
-    <p:sldLayoutId xmlns:r="http://schemas.openxmlformats.org/officeDocument/2006/relationships" id="2147483651" r:id="R59a69b171cb249d6"/>
-    <p:sldLayoutId xmlns:r="http://schemas.openxmlformats.org/officeDocument/2006/relationships" id="2147483652" r:id="R3b4877f22e024747"/>
-    <p:sldLayoutId xmlns:r="http://schemas.openxmlformats.org/officeDocument/2006/relationships" id="2147483653" r:id="Rb034b9c1f4d7491b"/>
-    <p:sldLayoutId xmlns:r="http://schemas.openxmlformats.org/officeDocument/2006/relationships" id="2147483654" r:id="R6cf200f9030741e4"/>
+    <p:sldLayoutId xmlns:r="http://schemas.openxmlformats.org/officeDocument/2006/relationships" id="2147483649" r:id="R46621acff3aa45c8"/>
+    <p:sldLayoutId xmlns:r="http://schemas.openxmlformats.org/officeDocument/2006/relationships" id="2147483650" r:id="Rd3103928456442b8"/>
+    <p:sldLayoutId xmlns:r="http://schemas.openxmlformats.org/officeDocument/2006/relationships" id="2147483651" r:id="R7f58072bf63f4eb2"/>
+    <p:sldLayoutId xmlns:r="http://schemas.openxmlformats.org/officeDocument/2006/relationships" id="2147483652" r:id="R812c19e0fc884bcb"/>
+    <p:sldLayoutId xmlns:r="http://schemas.openxmlformats.org/officeDocument/2006/relationships" id="2147483653" r:id="R3bb9fbb170bb4392"/>
+    <p:sldLayoutId xmlns:r="http://schemas.openxmlformats.org/officeDocument/2006/relationships" id="2147483654" r:id="R0a99c1cfc6ed4364"/>
   </p:sldLayoutIdLst>
   <p:txStyles>
     <p:titleStyle>
@@ -2718,10 +2718,10 @@
       </p:grpSpPr>
       <p:sp>
         <p:nvSpPr>
-          <p:cNvPr id="70" name="">
+          <p:cNvPr id="72" name="">
             <a:extLst xmlns:a="http://schemas.openxmlformats.org/drawingml/2006/main">
               <a:ext uri="{FF2B5EF4-FFF2-40B4-BE49-F238E27FC236}">
-                <a16:creationId xmlns:a16="http://schemas.microsoft.com/office/drawing/2014/main" id="{D35823C3-23EA-486F-A14C-FF18F9FC54E0}"/>
+                <a16:creationId xmlns:a16="http://schemas.microsoft.com/office/drawing/2014/main" id="{D4CFD0F9-6A59-4FB8-8ED9-1317988689C6}"/>
               </a:ext>
             </a:extLst>
           </p:cNvPr>
@@ -2752,7 +2752,7 @@
           <p:cNvPr id="2" name="한국어 질의로 영어 학술·기술 문서를 검색하는">
             <a:extLst xmlns:a="http://schemas.openxmlformats.org/drawingml/2006/main">
               <a:ext uri="{FF2B5EF4-FFF2-40B4-BE49-F238E27FC236}">
-                <a16:creationId xmlns:a16="http://schemas.microsoft.com/office/drawing/2014/main" id="{EC04968A-A661-41B5-97E0-DBC56404D650}"/>
+                <a16:creationId xmlns:a16="http://schemas.microsoft.com/office/drawing/2014/main" id="{414E6030-85A1-4EE5-83A0-EA678FCA0F17}"/>
               </a:ext>
             </a:extLst>
           </p:cNvPr>
@@ -2820,7 +2820,7 @@
           <p:cNvPr id="3" name="RAG에서의 HyDE·CAD·SCD 조합 실험">
             <a:extLst xmlns:a="http://schemas.openxmlformats.org/drawingml/2006/main">
               <a:ext uri="{FF2B5EF4-FFF2-40B4-BE49-F238E27FC236}">
-                <a16:creationId xmlns:a16="http://schemas.microsoft.com/office/drawing/2014/main" id="{F446C877-BCE2-41A9-A986-BC8E96DCDA61}"/>
+                <a16:creationId xmlns:a16="http://schemas.microsoft.com/office/drawing/2014/main" id="{96C305DE-F25A-43E5-8AA7-5D6CA2EBC169}"/>
               </a:ext>
             </a:extLst>
           </p:cNvPr>
@@ -2888,7 +2888,7 @@
           <p:cNvPr id="4" name="문종건 · 동국대학교 WISE캠퍼스 컴퓨터공학과 · 지도교수 김진석 · 2026.10.15">
             <a:extLst xmlns:a="http://schemas.openxmlformats.org/drawingml/2006/main">
               <a:ext uri="{FF2B5EF4-FFF2-40B4-BE49-F238E27FC236}">
-                <a16:creationId xmlns:a16="http://schemas.microsoft.com/office/drawing/2014/main" id="{4DCDC5CB-A832-4692-8720-66DA532565B7}"/>
+                <a16:creationId xmlns:a16="http://schemas.microsoft.com/office/drawing/2014/main" id="{99569B2E-80F7-40EB-A2BB-48CEBAF00D5C}"/>
               </a:ext>
             </a:extLst>
           </p:cNvPr>
@@ -2956,7 +2956,7 @@
           <p:cNvPr id="5" name="">
             <a:extLst xmlns:a="http://schemas.openxmlformats.org/drawingml/2006/main">
               <a:ext uri="{FF2B5EF4-FFF2-40B4-BE49-F238E27FC236}">
-                <a16:creationId xmlns:a16="http://schemas.microsoft.com/office/drawing/2014/main" id="{C91C276D-D979-4B92-B732-77454A6CDC01}"/>
+                <a16:creationId xmlns:a16="http://schemas.microsoft.com/office/drawing/2014/main" id="{253BF2B0-4536-4FD7-9A5E-F7DAEA3A6117}"/>
               </a:ext>
             </a:extLst>
           </p:cNvPr>
@@ -2987,7 +2987,7 @@
           <p:cNvPr id="6" name="01 연구 배경과 목적">
             <a:extLst xmlns:a="http://schemas.openxmlformats.org/drawingml/2006/main">
               <a:ext uri="{FF2B5EF4-FFF2-40B4-BE49-F238E27FC236}">
-                <a16:creationId xmlns:a16="http://schemas.microsoft.com/office/drawing/2014/main" id="{3FB551B7-90E5-49FC-A63E-81C6C6F5E81A}"/>
+                <a16:creationId xmlns:a16="http://schemas.microsoft.com/office/drawing/2014/main" id="{AC3BC1F2-5A93-46C5-A2FF-F82551289918}"/>
               </a:ext>
             </a:extLst>
           </p:cNvPr>
@@ -3052,10 +3052,10 @@
       </p:sp>
       <p:sp>
         <p:nvSpPr>
-          <p:cNvPr id="7" name="RAG는 질문과 관련된 문서 구간을 검색하고, 그 텍스트를 생성 모델에 제공해 답변을 만든다[1].">
+          <p:cNvPr id="7" name="검색 증강 생성(Retrieval-Augmented Generation, RAG)은 관련 문서 구간을 검색하고 그 텍">
             <a:extLst xmlns:a="http://schemas.openxmlformats.org/drawingml/2006/main">
               <a:ext uri="{FF2B5EF4-FFF2-40B4-BE49-F238E27FC236}">
-                <a16:creationId xmlns:a16="http://schemas.microsoft.com/office/drawing/2014/main" id="{517D2337-F1C6-4E16-9927-400AE51A10F9}"/>
+                <a16:creationId xmlns:a16="http://schemas.microsoft.com/office/drawing/2014/main" id="{9A929349-2D11-4E58-B171-02764181B38F}"/>
               </a:ext>
             </a:extLst>
           </p:cNvPr>
@@ -3113,7 +3113,7 @@
                 <a:ea typeface="Malgun Gothic"/>
                 <a:cs typeface="Malgun Gothic"/>
               </a:rPr>
-              <a:t>RAG는 질문과 관련된 문서 구간을 검색하고,</a:t>
+              <a:t>검색 증강 생성(Retrieval-Augmented Generation, RAG)은</a:t>
             </a:r>
           </a:p>
           <a:p xmlns:a="http://schemas.openxmlformats.org/drawingml/2006/main">
@@ -3136,17 +3136,17 @@
                 <a:ea typeface="Malgun Gothic"/>
                 <a:cs typeface="Malgun Gothic"/>
               </a:rPr>
-              <a:t>그 텍스트를 생성 모델에 제공해 답변을 만든다[1].</a:t>
+              <a:t>관련 문서 구간을 검색하고 그 텍스트로 답변을 생성한다[1].</a:t>
             </a:r>
           </a:p>
         </p:txBody>
       </p:sp>
       <p:sp>
         <p:nvSpPr>
-          <p:cNvPr id="8" name="HyDE: Hypothetical Document Embeddings[2] CAD: Context-Aware Deco">
+          <p:cNvPr id="8" name="HyDE(Hypothetical Document Embeddings): 가상 문서 검색[2] CAD(Context-A">
             <a:extLst xmlns:a="http://schemas.openxmlformats.org/drawingml/2006/main">
               <a:ext uri="{FF2B5EF4-FFF2-40B4-BE49-F238E27FC236}">
-                <a16:creationId xmlns:a16="http://schemas.microsoft.com/office/drawing/2014/main" id="{DECE8374-0FED-430E-95AB-2AD96C09C731}"/>
+                <a16:creationId xmlns:a16="http://schemas.microsoft.com/office/drawing/2014/main" id="{7B2AF846-F4B6-46DC-A435-2771E68310D7}"/>
               </a:ext>
             </a:extLst>
           </p:cNvPr>
@@ -3204,7 +3204,7 @@
                 <a:ea typeface="Malgun Gothic"/>
                 <a:cs typeface="Malgun Gothic"/>
               </a:rPr>
-              <a:t>HyDE: Hypothetical Document Embeddings[2]</a:t>
+              <a:t>HyDE(Hypothetical Document Embeddings): 가상 문서 검색[2]</a:t>
             </a:r>
           </a:p>
           <a:p xmlns:a="http://schemas.openxmlformats.org/drawingml/2006/main">
@@ -3227,7 +3227,7 @@
                 <a:ea typeface="Malgun Gothic"/>
                 <a:cs typeface="Malgun Gothic"/>
               </a:rPr>
-              <a:t>CAD: Context-Aware Decoding[3]</a:t>
+              <a:t>CAD(Context-Aware Decoding): 검색 근거의 영향 조정[3]</a:t>
             </a:r>
           </a:p>
           <a:p xmlns:a="http://schemas.openxmlformats.org/drawingml/2006/main">
@@ -3250,17 +3250,17 @@
                 <a:ea typeface="Malgun Gothic"/>
                 <a:cs typeface="Malgun Gothic"/>
               </a:rPr>
-              <a:t>SCD: Soft Constrained Decoding[4]</a:t>
+              <a:t>SCD(Soft Constrained Decoding): 출력 언어 제어[4]</a:t>
             </a:r>
           </a:p>
         </p:txBody>
       </p:sp>
       <p:sp>
         <p:nvSpPr>
-          <p:cNvPr id="9" name="본 연구는 한국어 질의로 영어 문서를 검색하는 RAG에서 검색 결과, 답변의 근거 충실도 및 출력 언어를 평가한다. ">
+          <p:cNvPr id="9" name="한국어 질문에 맞는 영어 근거를 찾고 한국어로 답변하는 과정에서는 검색 관련성과 근거 활용·출력 언어를 함께 평가할 ">
             <a:extLst xmlns:a="http://schemas.openxmlformats.org/drawingml/2006/main">
               <a:ext uri="{FF2B5EF4-FFF2-40B4-BE49-F238E27FC236}">
-                <a16:creationId xmlns:a16="http://schemas.microsoft.com/office/drawing/2014/main" id="{60ECDB5A-7CE7-4515-BF78-448231C7F4EC}"/>
+                <a16:creationId xmlns:a16="http://schemas.microsoft.com/office/drawing/2014/main" id="{5AA53F97-31E4-4F23-A372-1411F5AA103D}"/>
               </a:ext>
             </a:extLst>
           </p:cNvPr>
@@ -3272,7 +3272,7 @@
         <p:spPr>
           <a:xfrm xmlns:a="http://schemas.openxmlformats.org/drawingml/2006/main">
             <a:off x="704850" y="6038850"/>
-            <a:ext cx="9729975" cy="1000125"/>
+            <a:ext cx="9729975" cy="1219200"/>
           </a:xfrm>
           <a:prstGeom xmlns:a="http://schemas.openxmlformats.org/drawingml/2006/main" prst="rect">
             <a:avLst/>
@@ -3318,7 +3318,7 @@
                 <a:ea typeface="Malgun Gothic"/>
                 <a:cs typeface="Malgun Gothic"/>
               </a:rPr>
-              <a:t>본 연구는 한국어 질의로 영어 문서를 검색하는 RAG에서</a:t>
+              <a:t>한국어 질문에 맞는 영어 근거를 찾고 한국어로 답변하는</a:t>
             </a:r>
           </a:p>
           <a:p xmlns:a="http://schemas.openxmlformats.org/drawingml/2006/main">
@@ -3341,7 +3341,7 @@
                 <a:ea typeface="Malgun Gothic"/>
                 <a:cs typeface="Malgun Gothic"/>
               </a:rPr>
-              <a:t>검색 결과, 답변의 근거 충실도 및 출력 언어를 평가한다.</a:t>
+              <a:t>과정에서는 검색 관련성과 근거 활용·출력 언어를 함께</a:t>
             </a:r>
           </a:p>
           <a:p xmlns:a="http://schemas.openxmlformats.org/drawingml/2006/main">
@@ -3364,7 +3364,30 @@
                 <a:ea typeface="Malgun Gothic"/>
                 <a:cs typeface="Malgun Gothic"/>
               </a:rPr>
-              <a:t>같은 파이프라인에서 세 기법의 8개 조합을 비교한다.</a:t>
+              <a:t>평가할 필요가 있다. 본 연구는 같은 파이프라인에서</a:t>
+            </a:r>
+          </a:p>
+          <a:p xmlns:a="http://schemas.openxmlformats.org/drawingml/2006/main">
+            <a:pPr algn="l">
+              <a:defRPr sz="1800" b="1">
+                <a:solidFill>
+                  <a:srgbClr val="24324A"/>
+                </a:solidFill>
+                <a:latin typeface="Malgun Gothic"/>
+                <a:ea typeface="Malgun Gothic"/>
+                <a:cs typeface="Malgun Gothic"/>
+              </a:defRPr>
+            </a:pPr>
+            <a:r>
+              <a:rPr sz="1800" b="1">
+                <a:solidFill>
+                  <a:srgbClr val="24324A"/>
+                </a:solidFill>
+                <a:latin typeface="Malgun Gothic"/>
+                <a:ea typeface="Malgun Gothic"/>
+                <a:cs typeface="Malgun Gothic"/>
+              </a:rPr>
+              <a:t>세 기법의 적용 여부와 조합에 따른 결과를 비교한다.</a:t>
             </a:r>
           </a:p>
         </p:txBody>
@@ -3374,7 +3397,7 @@
           <p:cNvPr id="10" name="">
             <a:extLst xmlns:a="http://schemas.openxmlformats.org/drawingml/2006/main">
               <a:ext uri="{FF2B5EF4-FFF2-40B4-BE49-F238E27FC236}">
-                <a16:creationId xmlns:a16="http://schemas.microsoft.com/office/drawing/2014/main" id="{2C9F2623-5C6A-47A8-A02A-5852CA938A1A}"/>
+                <a16:creationId xmlns:a16="http://schemas.microsoft.com/office/drawing/2014/main" id="{4E19A4DE-40FC-46B6-BD73-6BA342D735C0}"/>
               </a:ext>
             </a:extLst>
           </p:cNvPr>
@@ -3405,7 +3428,7 @@
           <p:cNvPr id="11" name="02 Paper-RAG 구조와 기법 적용 위치">
             <a:extLst xmlns:a="http://schemas.openxmlformats.org/drawingml/2006/main">
               <a:ext uri="{FF2B5EF4-FFF2-40B4-BE49-F238E27FC236}">
-                <a16:creationId xmlns:a16="http://schemas.microsoft.com/office/drawing/2014/main" id="{831A511A-EBAF-4552-8060-1250B8897B84}"/>
+                <a16:creationId xmlns:a16="http://schemas.microsoft.com/office/drawing/2014/main" id="{8EFC967C-9332-43ED-9C7D-F9282239C933}"/>
               </a:ext>
             </a:extLst>
           </p:cNvPr>
@@ -3473,7 +3496,7 @@
           <p:cNvPr id="12" name="Paper-RAG는 본 연구의 고정 검색·생성 파이프라인이다.">
             <a:extLst xmlns:a="http://schemas.openxmlformats.org/drawingml/2006/main">
               <a:ext uri="{FF2B5EF4-FFF2-40B4-BE49-F238E27FC236}">
-                <a16:creationId xmlns:a16="http://schemas.microsoft.com/office/drawing/2014/main" id="{3E012770-4A2F-4642-A875-47E36DBFA26E}"/>
+                <a16:creationId xmlns:a16="http://schemas.microsoft.com/office/drawing/2014/main" id="{230E6C4D-C7F1-4F53-B47F-77EE654CA3D2}"/>
               </a:ext>
             </a:extLst>
           </p:cNvPr>
@@ -3541,7 +3564,7 @@
           <p:cNvPr id="13" name="">
             <a:extLst xmlns:a="http://schemas.openxmlformats.org/drawingml/2006/main">
               <a:ext uri="{FF2B5EF4-FFF2-40B4-BE49-F238E27FC236}">
-                <a16:creationId xmlns:a16="http://schemas.microsoft.com/office/drawing/2014/main" id="{633824F8-68EE-479D-AFCE-1BD54F4C00BA}"/>
+                <a16:creationId xmlns:a16="http://schemas.microsoft.com/office/drawing/2014/main" id="{8E08C655-605A-418C-96EC-E19917C45727}"/>
               </a:ext>
             </a:extLst>
           </p:cNvPr>
@@ -3574,7 +3597,7 @@
           <p:cNvPr id="14" name="한국어 질의 HyDE OFF: 원질의 HyDE ON: 영어 번역·가상 문서">
             <a:extLst xmlns:a="http://schemas.openxmlformats.org/drawingml/2006/main">
               <a:ext uri="{FF2B5EF4-FFF2-40B4-BE49-F238E27FC236}">
-                <a16:creationId xmlns:a16="http://schemas.microsoft.com/office/drawing/2014/main" id="{C543CEB6-22AE-4AB7-8E39-E239E36A5BB5}"/>
+                <a16:creationId xmlns:a16="http://schemas.microsoft.com/office/drawing/2014/main" id="{AFE4F61E-41E3-408A-AB8C-614B5B435CA2}"/>
               </a:ext>
             </a:extLst>
           </p:cNvPr>
@@ -3688,7 +3711,7 @@
           <p:cNvPr id="15" name="">
             <a:extLst xmlns:a="http://schemas.openxmlformats.org/drawingml/2006/main">
               <a:ext uri="{FF2B5EF4-FFF2-40B4-BE49-F238E27FC236}">
-                <a16:creationId xmlns:a16="http://schemas.microsoft.com/office/drawing/2014/main" id="{88A59CB5-7758-4951-A4CA-8D2264BB2C9C}"/>
+                <a16:creationId xmlns:a16="http://schemas.microsoft.com/office/drawing/2014/main" id="{32BA3CC5-9865-43A6-8D6A-1D34CFC52EDB}"/>
               </a:ext>
             </a:extLst>
           </p:cNvPr>
@@ -3721,7 +3744,7 @@
           <p:cNvPr id="16" name="BM25 희소 검색[6] 한국어 원질의 사용">
             <a:extLst xmlns:a="http://schemas.openxmlformats.org/drawingml/2006/main">
               <a:ext uri="{FF2B5EF4-FFF2-40B4-BE49-F238E27FC236}">
-                <a16:creationId xmlns:a16="http://schemas.microsoft.com/office/drawing/2014/main" id="{A77C4F8B-7DA6-49F3-8FAC-00F5273300E2}"/>
+                <a16:creationId xmlns:a16="http://schemas.microsoft.com/office/drawing/2014/main" id="{720E7D7B-8A6D-4714-8D55-7E990D8A8EED}"/>
               </a:ext>
             </a:extLst>
           </p:cNvPr>
@@ -3812,7 +3835,7 @@
           <p:cNvPr id="17" name="">
             <a:extLst xmlns:a="http://schemas.openxmlformats.org/drawingml/2006/main">
               <a:ext uri="{FF2B5EF4-FFF2-40B4-BE49-F238E27FC236}">
-                <a16:creationId xmlns:a16="http://schemas.microsoft.com/office/drawing/2014/main" id="{7ADEDB0E-41D7-449B-83C9-78C45206F615}"/>
+                <a16:creationId xmlns:a16="http://schemas.microsoft.com/office/drawing/2014/main" id="{7B5D37E8-E90C-4ED4-BBFF-28C96FEA3D39}"/>
               </a:ext>
             </a:extLst>
           </p:cNvPr>
@@ -3845,7 +3868,7 @@
           <p:cNvPr id="18" name="BGE-M3 밀집 검색[5]">
             <a:extLst xmlns:a="http://schemas.openxmlformats.org/drawingml/2006/main">
               <a:ext uri="{FF2B5EF4-FFF2-40B4-BE49-F238E27FC236}">
-                <a16:creationId xmlns:a16="http://schemas.microsoft.com/office/drawing/2014/main" id="{5D1E9E6D-5626-4A39-97D8-29CF6003D2A7}"/>
+                <a16:creationId xmlns:a16="http://schemas.microsoft.com/office/drawing/2014/main" id="{EF8E0E64-9451-4905-9C8E-7980447E52EA}"/>
               </a:ext>
             </a:extLst>
           </p:cNvPr>
@@ -3913,7 +3936,7 @@
           <p:cNvPr id="19" name="">
             <a:extLst xmlns:a="http://schemas.openxmlformats.org/drawingml/2006/main">
               <a:ext uri="{FF2B5EF4-FFF2-40B4-BE49-F238E27FC236}">
-                <a16:creationId xmlns:a16="http://schemas.microsoft.com/office/drawing/2014/main" id="{5266FDBD-685C-4542-928C-F6787244D3EE}"/>
+                <a16:creationId xmlns:a16="http://schemas.microsoft.com/office/drawing/2014/main" id="{D82A6468-7B39-4348-BE2C-91E8B8D476F8}"/>
               </a:ext>
             </a:extLst>
           </p:cNvPr>
@@ -3946,7 +3969,7 @@
           <p:cNvPr id="20" name="가중 RRF[7] 0.6 / 0.4, k=60">
             <a:extLst xmlns:a="http://schemas.openxmlformats.org/drawingml/2006/main">
               <a:ext uri="{FF2B5EF4-FFF2-40B4-BE49-F238E27FC236}">
-                <a16:creationId xmlns:a16="http://schemas.microsoft.com/office/drawing/2014/main" id="{D0421307-ED85-4229-9A2D-3D7C4663E28D}"/>
+                <a16:creationId xmlns:a16="http://schemas.microsoft.com/office/drawing/2014/main" id="{71F74FE8-7D44-4B69-9DB8-991105B62EC3}"/>
               </a:ext>
             </a:extLst>
           </p:cNvPr>
@@ -4037,7 +4060,7 @@
           <p:cNvPr id="21" name="">
             <a:extLst xmlns:a="http://schemas.openxmlformats.org/drawingml/2006/main">
               <a:ext uri="{FF2B5EF4-FFF2-40B4-BE49-F238E27FC236}">
-                <a16:creationId xmlns:a16="http://schemas.microsoft.com/office/drawing/2014/main" id="{D6415A48-CEDF-403D-B838-4D6EEE983967}"/>
+                <a16:creationId xmlns:a16="http://schemas.microsoft.com/office/drawing/2014/main" id="{75BA7326-1670-409B-BDEC-8A1981264671}"/>
               </a:ext>
             </a:extLst>
           </p:cNvPr>
@@ -4069,7 +4092,7 @@
           <p:cNvPr id="22" name="">
             <a:extLst xmlns:a="http://schemas.openxmlformats.org/drawingml/2006/main">
               <a:ext uri="{FF2B5EF4-FFF2-40B4-BE49-F238E27FC236}">
-                <a16:creationId xmlns:a16="http://schemas.microsoft.com/office/drawing/2014/main" id="{0D8872F7-8A69-483B-8C90-0E2720D8E609}"/>
+                <a16:creationId xmlns:a16="http://schemas.microsoft.com/office/drawing/2014/main" id="{5C51D29E-9C19-4E42-98FA-E0F0949EB7AF}"/>
               </a:ext>
             </a:extLst>
           </p:cNvPr>
@@ -4101,7 +4124,7 @@
           <p:cNvPr id="23" name="">
             <a:extLst xmlns:a="http://schemas.openxmlformats.org/drawingml/2006/main">
               <a:ext uri="{FF2B5EF4-FFF2-40B4-BE49-F238E27FC236}">
-                <a16:creationId xmlns:a16="http://schemas.microsoft.com/office/drawing/2014/main" id="{2A77BF00-3B43-4235-85DA-6EC1DA68E662}"/>
+                <a16:creationId xmlns:a16="http://schemas.microsoft.com/office/drawing/2014/main" id="{D98D7584-7D06-4D7C-A98F-CC35AD3D7912}"/>
               </a:ext>
             </a:extLst>
           </p:cNvPr>
@@ -4133,7 +4156,7 @@
           <p:cNvPr id="24" name="">
             <a:extLst xmlns:a="http://schemas.openxmlformats.org/drawingml/2006/main">
               <a:ext uri="{FF2B5EF4-FFF2-40B4-BE49-F238E27FC236}">
-                <a16:creationId xmlns:a16="http://schemas.microsoft.com/office/drawing/2014/main" id="{13CCD39A-D53C-4D2B-89B2-53B8563B12CC}"/>
+                <a16:creationId xmlns:a16="http://schemas.microsoft.com/office/drawing/2014/main" id="{B96C25D6-C7CC-44C4-9F1A-61F5C143F74D}"/>
               </a:ext>
             </a:extLst>
           </p:cNvPr>
@@ -4166,7 +4189,7 @@
           <p:cNvPr id="25" name="원질의 기반 CrossEncoder 재정렬[8] 상위 5개 구간 선택·문맥 길이 관리">
             <a:extLst xmlns:a="http://schemas.openxmlformats.org/drawingml/2006/main">
               <a:ext uri="{FF2B5EF4-FFF2-40B4-BE49-F238E27FC236}">
-                <a16:creationId xmlns:a16="http://schemas.microsoft.com/office/drawing/2014/main" id="{20D7C720-0DBA-4A27-B83E-5DDC97C39D4C}"/>
+                <a16:creationId xmlns:a16="http://schemas.microsoft.com/office/drawing/2014/main" id="{8A6ED402-ADE3-4E8D-98EB-389D05827471}"/>
               </a:ext>
             </a:extLst>
           </p:cNvPr>
@@ -4257,7 +4280,7 @@
           <p:cNvPr id="26" name="">
             <a:extLst xmlns:a="http://schemas.openxmlformats.org/drawingml/2006/main">
               <a:ext uri="{FF2B5EF4-FFF2-40B4-BE49-F238E27FC236}">
-                <a16:creationId xmlns:a16="http://schemas.microsoft.com/office/drawing/2014/main" id="{BC0B20FC-CF7A-4558-8780-ABD3853C1490}"/>
+                <a16:creationId xmlns:a16="http://schemas.microsoft.com/office/drawing/2014/main" id="{2A8934DE-3E6B-4F63-9A47-52D0F78FEF01}"/>
               </a:ext>
             </a:extLst>
           </p:cNvPr>
@@ -4290,7 +4313,7 @@
           <p:cNvPr id="27" name="Mi:dm 2.0 Base Instruct[18] CAD 로짓 결합 후 SCD 언어별 조정, 최종 답변 생성">
             <a:extLst xmlns:a="http://schemas.openxmlformats.org/drawingml/2006/main">
               <a:ext uri="{FF2B5EF4-FFF2-40B4-BE49-F238E27FC236}">
-                <a16:creationId xmlns:a16="http://schemas.microsoft.com/office/drawing/2014/main" id="{4DD244D3-FFEC-4C11-9459-61E9AA1EC77D}"/>
+                <a16:creationId xmlns:a16="http://schemas.microsoft.com/office/drawing/2014/main" id="{3BFFBBA9-1563-4914-8152-37EF5D7265B7}"/>
               </a:ext>
             </a:extLst>
           </p:cNvPr>
@@ -4381,7 +4404,7 @@
           <p:cNvPr id="28" name="">
             <a:extLst xmlns:a="http://schemas.openxmlformats.org/drawingml/2006/main">
               <a:ext uri="{FF2B5EF4-FFF2-40B4-BE49-F238E27FC236}">
-                <a16:creationId xmlns:a16="http://schemas.microsoft.com/office/drawing/2014/main" id="{5287C08F-CA51-4B67-84C1-DB65E881F735}"/>
+                <a16:creationId xmlns:a16="http://schemas.microsoft.com/office/drawing/2014/main" id="{CECA8F4E-FFD1-46AD-BF44-1C4DE2DD352D}"/>
               </a:ext>
             </a:extLst>
           </p:cNvPr>
@@ -4413,7 +4436,7 @@
           <p:cNvPr id="29" name="">
             <a:extLst xmlns:a="http://schemas.openxmlformats.org/drawingml/2006/main">
               <a:ext uri="{FF2B5EF4-FFF2-40B4-BE49-F238E27FC236}">
-                <a16:creationId xmlns:a16="http://schemas.microsoft.com/office/drawing/2014/main" id="{05BA7CDF-A363-4422-838B-76BBF79D8CF9}"/>
+                <a16:creationId xmlns:a16="http://schemas.microsoft.com/office/drawing/2014/main" id="{35412CEA-F558-4C19-A845-67A96B697C25}"/>
               </a:ext>
             </a:extLst>
           </p:cNvPr>
@@ -4445,7 +4468,7 @@
           <p:cNvPr id="30" name="">
             <a:extLst xmlns:a="http://schemas.openxmlformats.org/drawingml/2006/main">
               <a:ext uri="{FF2B5EF4-FFF2-40B4-BE49-F238E27FC236}">
-                <a16:creationId xmlns:a16="http://schemas.microsoft.com/office/drawing/2014/main" id="{80C4BD57-677B-4F56-BE98-11E7AA069625}"/>
+                <a16:creationId xmlns:a16="http://schemas.microsoft.com/office/drawing/2014/main" id="{1BA44F59-6A52-4CC5-897F-E928555663CB}"/>
               </a:ext>
             </a:extLst>
           </p:cNvPr>
@@ -4476,7 +4499,7 @@
           <p:cNvPr id="31" name="03 3요인 완전요인 실험 설계">
             <a:extLst xmlns:a="http://schemas.openxmlformats.org/drawingml/2006/main">
               <a:ext uri="{FF2B5EF4-FFF2-40B4-BE49-F238E27FC236}">
-                <a16:creationId xmlns:a16="http://schemas.microsoft.com/office/drawing/2014/main" id="{F5ABF092-2403-4197-9FB5-53C7E38664DA}"/>
+                <a16:creationId xmlns:a16="http://schemas.microsoft.com/office/drawing/2014/main" id="{B606FEA3-E2C9-4F85-8128-A061054E4E76}"/>
               </a:ext>
             </a:extLst>
           </p:cNvPr>
@@ -4544,7 +4567,7 @@
           <p:cNvPr id="32" name="H=HyDE, C=CAD, S=SCD   0=미적용, 1=적용">
             <a:extLst xmlns:a="http://schemas.openxmlformats.org/drawingml/2006/main">
               <a:ext uri="{FF2B5EF4-FFF2-40B4-BE49-F238E27FC236}">
-                <a16:creationId xmlns:a16="http://schemas.microsoft.com/office/drawing/2014/main" id="{EE1A7A57-A219-4916-871B-09FCE10A1E62}"/>
+                <a16:creationId xmlns:a16="http://schemas.microsoft.com/office/drawing/2014/main" id="{5AF07CB1-4768-4AEF-A4CE-D6396453DDED}"/>
               </a:ext>
             </a:extLst>
           </p:cNvPr>
@@ -4612,7 +4635,7 @@
           <p:cNvPr id="33" name="">
             <a:extLst xmlns:a="http://schemas.openxmlformats.org/drawingml/2006/main">
               <a:ext uri="{FF2B5EF4-FFF2-40B4-BE49-F238E27FC236}">
-                <a16:creationId xmlns:a16="http://schemas.microsoft.com/office/drawing/2014/main" id="{5C5FDABF-B9E4-4A4C-B029-4FB99C8D78E7}"/>
+                <a16:creationId xmlns:a16="http://schemas.microsoft.com/office/drawing/2014/main" id="{0DA121E0-5678-43DC-BD76-5AFD380A4A77}"/>
               </a:ext>
             </a:extLst>
           </p:cNvPr>
@@ -6142,7 +6165,7 @@
           <p:cNvPr id="34" name="영어 문서 4종 × 15개 질의 × 8조건 = 480개 생성 기록">
             <a:extLst xmlns:a="http://schemas.openxmlformats.org/drawingml/2006/main">
               <a:ext uri="{FF2B5EF4-FFF2-40B4-BE49-F238E27FC236}">
-                <a16:creationId xmlns:a16="http://schemas.microsoft.com/office/drawing/2014/main" id="{ADA00431-1B67-4234-898E-B051A2C40230}"/>
+                <a16:creationId xmlns:a16="http://schemas.microsoft.com/office/drawing/2014/main" id="{3303E800-AAF7-499C-98E4-208F49806ABE}"/>
               </a:ext>
             </a:extLst>
           </p:cNvPr>
@@ -6210,7 +6233,7 @@
           <p:cNvPr id="35" name="생성 512토큰, CAD α=0.5, SCD α=1.1·β=0.9·Tstart=5">
             <a:extLst xmlns:a="http://schemas.openxmlformats.org/drawingml/2006/main">
               <a:ext uri="{FF2B5EF4-FFF2-40B4-BE49-F238E27FC236}">
-                <a16:creationId xmlns:a16="http://schemas.microsoft.com/office/drawing/2014/main" id="{0E202563-AE2E-45D3-AB83-16530D35904B}"/>
+                <a16:creationId xmlns:a16="http://schemas.microsoft.com/office/drawing/2014/main" id="{E26896D2-20F6-46D7-B9F8-4880AA0B2A7F}"/>
               </a:ext>
             </a:extLst>
           </p:cNvPr>
@@ -6278,7 +6301,7 @@
           <p:cNvPr id="36" name="문서 요약을 15개 내용 단위로 나누어 질의를 작성하고, 총 60개 질의의 원문 페이지·정답 근거·답변 가능성을 확인">
             <a:extLst xmlns:a="http://schemas.openxmlformats.org/drawingml/2006/main">
               <a:ext uri="{FF2B5EF4-FFF2-40B4-BE49-F238E27FC236}">
-                <a16:creationId xmlns:a16="http://schemas.microsoft.com/office/drawing/2014/main" id="{55883192-2574-4382-9758-16B83518587C}"/>
+                <a16:creationId xmlns:a16="http://schemas.microsoft.com/office/drawing/2014/main" id="{6D56583D-CDF0-4D4C-8AC1-127D0208F063}"/>
               </a:ext>
             </a:extLst>
           </p:cNvPr>
@@ -6369,7 +6392,7 @@
           <p:cNvPr id="37" name="">
             <a:extLst xmlns:a="http://schemas.openxmlformats.org/drawingml/2006/main">
               <a:ext uri="{FF2B5EF4-FFF2-40B4-BE49-F238E27FC236}">
-                <a16:creationId xmlns:a16="http://schemas.microsoft.com/office/drawing/2014/main" id="{FD95D328-7D77-48BC-8842-1081E15193B9}"/>
+                <a16:creationId xmlns:a16="http://schemas.microsoft.com/office/drawing/2014/main" id="{E572C5AB-29F5-4CEA-8A76-ABBC8FA45D27}"/>
               </a:ext>
             </a:extLst>
           </p:cNvPr>
@@ -6400,7 +6423,7 @@
           <p:cNvPr id="38" name="04 평가 지표 및 실험·통계 방법">
             <a:extLst xmlns:a="http://schemas.openxmlformats.org/drawingml/2006/main">
               <a:ext uri="{FF2B5EF4-FFF2-40B4-BE49-F238E27FC236}">
-                <a16:creationId xmlns:a16="http://schemas.microsoft.com/office/drawing/2014/main" id="{E16B6B89-9A2F-4293-ABBD-414E900A639F}"/>
+                <a16:creationId xmlns:a16="http://schemas.microsoft.com/office/drawing/2014/main" id="{93562C60-058A-4342-8268-C54A1E300AF0}"/>
               </a:ext>
             </a:extLst>
           </p:cNvPr>
@@ -6468,7 +6491,7 @@
           <p:cNvPr id="39" name="근거 충실도: 답변 주장 중 검색 근거가 뒷받침하는 비율 답변 관련성: 답변에서 만든 질문과 원질문의 의미 유사도 문">
             <a:extLst xmlns:a="http://schemas.openxmlformats.org/drawingml/2006/main">
               <a:ext uri="{FF2B5EF4-FFF2-40B4-BE49-F238E27FC236}">
-                <a16:creationId xmlns:a16="http://schemas.microsoft.com/office/drawing/2014/main" id="{E56AA116-59F2-4752-AE9E-E61AB08CD624}"/>
+                <a16:creationId xmlns:a16="http://schemas.microsoft.com/office/drawing/2014/main" id="{D0E55636-1319-429C-8C8F-B79DF30B4D5B}"/>
               </a:ext>
             </a:extLst>
           </p:cNvPr>
@@ -6479,8 +6502,8 @@
         </p:nvSpPr>
         <p:spPr>
           <a:xfrm xmlns:a="http://schemas.openxmlformats.org/drawingml/2006/main">
-            <a:off x="704850" y="19726275"/>
-            <a:ext cx="9729975" cy="1524000"/>
+            <a:off x="704850" y="19716750"/>
+            <a:ext cx="9729975" cy="1428750"/>
           </a:xfrm>
           <a:prstGeom xmlns:a="http://schemas.openxmlformats.org/drawingml/2006/main" prst="rect">
             <a:avLst/>
@@ -6625,10 +6648,10 @@
       </p:sp>
       <p:sp>
         <p:nvSpPr>
-          <p:cNvPr id="40" name="높은 품질 점수는 근거 지지·질문 관련성·근거 활용을 뜻한다. 한국어 비율 0.700은 계산 대상 문자 중 한글이 7">
+          <p:cNvPr id="40" name="품질 관측값은 0~1이며, 높은 값은 각 측정 특성이 큼을 뜻한다. 관련성 +0.080은 적용−미적용 평균 대응 점수">
             <a:extLst xmlns:a="http://schemas.openxmlformats.org/drawingml/2006/main">
               <a:ext uri="{FF2B5EF4-FFF2-40B4-BE49-F238E27FC236}">
-                <a16:creationId xmlns:a16="http://schemas.microsoft.com/office/drawing/2014/main" id="{2B4B41E3-B459-4201-BB43-4D4B2573C6A3}"/>
+                <a16:creationId xmlns:a16="http://schemas.microsoft.com/office/drawing/2014/main" id="{1B29D8C8-3291-4B86-B849-4D0D89780C60}"/>
               </a:ext>
             </a:extLst>
           </p:cNvPr>
@@ -6639,8 +6662,8 @@
         </p:nvSpPr>
         <p:spPr>
           <a:xfrm xmlns:a="http://schemas.openxmlformats.org/drawingml/2006/main">
-            <a:off x="704850" y="21374100"/>
-            <a:ext cx="9729975" cy="590550"/>
+            <a:off x="704850" y="21240750"/>
+            <a:ext cx="9729975" cy="857250"/>
           </a:xfrm>
           <a:prstGeom xmlns:a="http://schemas.openxmlformats.org/drawingml/2006/main" prst="rect">
             <a:avLst/>
@@ -6686,7 +6709,7 @@
                 <a:ea typeface="Malgun Gothic"/>
                 <a:cs typeface="Malgun Gothic"/>
               </a:rPr>
-              <a:t>높은 품질 점수는 근거 지지·질문 관련성·근거 활용을 뜻한다.</a:t>
+              <a:t>품질 관측값은 0~1이며, 높은 값은 각 측정 특성이 큼을 뜻한다.</a:t>
             </a:r>
           </a:p>
           <a:p xmlns:a="http://schemas.openxmlformats.org/drawingml/2006/main">
@@ -6709,7 +6732,30 @@
                 <a:ea typeface="Malgun Gothic"/>
                 <a:cs typeface="Malgun Gothic"/>
               </a:rPr>
-              <a:t>한국어 비율 0.700은 계산 대상 문자 중 한글이 70.0%다.</a:t>
+              <a:t>관련성 +0.080은 적용−미적용 평균 대응 점수 차이다.</a:t>
+            </a:r>
+          </a:p>
+          <a:p xmlns:a="http://schemas.openxmlformats.org/drawingml/2006/main">
+            <a:pPr algn="l">
+              <a:defRPr sz="1800" b="0">
+                <a:solidFill>
+                  <a:srgbClr val="24324A"/>
+                </a:solidFill>
+                <a:latin typeface="Malgun Gothic"/>
+                <a:ea typeface="Malgun Gothic"/>
+                <a:cs typeface="Malgun Gothic"/>
+              </a:defRPr>
+            </a:pPr>
+            <a:r>
+              <a:rPr sz="1800" b="0">
+                <a:solidFill>
+                  <a:srgbClr val="24324A"/>
+                </a:solidFill>
+                <a:latin typeface="Malgun Gothic"/>
+                <a:ea typeface="Malgun Gothic"/>
+                <a:cs typeface="Malgun Gothic"/>
+              </a:rPr>
+              <a:t>한국어 비율 0.700은 70.0%, 차이 +0.218은 +21.8%p다.</a:t>
             </a:r>
           </a:p>
         </p:txBody>
@@ -6719,7 +6765,7 @@
           <p:cNvPr id="41" name="평가 예시  ext_raptor_011, H0C0S0">
             <a:extLst xmlns:a="http://schemas.openxmlformats.org/drawingml/2006/main">
               <a:ext uri="{FF2B5EF4-FFF2-40B4-BE49-F238E27FC236}">
-                <a16:creationId xmlns:a16="http://schemas.microsoft.com/office/drawing/2014/main" id="{03A6C5BF-682E-4460-BCA0-11AB3C4F2C91}"/>
+                <a16:creationId xmlns:a16="http://schemas.microsoft.com/office/drawing/2014/main" id="{A8568CF7-B47D-4687-BEA6-2A27D6EABCAF}"/>
               </a:ext>
             </a:extLst>
           </p:cNvPr>
@@ -6730,8 +6776,8 @@
         </p:nvSpPr>
         <p:spPr>
           <a:xfrm xmlns:a="http://schemas.openxmlformats.org/drawingml/2006/main">
-            <a:off x="704850" y="22136100"/>
-            <a:ext cx="9729975" cy="304800"/>
+            <a:off x="704850" y="22155150"/>
+            <a:ext cx="9729975" cy="285750"/>
           </a:xfrm>
           <a:prstGeom xmlns:a="http://schemas.openxmlformats.org/drawingml/2006/main" prst="rect">
             <a:avLst/>
@@ -6787,7 +6833,7 @@
           <p:cNvPr id="42" name="질문: Cinderella 사례의 정성 분석에서 RAPTOR의 tree-based retrieval이 DPR보다 주제">
             <a:extLst xmlns:a="http://schemas.openxmlformats.org/drawingml/2006/main">
               <a:ext uri="{FF2B5EF4-FFF2-40B4-BE49-F238E27FC236}">
-                <a16:creationId xmlns:a16="http://schemas.microsoft.com/office/drawing/2014/main" id="{ECC50F9D-90B1-493C-A108-3B3EB1BE735C}"/>
+                <a16:creationId xmlns:a16="http://schemas.microsoft.com/office/drawing/2014/main" id="{4A8E0F01-D313-4A5C-A6A1-6870A59525DB}"/>
               </a:ext>
             </a:extLst>
           </p:cNvPr>
@@ -6798,8 +6844,8 @@
         </p:nvSpPr>
         <p:spPr>
           <a:xfrm xmlns:a="http://schemas.openxmlformats.org/drawingml/2006/main">
-            <a:off x="704850" y="22526625"/>
-            <a:ext cx="9729975" cy="914400"/>
+            <a:off x="704850" y="22479000"/>
+            <a:ext cx="9729975" cy="857250"/>
           </a:xfrm>
           <a:prstGeom xmlns:a="http://schemas.openxmlformats.org/drawingml/2006/main" prst="rect">
             <a:avLst/>
@@ -6898,10 +6944,10 @@
       </p:sp>
       <p:sp>
         <p:nvSpPr>
-          <p:cNvPr id="43" name="검색 근거(발췌): “within higher-layer summaries” 참조답변(발췌): “The text re">
+          <p:cNvPr id="43" name="근거 발췌: “RAPTOR selects nodes from different layers” 답변 발췌: “질문의 요">
             <a:extLst xmlns:a="http://schemas.openxmlformats.org/drawingml/2006/main">
               <a:ext uri="{FF2B5EF4-FFF2-40B4-BE49-F238E27FC236}">
-                <a16:creationId xmlns:a16="http://schemas.microsoft.com/office/drawing/2014/main" id="{B9EBDAD6-A1BC-4CCC-9D44-13092DB44598}"/>
+                <a16:creationId xmlns:a16="http://schemas.microsoft.com/office/drawing/2014/main" id="{E7371E4D-A2D7-41CF-B322-C6F67FE179AE}"/>
               </a:ext>
             </a:extLst>
           </p:cNvPr>
@@ -6912,8 +6958,8 @@
         </p:nvSpPr>
         <p:spPr>
           <a:xfrm xmlns:a="http://schemas.openxmlformats.org/drawingml/2006/main">
-            <a:off x="704850" y="23517225"/>
-            <a:ext cx="9729975" cy="1219200"/>
+            <a:off x="704850" y="23431500"/>
+            <a:ext cx="9729975" cy="857250"/>
           </a:xfrm>
           <a:prstGeom xmlns:a="http://schemas.openxmlformats.org/drawingml/2006/main" prst="rect">
             <a:avLst/>
@@ -6959,7 +7005,7 @@
                 <a:ea typeface="Malgun Gothic"/>
                 <a:cs typeface="Malgun Gothic"/>
               </a:rPr>
-              <a:t>검색 근거(발췌): “within higher-layer summaries”</a:t>
+              <a:t>근거 발췌: “RAPTOR selects nodes from different layers”</a:t>
             </a:r>
           </a:p>
           <a:p xmlns:a="http://schemas.openxmlformats.org/drawingml/2006/main">
@@ -6982,7 +7028,7 @@
                 <a:ea typeface="Malgun Gothic"/>
                 <a:cs typeface="Malgun Gothic"/>
               </a:rPr>
-              <a:t>참조답변(발췌): “The text retrieved by RAPTOR”</a:t>
+              <a:t>답변 발췌: “질문의 요구사항에 따라 서로 다른</a:t>
             </a:r>
           </a:p>
           <a:p xmlns:a="http://schemas.openxmlformats.org/drawingml/2006/main">
@@ -7005,40 +7051,17 @@
                 <a:ea typeface="Malgun Gothic"/>
                 <a:cs typeface="Malgun Gothic"/>
               </a:rPr>
-              <a:t>생성 답변(발췌): “RAPTOR는 계층적 구조를 통해”</a:t>
-            </a:r>
-          </a:p>
-          <a:p xmlns:a="http://schemas.openxmlformats.org/drawingml/2006/main">
-            <a:pPr algn="l">
-              <a:defRPr sz="1800" b="0">
-                <a:solidFill>
-                  <a:srgbClr val="24324A"/>
-                </a:solidFill>
-                <a:latin typeface="Malgun Gothic"/>
-                <a:ea typeface="Malgun Gothic"/>
-                <a:cs typeface="Malgun Gothic"/>
-              </a:defRPr>
-            </a:pPr>
-            <a:r>
-              <a:rPr sz="1800" b="0">
-                <a:solidFill>
-                  <a:srgbClr val="24324A"/>
-                </a:solidFill>
-                <a:latin typeface="Malgun Gothic"/>
-                <a:ea typeface="Malgun Gothic"/>
-                <a:cs typeface="Malgun Gothic"/>
-              </a:rPr>
-              <a:t>평가: 충실도 1.000, 관련성 0.937</a:t>
+              <a:t>층위(layer)에서 노드를 선택할 수 있습니다.”</a:t>
             </a:r>
           </a:p>
         </p:txBody>
       </p:sp>
       <p:sp>
         <p:nvSpPr>
-          <p:cNvPr id="44" name="평가: RAGAS 0.2.15[10], gpt-4o, BGE-M3 임베딩 S0: 영어 문맥 / S1: 한국어 번역 평">
+          <p:cNvPr id="44" name="충실도 1.000: 평가자가 추출한 주장을 검색 문맥이 지지 관련성 0.937: 답변 기반 질문과 원질문의 평균 의미">
             <a:extLst xmlns:a="http://schemas.openxmlformats.org/drawingml/2006/main">
               <a:ext uri="{FF2B5EF4-FFF2-40B4-BE49-F238E27FC236}">
-                <a16:creationId xmlns:a16="http://schemas.microsoft.com/office/drawing/2014/main" id="{D915AAFD-DCF6-4FC6-964D-55EEADC1A995}"/>
+                <a16:creationId xmlns:a16="http://schemas.microsoft.com/office/drawing/2014/main" id="{0E44ED3F-B60F-4539-8872-68A249E14381}"/>
               </a:ext>
             </a:extLst>
           </p:cNvPr>
@@ -7049,8 +7072,8 @@
         </p:nvSpPr>
         <p:spPr>
           <a:xfrm xmlns:a="http://schemas.openxmlformats.org/drawingml/2006/main">
-            <a:off x="704850" y="24831675"/>
-            <a:ext cx="9729975" cy="904875"/>
+            <a:off x="704850" y="24384000"/>
+            <a:ext cx="9729975" cy="571500"/>
           </a:xfrm>
           <a:prstGeom xmlns:a="http://schemas.openxmlformats.org/drawingml/2006/main" prst="rect">
             <a:avLst/>
@@ -7096,7 +7119,7 @@
                 <a:ea typeface="Malgun Gothic"/>
                 <a:cs typeface="Malgun Gothic"/>
               </a:rPr>
-              <a:t>평가: RAGAS 0.2.15[10], gpt-4o, BGE-M3 임베딩</a:t>
+              <a:t>충실도 1.000: 평가자가 추출한 주장을 검색 문맥이 지지</a:t>
             </a:r>
           </a:p>
           <a:p xmlns:a="http://schemas.openxmlformats.org/drawingml/2006/main">
@@ -7119,40 +7142,17 @@
                 <a:ea typeface="Malgun Gothic"/>
                 <a:cs typeface="Malgun Gothic"/>
               </a:rPr>
-              <a:t>S0: 영어 문맥 / S1: 한국어 번역 평가 문맥</a:t>
-            </a:r>
-          </a:p>
-          <a:p xmlns:a="http://schemas.openxmlformats.org/drawingml/2006/main">
-            <a:pPr algn="l">
-              <a:defRPr sz="1800" b="0">
-                <a:solidFill>
-                  <a:srgbClr val="24324A"/>
-                </a:solidFill>
-                <a:latin typeface="Malgun Gothic"/>
-                <a:ea typeface="Malgun Gothic"/>
-                <a:cs typeface="Malgun Gothic"/>
-              </a:defRPr>
-            </a:pPr>
-            <a:r>
-              <a:rPr sz="1800" b="0">
-                <a:solidFill>
-                  <a:srgbClr val="24324A"/>
-                </a:solidFill>
-                <a:latin typeface="Malgun Gothic"/>
-                <a:ea typeface="Malgun Gothic"/>
-                <a:cs typeface="Malgun Gothic"/>
-              </a:rPr>
-              <a:t>생성에는 영어 문맥 사용, 저장 답변은 그대로 평가</a:t>
+              <a:t>관련성 0.937: 답변 기반 질문과 원질문의 평균 의미 유사도</a:t>
             </a:r>
           </a:p>
         </p:txBody>
       </p:sp>
       <p:sp>
         <p:nvSpPr>
-          <p:cNvPr id="45" name="질의 60개 반복측정, 양측 α=0.05와 Holm 보정 품질: S0·S1별 H×C / 문자 비율·시간: H×C×S ">
+          <p:cNvPr id="45" name="평가: RAGAS 0.2.15[10], gpt-4o, BGE-M3 임베딩 S0: 영어 문맥 / S1: 한국어 번역 평">
             <a:extLst xmlns:a="http://schemas.openxmlformats.org/drawingml/2006/main">
               <a:ext uri="{FF2B5EF4-FFF2-40B4-BE49-F238E27FC236}">
-                <a16:creationId xmlns:a16="http://schemas.microsoft.com/office/drawing/2014/main" id="{6BF1BC4B-B437-4A45-8C45-E8FC7F517435}"/>
+                <a16:creationId xmlns:a16="http://schemas.microsoft.com/office/drawing/2014/main" id="{383B2AFB-0588-4D96-B282-2CFA223686ED}"/>
               </a:ext>
             </a:extLst>
           </p:cNvPr>
@@ -7163,8 +7163,122 @@
         </p:nvSpPr>
         <p:spPr>
           <a:xfrm xmlns:a="http://schemas.openxmlformats.org/drawingml/2006/main">
-            <a:off x="704850" y="25822275"/>
-            <a:ext cx="9729975" cy="914400"/>
+            <a:off x="704850" y="25050750"/>
+            <a:ext cx="9729975" cy="857250"/>
+          </a:xfrm>
+          <a:prstGeom xmlns:a="http://schemas.openxmlformats.org/drawingml/2006/main" prst="rect">
+            <a:avLst/>
+          </a:prstGeom>
+          <a:noFill xmlns:a="http://schemas.openxmlformats.org/drawingml/2006/main"/>
+          <a:ln xmlns:a="http://schemas.openxmlformats.org/drawingml/2006/main" w="0">
+            <a:noFill/>
+          </a:ln>
+        </p:spPr>
+        <p:txBody>
+          <a:bodyPr xmlns:a="http://schemas.openxmlformats.org/drawingml/2006/main" wrap="none" lIns="0" tIns="0" rIns="0" bIns="0" anchor="t">
+            <a:noAutofit/>
+          </a:bodyPr>
+          <a:lstStyle xmlns:a="http://schemas.openxmlformats.org/drawingml/2006/main">
+            <a:defPPr algn="l">
+              <a:defRPr sz="1800" b="0">
+                <a:solidFill>
+                  <a:srgbClr val="24324A"/>
+                </a:solidFill>
+                <a:latin typeface="Malgun Gothic"/>
+                <a:ea typeface="Malgun Gothic"/>
+                <a:cs typeface="Malgun Gothic"/>
+              </a:defRPr>
+            </a:defPPr>
+          </a:lstStyle>
+          <a:p xmlns:a="http://schemas.openxmlformats.org/drawingml/2006/main">
+            <a:pPr algn="l">
+              <a:defRPr sz="1800" b="0">
+                <a:solidFill>
+                  <a:srgbClr val="24324A"/>
+                </a:solidFill>
+                <a:latin typeface="Malgun Gothic"/>
+                <a:ea typeface="Malgun Gothic"/>
+                <a:cs typeface="Malgun Gothic"/>
+              </a:defRPr>
+            </a:pPr>
+            <a:r>
+              <a:rPr sz="1800" b="0">
+                <a:solidFill>
+                  <a:srgbClr val="24324A"/>
+                </a:solidFill>
+                <a:latin typeface="Malgun Gothic"/>
+                <a:ea typeface="Malgun Gothic"/>
+                <a:cs typeface="Malgun Gothic"/>
+              </a:rPr>
+              <a:t>평가: RAGAS 0.2.15[10], gpt-4o, BGE-M3 임베딩</a:t>
+            </a:r>
+          </a:p>
+          <a:p xmlns:a="http://schemas.openxmlformats.org/drawingml/2006/main">
+            <a:pPr algn="l">
+              <a:defRPr sz="1800" b="0">
+                <a:solidFill>
+                  <a:srgbClr val="24324A"/>
+                </a:solidFill>
+                <a:latin typeface="Malgun Gothic"/>
+                <a:ea typeface="Malgun Gothic"/>
+                <a:cs typeface="Malgun Gothic"/>
+              </a:defRPr>
+            </a:pPr>
+            <a:r>
+              <a:rPr sz="1800" b="0">
+                <a:solidFill>
+                  <a:srgbClr val="24324A"/>
+                </a:solidFill>
+                <a:latin typeface="Malgun Gothic"/>
+                <a:ea typeface="Malgun Gothic"/>
+                <a:cs typeface="Malgun Gothic"/>
+              </a:rPr>
+              <a:t>S0: 영어 문맥 / S1: 한국어 번역 평가 문맥</a:t>
+            </a:r>
+          </a:p>
+          <a:p xmlns:a="http://schemas.openxmlformats.org/drawingml/2006/main">
+            <a:pPr algn="l">
+              <a:defRPr sz="1800" b="0">
+                <a:solidFill>
+                  <a:srgbClr val="24324A"/>
+                </a:solidFill>
+                <a:latin typeface="Malgun Gothic"/>
+                <a:ea typeface="Malgun Gothic"/>
+                <a:cs typeface="Malgun Gothic"/>
+              </a:defRPr>
+            </a:pPr>
+            <a:r>
+              <a:rPr sz="1800" b="0">
+                <a:solidFill>
+                  <a:srgbClr val="24324A"/>
+                </a:solidFill>
+                <a:latin typeface="Malgun Gothic"/>
+                <a:ea typeface="Malgun Gothic"/>
+                <a:cs typeface="Malgun Gothic"/>
+              </a:rPr>
+              <a:t>생성에는 영어 문맥 사용, 저장 답변은 그대로 평가</a:t>
+            </a:r>
+          </a:p>
+        </p:txBody>
+      </p:sp>
+      <p:sp>
+        <p:nvSpPr>
+          <p:cNvPr id="46" name="3요인 반복측정 분산분석(ANOVA)·대응 t-검정, Holm·α=0.05 질의 60개, 품질 S별 H×C / 문자 ">
+            <a:extLst xmlns:a="http://schemas.openxmlformats.org/drawingml/2006/main">
+              <a:ext uri="{FF2B5EF4-FFF2-40B4-BE49-F238E27FC236}">
+                <a16:creationId xmlns:a16="http://schemas.microsoft.com/office/drawing/2014/main" id="{7FC14F4B-CC3F-4027-9F13-E2BDF2AFDAB0}"/>
+              </a:ext>
+            </a:extLst>
+          </p:cNvPr>
+          <p:cNvSpPr>
+            <a:spLocks xmlns:a="http://schemas.openxmlformats.org/drawingml/2006/main" noGrp="1"/>
+          </p:cNvSpPr>
+          <p:nvPr/>
+        </p:nvSpPr>
+        <p:spPr>
+          <a:xfrm xmlns:a="http://schemas.openxmlformats.org/drawingml/2006/main">
+            <a:off x="704850" y="26003250"/>
+            <a:ext cx="9729975" cy="857250"/>
           </a:xfrm>
           <a:prstGeom xmlns:a="http://schemas.openxmlformats.org/drawingml/2006/main" prst="rect">
             <a:avLst/>
@@ -7210,7 +7324,7 @@
                 <a:ea typeface="Malgun Gothic"/>
                 <a:cs typeface="Malgun Gothic"/>
               </a:rPr>
-              <a:t>질의 60개 반복측정, 양측 α=0.05와 Holm 보정</a:t>
+              <a:t>3요인 반복측정 분산분석(ANOVA)·대응 t-검정, Holm·α=0.05</a:t>
             </a:r>
           </a:p>
           <a:p xmlns:a="http://schemas.openxmlformats.org/drawingml/2006/main">
@@ -7233,7 +7347,7 @@
                 <a:ea typeface="Malgun Gothic"/>
                 <a:cs typeface="Malgun Gothic"/>
               </a:rPr>
-              <a:t>품질: S0·S1별 H×C / 문자 비율·시간: H×C×S</a:t>
+              <a:t>질의 60개, 품질 S별 H×C / 문자 비율·시간 H×C×S</a:t>
             </a:r>
           </a:p>
           <a:p xmlns:a="http://schemas.openxmlformats.org/drawingml/2006/main">
@@ -7263,10 +7377,10 @@
       </p:sp>
       <p:sp>
         <p:nvSpPr>
-          <p:cNvPr id="46" name="">
+          <p:cNvPr id="47" name="">
             <a:extLst xmlns:a="http://schemas.openxmlformats.org/drawingml/2006/main">
               <a:ext uri="{FF2B5EF4-FFF2-40B4-BE49-F238E27FC236}">
-                <a16:creationId xmlns:a16="http://schemas.microsoft.com/office/drawing/2014/main" id="{CFFBF10B-3415-4B7C-AF38-DA36D7587279}"/>
+                <a16:creationId xmlns:a16="http://schemas.microsoft.com/office/drawing/2014/main" id="{40C8C176-4CCA-41F3-A201-F320E83D0675}"/>
               </a:ext>
             </a:extLst>
           </p:cNvPr>
@@ -7294,10 +7408,10 @@
       </p:sp>
       <p:sp>
         <p:nvSpPr>
-          <p:cNvPr id="47" name="05 조합별 결과와 통계 검정">
+          <p:cNvPr id="48" name="05 조합별 결과와 통계 검정">
             <a:extLst xmlns:a="http://schemas.openxmlformats.org/drawingml/2006/main">
               <a:ext uri="{FF2B5EF4-FFF2-40B4-BE49-F238E27FC236}">
-                <a16:creationId xmlns:a16="http://schemas.microsoft.com/office/drawing/2014/main" id="{31AAFAA6-6349-4EE3-A1BB-23B8359C481E}"/>
+                <a16:creationId xmlns:a16="http://schemas.microsoft.com/office/drawing/2014/main" id="{2AA2D5B0-1C99-408F-8933-6E71054954D5}"/>
               </a:ext>
             </a:extLst>
           </p:cNvPr>
@@ -7362,10 +7476,10 @@
       </p:sp>
       <p:sp>
         <p:nvSpPr>
-          <p:cNvPr id="48" name="8조건 평균(SD)  ·  시간 단위: 초">
+          <p:cNvPr id="49" name="HyDE·CAD·SCD 8조합의 품질·한국어 비율·시간 평균(SD)">
             <a:extLst xmlns:a="http://schemas.openxmlformats.org/drawingml/2006/main">
               <a:ext uri="{FF2B5EF4-FFF2-40B4-BE49-F238E27FC236}">
-                <a16:creationId xmlns:a16="http://schemas.microsoft.com/office/drawing/2014/main" id="{9452CE0E-B064-48C6-A3EF-67ED8AEEC7E8}"/>
+                <a16:creationId xmlns:a16="http://schemas.microsoft.com/office/drawing/2014/main" id="{ACF56130-E376-4F8B-8215-D52EAFE6200F}"/>
               </a:ext>
             </a:extLst>
           </p:cNvPr>
@@ -7423,17 +7537,17 @@
                 <a:ea typeface="Malgun Gothic"/>
                 <a:cs typeface="Malgun Gothic"/>
               </a:rPr>
-              <a:t>8조건 평균(SD)  ·  시간 단위: 초</a:t>
+              <a:t>HyDE·CAD·SCD 8조합의 품질·한국어 비율·시간 평균(SD)</a:t>
             </a:r>
           </a:p>
         </p:txBody>
       </p:sp>
       <p:graphicFrame>
         <p:nvGraphicFramePr>
-          <p:cNvPr id="49" name="">
+          <p:cNvPr id="50" name="">
             <a:extLst xmlns:a="http://schemas.openxmlformats.org/drawingml/2006/main">
               <a:ext uri="{FF2B5EF4-FFF2-40B4-BE49-F238E27FC236}">
-                <a16:creationId xmlns:a16="http://schemas.microsoft.com/office/drawing/2014/main" id="{F091D218-7506-4DF4-802A-3B40A27C32E6}"/>
+                <a16:creationId xmlns:a16="http://schemas.microsoft.com/office/drawing/2014/main" id="{18C5C0EA-2652-44CB-B4B4-A33DBCA33A85}"/>
               </a:ext>
             </a:extLst>
           </p:cNvPr>
@@ -8247,7 +8361,7 @@
                           <a:ea typeface="Malgun Gothic"/>
                           <a:cs typeface="Malgun Gothic"/>
                         </a:rPr>
-                        <a:t>H0C0S1</a:t>
+                        <a:t>H0C1S0</a:t>
                       </a:r>
                     </a:p>
                   </a:txBody>
@@ -8292,7 +8406,7 @@
                           <a:ea typeface="Malgun Gothic"/>
                           <a:cs typeface="Malgun Gothic"/>
                         </a:rPr>
-                        <a:t>0.787</a:t>
+                        <a:t>0.839</a:t>
                       </a:r>
                     </a:p>
                     <a:p>
@@ -8306,7 +8420,7 @@
                           <a:ea typeface="Malgun Gothic"/>
                           <a:cs typeface="Malgun Gothic"/>
                         </a:rPr>
-                        <a:t>(0.254)</a:t>
+                        <a:t>(0.201)</a:t>
                       </a:r>
                     </a:p>
                   </a:txBody>
@@ -8345,7 +8459,7 @@
                           <a:ea typeface="Malgun Gothic"/>
                           <a:cs typeface="Malgun Gothic"/>
                         </a:rPr>
-                        <a:t>0.637</a:t>
+                        <a:t>0.675</a:t>
                       </a:r>
                     </a:p>
                     <a:p>
@@ -8359,7 +8473,7 @@
                           <a:ea typeface="Malgun Gothic"/>
                           <a:cs typeface="Malgun Gothic"/>
                         </a:rPr>
-                        <a:t>(0.296)</a:t>
+                        <a:t>(0.261)</a:t>
                       </a:r>
                     </a:p>
                   </a:txBody>
@@ -8398,7 +8512,7 @@
                           <a:ea typeface="Malgun Gothic"/>
                           <a:cs typeface="Malgun Gothic"/>
                         </a:rPr>
-                        <a:t>0.763</a:t>
+                        <a:t>0.740</a:t>
                       </a:r>
                     </a:p>
                     <a:p>
@@ -8412,7 +8526,7 @@
                           <a:ea typeface="Malgun Gothic"/>
                           <a:cs typeface="Malgun Gothic"/>
                         </a:rPr>
-                        <a:t>(0.300)</a:t>
+                        <a:t>(0.302)</a:t>
                       </a:r>
                     </a:p>
                   </a:txBody>
@@ -8451,7 +8565,7 @@
                           <a:ea typeface="Malgun Gothic"/>
                           <a:cs typeface="Malgun Gothic"/>
                         </a:rPr>
-                        <a:t>0.900</a:t>
+                        <a:t>0.917</a:t>
                       </a:r>
                     </a:p>
                     <a:p>
@@ -8465,7 +8579,7 @@
                           <a:ea typeface="Malgun Gothic"/>
                           <a:cs typeface="Malgun Gothic"/>
                         </a:rPr>
-                        <a:t>(0.303)</a:t>
+                        <a:t>(0.279)</a:t>
                       </a:r>
                     </a:p>
                   </a:txBody>
@@ -8504,7 +8618,7 @@
                           <a:ea typeface="Malgun Gothic"/>
                           <a:cs typeface="Malgun Gothic"/>
                         </a:rPr>
-                        <a:t>0.699</a:t>
+                        <a:t>0.488</a:t>
                       </a:r>
                     </a:p>
                     <a:p>
@@ -8518,7 +8632,7 @@
                           <a:ea typeface="Malgun Gothic"/>
                           <a:cs typeface="Malgun Gothic"/>
                         </a:rPr>
-                        <a:t>(0.329)</a:t>
+                        <a:t>(0.245)</a:t>
                       </a:r>
                     </a:p>
                   </a:txBody>
@@ -8557,7 +8671,7 @@
                           <a:ea typeface="Malgun Gothic"/>
                           <a:cs typeface="Malgun Gothic"/>
                         </a:rPr>
-                        <a:t>18.898</a:t>
+                        <a:t>63.867</a:t>
                       </a:r>
                     </a:p>
                     <a:p>
@@ -8571,7 +8685,7 @@
                           <a:ea typeface="Malgun Gothic"/>
                           <a:cs typeface="Malgun Gothic"/>
                         </a:rPr>
-                        <a:t>(5.085)</a:t>
+                        <a:t>(25.312)</a:t>
                       </a:r>
                     </a:p>
                   </a:txBody>
@@ -8612,7 +8726,7 @@
                           <a:ea typeface="Malgun Gothic"/>
                           <a:cs typeface="Malgun Gothic"/>
                         </a:rPr>
-                        <a:t>H0C1S0</a:t>
+                        <a:t>H1C0S0</a:t>
                       </a:r>
                     </a:p>
                   </a:txBody>
@@ -8657,7 +8771,7 @@
                           <a:ea typeface="Malgun Gothic"/>
                           <a:cs typeface="Malgun Gothic"/>
                         </a:rPr>
-                        <a:t>0.839</a:t>
+                        <a:t>0.834</a:t>
                       </a:r>
                     </a:p>
                     <a:p>
@@ -8671,7 +8785,7 @@
                           <a:ea typeface="Malgun Gothic"/>
                           <a:cs typeface="Malgun Gothic"/>
                         </a:rPr>
-                        <a:t>(0.201)</a:t>
+                        <a:t>(0.186)</a:t>
                       </a:r>
                     </a:p>
                   </a:txBody>
@@ -8710,7 +8824,7 @@
                           <a:ea typeface="Malgun Gothic"/>
                           <a:cs typeface="Malgun Gothic"/>
                         </a:rPr>
-                        <a:t>0.675</a:t>
+                        <a:t>0.763</a:t>
                       </a:r>
                     </a:p>
                     <a:p>
@@ -8724,7 +8838,7 @@
                           <a:ea typeface="Malgun Gothic"/>
                           <a:cs typeface="Malgun Gothic"/>
                         </a:rPr>
-                        <a:t>(0.261)</a:t>
+                        <a:t>(0.209)</a:t>
                       </a:r>
                     </a:p>
                   </a:txBody>
@@ -8763,7 +8877,7 @@
                           <a:ea typeface="Malgun Gothic"/>
                           <a:cs typeface="Malgun Gothic"/>
                         </a:rPr>
-                        <a:t>0.740</a:t>
+                        <a:t>0.714</a:t>
                       </a:r>
                     </a:p>
                     <a:p>
@@ -8777,7 +8891,7 @@
                           <a:ea typeface="Malgun Gothic"/>
                           <a:cs typeface="Malgun Gothic"/>
                         </a:rPr>
-                        <a:t>(0.302)</a:t>
+                        <a:t>(0.296)</a:t>
                       </a:r>
                     </a:p>
                   </a:txBody>
@@ -8816,7 +8930,7 @@
                           <a:ea typeface="Malgun Gothic"/>
                           <a:cs typeface="Malgun Gothic"/>
                         </a:rPr>
-                        <a:t>0.917</a:t>
+                        <a:t>0.933</a:t>
                       </a:r>
                     </a:p>
                     <a:p>
@@ -8830,7 +8944,7 @@
                           <a:ea typeface="Malgun Gothic"/>
                           <a:cs typeface="Malgun Gothic"/>
                         </a:rPr>
-                        <a:t>(0.279)</a:t>
+                        <a:t>(0.252)</a:t>
                       </a:r>
                     </a:p>
                   </a:txBody>
@@ -8869,7 +8983,7 @@
                           <a:ea typeface="Malgun Gothic"/>
                           <a:cs typeface="Malgun Gothic"/>
                         </a:rPr>
-                        <a:t>0.488</a:t>
+                        <a:t>0.556</a:t>
                       </a:r>
                     </a:p>
                     <a:p>
@@ -8883,7 +8997,7 @@
                           <a:ea typeface="Malgun Gothic"/>
                           <a:cs typeface="Malgun Gothic"/>
                         </a:rPr>
-                        <a:t>(0.245)</a:t>
+                        <a:t>(0.213)</a:t>
                       </a:r>
                     </a:p>
                   </a:txBody>
@@ -8922,7 +9036,7 @@
                           <a:ea typeface="Malgun Gothic"/>
                           <a:cs typeface="Malgun Gothic"/>
                         </a:rPr>
-                        <a:t>63.867</a:t>
+                        <a:t>23.440</a:t>
                       </a:r>
                     </a:p>
                     <a:p>
@@ -8936,7 +9050,7 @@
                           <a:ea typeface="Malgun Gothic"/>
                           <a:cs typeface="Malgun Gothic"/>
                         </a:rPr>
-                        <a:t>(25.312)</a:t>
+                        <a:t>(4.707)</a:t>
                       </a:r>
                     </a:p>
                   </a:txBody>
@@ -8977,7 +9091,7 @@
                           <a:ea typeface="Malgun Gothic"/>
                           <a:cs typeface="Malgun Gothic"/>
                         </a:rPr>
-                        <a:t>H0C1S1</a:t>
+                        <a:t>H1C1S0</a:t>
                       </a:r>
                     </a:p>
                   </a:txBody>
@@ -9022,7 +9136,7 @@
                           <a:ea typeface="Malgun Gothic"/>
                           <a:cs typeface="Malgun Gothic"/>
                         </a:rPr>
-                        <a:t>0.777</a:t>
+                        <a:t>0.860</a:t>
                       </a:r>
                     </a:p>
                     <a:p>
@@ -9036,7 +9150,7 @@
                           <a:ea typeface="Malgun Gothic"/>
                           <a:cs typeface="Malgun Gothic"/>
                         </a:rPr>
-                        <a:t>(0.270)</a:t>
+                        <a:t>(0.181)</a:t>
                       </a:r>
                     </a:p>
                   </a:txBody>
@@ -9075,7 +9189,7 @@
                           <a:ea typeface="Malgun Gothic"/>
                           <a:cs typeface="Malgun Gothic"/>
                         </a:rPr>
-                        <a:t>0.600</a:t>
+                        <a:t>0.705</a:t>
                       </a:r>
                     </a:p>
                     <a:p>
@@ -9089,7 +9203,7 @@
                           <a:ea typeface="Malgun Gothic"/>
                           <a:cs typeface="Malgun Gothic"/>
                         </a:rPr>
-                        <a:t>(0.321)</a:t>
+                        <a:t>(0.248)</a:t>
                       </a:r>
                     </a:p>
                   </a:txBody>
@@ -9128,7 +9242,7 @@
                           <a:ea typeface="Malgun Gothic"/>
                           <a:cs typeface="Malgun Gothic"/>
                         </a:rPr>
-                        <a:t>0.752</a:t>
+                        <a:t>0.736</a:t>
                       </a:r>
                     </a:p>
                     <a:p>
@@ -9142,7 +9256,7 @@
                           <a:ea typeface="Malgun Gothic"/>
                           <a:cs typeface="Malgun Gothic"/>
                         </a:rPr>
-                        <a:t>(0.301)</a:t>
+                        <a:t>(0.271)</a:t>
                       </a:r>
                     </a:p>
                   </a:txBody>
@@ -9181,7 +9295,7 @@
                           <a:ea typeface="Malgun Gothic"/>
                           <a:cs typeface="Malgun Gothic"/>
                         </a:rPr>
-                        <a:t>0.850</a:t>
+                        <a:t>0.900</a:t>
                       </a:r>
                     </a:p>
                     <a:p>
@@ -9195,7 +9309,7 @@
                           <a:ea typeface="Malgun Gothic"/>
                           <a:cs typeface="Malgun Gothic"/>
                         </a:rPr>
-                        <a:t>(0.360)</a:t>
+                        <a:t>(0.303)</a:t>
                       </a:r>
                     </a:p>
                   </a:txBody>
@@ -9234,7 +9348,7 @@
                           <a:ea typeface="Malgun Gothic"/>
                           <a:cs typeface="Malgun Gothic"/>
                         </a:rPr>
-                        <a:t>0.719</a:t>
+                        <a:t>0.503</a:t>
                       </a:r>
                     </a:p>
                     <a:p>
@@ -9248,7 +9362,7 @@
                           <a:ea typeface="Malgun Gothic"/>
                           <a:cs typeface="Malgun Gothic"/>
                         </a:rPr>
-                        <a:t>(0.218)</a:t>
+                        <a:t>(0.229)</a:t>
                       </a:r>
                     </a:p>
                   </a:txBody>
@@ -9287,7 +9401,7 @@
                           <a:ea typeface="Malgun Gothic"/>
                           <a:cs typeface="Malgun Gothic"/>
                         </a:rPr>
-                        <a:t>55.159</a:t>
+                        <a:t>73.532</a:t>
                       </a:r>
                     </a:p>
                     <a:p>
@@ -9301,7 +9415,7 @@
                           <a:ea typeface="Malgun Gothic"/>
                           <a:cs typeface="Malgun Gothic"/>
                         </a:rPr>
-                        <a:t>(26.465)</a:t>
+                        <a:t>(21.584)</a:t>
                       </a:r>
                     </a:p>
                   </a:txBody>
@@ -9342,7 +9456,7 @@
                           <a:ea typeface="Malgun Gothic"/>
                           <a:cs typeface="Malgun Gothic"/>
                         </a:rPr>
-                        <a:t>H1C0S0</a:t>
+                        <a:t>H0C0S1</a:t>
                       </a:r>
                     </a:p>
                   </a:txBody>
@@ -9387,7 +9501,7 @@
                           <a:ea typeface="Malgun Gothic"/>
                           <a:cs typeface="Malgun Gothic"/>
                         </a:rPr>
-                        <a:t>0.834</a:t>
+                        <a:t>0.787</a:t>
                       </a:r>
                     </a:p>
                     <a:p>
@@ -9401,7 +9515,7 @@
                           <a:ea typeface="Malgun Gothic"/>
                           <a:cs typeface="Malgun Gothic"/>
                         </a:rPr>
-                        <a:t>(0.186)</a:t>
+                        <a:t>(0.254)</a:t>
                       </a:r>
                     </a:p>
                   </a:txBody>
@@ -9440,6 +9554,59 @@
                           <a:ea typeface="Malgun Gothic"/>
                           <a:cs typeface="Malgun Gothic"/>
                         </a:rPr>
+                        <a:t>0.637</a:t>
+                      </a:r>
+                    </a:p>
+                    <a:p>
+                      <a:pPr algn="r"/>
+                      <a:r>
+                        <a:rPr sz="1800" b="0">
+                          <a:solidFill>
+                            <a:srgbClr val="24324A"/>
+                          </a:solidFill>
+                          <a:latin typeface="Malgun Gothic"/>
+                          <a:ea typeface="Malgun Gothic"/>
+                          <a:cs typeface="Malgun Gothic"/>
+                        </a:rPr>
+                        <a:t>(0.296)</a:t>
+                      </a:r>
+                    </a:p>
+                  </a:txBody>
+                  <a:tcPr marL="91440" marR="91440" marT="45720" marB="45720" anchor="ctr">
+                    <a:lnR w="6668">
+                      <a:solidFill>
+                        <a:srgbClr val="D8CFE4"/>
+                      </a:solidFill>
+                      <a:prstDash val="solid"/>
+                    </a:lnR>
+                    <a:lnB w="6668">
+                      <a:solidFill>
+                        <a:srgbClr val="D8CFE4"/>
+                      </a:solidFill>
+                      <a:prstDash val="solid"/>
+                    </a:lnB>
+                    <a:solidFill>
+                      <a:srgbClr val="FFFFFF"/>
+                    </a:solidFill>
+                  </a:tcPr>
+                </a:tc>
+                <a:tc>
+                  <a:txBody>
+                    <a:bodyPr wrap="none" lIns="38100" tIns="38100" rIns="38100" bIns="38100">
+                      <a:noAutofit/>
+                    </a:bodyPr>
+                    <a:lstStyle/>
+                    <a:p>
+                      <a:pPr algn="r"/>
+                      <a:r>
+                        <a:rPr sz="1800" b="0">
+                          <a:solidFill>
+                            <a:srgbClr val="24324A"/>
+                          </a:solidFill>
+                          <a:latin typeface="Malgun Gothic"/>
+                          <a:ea typeface="Malgun Gothic"/>
+                          <a:cs typeface="Malgun Gothic"/>
+                        </a:rPr>
                         <a:t>0.763</a:t>
                       </a:r>
                     </a:p>
@@ -9454,7 +9621,7 @@
                           <a:ea typeface="Malgun Gothic"/>
                           <a:cs typeface="Malgun Gothic"/>
                         </a:rPr>
-                        <a:t>(0.209)</a:t>
+                        <a:t>(0.300)</a:t>
                       </a:r>
                     </a:p>
                   </a:txBody>
@@ -9493,7 +9660,7 @@
                           <a:ea typeface="Malgun Gothic"/>
                           <a:cs typeface="Malgun Gothic"/>
                         </a:rPr>
-                        <a:t>0.714</a:t>
+                        <a:t>0.900</a:t>
                       </a:r>
                     </a:p>
                     <a:p>
@@ -9507,7 +9674,7 @@
                           <a:ea typeface="Malgun Gothic"/>
                           <a:cs typeface="Malgun Gothic"/>
                         </a:rPr>
-                        <a:t>(0.296)</a:t>
+                        <a:t>(0.303)</a:t>
                       </a:r>
                     </a:p>
                   </a:txBody>
@@ -9546,7 +9713,7 @@
                           <a:ea typeface="Malgun Gothic"/>
                           <a:cs typeface="Malgun Gothic"/>
                         </a:rPr>
-                        <a:t>0.933</a:t>
+                        <a:t>0.699</a:t>
                       </a:r>
                     </a:p>
                     <a:p>
@@ -9560,7 +9727,7 @@
                           <a:ea typeface="Malgun Gothic"/>
                           <a:cs typeface="Malgun Gothic"/>
                         </a:rPr>
-                        <a:t>(0.252)</a:t>
+                        <a:t>(0.329)</a:t>
                       </a:r>
                     </a:p>
                   </a:txBody>
@@ -9599,7 +9766,7 @@
                           <a:ea typeface="Malgun Gothic"/>
                           <a:cs typeface="Malgun Gothic"/>
                         </a:rPr>
-                        <a:t>0.556</a:t>
+                        <a:t>18.898</a:t>
                       </a:r>
                     </a:p>
                     <a:p>
@@ -9613,60 +9780,7 @@
                           <a:ea typeface="Malgun Gothic"/>
                           <a:cs typeface="Malgun Gothic"/>
                         </a:rPr>
-                        <a:t>(0.213)</a:t>
-                      </a:r>
-                    </a:p>
-                  </a:txBody>
-                  <a:tcPr marL="91440" marR="91440" marT="45720" marB="45720" anchor="ctr">
-                    <a:lnR w="6668">
-                      <a:solidFill>
-                        <a:srgbClr val="D8CFE4"/>
-                      </a:solidFill>
-                      <a:prstDash val="solid"/>
-                    </a:lnR>
-                    <a:lnB w="6668">
-                      <a:solidFill>
-                        <a:srgbClr val="D8CFE4"/>
-                      </a:solidFill>
-                      <a:prstDash val="solid"/>
-                    </a:lnB>
-                    <a:solidFill>
-                      <a:srgbClr val="FFFFFF"/>
-                    </a:solidFill>
-                  </a:tcPr>
-                </a:tc>
-                <a:tc>
-                  <a:txBody>
-                    <a:bodyPr wrap="none" lIns="38100" tIns="38100" rIns="38100" bIns="38100">
-                      <a:noAutofit/>
-                    </a:bodyPr>
-                    <a:lstStyle/>
-                    <a:p>
-                      <a:pPr algn="r"/>
-                      <a:r>
-                        <a:rPr sz="1800" b="0">
-                          <a:solidFill>
-                            <a:srgbClr val="24324A"/>
-                          </a:solidFill>
-                          <a:latin typeface="Malgun Gothic"/>
-                          <a:ea typeface="Malgun Gothic"/>
-                          <a:cs typeface="Malgun Gothic"/>
-                        </a:rPr>
-                        <a:t>23.440</a:t>
-                      </a:r>
-                    </a:p>
-                    <a:p>
-                      <a:pPr algn="r"/>
-                      <a:r>
-                        <a:rPr sz="1800" b="0">
-                          <a:solidFill>
-                            <a:srgbClr val="24324A"/>
-                          </a:solidFill>
-                          <a:latin typeface="Malgun Gothic"/>
-                          <a:ea typeface="Malgun Gothic"/>
-                          <a:cs typeface="Malgun Gothic"/>
-                        </a:rPr>
-                        <a:t>(4.707)</a:t>
+                        <a:t>(5.085)</a:t>
                       </a:r>
                     </a:p>
                   </a:txBody>
@@ -9707,7 +9821,7 @@
                           <a:ea typeface="Malgun Gothic"/>
                           <a:cs typeface="Malgun Gothic"/>
                         </a:rPr>
-                        <a:t>H1C0S1</a:t>
+                        <a:t>H0C1S1</a:t>
                       </a:r>
                     </a:p>
                   </a:txBody>
@@ -9752,7 +9866,7 @@
                           <a:ea typeface="Malgun Gothic"/>
                           <a:cs typeface="Malgun Gothic"/>
                         </a:rPr>
-                        <a:t>0.822</a:t>
+                        <a:t>0.777</a:t>
                       </a:r>
                     </a:p>
                     <a:p>
@@ -9766,6 +9880,218 @@
                           <a:ea typeface="Malgun Gothic"/>
                           <a:cs typeface="Malgun Gothic"/>
                         </a:rPr>
+                        <a:t>(0.270)</a:t>
+                      </a:r>
+                    </a:p>
+                  </a:txBody>
+                  <a:tcPr marL="91440" marR="91440" marT="45720" marB="45720" anchor="ctr">
+                    <a:lnR w="6668">
+                      <a:solidFill>
+                        <a:srgbClr val="D8CFE4"/>
+                      </a:solidFill>
+                      <a:prstDash val="solid"/>
+                    </a:lnR>
+                    <a:lnB w="6668">
+                      <a:solidFill>
+                        <a:srgbClr val="D8CFE4"/>
+                      </a:solidFill>
+                      <a:prstDash val="solid"/>
+                    </a:lnB>
+                    <a:solidFill>
+                      <a:srgbClr val="F8F6FA"/>
+                    </a:solidFill>
+                  </a:tcPr>
+                </a:tc>
+                <a:tc>
+                  <a:txBody>
+                    <a:bodyPr wrap="none" lIns="38100" tIns="38100" rIns="38100" bIns="38100">
+                      <a:noAutofit/>
+                    </a:bodyPr>
+                    <a:lstStyle/>
+                    <a:p>
+                      <a:pPr algn="r"/>
+                      <a:r>
+                        <a:rPr sz="1800" b="0">
+                          <a:solidFill>
+                            <a:srgbClr val="24324A"/>
+                          </a:solidFill>
+                          <a:latin typeface="Malgun Gothic"/>
+                          <a:ea typeface="Malgun Gothic"/>
+                          <a:cs typeface="Malgun Gothic"/>
+                        </a:rPr>
+                        <a:t>0.600</a:t>
+                      </a:r>
+                    </a:p>
+                    <a:p>
+                      <a:pPr algn="r"/>
+                      <a:r>
+                        <a:rPr sz="1800" b="0">
+                          <a:solidFill>
+                            <a:srgbClr val="24324A"/>
+                          </a:solidFill>
+                          <a:latin typeface="Malgun Gothic"/>
+                          <a:ea typeface="Malgun Gothic"/>
+                          <a:cs typeface="Malgun Gothic"/>
+                        </a:rPr>
+                        <a:t>(0.321)</a:t>
+                      </a:r>
+                    </a:p>
+                  </a:txBody>
+                  <a:tcPr marL="91440" marR="91440" marT="45720" marB="45720" anchor="ctr">
+                    <a:lnR w="6668">
+                      <a:solidFill>
+                        <a:srgbClr val="D8CFE4"/>
+                      </a:solidFill>
+                      <a:prstDash val="solid"/>
+                    </a:lnR>
+                    <a:lnB w="6668">
+                      <a:solidFill>
+                        <a:srgbClr val="D8CFE4"/>
+                      </a:solidFill>
+                      <a:prstDash val="solid"/>
+                    </a:lnB>
+                    <a:solidFill>
+                      <a:srgbClr val="F8F6FA"/>
+                    </a:solidFill>
+                  </a:tcPr>
+                </a:tc>
+                <a:tc>
+                  <a:txBody>
+                    <a:bodyPr wrap="none" lIns="38100" tIns="38100" rIns="38100" bIns="38100">
+                      <a:noAutofit/>
+                    </a:bodyPr>
+                    <a:lstStyle/>
+                    <a:p>
+                      <a:pPr algn="r"/>
+                      <a:r>
+                        <a:rPr sz="1800" b="0">
+                          <a:solidFill>
+                            <a:srgbClr val="24324A"/>
+                          </a:solidFill>
+                          <a:latin typeface="Malgun Gothic"/>
+                          <a:ea typeface="Malgun Gothic"/>
+                          <a:cs typeface="Malgun Gothic"/>
+                        </a:rPr>
+                        <a:t>0.752</a:t>
+                      </a:r>
+                    </a:p>
+                    <a:p>
+                      <a:pPr algn="r"/>
+                      <a:r>
+                        <a:rPr sz="1800" b="0">
+                          <a:solidFill>
+                            <a:srgbClr val="24324A"/>
+                          </a:solidFill>
+                          <a:latin typeface="Malgun Gothic"/>
+                          <a:ea typeface="Malgun Gothic"/>
+                          <a:cs typeface="Malgun Gothic"/>
+                        </a:rPr>
+                        <a:t>(0.301)</a:t>
+                      </a:r>
+                    </a:p>
+                  </a:txBody>
+                  <a:tcPr marL="91440" marR="91440" marT="45720" marB="45720" anchor="ctr">
+                    <a:lnR w="6668">
+                      <a:solidFill>
+                        <a:srgbClr val="D8CFE4"/>
+                      </a:solidFill>
+                      <a:prstDash val="solid"/>
+                    </a:lnR>
+                    <a:lnB w="6668">
+                      <a:solidFill>
+                        <a:srgbClr val="D8CFE4"/>
+                      </a:solidFill>
+                      <a:prstDash val="solid"/>
+                    </a:lnB>
+                    <a:solidFill>
+                      <a:srgbClr val="F8F6FA"/>
+                    </a:solidFill>
+                  </a:tcPr>
+                </a:tc>
+                <a:tc>
+                  <a:txBody>
+                    <a:bodyPr wrap="none" lIns="38100" tIns="38100" rIns="38100" bIns="38100">
+                      <a:noAutofit/>
+                    </a:bodyPr>
+                    <a:lstStyle/>
+                    <a:p>
+                      <a:pPr algn="r"/>
+                      <a:r>
+                        <a:rPr sz="1800" b="0">
+                          <a:solidFill>
+                            <a:srgbClr val="24324A"/>
+                          </a:solidFill>
+                          <a:latin typeface="Malgun Gothic"/>
+                          <a:ea typeface="Malgun Gothic"/>
+                          <a:cs typeface="Malgun Gothic"/>
+                        </a:rPr>
+                        <a:t>0.850</a:t>
+                      </a:r>
+                    </a:p>
+                    <a:p>
+                      <a:pPr algn="r"/>
+                      <a:r>
+                        <a:rPr sz="1800" b="0">
+                          <a:solidFill>
+                            <a:srgbClr val="24324A"/>
+                          </a:solidFill>
+                          <a:latin typeface="Malgun Gothic"/>
+                          <a:ea typeface="Malgun Gothic"/>
+                          <a:cs typeface="Malgun Gothic"/>
+                        </a:rPr>
+                        <a:t>(0.360)</a:t>
+                      </a:r>
+                    </a:p>
+                  </a:txBody>
+                  <a:tcPr marL="91440" marR="91440" marT="45720" marB="45720" anchor="ctr">
+                    <a:lnR w="6668">
+                      <a:solidFill>
+                        <a:srgbClr val="D8CFE4"/>
+                      </a:solidFill>
+                      <a:prstDash val="solid"/>
+                    </a:lnR>
+                    <a:lnB w="6668">
+                      <a:solidFill>
+                        <a:srgbClr val="D8CFE4"/>
+                      </a:solidFill>
+                      <a:prstDash val="solid"/>
+                    </a:lnB>
+                    <a:solidFill>
+                      <a:srgbClr val="F8F6FA"/>
+                    </a:solidFill>
+                  </a:tcPr>
+                </a:tc>
+                <a:tc>
+                  <a:txBody>
+                    <a:bodyPr wrap="none" lIns="38100" tIns="38100" rIns="38100" bIns="38100">
+                      <a:noAutofit/>
+                    </a:bodyPr>
+                    <a:lstStyle/>
+                    <a:p>
+                      <a:pPr algn="r"/>
+                      <a:r>
+                        <a:rPr sz="1800" b="0">
+                          <a:solidFill>
+                            <a:srgbClr val="24324A"/>
+                          </a:solidFill>
+                          <a:latin typeface="Malgun Gothic"/>
+                          <a:ea typeface="Malgun Gothic"/>
+                          <a:cs typeface="Malgun Gothic"/>
+                        </a:rPr>
+                        <a:t>0.719</a:t>
+                      </a:r>
+                    </a:p>
+                    <a:p>
+                      <a:pPr algn="r"/>
+                      <a:r>
+                        <a:rPr sz="1800" b="0">
+                          <a:solidFill>
+                            <a:srgbClr val="24324A"/>
+                          </a:solidFill>
+                          <a:latin typeface="Malgun Gothic"/>
+                          <a:ea typeface="Malgun Gothic"/>
+                          <a:cs typeface="Malgun Gothic"/>
+                        </a:rPr>
                         <a:t>(0.218)</a:t>
                       </a:r>
                     </a:p>
@@ -9805,7 +10131,7 @@
                           <a:ea typeface="Malgun Gothic"/>
                           <a:cs typeface="Malgun Gothic"/>
                         </a:rPr>
-                        <a:t>0.710</a:t>
+                        <a:t>55.159</a:t>
                       </a:r>
                     </a:p>
                     <a:p>
@@ -9819,219 +10145,7 @@
                           <a:ea typeface="Malgun Gothic"/>
                           <a:cs typeface="Malgun Gothic"/>
                         </a:rPr>
-                        <a:t>(0.272)</a:t>
-                      </a:r>
-                    </a:p>
-                  </a:txBody>
-                  <a:tcPr marL="91440" marR="91440" marT="45720" marB="45720" anchor="ctr">
-                    <a:lnR w="6668">
-                      <a:solidFill>
-                        <a:srgbClr val="D8CFE4"/>
-                      </a:solidFill>
-                      <a:prstDash val="solid"/>
-                    </a:lnR>
-                    <a:lnB w="6668">
-                      <a:solidFill>
-                        <a:srgbClr val="D8CFE4"/>
-                      </a:solidFill>
-                      <a:prstDash val="solid"/>
-                    </a:lnB>
-                    <a:solidFill>
-                      <a:srgbClr val="F8F6FA"/>
-                    </a:solidFill>
-                  </a:tcPr>
-                </a:tc>
-                <a:tc>
-                  <a:txBody>
-                    <a:bodyPr wrap="none" lIns="38100" tIns="38100" rIns="38100" bIns="38100">
-                      <a:noAutofit/>
-                    </a:bodyPr>
-                    <a:lstStyle/>
-                    <a:p>
-                      <a:pPr algn="r"/>
-                      <a:r>
-                        <a:rPr sz="1800" b="0">
-                          <a:solidFill>
-                            <a:srgbClr val="24324A"/>
-                          </a:solidFill>
-                          <a:latin typeface="Malgun Gothic"/>
-                          <a:ea typeface="Malgun Gothic"/>
-                          <a:cs typeface="Malgun Gothic"/>
-                        </a:rPr>
-                        <a:t>0.743</a:t>
-                      </a:r>
-                    </a:p>
-                    <a:p>
-                      <a:pPr algn="r"/>
-                      <a:r>
-                        <a:rPr sz="1800" b="0">
-                          <a:solidFill>
-                            <a:srgbClr val="24324A"/>
-                          </a:solidFill>
-                          <a:latin typeface="Malgun Gothic"/>
-                          <a:ea typeface="Malgun Gothic"/>
-                          <a:cs typeface="Malgun Gothic"/>
-                        </a:rPr>
-                        <a:t>(0.281)</a:t>
-                      </a:r>
-                    </a:p>
-                  </a:txBody>
-                  <a:tcPr marL="91440" marR="91440" marT="45720" marB="45720" anchor="ctr">
-                    <a:lnR w="6668">
-                      <a:solidFill>
-                        <a:srgbClr val="D8CFE4"/>
-                      </a:solidFill>
-                      <a:prstDash val="solid"/>
-                    </a:lnR>
-                    <a:lnB w="6668">
-                      <a:solidFill>
-                        <a:srgbClr val="D8CFE4"/>
-                      </a:solidFill>
-                      <a:prstDash val="solid"/>
-                    </a:lnB>
-                    <a:solidFill>
-                      <a:srgbClr val="F8F6FA"/>
-                    </a:solidFill>
-                  </a:tcPr>
-                </a:tc>
-                <a:tc>
-                  <a:txBody>
-                    <a:bodyPr wrap="none" lIns="38100" tIns="38100" rIns="38100" bIns="38100">
-                      <a:noAutofit/>
-                    </a:bodyPr>
-                    <a:lstStyle/>
-                    <a:p>
-                      <a:pPr algn="r"/>
-                      <a:r>
-                        <a:rPr sz="1800" b="0">
-                          <a:solidFill>
-                            <a:srgbClr val="24324A"/>
-                          </a:solidFill>
-                          <a:latin typeface="Malgun Gothic"/>
-                          <a:ea typeface="Malgun Gothic"/>
-                          <a:cs typeface="Malgun Gothic"/>
-                        </a:rPr>
-                        <a:t>0.900</a:t>
-                      </a:r>
-                    </a:p>
-                    <a:p>
-                      <a:pPr algn="r"/>
-                      <a:r>
-                        <a:rPr sz="1800" b="0">
-                          <a:solidFill>
-                            <a:srgbClr val="24324A"/>
-                          </a:solidFill>
-                          <a:latin typeface="Malgun Gothic"/>
-                          <a:ea typeface="Malgun Gothic"/>
-                          <a:cs typeface="Malgun Gothic"/>
-                        </a:rPr>
-                        <a:t>(0.303)</a:t>
-                      </a:r>
-                    </a:p>
-                  </a:txBody>
-                  <a:tcPr marL="91440" marR="91440" marT="45720" marB="45720" anchor="ctr">
-                    <a:lnR w="6668">
-                      <a:solidFill>
-                        <a:srgbClr val="D8CFE4"/>
-                      </a:solidFill>
-                      <a:prstDash val="solid"/>
-                    </a:lnR>
-                    <a:lnB w="6668">
-                      <a:solidFill>
-                        <a:srgbClr val="D8CFE4"/>
-                      </a:solidFill>
-                      <a:prstDash val="solid"/>
-                    </a:lnB>
-                    <a:solidFill>
-                      <a:srgbClr val="F8F6FA"/>
-                    </a:solidFill>
-                  </a:tcPr>
-                </a:tc>
-                <a:tc>
-                  <a:txBody>
-                    <a:bodyPr wrap="none" lIns="38100" tIns="38100" rIns="38100" bIns="38100">
-                      <a:noAutofit/>
-                    </a:bodyPr>
-                    <a:lstStyle/>
-                    <a:p>
-                      <a:pPr algn="r"/>
-                      <a:r>
-                        <a:rPr sz="1800" b="0">
-                          <a:solidFill>
-                            <a:srgbClr val="24324A"/>
-                          </a:solidFill>
-                          <a:latin typeface="Malgun Gothic"/>
-                          <a:ea typeface="Malgun Gothic"/>
-                          <a:cs typeface="Malgun Gothic"/>
-                        </a:rPr>
-                        <a:t>0.807</a:t>
-                      </a:r>
-                    </a:p>
-                    <a:p>
-                      <a:pPr algn="r"/>
-                      <a:r>
-                        <a:rPr sz="1800" b="0">
-                          <a:solidFill>
-                            <a:srgbClr val="24324A"/>
-                          </a:solidFill>
-                          <a:latin typeface="Malgun Gothic"/>
-                          <a:ea typeface="Malgun Gothic"/>
-                          <a:cs typeface="Malgun Gothic"/>
-                        </a:rPr>
-                        <a:t>(0.200)</a:t>
-                      </a:r>
-                    </a:p>
-                  </a:txBody>
-                  <a:tcPr marL="91440" marR="91440" marT="45720" marB="45720" anchor="ctr">
-                    <a:lnR w="6668">
-                      <a:solidFill>
-                        <a:srgbClr val="D8CFE4"/>
-                      </a:solidFill>
-                      <a:prstDash val="solid"/>
-                    </a:lnR>
-                    <a:lnB w="6668">
-                      <a:solidFill>
-                        <a:srgbClr val="D8CFE4"/>
-                      </a:solidFill>
-                      <a:prstDash val="solid"/>
-                    </a:lnB>
-                    <a:solidFill>
-                      <a:srgbClr val="F8F6FA"/>
-                    </a:solidFill>
-                  </a:tcPr>
-                </a:tc>
-                <a:tc>
-                  <a:txBody>
-                    <a:bodyPr wrap="none" lIns="38100" tIns="38100" rIns="38100" bIns="38100">
-                      <a:noAutofit/>
-                    </a:bodyPr>
-                    <a:lstStyle/>
-                    <a:p>
-                      <a:pPr algn="r"/>
-                      <a:r>
-                        <a:rPr sz="1800" b="0">
-                          <a:solidFill>
-                            <a:srgbClr val="24324A"/>
-                          </a:solidFill>
-                          <a:latin typeface="Malgun Gothic"/>
-                          <a:ea typeface="Malgun Gothic"/>
-                          <a:cs typeface="Malgun Gothic"/>
-                        </a:rPr>
-                        <a:t>24.892</a:t>
-                      </a:r>
-                    </a:p>
-                    <a:p>
-                      <a:pPr algn="r"/>
-                      <a:r>
-                        <a:rPr sz="1800" b="0">
-                          <a:solidFill>
-                            <a:srgbClr val="24324A"/>
-                          </a:solidFill>
-                          <a:latin typeface="Malgun Gothic"/>
-                          <a:ea typeface="Malgun Gothic"/>
-                          <a:cs typeface="Malgun Gothic"/>
-                        </a:rPr>
-                        <a:t>(5.196)</a:t>
+                        <a:t>(26.465)</a:t>
                       </a:r>
                     </a:p>
                   </a:txBody>
@@ -10072,7 +10186,7 @@
                           <a:ea typeface="Malgun Gothic"/>
                           <a:cs typeface="Malgun Gothic"/>
                         </a:rPr>
-                        <a:t>H1C1S0</a:t>
+                        <a:t>H1C0S1</a:t>
                       </a:r>
                     </a:p>
                   </a:txBody>
@@ -10117,7 +10231,7 @@
                           <a:ea typeface="Malgun Gothic"/>
                           <a:cs typeface="Malgun Gothic"/>
                         </a:rPr>
-                        <a:t>0.860</a:t>
+                        <a:t>0.822</a:t>
                       </a:r>
                     </a:p>
                     <a:p>
@@ -10131,7 +10245,7 @@
                           <a:ea typeface="Malgun Gothic"/>
                           <a:cs typeface="Malgun Gothic"/>
                         </a:rPr>
-                        <a:t>(0.181)</a:t>
+                        <a:t>(0.218)</a:t>
                       </a:r>
                     </a:p>
                   </a:txBody>
@@ -10170,7 +10284,7 @@
                           <a:ea typeface="Malgun Gothic"/>
                           <a:cs typeface="Malgun Gothic"/>
                         </a:rPr>
-                        <a:t>0.705</a:t>
+                        <a:t>0.710</a:t>
                       </a:r>
                     </a:p>
                     <a:p>
@@ -10184,7 +10298,7 @@
                           <a:ea typeface="Malgun Gothic"/>
                           <a:cs typeface="Malgun Gothic"/>
                         </a:rPr>
-                        <a:t>(0.248)</a:t>
+                        <a:t>(0.272)</a:t>
                       </a:r>
                     </a:p>
                   </a:txBody>
@@ -10223,7 +10337,7 @@
                           <a:ea typeface="Malgun Gothic"/>
                           <a:cs typeface="Malgun Gothic"/>
                         </a:rPr>
-                        <a:t>0.736</a:t>
+                        <a:t>0.743</a:t>
                       </a:r>
                     </a:p>
                     <a:p>
@@ -10237,7 +10351,7 @@
                           <a:ea typeface="Malgun Gothic"/>
                           <a:cs typeface="Malgun Gothic"/>
                         </a:rPr>
-                        <a:t>(0.271)</a:t>
+                        <a:t>(0.281)</a:t>
                       </a:r>
                     </a:p>
                   </a:txBody>
@@ -10329,7 +10443,7 @@
                           <a:ea typeface="Malgun Gothic"/>
                           <a:cs typeface="Malgun Gothic"/>
                         </a:rPr>
-                        <a:t>0.503</a:t>
+                        <a:t>0.807</a:t>
                       </a:r>
                     </a:p>
                     <a:p>
@@ -10343,7 +10457,7 @@
                           <a:ea typeface="Malgun Gothic"/>
                           <a:cs typeface="Malgun Gothic"/>
                         </a:rPr>
-                        <a:t>(0.229)</a:t>
+                        <a:t>(0.200)</a:t>
                       </a:r>
                     </a:p>
                   </a:txBody>
@@ -10382,7 +10496,7 @@
                           <a:ea typeface="Malgun Gothic"/>
                           <a:cs typeface="Malgun Gothic"/>
                         </a:rPr>
-                        <a:t>73.532</a:t>
+                        <a:t>24.892</a:t>
                       </a:r>
                     </a:p>
                     <a:p>
@@ -10396,7 +10510,7 @@
                           <a:ea typeface="Malgun Gothic"/>
                           <a:cs typeface="Malgun Gothic"/>
                         </a:rPr>
-                        <a:t>(21.584)</a:t>
+                        <a:t>(5.196)</a:t>
                       </a:r>
                     </a:p>
                   </a:txBody>
@@ -10790,10 +10904,41 @@
       </p:graphicFrame>
       <p:sp>
         <p:nvSpPr>
-          <p:cNvPr id="50" name="S0: 영어 평가 문맥 / S1: 한국어 번역 평가 문맥 충실도 H0C1S0 n=58, H0C0S1 n=57, 나머지">
+          <p:cNvPr id="51" name="">
             <a:extLst xmlns:a="http://schemas.openxmlformats.org/drawingml/2006/main">
               <a:ext uri="{FF2B5EF4-FFF2-40B4-BE49-F238E27FC236}">
-                <a16:creationId xmlns:a16="http://schemas.microsoft.com/office/drawing/2014/main" id="{0D3B1E56-A283-4827-8783-317A3538BF5D}"/>
+                <a16:creationId xmlns:a16="http://schemas.microsoft.com/office/drawing/2014/main" id="{FBEB5C39-5AE7-4E22-B0C3-ACFDAC2E8463}"/>
+              </a:ext>
+            </a:extLst>
+          </p:cNvPr>
+          <p:cNvSpPr>
+            <a:spLocks xmlns:a="http://schemas.openxmlformats.org/drawingml/2006/main" noGrp="1"/>
+          </p:cNvSpPr>
+          <p:nvPr/>
+        </p:nvSpPr>
+        <p:spPr>
+          <a:xfrm xmlns:a="http://schemas.openxmlformats.org/drawingml/2006/main">
+            <a:off x="10949175" y="8024813"/>
+            <a:ext cx="9729975" cy="28575"/>
+          </a:xfrm>
+          <a:prstGeom xmlns:a="http://schemas.openxmlformats.org/drawingml/2006/main" prst="rect">
+            <a:avLst/>
+          </a:prstGeom>
+          <a:solidFill xmlns:a="http://schemas.openxmlformats.org/drawingml/2006/main">
+            <a:srgbClr val="695184"/>
+          </a:solidFill>
+          <a:ln xmlns:a="http://schemas.openxmlformats.org/drawingml/2006/main" w="0">
+            <a:noFill/>
+            <a:prstDash val="solid"/>
+          </a:ln>
+        </p:spPr>
+      </p:sp>
+      <p:sp>
+        <p:nvSpPr>
+          <p:cNvPr id="52" name="S0: 영어 평가 문맥 / S1: 한국어 번역 평가 문맥 충실도 H0C1S0 n=58, H0C0S1 n=57, 나머지">
+            <a:extLst xmlns:a="http://schemas.openxmlformats.org/drawingml/2006/main">
+              <a:ext uri="{FF2B5EF4-FFF2-40B4-BE49-F238E27FC236}">
+                <a16:creationId xmlns:a16="http://schemas.microsoft.com/office/drawing/2014/main" id="{C51A5B8D-32CE-4FD0-8442-B6A9D7F0BB4C}"/>
               </a:ext>
             </a:extLst>
           </p:cNvPr>
@@ -10897,17 +11042,17 @@
                 <a:ea typeface="Malgun Gothic"/>
                 <a:cs typeface="Malgun Gothic"/>
               </a:rPr>
-              <a:t>한국어 비율과 시간은 생성 기록에서 직접 계산</a:t>
+              <a:t>한국어 비율·시간(초)은 생성 기록에서 직접 계산</a:t>
             </a:r>
           </a:p>
         </p:txBody>
       </p:sp>
       <p:sp>
         <p:nvSpPr>
-          <p:cNvPr id="51" name="3요인 반복측정 ANOVA  ·  각 효과 df=(1,59)">
+          <p:cNvPr id="53" name="3요인 반복측정 ANOVA  ·  각 효과 df=(1,59)">
             <a:extLst xmlns:a="http://schemas.openxmlformats.org/drawingml/2006/main">
               <a:ext uri="{FF2B5EF4-FFF2-40B4-BE49-F238E27FC236}">
-                <a16:creationId xmlns:a16="http://schemas.microsoft.com/office/drawing/2014/main" id="{B32BA9A8-429B-4407-9CF6-C975434942B2}"/>
+                <a16:creationId xmlns:a16="http://schemas.microsoft.com/office/drawing/2014/main" id="{F286C0D7-7932-46EC-86F4-DDFBFA77BC5A}"/>
               </a:ext>
             </a:extLst>
           </p:cNvPr>
@@ -10972,10 +11117,10 @@
       </p:sp>
       <p:graphicFrame>
         <p:nvGraphicFramePr>
-          <p:cNvPr id="52" name="">
+          <p:cNvPr id="54" name="">
             <a:extLst xmlns:a="http://schemas.openxmlformats.org/drawingml/2006/main">
               <a:ext uri="{FF2B5EF4-FFF2-40B4-BE49-F238E27FC236}">
-                <a16:creationId xmlns:a16="http://schemas.microsoft.com/office/drawing/2014/main" id="{6A7C8353-A6EA-4A12-92C9-43506A6C81DC}"/>
+                <a16:creationId xmlns:a16="http://schemas.microsoft.com/office/drawing/2014/main" id="{B4EB41FC-FB60-4D81-9CE9-B108CD7402D9}"/>
               </a:ext>
             </a:extLst>
           </p:cNvPr>
@@ -12685,10 +12830,10 @@
       </p:graphicFrame>
       <p:sp>
         <p:nvSpPr>
-          <p:cNvPr id="53" name="문자 비율·시간은 각각 7검정에 Holm 보정. RAGAS H×C 검정은 평가 문맥 언어별로 수행했으며, 전체 24검">
+          <p:cNvPr id="55" name="문자 비율·시간은 각각 7검정에 Holm 보정. RAGAS H×C 검정은 평가 문맥 언어별로 수행했으며, 전체 24검">
             <a:extLst xmlns:a="http://schemas.openxmlformats.org/drawingml/2006/main">
               <a:ext uri="{FF2B5EF4-FFF2-40B4-BE49-F238E27FC236}">
-                <a16:creationId xmlns:a16="http://schemas.microsoft.com/office/drawing/2014/main" id="{4C383798-9742-444E-B2C6-2EC178B73E02}"/>
+                <a16:creationId xmlns:a16="http://schemas.microsoft.com/office/drawing/2014/main" id="{C10B7B79-3FF2-4E2B-80A6-BCC642900708}"/>
               </a:ext>
             </a:extLst>
           </p:cNvPr>
@@ -12799,10 +12944,10 @@
       </p:sp>
       <p:sp>
         <p:nvSpPr>
-          <p:cNvPr id="54" name="기법별 대응 비교  ·  질의별 평균 차이, 양측 검정">
+          <p:cNvPr id="56" name="기법별 대응 비교  ·  질의별 평균 차이, 양측 검정">
             <a:extLst xmlns:a="http://schemas.openxmlformats.org/drawingml/2006/main">
               <a:ext uri="{FF2B5EF4-FFF2-40B4-BE49-F238E27FC236}">
-                <a16:creationId xmlns:a16="http://schemas.microsoft.com/office/drawing/2014/main" id="{D62BA19D-8821-4DF2-A62A-A925B121B95E}"/>
+                <a16:creationId xmlns:a16="http://schemas.microsoft.com/office/drawing/2014/main" id="{4689A15E-6183-463B-A8CF-57B562BE3071}"/>
               </a:ext>
             </a:extLst>
           </p:cNvPr>
@@ -12867,10 +13012,10 @@
       </p:sp>
       <p:graphicFrame>
         <p:nvGraphicFramePr>
-          <p:cNvPr id="55" name="">
+          <p:cNvPr id="57" name="">
             <a:extLst xmlns:a="http://schemas.openxmlformats.org/drawingml/2006/main">
               <a:ext uri="{FF2B5EF4-FFF2-40B4-BE49-F238E27FC236}">
-                <a16:creationId xmlns:a16="http://schemas.microsoft.com/office/drawing/2014/main" id="{F34D4D0D-B46E-44B9-AB8D-A00EA92BB506}"/>
+                <a16:creationId xmlns:a16="http://schemas.microsoft.com/office/drawing/2014/main" id="{EBCE8195-3933-4077-A4E0-B94F47BE84C7}"/>
               </a:ext>
             </a:extLst>
           </p:cNvPr>
@@ -13908,10 +14053,10 @@
       </p:graphicFrame>
       <p:sp>
         <p:nvSpPr>
-          <p:cNvPr id="56" name="HyDE: C0S0, CAD: H0S0, SCD: H0의 CAD 상태 평균 보정: HyDE·CAD 각 4지표, SCD">
+          <p:cNvPr id="58" name="HyDE: C0S0, CAD: H0S0, SCD: H0의 CAD 상태 평균 보정: HyDE·CAD 각 4지표, SCD">
             <a:extLst xmlns:a="http://schemas.openxmlformats.org/drawingml/2006/main">
               <a:ext uri="{FF2B5EF4-FFF2-40B4-BE49-F238E27FC236}">
-                <a16:creationId xmlns:a16="http://schemas.microsoft.com/office/drawing/2014/main" id="{D2BF6CEB-1CA8-467F-BC20-5A13D7AE7021}"/>
+                <a16:creationId xmlns:a16="http://schemas.microsoft.com/office/drawing/2014/main" id="{FE592256-9FEF-486E-8F6F-C721D671F915}"/>
               </a:ext>
             </a:extLst>
           </p:cNvPr>
@@ -14022,10 +14167,10 @@
       </p:sp>
       <p:sp>
         <p:nvSpPr>
-          <p:cNvPr id="57" name="">
+          <p:cNvPr id="59" name="">
             <a:extLst xmlns:a="http://schemas.openxmlformats.org/drawingml/2006/main">
               <a:ext uri="{FF2B5EF4-FFF2-40B4-BE49-F238E27FC236}">
-                <a16:creationId xmlns:a16="http://schemas.microsoft.com/office/drawing/2014/main" id="{78A781B1-22AE-4A8D-AF1F-6FDB4D1B0AA6}"/>
+                <a16:creationId xmlns:a16="http://schemas.microsoft.com/office/drawing/2014/main" id="{783FA76B-B508-4B0E-948A-B4E5AE4E9DC1}"/>
               </a:ext>
             </a:extLst>
           </p:cNvPr>
@@ -14053,10 +14198,10 @@
       </p:sp>
       <p:sp>
         <p:nvSpPr>
-          <p:cNvPr id="58" name="06 결과 해석">
+          <p:cNvPr id="60" name="06 결과 해석">
             <a:extLst xmlns:a="http://schemas.openxmlformats.org/drawingml/2006/main">
               <a:ext uri="{FF2B5EF4-FFF2-40B4-BE49-F238E27FC236}">
-                <a16:creationId xmlns:a16="http://schemas.microsoft.com/office/drawing/2014/main" id="{50A3C81F-B2E6-468C-8A13-707E231BCED7}"/>
+                <a16:creationId xmlns:a16="http://schemas.microsoft.com/office/drawing/2014/main" id="{EBA99112-248E-4BD5-BF3A-4E0C3FB2FA73}"/>
               </a:ext>
             </a:extLst>
           </p:cNvPr>
@@ -14121,10 +14266,10 @@
       </p:sp>
       <p:sp>
         <p:nvSpPr>
-          <p:cNvPr id="59" name="HyDE 관련성 차이는 +0.080점, Holm 보정 p=0.117이다. CAD 충실도 차이는 +0.029점(SD 0">
+          <p:cNvPr id="61" name="HyDE의 양의 관련성 차이는 다중비교 보정 결과와 함께 해석한다. CAD는 질의별 충실도 변동과 추가 실행 시간을 ">
             <a:extLst xmlns:a="http://schemas.openxmlformats.org/drawingml/2006/main">
               <a:ext uri="{FF2B5EF4-FFF2-40B4-BE49-F238E27FC236}">
-                <a16:creationId xmlns:a16="http://schemas.microsoft.com/office/drawing/2014/main" id="{0FABEBDA-F489-410E-A20A-D1448022DB53}"/>
+                <a16:creationId xmlns:a16="http://schemas.microsoft.com/office/drawing/2014/main" id="{CA18B5E5-E0BA-49B3-81AA-C010BAE6B737}"/>
               </a:ext>
             </a:extLst>
           </p:cNvPr>
@@ -14182,7 +14327,7 @@
                 <a:ea typeface="Malgun Gothic"/>
                 <a:cs typeface="Malgun Gothic"/>
               </a:rPr>
-              <a:t>HyDE 관련성 차이는 +0.080점, Holm 보정 p=0.117이다.</a:t>
+              <a:t>HyDE의 양의 관련성 차이는 다중비교 보정 결과와 함께 해석한다.</a:t>
             </a:r>
           </a:p>
           <a:p xmlns:a="http://schemas.openxmlformats.org/drawingml/2006/main">
@@ -14205,7 +14350,7 @@
                 <a:ea typeface="Malgun Gothic"/>
                 <a:cs typeface="Malgun Gothic"/>
               </a:rPr>
-              <a:t>CAD 충실도 차이는 +0.029점(SD 0.255), p=0.393이다.</a:t>
+              <a:t>CAD는 질의별 충실도 변동과 추가 실행 시간을 함께 비교한다.</a:t>
             </a:r>
           </a:p>
           <a:p xmlns:a="http://schemas.openxmlformats.org/drawingml/2006/main">
@@ -14228,7 +14373,7 @@
                 <a:ea typeface="Malgun Gothic"/>
                 <a:cs typeface="Malgun Gothic"/>
               </a:rPr>
-              <a:t>SCD 문자 비율의 주·전체 비교는 모두 보정 p&lt;0.001이다.</a:t>
+              <a:t>SCD의 효과는 생성 답변에서 한글이 차지하는 비중의 증가다.</a:t>
             </a:r>
           </a:p>
           <a:p xmlns:a="http://schemas.openxmlformats.org/drawingml/2006/main">
@@ -14251,17 +14396,17 @@
                 <a:ea typeface="Malgun Gothic"/>
                 <a:cs typeface="Malgun Gothic"/>
               </a:rPr>
-              <a:t>HyDE 비교에는 번역·가상 문서 샘플링의 차이가 포함된다.</a:t>
+              <a:t>시간의 C×S 상호작용은 SCD별 CAD 시간 증가가 다름을 뜻한다.</a:t>
             </a:r>
           </a:p>
         </p:txBody>
       </p:sp>
       <p:sp>
         <p:nvSpPr>
-          <p:cNvPr id="60" name="">
+          <p:cNvPr id="62" name="">
             <a:extLst xmlns:a="http://schemas.openxmlformats.org/drawingml/2006/main">
               <a:ext uri="{FF2B5EF4-FFF2-40B4-BE49-F238E27FC236}">
-                <a16:creationId xmlns:a16="http://schemas.microsoft.com/office/drawing/2014/main" id="{4A955602-12DA-44DC-A84D-3186E76932A4}"/>
+                <a16:creationId xmlns:a16="http://schemas.microsoft.com/office/drawing/2014/main" id="{1A6884D4-63CA-443C-A900-861751A1763D}"/>
               </a:ext>
             </a:extLst>
           </p:cNvPr>
@@ -14289,10 +14434,10 @@
       </p:sp>
       <p:sp>
         <p:nvSpPr>
-          <p:cNvPr id="61" name="07 결론">
+          <p:cNvPr id="63" name="07 결론">
             <a:extLst xmlns:a="http://schemas.openxmlformats.org/drawingml/2006/main">
               <a:ext uri="{FF2B5EF4-FFF2-40B4-BE49-F238E27FC236}">
-                <a16:creationId xmlns:a16="http://schemas.microsoft.com/office/drawing/2014/main" id="{F51BB986-9EB1-4E30-A92A-52FDA2D62D97}"/>
+                <a16:creationId xmlns:a16="http://schemas.microsoft.com/office/drawing/2014/main" id="{2D47D047-7B98-4B89-B0BE-4840EBB284D7}"/>
               </a:ext>
             </a:extLst>
           </p:cNvPr>
@@ -14357,10 +14502,10 @@
       </p:sp>
       <p:sp>
         <p:nvSpPr>
-          <p:cNvPr id="62" name="본 연구는 HyDE·CAD·SCD 조합별 답변 품질, 한국어 문자 비율 및 실행 시간을 평가하였다. SCD는 한국어 ">
+          <p:cNvPr id="64" name="답변 품질은 평균 대응 차이와 보정 검정 결과로 판단한다. 한국어 사용 비중을 높이는 목적에는 SCD 결과를 참고한다">
             <a:extLst xmlns:a="http://schemas.openxmlformats.org/drawingml/2006/main">
               <a:ext uri="{FF2B5EF4-FFF2-40B4-BE49-F238E27FC236}">
-                <a16:creationId xmlns:a16="http://schemas.microsoft.com/office/drawing/2014/main" id="{10BFA70D-3412-40BB-9DDD-7E9BCC2DCD01}"/>
+                <a16:creationId xmlns:a16="http://schemas.microsoft.com/office/drawing/2014/main" id="{256E70C1-58A4-45EF-AD39-25ABE644EB11}"/>
               </a:ext>
             </a:extLst>
           </p:cNvPr>
@@ -14418,7 +14563,7 @@
                 <a:ea typeface="Malgun Gothic"/>
                 <a:cs typeface="Malgun Gothic"/>
               </a:rPr>
-              <a:t>본 연구는 HyDE·CAD·SCD 조합별 답변 품질,</a:t>
+              <a:t>답변 품질은 평균 대응 차이와 보정 검정 결과로 판단한다.</a:t>
             </a:r>
           </a:p>
           <a:p xmlns:a="http://schemas.openxmlformats.org/drawingml/2006/main">
@@ -14441,7 +14586,7 @@
                 <a:ea typeface="Malgun Gothic"/>
                 <a:cs typeface="Malgun Gothic"/>
               </a:rPr>
-              <a:t>한국어 문자 비율 및 실행 시간을 평가하였다.</a:t>
+              <a:t>한국어 사용 비중을 높이는 목적에는 SCD 결과를 참고한다.</a:t>
             </a:r>
           </a:p>
           <a:p xmlns:a="http://schemas.openxmlformats.org/drawingml/2006/main">
@@ -14464,7 +14609,7 @@
                 <a:ea typeface="Malgun Gothic"/>
                 <a:cs typeface="Malgun Gothic"/>
               </a:rPr>
-              <a:t>SCD는 한국어 문자 비율을 높였다(보정 p&lt;0.001).</a:t>
+              <a:t>CAD 적용은 질의별 충실도와 추가 실행 시간을 함께 검토한다.</a:t>
             </a:r>
           </a:p>
           <a:p xmlns:a="http://schemas.openxmlformats.org/drawingml/2006/main">
@@ -14487,7 +14632,7 @@
                 <a:ea typeface="Malgun Gothic"/>
                 <a:cs typeface="Malgun Gothic"/>
               </a:rPr>
-              <a:t>실행 시간의 H·C 주효과와 C×S 상호작용도 유의하였다.</a:t>
+              <a:t>HyDE 적용은 번역·가상 문서 생성과 검색 결과를 함께 비교한다.</a:t>
             </a:r>
           </a:p>
           <a:p xmlns:a="http://schemas.openxmlformats.org/drawingml/2006/main">
@@ -14510,17 +14655,17 @@
                 <a:ea typeface="Malgun Gothic"/>
                 <a:cs typeface="Malgun Gothic"/>
               </a:rPr>
-              <a:t>적용 조건은 목표 언어, 품질 결과와 허용 시간으로 비교한다.</a:t>
+              <a:t>최종 조합은 목표 언어·품질·허용 시간을 기준으로 선택한다.</a:t>
             </a:r>
           </a:p>
         </p:txBody>
       </p:sp>
       <p:sp>
         <p:nvSpPr>
-          <p:cNvPr id="63" name="">
+          <p:cNvPr id="65" name="">
             <a:extLst xmlns:a="http://schemas.openxmlformats.org/drawingml/2006/main">
               <a:ext uri="{FF2B5EF4-FFF2-40B4-BE49-F238E27FC236}">
-                <a16:creationId xmlns:a16="http://schemas.microsoft.com/office/drawing/2014/main" id="{A0D43F72-4EDF-43ED-9C58-F370A36175EE}"/>
+                <a16:creationId xmlns:a16="http://schemas.microsoft.com/office/drawing/2014/main" id="{699F36F0-008A-486C-9464-90212E23269A}"/>
               </a:ext>
             </a:extLst>
           </p:cNvPr>
@@ -14548,10 +14693,10 @@
       </p:sp>
       <p:sp>
         <p:nvSpPr>
-          <p:cNvPr id="64" name="08 주요 참고문헌">
+          <p:cNvPr id="66" name="08 주요 참고문헌">
             <a:extLst xmlns:a="http://schemas.openxmlformats.org/drawingml/2006/main">
               <a:ext uri="{FF2B5EF4-FFF2-40B4-BE49-F238E27FC236}">
-                <a16:creationId xmlns:a16="http://schemas.microsoft.com/office/drawing/2014/main" id="{73AFB703-F9C2-47C5-8A45-A19A38D34DDC}"/>
+                <a16:creationId xmlns:a16="http://schemas.microsoft.com/office/drawing/2014/main" id="{95B1E49D-E49A-4F7F-8889-8CFB7843BF7F}"/>
               </a:ext>
             </a:extLst>
           </p:cNvPr>
@@ -14616,10 +14761,10 @@
       </p:sp>
       <p:sp>
         <p:nvSpPr>
-          <p:cNvPr id="65" name="[1] Lewis et al. RAG. NeurIPS, 2020. [2] Gao et al. HyDE. ACL, 20">
+          <p:cNvPr id="67" name="[1] Lewis et al. RAG. NeurIPS, 2020. [2] Gao et al. HyDE. ACL, 20">
             <a:extLst xmlns:a="http://schemas.openxmlformats.org/drawingml/2006/main">
               <a:ext uri="{FF2B5EF4-FFF2-40B4-BE49-F238E27FC236}">
-                <a16:creationId xmlns:a16="http://schemas.microsoft.com/office/drawing/2014/main" id="{2B27162D-187F-4E38-AEB3-B3CE866B6835}"/>
+                <a16:creationId xmlns:a16="http://schemas.microsoft.com/office/drawing/2014/main" id="{5EDDFBC0-7294-47D3-B29B-78AC6D39D854}"/>
               </a:ext>
             </a:extLst>
           </p:cNvPr>
@@ -14730,10 +14875,10 @@
       </p:sp>
       <p:sp>
         <p:nvSpPr>
-          <p:cNvPr id="66" name="[4] Li et al. Language Drift and SCD. AAAI, 2026. [5] Chen et al.">
+          <p:cNvPr id="68" name="[4] Li et al. Language Drift and SCD. AAAI, 2026. [5] Chen et al.">
             <a:extLst xmlns:a="http://schemas.openxmlformats.org/drawingml/2006/main">
               <a:ext uri="{FF2B5EF4-FFF2-40B4-BE49-F238E27FC236}">
-                <a16:creationId xmlns:a16="http://schemas.microsoft.com/office/drawing/2014/main" id="{3DF0032D-802C-48C5-BA16-7DA4BC802D2C}"/>
+                <a16:creationId xmlns:a16="http://schemas.microsoft.com/office/drawing/2014/main" id="{7787E8CB-0758-47D2-97BE-4288DA5F967C}"/>
               </a:ext>
             </a:extLst>
           </p:cNvPr>
@@ -14844,10 +14989,10 @@
       </p:sp>
       <p:sp>
         <p:nvSpPr>
-          <p:cNvPr id="67" name="전체 22편과 통계 상세표·결측·민감도 분석은 동봉 자료에 수록">
+          <p:cNvPr id="69" name="전체 22편과 통계 상세표·결측·민감도 분석은 동봉 자료에 수록">
             <a:extLst xmlns:a="http://schemas.openxmlformats.org/drawingml/2006/main">
               <a:ext uri="{FF2B5EF4-FFF2-40B4-BE49-F238E27FC236}">
-                <a16:creationId xmlns:a16="http://schemas.microsoft.com/office/drawing/2014/main" id="{B04FD7C5-9E6A-483A-BC80-6ED18BC1A9F4}"/>
+                <a16:creationId xmlns:a16="http://schemas.microsoft.com/office/drawing/2014/main" id="{F6B3B1A1-E625-4E2E-A892-C40874E07B4C}"/>
               </a:ext>
             </a:extLst>
           </p:cNvPr>
@@ -14912,10 +15057,10 @@
       </p:sp>
       <p:sp>
         <p:nvSpPr>
-          <p:cNvPr id="68" name="영어 문서 4종 · 질의 60개 · 생성 모델 1종 · 질의별 반복측정">
+          <p:cNvPr id="70" name="영어 문서 4종 · 질의 60개 · 생성 모델 1종 · 질의별 반복측정">
             <a:extLst xmlns:a="http://schemas.openxmlformats.org/drawingml/2006/main">
               <a:ext uri="{FF2B5EF4-FFF2-40B4-BE49-F238E27FC236}">
-                <a16:creationId xmlns:a16="http://schemas.microsoft.com/office/drawing/2014/main" id="{8CF0F5B7-1181-4D32-A78F-EE3315576E85}"/>
+                <a16:creationId xmlns:a16="http://schemas.microsoft.com/office/drawing/2014/main" id="{5FF644E9-4725-449D-BF43-1E2E293850B6}"/>
               </a:ext>
             </a:extLst>
           </p:cNvPr>
@@ -14980,10 +15125,10 @@
       </p:sp>
       <p:sp>
         <p:nvSpPr>
-          <p:cNvPr id="69" name="A1 594 × 841 mm">
+          <p:cNvPr id="71" name="A1 594 × 841 mm">
             <a:extLst xmlns:a="http://schemas.openxmlformats.org/drawingml/2006/main">
               <a:ext uri="{FF2B5EF4-FFF2-40B4-BE49-F238E27FC236}">
-                <a16:creationId xmlns:a16="http://schemas.microsoft.com/office/drawing/2014/main" id="{24D13A9D-62CE-4199-ABA1-F0203CA00441}"/>
+                <a16:creationId xmlns:a16="http://schemas.microsoft.com/office/drawing/2014/main" id="{1B5BD4AF-57A6-4905-BB0B-694E3C210360}"/>
               </a:ext>
             </a:extLst>
           </p:cNvPr>
@@ -15049,7 +15194,7 @@
     </p:spTree>
     <p:extLst>
       <p:ext uri="{BB962C8B-B14F-4D97-AF65-F5344CB8AC3E}">
-        <p14:creationId xmlns:p14="http://schemas.microsoft.com/office/powerpoint/2010/main" val="912304359"/>
+        <p14:creationId xmlns:p14="http://schemas.microsoft.com/office/powerpoint/2010/main" val="1438640253"/>
       </p:ext>
     </p:extLst>
   </p:cSld>

</xml_diff>

<commit_message>
Finalize 72-item thesis and A1 poster submission audit
</commit_message>
<xml_diff>
--- a/FINALDOCS/POSTER/A1_FINAL_TITLE_CONFIRMED_20261010/M_RAG_A1_FINAL_EDITABLE.pptx
+++ b/FINALDOCS/POSTER/A1_FINAL_TITLE_CONFIRMED_20261010/M_RAG_A1_FINAL_EDITABLE.pptx
@@ -2,13 +2,13 @@
 <file path=ppt/presentation.xml><?xml version="1.0" encoding="utf-8"?>
 <p:presentation xmlns:p="http://schemas.openxmlformats.org/presentationml/2006/main">
   <p:sldMasterIdLst>
-    <p:sldMasterId xmlns:r="http://schemas.openxmlformats.org/officeDocument/2006/relationships" id="2147483648" r:id="Rb58195702ba64367"/>
+    <p:sldMasterId xmlns:r="http://schemas.openxmlformats.org/officeDocument/2006/relationships" id="2147483648" r:id="R16a58bf6f0514c86"/>
   </p:sldMasterIdLst>
   <p:notesMasterIdLst>
-    <p:notesMasterId xmlns:r="http://schemas.openxmlformats.org/officeDocument/2006/relationships" r:id="R8355700b404142f7"/>
+    <p:notesMasterId xmlns:r="http://schemas.openxmlformats.org/officeDocument/2006/relationships" r:id="R0c7be1f8abc2443b"/>
   </p:notesMasterIdLst>
   <p:sldIdLst>
-    <p:sldId xmlns:r="http://schemas.openxmlformats.org/officeDocument/2006/relationships" id="256" r:id="Rb4fbd5e9c87042fd"/>
+    <p:sldId xmlns:r="http://schemas.openxmlformats.org/officeDocument/2006/relationships" id="256" r:id="R2d580b33d23d47bc"/>
   </p:sldIdLst>
   <p:sldSz cx="21384000" cy="30276000"/>
   <p:notesSz cx="6858000" cy="9144000"/>
@@ -489,7 +489,7 @@
           <p:cNvPr id="3" name="Title">
             <a:extLst xmlns:a="http://schemas.openxmlformats.org/drawingml/2006/main">
               <a:ext uri="{FF2B5EF4-FFF2-40B4-BE49-F238E27FC236}">
-                <a16:creationId xmlns:a16="http://schemas.microsoft.com/office/drawing/2014/main" id="{5A91EE45-AEDF-480A-88C7-3C7272C2A7BA}"/>
+                <a16:creationId xmlns:a16="http://schemas.microsoft.com/office/drawing/2014/main" id="{848359CC-4D8E-41DA-B605-F3350540D806}"/>
               </a:ext>
             </a:extLst>
           </p:cNvPr>
@@ -646,7 +646,7 @@
           <p:cNvPr id="2" name="Subtitle">
             <a:extLst xmlns:a="http://schemas.openxmlformats.org/drawingml/2006/main">
               <a:ext uri="{FF2B5EF4-FFF2-40B4-BE49-F238E27FC236}">
-                <a16:creationId xmlns:a16="http://schemas.microsoft.com/office/drawing/2014/main" id="{C2CD1A07-9918-4FF9-99C6-7D12E3803759}"/>
+                <a16:creationId xmlns:a16="http://schemas.microsoft.com/office/drawing/2014/main" id="{74BC5F42-0E1F-46A2-9DB6-8C739EE2893B}"/>
               </a:ext>
             </a:extLst>
           </p:cNvPr>
@@ -820,7 +820,7 @@
           <p:cNvPr id="2" name="Section title">
             <a:extLst xmlns:a="http://schemas.openxmlformats.org/drawingml/2006/main">
               <a:ext uri="{FF2B5EF4-FFF2-40B4-BE49-F238E27FC236}">
-                <a16:creationId xmlns:a16="http://schemas.microsoft.com/office/drawing/2014/main" id="{9AC45DD9-BA39-4048-B4CE-6764F84D21EF}"/>
+                <a16:creationId xmlns:a16="http://schemas.microsoft.com/office/drawing/2014/main" id="{2363FC78-7A49-4239-99E6-CC0177D37821}"/>
               </a:ext>
             </a:extLst>
           </p:cNvPr>
@@ -994,7 +994,7 @@
           <p:cNvPr id="3" name="Title">
             <a:extLst xmlns:a="http://schemas.openxmlformats.org/drawingml/2006/main">
               <a:ext uri="{FF2B5EF4-FFF2-40B4-BE49-F238E27FC236}">
-                <a16:creationId xmlns:a16="http://schemas.microsoft.com/office/drawing/2014/main" id="{EA2FC633-F36A-4EEA-90D5-68F57241DFF3}"/>
+                <a16:creationId xmlns:a16="http://schemas.microsoft.com/office/drawing/2014/main" id="{E00B04E8-BB69-4285-9978-64BE368C77B1}"/>
               </a:ext>
             </a:extLst>
           </p:cNvPr>
@@ -1151,7 +1151,7 @@
           <p:cNvPr id="2" name="Body">
             <a:extLst xmlns:a="http://schemas.openxmlformats.org/drawingml/2006/main">
               <a:ext uri="{FF2B5EF4-FFF2-40B4-BE49-F238E27FC236}">
-                <a16:creationId xmlns:a16="http://schemas.microsoft.com/office/drawing/2014/main" id="{783B1D4C-AC93-4A3D-8A26-AFEE41E4C427}"/>
+                <a16:creationId xmlns:a16="http://schemas.microsoft.com/office/drawing/2014/main" id="{46821DE3-51DA-48BA-A39F-B87A769B079F}"/>
               </a:ext>
             </a:extLst>
           </p:cNvPr>
@@ -1325,7 +1325,7 @@
           <p:cNvPr id="4" name="Title">
             <a:extLst xmlns:a="http://schemas.openxmlformats.org/drawingml/2006/main">
               <a:ext uri="{FF2B5EF4-FFF2-40B4-BE49-F238E27FC236}">
-                <a16:creationId xmlns:a16="http://schemas.microsoft.com/office/drawing/2014/main" id="{A440D7EE-AFD1-4E82-9163-A560D9952CE9}"/>
+                <a16:creationId xmlns:a16="http://schemas.microsoft.com/office/drawing/2014/main" id="{4417882F-10E4-4CBA-BA7F-927DD5C4EDD7}"/>
               </a:ext>
             </a:extLst>
           </p:cNvPr>
@@ -1482,7 +1482,7 @@
           <p:cNvPr id="2" name="Left column">
             <a:extLst xmlns:a="http://schemas.openxmlformats.org/drawingml/2006/main">
               <a:ext uri="{FF2B5EF4-FFF2-40B4-BE49-F238E27FC236}">
-                <a16:creationId xmlns:a16="http://schemas.microsoft.com/office/drawing/2014/main" id="{ACD2F858-2D47-4E29-8E4E-26103C1AAD9A}"/>
+                <a16:creationId xmlns:a16="http://schemas.microsoft.com/office/drawing/2014/main" id="{38F0C527-7D24-474D-9CD5-E5253C099CCF}"/>
               </a:ext>
             </a:extLst>
           </p:cNvPr>
@@ -1639,7 +1639,7 @@
           <p:cNvPr id="3" name="Right column">
             <a:extLst xmlns:a="http://schemas.openxmlformats.org/drawingml/2006/main">
               <a:ext uri="{FF2B5EF4-FFF2-40B4-BE49-F238E27FC236}">
-                <a16:creationId xmlns:a16="http://schemas.microsoft.com/office/drawing/2014/main" id="{B61D93B1-80B0-49DF-9599-A0DB19857A1D}"/>
+                <a16:creationId xmlns:a16="http://schemas.microsoft.com/office/drawing/2014/main" id="{F7E70C3C-7F85-4165-9203-78C225FC2B3F}"/>
               </a:ext>
             </a:extLst>
           </p:cNvPr>
@@ -1813,7 +1813,7 @@
           <p:cNvPr id="3" name="Title">
             <a:extLst xmlns:a="http://schemas.openxmlformats.org/drawingml/2006/main">
               <a:ext uri="{FF2B5EF4-FFF2-40B4-BE49-F238E27FC236}">
-                <a16:creationId xmlns:a16="http://schemas.microsoft.com/office/drawing/2014/main" id="{7F44DFE3-DAF9-4DE6-9B54-B21F62016ABD}"/>
+                <a16:creationId xmlns:a16="http://schemas.microsoft.com/office/drawing/2014/main" id="{F2C5F39C-57B8-42F2-A00D-676970CBB52F}"/>
               </a:ext>
             </a:extLst>
           </p:cNvPr>
@@ -1970,7 +1970,7 @@
           <p:cNvPr id="2" name="Left column">
             <a:extLst xmlns:a="http://schemas.openxmlformats.org/drawingml/2006/main">
               <a:ext uri="{FF2B5EF4-FFF2-40B4-BE49-F238E27FC236}">
-                <a16:creationId xmlns:a16="http://schemas.microsoft.com/office/drawing/2014/main" id="{90350097-BA1C-4BAA-A102-E2B244F84659}"/>
+                <a16:creationId xmlns:a16="http://schemas.microsoft.com/office/drawing/2014/main" id="{73BAD953-F47A-4175-9BCA-5CE55BF76925}"/>
               </a:ext>
             </a:extLst>
           </p:cNvPr>
@@ -2165,12 +2165,12 @@
   </p:cSld>
   <p:clrMap bg1="lt1" tx1="dk1" bg2="lt2" tx2="dk2" accent1="accent1" accent2="accent2" accent3="accent3" accent4="accent4" accent5="accent5" accent6="accent6" hlink="hlink" folHlink="folHlink"/>
   <p:sldLayoutIdLst>
-    <p:sldLayoutId xmlns:r="http://schemas.openxmlformats.org/officeDocument/2006/relationships" id="2147483649" r:id="R46621acff3aa45c8"/>
-    <p:sldLayoutId xmlns:r="http://schemas.openxmlformats.org/officeDocument/2006/relationships" id="2147483650" r:id="Rd3103928456442b8"/>
-    <p:sldLayoutId xmlns:r="http://schemas.openxmlformats.org/officeDocument/2006/relationships" id="2147483651" r:id="R7f58072bf63f4eb2"/>
-    <p:sldLayoutId xmlns:r="http://schemas.openxmlformats.org/officeDocument/2006/relationships" id="2147483652" r:id="R812c19e0fc884bcb"/>
-    <p:sldLayoutId xmlns:r="http://schemas.openxmlformats.org/officeDocument/2006/relationships" id="2147483653" r:id="R3bb9fbb170bb4392"/>
-    <p:sldLayoutId xmlns:r="http://schemas.openxmlformats.org/officeDocument/2006/relationships" id="2147483654" r:id="R0a99c1cfc6ed4364"/>
+    <p:sldLayoutId xmlns:r="http://schemas.openxmlformats.org/officeDocument/2006/relationships" id="2147483649" r:id="R80110722d007410e"/>
+    <p:sldLayoutId xmlns:r="http://schemas.openxmlformats.org/officeDocument/2006/relationships" id="2147483650" r:id="Rb335736f41194d7f"/>
+    <p:sldLayoutId xmlns:r="http://schemas.openxmlformats.org/officeDocument/2006/relationships" id="2147483651" r:id="Rdedbe022be4e4e5c"/>
+    <p:sldLayoutId xmlns:r="http://schemas.openxmlformats.org/officeDocument/2006/relationships" id="2147483652" r:id="R9326ff41311e4390"/>
+    <p:sldLayoutId xmlns:r="http://schemas.openxmlformats.org/officeDocument/2006/relationships" id="2147483653" r:id="R0794f6036e83440f"/>
+    <p:sldLayoutId xmlns:r="http://schemas.openxmlformats.org/officeDocument/2006/relationships" id="2147483654" r:id="Rc3cde7c99c9546a3"/>
   </p:sldLayoutIdLst>
   <p:txStyles>
     <p:titleStyle>
@@ -2718,10 +2718,10 @@
       </p:grpSpPr>
       <p:sp>
         <p:nvSpPr>
-          <p:cNvPr id="72" name="">
+          <p:cNvPr id="75" name="">
             <a:extLst xmlns:a="http://schemas.openxmlformats.org/drawingml/2006/main">
               <a:ext uri="{FF2B5EF4-FFF2-40B4-BE49-F238E27FC236}">
-                <a16:creationId xmlns:a16="http://schemas.microsoft.com/office/drawing/2014/main" id="{D4CFD0F9-6A59-4FB8-8ED9-1317988689C6}"/>
+                <a16:creationId xmlns:a16="http://schemas.microsoft.com/office/drawing/2014/main" id="{662205CB-56E8-4729-BFA7-C57BB698F207}"/>
               </a:ext>
             </a:extLst>
           </p:cNvPr>
@@ -2752,7 +2752,7 @@
           <p:cNvPr id="2" name="한국어 질의로 영어 학술·기술 문서를 검색하는">
             <a:extLst xmlns:a="http://schemas.openxmlformats.org/drawingml/2006/main">
               <a:ext uri="{FF2B5EF4-FFF2-40B4-BE49-F238E27FC236}">
-                <a16:creationId xmlns:a16="http://schemas.microsoft.com/office/drawing/2014/main" id="{414E6030-85A1-4EE5-83A0-EA678FCA0F17}"/>
+                <a16:creationId xmlns:a16="http://schemas.microsoft.com/office/drawing/2014/main" id="{7E48507D-2D4A-4296-9D3D-6C6B4369C461}"/>
               </a:ext>
             </a:extLst>
           </p:cNvPr>
@@ -2820,7 +2820,7 @@
           <p:cNvPr id="3" name="RAG에서의 HyDE·CAD·SCD 조합 실험">
             <a:extLst xmlns:a="http://schemas.openxmlformats.org/drawingml/2006/main">
               <a:ext uri="{FF2B5EF4-FFF2-40B4-BE49-F238E27FC236}">
-                <a16:creationId xmlns:a16="http://schemas.microsoft.com/office/drawing/2014/main" id="{96C305DE-F25A-43E5-8AA7-5D6CA2EBC169}"/>
+                <a16:creationId xmlns:a16="http://schemas.microsoft.com/office/drawing/2014/main" id="{DE9E98EE-3B20-40D8-A5F2-0A5C489A4718}"/>
               </a:ext>
             </a:extLst>
           </p:cNvPr>
@@ -2888,7 +2888,7 @@
           <p:cNvPr id="4" name="문종건 · 동국대학교 WISE캠퍼스 컴퓨터공학과 · 지도교수 김진석 · 2026.10.15">
             <a:extLst xmlns:a="http://schemas.openxmlformats.org/drawingml/2006/main">
               <a:ext uri="{FF2B5EF4-FFF2-40B4-BE49-F238E27FC236}">
-                <a16:creationId xmlns:a16="http://schemas.microsoft.com/office/drawing/2014/main" id="{99569B2E-80F7-40EB-A2BB-48CEBAF00D5C}"/>
+                <a16:creationId xmlns:a16="http://schemas.microsoft.com/office/drawing/2014/main" id="{A58E3837-B1B5-4DBC-B883-05FB9CDA6C3C}"/>
               </a:ext>
             </a:extLst>
           </p:cNvPr>
@@ -2956,7 +2956,7 @@
           <p:cNvPr id="5" name="">
             <a:extLst xmlns:a="http://schemas.openxmlformats.org/drawingml/2006/main">
               <a:ext uri="{FF2B5EF4-FFF2-40B4-BE49-F238E27FC236}">
-                <a16:creationId xmlns:a16="http://schemas.microsoft.com/office/drawing/2014/main" id="{253BF2B0-4536-4FD7-9A5E-F7DAEA3A6117}"/>
+                <a16:creationId xmlns:a16="http://schemas.microsoft.com/office/drawing/2014/main" id="{7C80E843-63AE-4D8B-937D-DCFDB40039E9}"/>
               </a:ext>
             </a:extLst>
           </p:cNvPr>
@@ -2987,7 +2987,7 @@
           <p:cNvPr id="6" name="01 연구 배경과 목적">
             <a:extLst xmlns:a="http://schemas.openxmlformats.org/drawingml/2006/main">
               <a:ext uri="{FF2B5EF4-FFF2-40B4-BE49-F238E27FC236}">
-                <a16:creationId xmlns:a16="http://schemas.microsoft.com/office/drawing/2014/main" id="{AC3BC1F2-5A93-46C5-A2FF-F82551289918}"/>
+                <a16:creationId xmlns:a16="http://schemas.microsoft.com/office/drawing/2014/main" id="{12AD9B65-CF84-4269-BB0F-89D76A16B10F}"/>
               </a:ext>
             </a:extLst>
           </p:cNvPr>
@@ -3055,7 +3055,7 @@
           <p:cNvPr id="7" name="검색 증강 생성(Retrieval-Augmented Generation, RAG)은 관련 문서 구간을 검색하고 그 텍">
             <a:extLst xmlns:a="http://schemas.openxmlformats.org/drawingml/2006/main">
               <a:ext uri="{FF2B5EF4-FFF2-40B4-BE49-F238E27FC236}">
-                <a16:creationId xmlns:a16="http://schemas.microsoft.com/office/drawing/2014/main" id="{9A929349-2D11-4E58-B171-02764181B38F}"/>
+                <a16:creationId xmlns:a16="http://schemas.microsoft.com/office/drawing/2014/main" id="{BFC63E54-7552-448F-B768-4B376ACD3CBC}"/>
               </a:ext>
             </a:extLst>
           </p:cNvPr>
@@ -3143,10 +3143,10 @@
       </p:sp>
       <p:sp>
         <p:nvSpPr>
-          <p:cNvPr id="8" name="HyDE(Hypothetical Document Embeddings): 가상 문서 검색[2] CAD(Context-A">
+          <p:cNvPr id="8" name="HyDE: 가상 문서 임베딩(Hypothetical Document Embeddings) 가상 문서 검색 입력 구성[">
             <a:extLst xmlns:a="http://schemas.openxmlformats.org/drawingml/2006/main">
               <a:ext uri="{FF2B5EF4-FFF2-40B4-BE49-F238E27FC236}">
-                <a16:creationId xmlns:a16="http://schemas.microsoft.com/office/drawing/2014/main" id="{7B2AF846-F4B6-46DC-A435-2771E68310D7}"/>
+                <a16:creationId xmlns:a16="http://schemas.microsoft.com/office/drawing/2014/main" id="{2C6D1E42-A1B6-4FC3-8ECF-95944688FB22}"/>
               </a:ext>
             </a:extLst>
           </p:cNvPr>
@@ -3157,8 +3157,8 @@
         </p:nvSpPr>
         <p:spPr>
           <a:xfrm xmlns:a="http://schemas.openxmlformats.org/drawingml/2006/main">
-            <a:off x="704850" y="4905375"/>
-            <a:ext cx="9729975" cy="971550"/>
+            <a:off x="704850" y="4705350"/>
+            <a:ext cx="9729975" cy="1714500"/>
           </a:xfrm>
           <a:prstGeom xmlns:a="http://schemas.openxmlformats.org/drawingml/2006/main" prst="rect">
             <a:avLst/>
@@ -3204,7 +3204,7 @@
                 <a:ea typeface="Malgun Gothic"/>
                 <a:cs typeface="Malgun Gothic"/>
               </a:rPr>
-              <a:t>HyDE(Hypothetical Document Embeddings): 가상 문서 검색[2]</a:t>
+              <a:t>HyDE: 가상 문서 임베딩(Hypothetical Document Embeddings)</a:t>
             </a:r>
           </a:p>
           <a:p xmlns:a="http://schemas.openxmlformats.org/drawingml/2006/main">
@@ -3227,7 +3227,7 @@
                 <a:ea typeface="Malgun Gothic"/>
                 <a:cs typeface="Malgun Gothic"/>
               </a:rPr>
-              <a:t>CAD(Context-Aware Decoding): 검색 근거의 영향 조정[3]</a:t>
+              <a:t>가상 문서 검색 입력 구성[2]</a:t>
             </a:r>
           </a:p>
           <a:p xmlns:a="http://schemas.openxmlformats.org/drawingml/2006/main">
@@ -3250,17 +3250,86 @@
                 <a:ea typeface="Malgun Gothic"/>
                 <a:cs typeface="Malgun Gothic"/>
               </a:rPr>
-              <a:t>SCD(Soft Constrained Decoding): 출력 언어 제어[4]</a:t>
+              <a:t>CAD: 문맥 인식 디코딩(Context-Aware Decoding)</a:t>
+            </a:r>
+          </a:p>
+          <a:p xmlns:a="http://schemas.openxmlformats.org/drawingml/2006/main">
+            <a:pPr algn="l">
+              <a:defRPr sz="1800" b="0">
+                <a:solidFill>
+                  <a:srgbClr val="24324A"/>
+                </a:solidFill>
+                <a:latin typeface="Malgun Gothic"/>
+                <a:ea typeface="Malgun Gothic"/>
+                <a:cs typeface="Malgun Gothic"/>
+              </a:defRPr>
+            </a:pPr>
+            <a:r>
+              <a:rPr sz="1800" b="0">
+                <a:solidFill>
+                  <a:srgbClr val="24324A"/>
+                </a:solidFill>
+                <a:latin typeface="Malgun Gothic"/>
+                <a:ea typeface="Malgun Gothic"/>
+                <a:cs typeface="Malgun Gothic"/>
+              </a:rPr>
+              <a:t>검색 근거의 영향 조정[3]</a:t>
+            </a:r>
+          </a:p>
+          <a:p xmlns:a="http://schemas.openxmlformats.org/drawingml/2006/main">
+            <a:pPr algn="l">
+              <a:defRPr sz="1800" b="0">
+                <a:solidFill>
+                  <a:srgbClr val="24324A"/>
+                </a:solidFill>
+                <a:latin typeface="Malgun Gothic"/>
+                <a:ea typeface="Malgun Gothic"/>
+                <a:cs typeface="Malgun Gothic"/>
+              </a:defRPr>
+            </a:pPr>
+            <a:r>
+              <a:rPr sz="1800" b="0">
+                <a:solidFill>
+                  <a:srgbClr val="24324A"/>
+                </a:solidFill>
+                <a:latin typeface="Malgun Gothic"/>
+                <a:ea typeface="Malgun Gothic"/>
+                <a:cs typeface="Malgun Gothic"/>
+              </a:rPr>
+              <a:t>SCD: 소프트 제약 디코딩(Soft Constrained Decoding)</a:t>
+            </a:r>
+          </a:p>
+          <a:p xmlns:a="http://schemas.openxmlformats.org/drawingml/2006/main">
+            <a:pPr algn="l">
+              <a:defRPr sz="1800" b="0">
+                <a:solidFill>
+                  <a:srgbClr val="24324A"/>
+                </a:solidFill>
+                <a:latin typeface="Malgun Gothic"/>
+                <a:ea typeface="Malgun Gothic"/>
+                <a:cs typeface="Malgun Gothic"/>
+              </a:defRPr>
+            </a:pPr>
+            <a:r>
+              <a:rPr sz="1800" b="0">
+                <a:solidFill>
+                  <a:srgbClr val="24324A"/>
+                </a:solidFill>
+                <a:latin typeface="Malgun Gothic"/>
+                <a:ea typeface="Malgun Gothic"/>
+                <a:cs typeface="Malgun Gothic"/>
+              </a:rPr>
+              <a:t>출력 언어 제어[4]</a:t>
             </a:r>
           </a:p>
         </p:txBody>
       </p:sp>
       <p:sp>
         <p:nvSpPr>
-          <p:cNvPr id="9" name="한국어 질문에 맞는 영어 근거를 찾고 한국어로 답변하는 과정에서는 검색 관련성과 근거 활용·출력 언어를 함께 평가할 ">
+          <p:cNvPr id="9" name="한국어 질의와 영어 문서의 표현 차이, 근거의 답변 반영, 출력 언어를 단계별로 평가할 필요가 있다. 본 연구는 동일">
             <a:extLst xmlns:a="http://schemas.openxmlformats.org/drawingml/2006/main">
               <a:ext uri="{FF2B5EF4-FFF2-40B4-BE49-F238E27FC236}">
-                <a16:creationId xmlns:a16="http://schemas.microsoft.com/office/drawing/2014/main" id="{5AA53F97-31E4-4F23-A372-1411F5AA103D}"/>
+                <a16:creationId xmlns:a16="http://schemas.microsoft.com/office/drawing/2014/main" id="{5640AC6E-A6B8-4075-A853-035C7FB1D2F5}"/>
               </a:ext>
             </a:extLst>
           </p:cNvPr>
@@ -3271,8 +3340,8 @@
         </p:nvSpPr>
         <p:spPr>
           <a:xfrm xmlns:a="http://schemas.openxmlformats.org/drawingml/2006/main">
-            <a:off x="704850" y="6038850"/>
-            <a:ext cx="9729975" cy="1219200"/>
+            <a:off x="704850" y="6457950"/>
+            <a:ext cx="9729975" cy="857250"/>
           </a:xfrm>
           <a:prstGeom xmlns:a="http://schemas.openxmlformats.org/drawingml/2006/main" prst="rect">
             <a:avLst/>
@@ -3318,7 +3387,7 @@
                 <a:ea typeface="Malgun Gothic"/>
                 <a:cs typeface="Malgun Gothic"/>
               </a:rPr>
-              <a:t>한국어 질문에 맞는 영어 근거를 찾고 한국어로 답변하는</a:t>
+              <a:t>한국어 질의와 영어 문서의 표현 차이, 근거의 답변 반영,</a:t>
             </a:r>
           </a:p>
           <a:p xmlns:a="http://schemas.openxmlformats.org/drawingml/2006/main">
@@ -3341,7 +3410,7 @@
                 <a:ea typeface="Malgun Gothic"/>
                 <a:cs typeface="Malgun Gothic"/>
               </a:rPr>
-              <a:t>과정에서는 검색 관련성과 근거 활용·출력 언어를 함께</a:t>
+              <a:t>출력 언어를 단계별로 평가할 필요가 있다. 본 연구는</a:t>
             </a:r>
           </a:p>
           <a:p xmlns:a="http://schemas.openxmlformats.org/drawingml/2006/main">
@@ -3364,30 +3433,7 @@
                 <a:ea typeface="Malgun Gothic"/>
                 <a:cs typeface="Malgun Gothic"/>
               </a:rPr>
-              <a:t>평가할 필요가 있다. 본 연구는 같은 파이프라인에서</a:t>
-            </a:r>
-          </a:p>
-          <a:p xmlns:a="http://schemas.openxmlformats.org/drawingml/2006/main">
-            <a:pPr algn="l">
-              <a:defRPr sz="1800" b="1">
-                <a:solidFill>
-                  <a:srgbClr val="24324A"/>
-                </a:solidFill>
-                <a:latin typeface="Malgun Gothic"/>
-                <a:ea typeface="Malgun Gothic"/>
-                <a:cs typeface="Malgun Gothic"/>
-              </a:defRPr>
-            </a:pPr>
-            <a:r>
-              <a:rPr sz="1800" b="1">
-                <a:solidFill>
-                  <a:srgbClr val="24324A"/>
-                </a:solidFill>
-                <a:latin typeface="Malgun Gothic"/>
-                <a:ea typeface="Malgun Gothic"/>
-                <a:cs typeface="Malgun Gothic"/>
-              </a:rPr>
-              <a:t>세 기법의 적용 여부와 조합에 따른 결과를 비교한다.</a:t>
+              <a:t>동일 파이프라인에서 세 기법의 개별·조합 효과를 비교한다.</a:t>
             </a:r>
           </a:p>
         </p:txBody>
@@ -3397,7 +3443,7 @@
           <p:cNvPr id="10" name="">
             <a:extLst xmlns:a="http://schemas.openxmlformats.org/drawingml/2006/main">
               <a:ext uri="{FF2B5EF4-FFF2-40B4-BE49-F238E27FC236}">
-                <a16:creationId xmlns:a16="http://schemas.microsoft.com/office/drawing/2014/main" id="{4E19A4DE-40FC-46B6-BD73-6BA342D735C0}"/>
+                <a16:creationId xmlns:a16="http://schemas.microsoft.com/office/drawing/2014/main" id="{D1666CEC-2BBE-4D35-AA6F-C305A50BB28B}"/>
               </a:ext>
             </a:extLst>
           </p:cNvPr>
@@ -3428,7 +3474,7 @@
           <p:cNvPr id="11" name="02 Paper-RAG 구조와 기법 적용 위치">
             <a:extLst xmlns:a="http://schemas.openxmlformats.org/drawingml/2006/main">
               <a:ext uri="{FF2B5EF4-FFF2-40B4-BE49-F238E27FC236}">
-                <a16:creationId xmlns:a16="http://schemas.microsoft.com/office/drawing/2014/main" id="{8EFC967C-9332-43ED-9C7D-F9282239C933}"/>
+                <a16:creationId xmlns:a16="http://schemas.microsoft.com/office/drawing/2014/main" id="{A359DAFF-1DCC-42DF-9631-830EB45CBF2F}"/>
               </a:ext>
             </a:extLst>
           </p:cNvPr>
@@ -3496,7 +3542,7 @@
           <p:cNvPr id="12" name="Paper-RAG는 본 연구의 고정 검색·생성 파이프라인이다.">
             <a:extLst xmlns:a="http://schemas.openxmlformats.org/drawingml/2006/main">
               <a:ext uri="{FF2B5EF4-FFF2-40B4-BE49-F238E27FC236}">
-                <a16:creationId xmlns:a16="http://schemas.microsoft.com/office/drawing/2014/main" id="{230E6C4D-C7F1-4F53-B47F-77EE654CA3D2}"/>
+                <a16:creationId xmlns:a16="http://schemas.microsoft.com/office/drawing/2014/main" id="{65CEE761-27C9-46D0-8B8B-E8C8D9B8C5FA}"/>
               </a:ext>
             </a:extLst>
           </p:cNvPr>
@@ -3564,7 +3610,7 @@
           <p:cNvPr id="13" name="">
             <a:extLst xmlns:a="http://schemas.openxmlformats.org/drawingml/2006/main">
               <a:ext uri="{FF2B5EF4-FFF2-40B4-BE49-F238E27FC236}">
-                <a16:creationId xmlns:a16="http://schemas.microsoft.com/office/drawing/2014/main" id="{8E08C655-605A-418C-96EC-E19917C45727}"/>
+                <a16:creationId xmlns:a16="http://schemas.microsoft.com/office/drawing/2014/main" id="{FDEC1F70-A555-4911-84C4-1E7D6F0D97E6}"/>
               </a:ext>
             </a:extLst>
           </p:cNvPr>
@@ -3597,7 +3643,7 @@
           <p:cNvPr id="14" name="한국어 질의 HyDE OFF: 원질의 HyDE ON: 영어 번역·가상 문서">
             <a:extLst xmlns:a="http://schemas.openxmlformats.org/drawingml/2006/main">
               <a:ext uri="{FF2B5EF4-FFF2-40B4-BE49-F238E27FC236}">
-                <a16:creationId xmlns:a16="http://schemas.microsoft.com/office/drawing/2014/main" id="{AFE4F61E-41E3-408A-AB8C-614B5B435CA2}"/>
+                <a16:creationId xmlns:a16="http://schemas.microsoft.com/office/drawing/2014/main" id="{618FAC3F-A521-42F8-9CD6-066189936BE8}"/>
               </a:ext>
             </a:extLst>
           </p:cNvPr>
@@ -3711,7 +3757,7 @@
           <p:cNvPr id="15" name="">
             <a:extLst xmlns:a="http://schemas.openxmlformats.org/drawingml/2006/main">
               <a:ext uri="{FF2B5EF4-FFF2-40B4-BE49-F238E27FC236}">
-                <a16:creationId xmlns:a16="http://schemas.microsoft.com/office/drawing/2014/main" id="{32BA3CC5-9865-43A6-8D6A-1D34CFC52EDB}"/>
+                <a16:creationId xmlns:a16="http://schemas.microsoft.com/office/drawing/2014/main" id="{31FAE63D-9DB8-416E-88E6-ABF20C78A2AE}"/>
               </a:ext>
             </a:extLst>
           </p:cNvPr>
@@ -3744,7 +3790,7 @@
           <p:cNvPr id="16" name="BM25 희소 검색[6] 한국어 원질의 사용">
             <a:extLst xmlns:a="http://schemas.openxmlformats.org/drawingml/2006/main">
               <a:ext uri="{FF2B5EF4-FFF2-40B4-BE49-F238E27FC236}">
-                <a16:creationId xmlns:a16="http://schemas.microsoft.com/office/drawing/2014/main" id="{720E7D7B-8A6D-4714-8D55-7E990D8A8EED}"/>
+                <a16:creationId xmlns:a16="http://schemas.microsoft.com/office/drawing/2014/main" id="{7A4978EA-8000-42B7-A520-16E123176525}"/>
               </a:ext>
             </a:extLst>
           </p:cNvPr>
@@ -3835,7 +3881,7 @@
           <p:cNvPr id="17" name="">
             <a:extLst xmlns:a="http://schemas.openxmlformats.org/drawingml/2006/main">
               <a:ext uri="{FF2B5EF4-FFF2-40B4-BE49-F238E27FC236}">
-                <a16:creationId xmlns:a16="http://schemas.microsoft.com/office/drawing/2014/main" id="{7B5D37E8-E90C-4ED4-BBFF-28C96FEA3D39}"/>
+                <a16:creationId xmlns:a16="http://schemas.microsoft.com/office/drawing/2014/main" id="{A255968A-A3AF-4E1A-8A39-A96B04DDD5BA}"/>
               </a:ext>
             </a:extLst>
           </p:cNvPr>
@@ -3868,7 +3914,7 @@
           <p:cNvPr id="18" name="BGE-M3 밀집 검색[5]">
             <a:extLst xmlns:a="http://schemas.openxmlformats.org/drawingml/2006/main">
               <a:ext uri="{FF2B5EF4-FFF2-40B4-BE49-F238E27FC236}">
-                <a16:creationId xmlns:a16="http://schemas.microsoft.com/office/drawing/2014/main" id="{EF8E0E64-9451-4905-9C8E-7980447E52EA}"/>
+                <a16:creationId xmlns:a16="http://schemas.microsoft.com/office/drawing/2014/main" id="{861CA805-13DA-42D7-83F2-F22FA1AAD0A2}"/>
               </a:ext>
             </a:extLst>
           </p:cNvPr>
@@ -3936,7 +3982,7 @@
           <p:cNvPr id="19" name="">
             <a:extLst xmlns:a="http://schemas.openxmlformats.org/drawingml/2006/main">
               <a:ext uri="{FF2B5EF4-FFF2-40B4-BE49-F238E27FC236}">
-                <a16:creationId xmlns:a16="http://schemas.microsoft.com/office/drawing/2014/main" id="{D82A6468-7B39-4348-BE2C-91E8B8D476F8}"/>
+                <a16:creationId xmlns:a16="http://schemas.microsoft.com/office/drawing/2014/main" id="{F05EAABA-C861-4B00-B54C-CED5A7772525}"/>
               </a:ext>
             </a:extLst>
           </p:cNvPr>
@@ -3969,7 +4015,7 @@
           <p:cNvPr id="20" name="가중 RRF[7] 0.6 / 0.4, k=60">
             <a:extLst xmlns:a="http://schemas.openxmlformats.org/drawingml/2006/main">
               <a:ext uri="{FF2B5EF4-FFF2-40B4-BE49-F238E27FC236}">
-                <a16:creationId xmlns:a16="http://schemas.microsoft.com/office/drawing/2014/main" id="{71F74FE8-7D44-4B69-9DB8-991105B62EC3}"/>
+                <a16:creationId xmlns:a16="http://schemas.microsoft.com/office/drawing/2014/main" id="{D8AFCB13-FB30-44B0-B4CE-00343984AA7E}"/>
               </a:ext>
             </a:extLst>
           </p:cNvPr>
@@ -4060,7 +4106,7 @@
           <p:cNvPr id="21" name="">
             <a:extLst xmlns:a="http://schemas.openxmlformats.org/drawingml/2006/main">
               <a:ext uri="{FF2B5EF4-FFF2-40B4-BE49-F238E27FC236}">
-                <a16:creationId xmlns:a16="http://schemas.microsoft.com/office/drawing/2014/main" id="{75BA7326-1670-409B-BDEC-8A1981264671}"/>
+                <a16:creationId xmlns:a16="http://schemas.microsoft.com/office/drawing/2014/main" id="{6E75C063-180B-46BC-9C20-AF20BE810BCD}"/>
               </a:ext>
             </a:extLst>
           </p:cNvPr>
@@ -4092,7 +4138,7 @@
           <p:cNvPr id="22" name="">
             <a:extLst xmlns:a="http://schemas.openxmlformats.org/drawingml/2006/main">
               <a:ext uri="{FF2B5EF4-FFF2-40B4-BE49-F238E27FC236}">
-                <a16:creationId xmlns:a16="http://schemas.microsoft.com/office/drawing/2014/main" id="{5C51D29E-9C19-4E42-98FA-E0F0949EB7AF}"/>
+                <a16:creationId xmlns:a16="http://schemas.microsoft.com/office/drawing/2014/main" id="{A3AAAD59-D5F6-4AB8-B76E-8385F8D5ADFA}"/>
               </a:ext>
             </a:extLst>
           </p:cNvPr>
@@ -4124,7 +4170,7 @@
           <p:cNvPr id="23" name="">
             <a:extLst xmlns:a="http://schemas.openxmlformats.org/drawingml/2006/main">
               <a:ext uri="{FF2B5EF4-FFF2-40B4-BE49-F238E27FC236}">
-                <a16:creationId xmlns:a16="http://schemas.microsoft.com/office/drawing/2014/main" id="{D98D7584-7D06-4D7C-A98F-CC35AD3D7912}"/>
+                <a16:creationId xmlns:a16="http://schemas.microsoft.com/office/drawing/2014/main" id="{6AEDD4FF-C09C-4596-964A-E360834D7571}"/>
               </a:ext>
             </a:extLst>
           </p:cNvPr>
@@ -4156,7 +4202,7 @@
           <p:cNvPr id="24" name="">
             <a:extLst xmlns:a="http://schemas.openxmlformats.org/drawingml/2006/main">
               <a:ext uri="{FF2B5EF4-FFF2-40B4-BE49-F238E27FC236}">
-                <a16:creationId xmlns:a16="http://schemas.microsoft.com/office/drawing/2014/main" id="{B96C25D6-C7CC-44C4-9F1A-61F5C143F74D}"/>
+                <a16:creationId xmlns:a16="http://schemas.microsoft.com/office/drawing/2014/main" id="{DE693ADC-3015-4F57-8330-E5354036F23F}"/>
               </a:ext>
             </a:extLst>
           </p:cNvPr>
@@ -4189,7 +4235,7 @@
           <p:cNvPr id="25" name="원질의 기반 CrossEncoder 재정렬[8] 상위 5개 구간 선택·문맥 길이 관리">
             <a:extLst xmlns:a="http://schemas.openxmlformats.org/drawingml/2006/main">
               <a:ext uri="{FF2B5EF4-FFF2-40B4-BE49-F238E27FC236}">
-                <a16:creationId xmlns:a16="http://schemas.microsoft.com/office/drawing/2014/main" id="{8A6ED402-ADE3-4E8D-98EB-389D05827471}"/>
+                <a16:creationId xmlns:a16="http://schemas.microsoft.com/office/drawing/2014/main" id="{5114DAB0-4999-4624-93DB-3B3EB37ABD3F}"/>
               </a:ext>
             </a:extLst>
           </p:cNvPr>
@@ -4280,7 +4326,7 @@
           <p:cNvPr id="26" name="">
             <a:extLst xmlns:a="http://schemas.openxmlformats.org/drawingml/2006/main">
               <a:ext uri="{FF2B5EF4-FFF2-40B4-BE49-F238E27FC236}">
-                <a16:creationId xmlns:a16="http://schemas.microsoft.com/office/drawing/2014/main" id="{2A8934DE-3E6B-4F63-9A47-52D0F78FEF01}"/>
+                <a16:creationId xmlns:a16="http://schemas.microsoft.com/office/drawing/2014/main" id="{D9980D2E-0D33-46F0-B537-E56B9A7EDB14}"/>
               </a:ext>
             </a:extLst>
           </p:cNvPr>
@@ -4313,7 +4359,7 @@
           <p:cNvPr id="27" name="Mi:dm 2.0 Base Instruct[18] CAD 로짓 결합 후 SCD 언어별 조정, 최종 답변 생성">
             <a:extLst xmlns:a="http://schemas.openxmlformats.org/drawingml/2006/main">
               <a:ext uri="{FF2B5EF4-FFF2-40B4-BE49-F238E27FC236}">
-                <a16:creationId xmlns:a16="http://schemas.microsoft.com/office/drawing/2014/main" id="{3BFFBBA9-1563-4914-8152-37EF5D7265B7}"/>
+                <a16:creationId xmlns:a16="http://schemas.microsoft.com/office/drawing/2014/main" id="{C5BF05F1-93FA-4260-957B-C4B483540810}"/>
               </a:ext>
             </a:extLst>
           </p:cNvPr>
@@ -4404,7 +4450,7 @@
           <p:cNvPr id="28" name="">
             <a:extLst xmlns:a="http://schemas.openxmlformats.org/drawingml/2006/main">
               <a:ext uri="{FF2B5EF4-FFF2-40B4-BE49-F238E27FC236}">
-                <a16:creationId xmlns:a16="http://schemas.microsoft.com/office/drawing/2014/main" id="{CECA8F4E-FFD1-46AD-BF44-1C4DE2DD352D}"/>
+                <a16:creationId xmlns:a16="http://schemas.microsoft.com/office/drawing/2014/main" id="{8F48F89E-EF29-42DA-AA6E-5B5FB43D42B5}"/>
               </a:ext>
             </a:extLst>
           </p:cNvPr>
@@ -4436,7 +4482,7 @@
           <p:cNvPr id="29" name="">
             <a:extLst xmlns:a="http://schemas.openxmlformats.org/drawingml/2006/main">
               <a:ext uri="{FF2B5EF4-FFF2-40B4-BE49-F238E27FC236}">
-                <a16:creationId xmlns:a16="http://schemas.microsoft.com/office/drawing/2014/main" id="{35412CEA-F558-4C19-A845-67A96B697C25}"/>
+                <a16:creationId xmlns:a16="http://schemas.microsoft.com/office/drawing/2014/main" id="{8792B1DD-2037-4653-A37D-E7707BEBAA48}"/>
               </a:ext>
             </a:extLst>
           </p:cNvPr>
@@ -4468,7 +4514,7 @@
           <p:cNvPr id="30" name="">
             <a:extLst xmlns:a="http://schemas.openxmlformats.org/drawingml/2006/main">
               <a:ext uri="{FF2B5EF4-FFF2-40B4-BE49-F238E27FC236}">
-                <a16:creationId xmlns:a16="http://schemas.microsoft.com/office/drawing/2014/main" id="{1BA44F59-6A52-4CC5-897F-E928555663CB}"/>
+                <a16:creationId xmlns:a16="http://schemas.microsoft.com/office/drawing/2014/main" id="{E1740FB1-CC0B-47DB-937E-60985F7F4FC1}"/>
               </a:ext>
             </a:extLst>
           </p:cNvPr>
@@ -4499,7 +4545,7 @@
           <p:cNvPr id="31" name="03 3요인 완전요인 실험 설계">
             <a:extLst xmlns:a="http://schemas.openxmlformats.org/drawingml/2006/main">
               <a:ext uri="{FF2B5EF4-FFF2-40B4-BE49-F238E27FC236}">
-                <a16:creationId xmlns:a16="http://schemas.microsoft.com/office/drawing/2014/main" id="{B606FEA3-E2C9-4F85-8128-A061054E4E76}"/>
+                <a16:creationId xmlns:a16="http://schemas.microsoft.com/office/drawing/2014/main" id="{A87ECBC9-0566-4AF1-A6A6-B495B714053E}"/>
               </a:ext>
             </a:extLst>
           </p:cNvPr>
@@ -4567,7 +4613,7 @@
           <p:cNvPr id="32" name="H=HyDE, C=CAD, S=SCD   0=미적용, 1=적용">
             <a:extLst xmlns:a="http://schemas.openxmlformats.org/drawingml/2006/main">
               <a:ext uri="{FF2B5EF4-FFF2-40B4-BE49-F238E27FC236}">
-                <a16:creationId xmlns:a16="http://schemas.microsoft.com/office/drawing/2014/main" id="{5AF07CB1-4768-4AEF-A4CE-D6396453DDED}"/>
+                <a16:creationId xmlns:a16="http://schemas.microsoft.com/office/drawing/2014/main" id="{9F93F138-42C0-4DF2-BE1A-C4F25E7AAB51}"/>
               </a:ext>
             </a:extLst>
           </p:cNvPr>
@@ -4635,7 +4681,7 @@
           <p:cNvPr id="33" name="">
             <a:extLst xmlns:a="http://schemas.openxmlformats.org/drawingml/2006/main">
               <a:ext uri="{FF2B5EF4-FFF2-40B4-BE49-F238E27FC236}">
-                <a16:creationId xmlns:a16="http://schemas.microsoft.com/office/drawing/2014/main" id="{0DA121E0-5678-43DC-BD76-5AFD380A4A77}"/>
+                <a16:creationId xmlns:a16="http://schemas.microsoft.com/office/drawing/2014/main" id="{C4168366-7139-4AC4-B94A-0B6C1F71BCE1}"/>
               </a:ext>
             </a:extLst>
           </p:cNvPr>
@@ -6165,7 +6211,7 @@
           <p:cNvPr id="34" name="영어 문서 4종 × 15개 질의 × 8조건 = 480개 생성 기록">
             <a:extLst xmlns:a="http://schemas.openxmlformats.org/drawingml/2006/main">
               <a:ext uri="{FF2B5EF4-FFF2-40B4-BE49-F238E27FC236}">
-                <a16:creationId xmlns:a16="http://schemas.microsoft.com/office/drawing/2014/main" id="{3303E800-AAF7-499C-98E4-208F49806ABE}"/>
+                <a16:creationId xmlns:a16="http://schemas.microsoft.com/office/drawing/2014/main" id="{66864D79-5146-44E8-920A-A53838BB732D}"/>
               </a:ext>
             </a:extLst>
           </p:cNvPr>
@@ -6233,7 +6279,7 @@
           <p:cNvPr id="35" name="생성 512토큰, CAD α=0.5, SCD α=1.1·β=0.9·Tstart=5">
             <a:extLst xmlns:a="http://schemas.openxmlformats.org/drawingml/2006/main">
               <a:ext uri="{FF2B5EF4-FFF2-40B4-BE49-F238E27FC236}">
-                <a16:creationId xmlns:a16="http://schemas.microsoft.com/office/drawing/2014/main" id="{E26896D2-20F6-46D7-B9F8-4880AA0B2A7F}"/>
+                <a16:creationId xmlns:a16="http://schemas.microsoft.com/office/drawing/2014/main" id="{2A888506-9B62-4DFC-A046-71AEC1A91D87}"/>
               </a:ext>
             </a:extLst>
           </p:cNvPr>
@@ -6301,7 +6347,7 @@
           <p:cNvPr id="36" name="문서 요약을 15개 내용 단위로 나누어 질의를 작성하고, 총 60개 질의의 원문 페이지·정답 근거·답변 가능성을 확인">
             <a:extLst xmlns:a="http://schemas.openxmlformats.org/drawingml/2006/main">
               <a:ext uri="{FF2B5EF4-FFF2-40B4-BE49-F238E27FC236}">
-                <a16:creationId xmlns:a16="http://schemas.microsoft.com/office/drawing/2014/main" id="{6D56583D-CDF0-4D4C-8AC1-127D0208F063}"/>
+                <a16:creationId xmlns:a16="http://schemas.microsoft.com/office/drawing/2014/main" id="{D676F183-EBA1-4044-9E7D-3DCA6E5475AD}"/>
               </a:ext>
             </a:extLst>
           </p:cNvPr>
@@ -6392,7 +6438,7 @@
           <p:cNvPr id="37" name="">
             <a:extLst xmlns:a="http://schemas.openxmlformats.org/drawingml/2006/main">
               <a:ext uri="{FF2B5EF4-FFF2-40B4-BE49-F238E27FC236}">
-                <a16:creationId xmlns:a16="http://schemas.microsoft.com/office/drawing/2014/main" id="{E572C5AB-29F5-4CEA-8A76-ABBC8FA45D27}"/>
+                <a16:creationId xmlns:a16="http://schemas.microsoft.com/office/drawing/2014/main" id="{AC086B2B-56E3-4844-AF51-CABA5AC89075}"/>
               </a:ext>
             </a:extLst>
           </p:cNvPr>
@@ -6423,7 +6469,7 @@
           <p:cNvPr id="38" name="04 평가 지표 및 실험·통계 방법">
             <a:extLst xmlns:a="http://schemas.openxmlformats.org/drawingml/2006/main">
               <a:ext uri="{FF2B5EF4-FFF2-40B4-BE49-F238E27FC236}">
-                <a16:creationId xmlns:a16="http://schemas.microsoft.com/office/drawing/2014/main" id="{93562C60-058A-4342-8268-C54A1E300AF0}"/>
+                <a16:creationId xmlns:a16="http://schemas.microsoft.com/office/drawing/2014/main" id="{C6C06BA7-1329-4939-965D-859F5F94A444}"/>
               </a:ext>
             </a:extLst>
           </p:cNvPr>
@@ -6488,10 +6534,10 @@
       </p:sp>
       <p:sp>
         <p:nvSpPr>
-          <p:cNvPr id="39" name="근거 충실도: 답변 주장 중 검색 근거가 뒷받침하는 비율 답변 관련성: 답변에서 만든 질문과 원질문의 의미 유사도 문">
+          <p:cNvPr id="39" name="근거 충실도: 높을수록 검색 근거가 지지하는 답변 주장 비율이 크다. 답변 관련성: 높을수록 답변 기반 질문과 원질문">
             <a:extLst xmlns:a="http://schemas.openxmlformats.org/drawingml/2006/main">
               <a:ext uri="{FF2B5EF4-FFF2-40B4-BE49-F238E27FC236}">
-                <a16:creationId xmlns:a16="http://schemas.microsoft.com/office/drawing/2014/main" id="{D0E55636-1319-429C-8C8F-B79DF30B4D5B}"/>
+                <a16:creationId xmlns:a16="http://schemas.microsoft.com/office/drawing/2014/main" id="{5E7403BF-CFB6-4272-9D80-9510D5D9744F}"/>
               </a:ext>
             </a:extLst>
           </p:cNvPr>
@@ -6549,7 +6595,7 @@
                 <a:ea typeface="Malgun Gothic"/>
                 <a:cs typeface="Malgun Gothic"/>
               </a:rPr>
-              <a:t>근거 충실도: 답변 주장 중 검색 근거가 뒷받침하는 비율</a:t>
+              <a:t>근거 충실도: 높을수록 검색 근거가 지지하는 답변 주장 비율이 크다.</a:t>
             </a:r>
           </a:p>
           <a:p xmlns:a="http://schemas.openxmlformats.org/drawingml/2006/main">
@@ -6572,7 +6618,7 @@
                 <a:ea typeface="Malgun Gothic"/>
                 <a:cs typeface="Malgun Gothic"/>
               </a:rPr>
-              <a:t>답변 관련성: 답변에서 만든 질문과 원질문의 의미 유사도</a:t>
+              <a:t>답변 관련성: 높을수록 답변 기반 질문과 원질문의 의미가 가깝다.</a:t>
             </a:r>
           </a:p>
           <a:p xmlns:a="http://schemas.openxmlformats.org/drawingml/2006/main">
@@ -6595,7 +6641,7 @@
                 <a:ea typeface="Malgun Gothic"/>
                 <a:cs typeface="Malgun Gothic"/>
               </a:rPr>
-              <a:t>문맥 정밀도: 참조 답변에 유용한 구간의 상위 배치 정도</a:t>
+              <a:t>문맥 정밀도: 높을수록 참조 답변에 유용한 구간이 상위에 놓인다.</a:t>
             </a:r>
           </a:p>
           <a:p xmlns:a="http://schemas.openxmlformats.org/drawingml/2006/main">
@@ -6618,7 +6664,7 @@
                 <a:ea typeface="Malgun Gothic"/>
                 <a:cs typeface="Malgun Gothic"/>
               </a:rPr>
-              <a:t>문맥 재현율: 참조 답변 주장을 검색 문맥이 포괄하는 비율</a:t>
+              <a:t>문맥 재현율: 높을수록 검색 근거가 포괄하는 참조 답변 비중이 크다.</a:t>
             </a:r>
           </a:p>
           <a:p xmlns:a="http://schemas.openxmlformats.org/drawingml/2006/main">
@@ -6641,17 +6687,17 @@
                 <a:ea typeface="Malgun Gothic"/>
                 <a:cs typeface="Malgun Gothic"/>
               </a:rPr>
-              <a:t>한국어 비율: 한글 / (한글 + ASCII 영문자)</a:t>
+              <a:t>한국어 비율: 한글 / (한글 + ASCII 영문자), 높을수록 한글 비중이 크다.</a:t>
             </a:r>
           </a:p>
         </p:txBody>
       </p:sp>
       <p:sp>
         <p:nvSpPr>
-          <p:cNvPr id="40" name="품질 관측값은 0~1이며, 높은 값은 각 측정 특성이 큼을 뜻한다. 관련성 +0.080은 적용−미적용 평균 대응 점수">
+          <p:cNvPr id="40" name="품질 관측값은 0~1이다. 관련성 +0.080은 ON−OFF 평균 차이 0.080점이다. SD는 질의별 분포의 표본표">
             <a:extLst xmlns:a="http://schemas.openxmlformats.org/drawingml/2006/main">
               <a:ext uri="{FF2B5EF4-FFF2-40B4-BE49-F238E27FC236}">
-                <a16:creationId xmlns:a16="http://schemas.microsoft.com/office/drawing/2014/main" id="{1B29D8C8-3291-4B86-B849-4D0D89780C60}"/>
+                <a16:creationId xmlns:a16="http://schemas.microsoft.com/office/drawing/2014/main" id="{F22B2673-8C83-4EA0-8AF8-AB950575FE39}"/>
               </a:ext>
             </a:extLst>
           </p:cNvPr>
@@ -6662,7 +6708,7 @@
         </p:nvSpPr>
         <p:spPr>
           <a:xfrm xmlns:a="http://schemas.openxmlformats.org/drawingml/2006/main">
-            <a:off x="704850" y="21240750"/>
+            <a:off x="704850" y="21193125"/>
             <a:ext cx="9729975" cy="857250"/>
           </a:xfrm>
           <a:prstGeom xmlns:a="http://schemas.openxmlformats.org/drawingml/2006/main" prst="rect">
@@ -6709,7 +6755,7 @@
                 <a:ea typeface="Malgun Gothic"/>
                 <a:cs typeface="Malgun Gothic"/>
               </a:rPr>
-              <a:t>품질 관측값은 0~1이며, 높은 값은 각 측정 특성이 큼을 뜻한다.</a:t>
+              <a:t>품질 관측값은 0~1이다. 관련성 +0.080은 ON−OFF 평균 차이</a:t>
             </a:r>
           </a:p>
           <a:p xmlns:a="http://schemas.openxmlformats.org/drawingml/2006/main">
@@ -6732,7 +6778,7 @@
                 <a:ea typeface="Malgun Gothic"/>
                 <a:cs typeface="Malgun Gothic"/>
               </a:rPr>
-              <a:t>관련성 +0.080은 적용−미적용 평균 대응 점수 차이다.</a:t>
+              <a:t>0.080점이다. SD는 질의별 분포의 표본표준편차다.</a:t>
             </a:r>
           </a:p>
           <a:p xmlns:a="http://schemas.openxmlformats.org/drawingml/2006/main">
@@ -6765,7 +6811,7 @@
           <p:cNvPr id="41" name="평가 예시  ext_raptor_011, H0C0S0">
             <a:extLst xmlns:a="http://schemas.openxmlformats.org/drawingml/2006/main">
               <a:ext uri="{FF2B5EF4-FFF2-40B4-BE49-F238E27FC236}">
-                <a16:creationId xmlns:a16="http://schemas.microsoft.com/office/drawing/2014/main" id="{A8568CF7-B47D-4687-BEA6-2A27D6EABCAF}"/>
+                <a16:creationId xmlns:a16="http://schemas.microsoft.com/office/drawing/2014/main" id="{D7CBEFEC-D542-43E3-A12F-310A3F67EA91}"/>
               </a:ext>
             </a:extLst>
           </p:cNvPr>
@@ -6776,7 +6822,7 @@
         </p:nvSpPr>
         <p:spPr>
           <a:xfrm xmlns:a="http://schemas.openxmlformats.org/drawingml/2006/main">
-            <a:off x="704850" y="22155150"/>
+            <a:off x="704850" y="22098000"/>
             <a:ext cx="9729975" cy="285750"/>
           </a:xfrm>
           <a:prstGeom xmlns:a="http://schemas.openxmlformats.org/drawingml/2006/main" prst="rect">
@@ -6833,7 +6879,7 @@
           <p:cNvPr id="42" name="질문: Cinderella 사례의 정성 분석에서 RAPTOR의 tree-based retrieval이 DPR보다 주제">
             <a:extLst xmlns:a="http://schemas.openxmlformats.org/drawingml/2006/main">
               <a:ext uri="{FF2B5EF4-FFF2-40B4-BE49-F238E27FC236}">
-                <a16:creationId xmlns:a16="http://schemas.microsoft.com/office/drawing/2014/main" id="{4A8E0F01-D313-4A5C-A6A1-6870A59525DB}"/>
+                <a16:creationId xmlns:a16="http://schemas.microsoft.com/office/drawing/2014/main" id="{EF383AD0-D560-4E46-B03C-277EBE950E8B}"/>
               </a:ext>
             </a:extLst>
           </p:cNvPr>
@@ -6844,7 +6890,7 @@
         </p:nvSpPr>
         <p:spPr>
           <a:xfrm xmlns:a="http://schemas.openxmlformats.org/drawingml/2006/main">
-            <a:off x="704850" y="22479000"/>
+            <a:off x="704850" y="22402800"/>
             <a:ext cx="9729975" cy="857250"/>
           </a:xfrm>
           <a:prstGeom xmlns:a="http://schemas.openxmlformats.org/drawingml/2006/main" prst="rect">
@@ -6944,10 +6990,10 @@
       </p:sp>
       <p:sp>
         <p:nvSpPr>
-          <p:cNvPr id="43" name="근거 발췌: “RAPTOR selects nodes from different layers” 답변 발췌: “질문의 요">
+          <p:cNvPr id="43" name="참조 답변 요지(원문 p.19): RAPTOR는 이야기의 주요 부분을, DPR은 이야기의 좁은 일부를 자세히 검색한다">
             <a:extLst xmlns:a="http://schemas.openxmlformats.org/drawingml/2006/main">
               <a:ext uri="{FF2B5EF4-FFF2-40B4-BE49-F238E27FC236}">
-                <a16:creationId xmlns:a16="http://schemas.microsoft.com/office/drawing/2014/main" id="{E7371E4D-A2D7-41CF-B322-C6F67FE179AE}"/>
+                <a16:creationId xmlns:a16="http://schemas.microsoft.com/office/drawing/2014/main" id="{2AAA700B-49E2-4B20-8E39-0266A247F7C2}"/>
               </a:ext>
             </a:extLst>
           </p:cNvPr>
@@ -6958,7 +7004,98 @@
         </p:nvSpPr>
         <p:spPr>
           <a:xfrm xmlns:a="http://schemas.openxmlformats.org/drawingml/2006/main">
-            <a:off x="704850" y="23431500"/>
+            <a:off x="704850" y="23288625"/>
+            <a:ext cx="9729975" cy="571500"/>
+          </a:xfrm>
+          <a:prstGeom xmlns:a="http://schemas.openxmlformats.org/drawingml/2006/main" prst="rect">
+            <a:avLst/>
+          </a:prstGeom>
+          <a:noFill xmlns:a="http://schemas.openxmlformats.org/drawingml/2006/main"/>
+          <a:ln xmlns:a="http://schemas.openxmlformats.org/drawingml/2006/main" w="0">
+            <a:noFill/>
+          </a:ln>
+        </p:spPr>
+        <p:txBody>
+          <a:bodyPr xmlns:a="http://schemas.openxmlformats.org/drawingml/2006/main" wrap="none" lIns="0" tIns="0" rIns="0" bIns="0" anchor="t">
+            <a:noAutofit/>
+          </a:bodyPr>
+          <a:lstStyle xmlns:a="http://schemas.openxmlformats.org/drawingml/2006/main">
+            <a:defPPr algn="l">
+              <a:defRPr sz="1800" b="0">
+                <a:solidFill>
+                  <a:srgbClr val="24324A"/>
+                </a:solidFill>
+                <a:latin typeface="Malgun Gothic"/>
+                <a:ea typeface="Malgun Gothic"/>
+                <a:cs typeface="Malgun Gothic"/>
+              </a:defRPr>
+            </a:defPPr>
+          </a:lstStyle>
+          <a:p xmlns:a="http://schemas.openxmlformats.org/drawingml/2006/main">
+            <a:pPr algn="l">
+              <a:defRPr sz="1800" b="0">
+                <a:solidFill>
+                  <a:srgbClr val="24324A"/>
+                </a:solidFill>
+                <a:latin typeface="Malgun Gothic"/>
+                <a:ea typeface="Malgun Gothic"/>
+                <a:cs typeface="Malgun Gothic"/>
+              </a:defRPr>
+            </a:pPr>
+            <a:r>
+              <a:rPr sz="1800" b="0">
+                <a:solidFill>
+                  <a:srgbClr val="24324A"/>
+                </a:solidFill>
+                <a:latin typeface="Malgun Gothic"/>
+                <a:ea typeface="Malgun Gothic"/>
+                <a:cs typeface="Malgun Gothic"/>
+              </a:rPr>
+              <a:t>참조 답변 요지(원문 p.19): RAPTOR는 이야기의 주요 부분을,</a:t>
+            </a:r>
+          </a:p>
+          <a:p xmlns:a="http://schemas.openxmlformats.org/drawingml/2006/main">
+            <a:pPr algn="l">
+              <a:defRPr sz="1800" b="0">
+                <a:solidFill>
+                  <a:srgbClr val="24324A"/>
+                </a:solidFill>
+                <a:latin typeface="Malgun Gothic"/>
+                <a:ea typeface="Malgun Gothic"/>
+                <a:cs typeface="Malgun Gothic"/>
+              </a:defRPr>
+            </a:pPr>
+            <a:r>
+              <a:rPr sz="1800" b="0">
+                <a:solidFill>
+                  <a:srgbClr val="24324A"/>
+                </a:solidFill>
+                <a:latin typeface="Malgun Gothic"/>
+                <a:ea typeface="Malgun Gothic"/>
+                <a:cs typeface="Malgun Gothic"/>
+              </a:rPr>
+              <a:t>DPR은 이야기의 좁은 일부를 자세히 검색한다.</a:t>
+            </a:r>
+          </a:p>
+        </p:txBody>
+      </p:sp>
+      <p:sp>
+        <p:nvSpPr>
+          <p:cNvPr id="44" name="근거 발췌: “RAPTOR selects nodes from different layers” 생성 답변 발췌: “질문">
+            <a:extLst xmlns:a="http://schemas.openxmlformats.org/drawingml/2006/main">
+              <a:ext uri="{FF2B5EF4-FFF2-40B4-BE49-F238E27FC236}">
+                <a16:creationId xmlns:a16="http://schemas.microsoft.com/office/drawing/2014/main" id="{A8337AA5-218A-40ED-AEDA-2E0982324AA5}"/>
+              </a:ext>
+            </a:extLst>
+          </p:cNvPr>
+          <p:cNvSpPr>
+            <a:spLocks xmlns:a="http://schemas.openxmlformats.org/drawingml/2006/main" noGrp="1"/>
+          </p:cNvSpPr>
+          <p:nvPr/>
+        </p:nvSpPr>
+        <p:spPr>
+          <a:xfrm xmlns:a="http://schemas.openxmlformats.org/drawingml/2006/main">
+            <a:off x="704850" y="23888700"/>
             <a:ext cx="9729975" cy="857250"/>
           </a:xfrm>
           <a:prstGeom xmlns:a="http://schemas.openxmlformats.org/drawingml/2006/main" prst="rect">
@@ -7028,7 +7165,7 @@
                 <a:ea typeface="Malgun Gothic"/>
                 <a:cs typeface="Malgun Gothic"/>
               </a:rPr>
-              <a:t>답변 발췌: “질문의 요구사항에 따라 서로 다른</a:t>
+              <a:t>생성 답변 발췌: “질문의 요구사항에 따라 서로 다른</a:t>
             </a:r>
           </a:p>
           <a:p xmlns:a="http://schemas.openxmlformats.org/drawingml/2006/main">
@@ -7058,10 +7195,10 @@
       </p:sp>
       <p:sp>
         <p:nvSpPr>
-          <p:cNvPr id="44" name="충실도 1.000: 평가자가 추출한 주장을 검색 문맥이 지지 관련성 0.937: 답변 기반 질문과 원질문의 평균 의미">
+          <p:cNvPr id="45" name="충실도 1.000: 추출된 답변 주장을 검색 문맥이 모두 지지 관련성 0.937: 답변 기반 질문과 원질문의 평균 의">
             <a:extLst xmlns:a="http://schemas.openxmlformats.org/drawingml/2006/main">
               <a:ext uri="{FF2B5EF4-FFF2-40B4-BE49-F238E27FC236}">
-                <a16:creationId xmlns:a16="http://schemas.microsoft.com/office/drawing/2014/main" id="{0E44ED3F-B60F-4539-8872-68A249E14381}"/>
+                <a16:creationId xmlns:a16="http://schemas.microsoft.com/office/drawing/2014/main" id="{C54C3DD1-49C8-44B4-A3A2-B81BE8991EBE}"/>
               </a:ext>
             </a:extLst>
           </p:cNvPr>
@@ -7072,7 +7209,7 @@
         </p:nvSpPr>
         <p:spPr>
           <a:xfrm xmlns:a="http://schemas.openxmlformats.org/drawingml/2006/main">
-            <a:off x="704850" y="24384000"/>
+            <a:off x="704850" y="24784050"/>
             <a:ext cx="9729975" cy="571500"/>
           </a:xfrm>
           <a:prstGeom xmlns:a="http://schemas.openxmlformats.org/drawingml/2006/main" prst="rect">
@@ -7119,7 +7256,7 @@
                 <a:ea typeface="Malgun Gothic"/>
                 <a:cs typeface="Malgun Gothic"/>
               </a:rPr>
-              <a:t>충실도 1.000: 평가자가 추출한 주장을 검색 문맥이 지지</a:t>
+              <a:t>충실도 1.000: 추출된 답변 주장을 검색 문맥이 모두 지지</a:t>
             </a:r>
           </a:p>
           <a:p xmlns:a="http://schemas.openxmlformats.org/drawingml/2006/main">
@@ -7149,10 +7286,10 @@
       </p:sp>
       <p:sp>
         <p:nvSpPr>
-          <p:cNvPr id="45" name="평가: RAGAS 0.2.15[10], gpt-4o, BGE-M3 임베딩 S0: 영어 문맥 / S1: 한국어 번역 평">
+          <p:cNvPr id="46" name="평가: RAGAS 0.2.15[10], gpt-4o, BGE-M3 임베딩 S0: 영어 문맥 / S1: 한국어 번역 평">
             <a:extLst xmlns:a="http://schemas.openxmlformats.org/drawingml/2006/main">
               <a:ext uri="{FF2B5EF4-FFF2-40B4-BE49-F238E27FC236}">
-                <a16:creationId xmlns:a16="http://schemas.microsoft.com/office/drawing/2014/main" id="{383B2AFB-0588-4D96-B282-2CFA223686ED}"/>
+                <a16:creationId xmlns:a16="http://schemas.microsoft.com/office/drawing/2014/main" id="{922E7EA3-F45C-4B98-97EF-F3326A84E5DC}"/>
               </a:ext>
             </a:extLst>
           </p:cNvPr>
@@ -7163,7 +7300,7 @@
         </p:nvSpPr>
         <p:spPr>
           <a:xfrm xmlns:a="http://schemas.openxmlformats.org/drawingml/2006/main">
-            <a:off x="704850" y="25050750"/>
+            <a:off x="704850" y="25393650"/>
             <a:ext cx="9729975" cy="857250"/>
           </a:xfrm>
           <a:prstGeom xmlns:a="http://schemas.openxmlformats.org/drawingml/2006/main" prst="rect">
@@ -7263,10 +7400,10 @@
       </p:sp>
       <p:sp>
         <p:nvSpPr>
-          <p:cNvPr id="46" name="3요인 반복측정 분산분석(ANOVA)·대응 t-검정, Holm·α=0.05 질의 60개, 품질 S별 H×C / 문자 ">
+          <p:cNvPr id="47" name="반복측정 분산분석(ANOVA)·대응 t-검정·Holm, α=0.05 품질 S별 H×C / 문자·시간 H×C×S, SC">
             <a:extLst xmlns:a="http://schemas.openxmlformats.org/drawingml/2006/main">
               <a:ext uri="{FF2B5EF4-FFF2-40B4-BE49-F238E27FC236}">
-                <a16:creationId xmlns:a16="http://schemas.microsoft.com/office/drawing/2014/main" id="{7FC14F4B-CC3F-4027-9F13-E2BDF2AFDAB0}"/>
+                <a16:creationId xmlns:a16="http://schemas.microsoft.com/office/drawing/2014/main" id="{E842B2F6-E2E2-44AA-AA30-352B9330298E}"/>
               </a:ext>
             </a:extLst>
           </p:cNvPr>
@@ -7277,8 +7414,8 @@
         </p:nvSpPr>
         <p:spPr>
           <a:xfrm xmlns:a="http://schemas.openxmlformats.org/drawingml/2006/main">
-            <a:off x="704850" y="26003250"/>
-            <a:ext cx="9729975" cy="857250"/>
+            <a:off x="704850" y="26289000"/>
+            <a:ext cx="9729975" cy="571500"/>
           </a:xfrm>
           <a:prstGeom xmlns:a="http://schemas.openxmlformats.org/drawingml/2006/main" prst="rect">
             <a:avLst/>
@@ -7324,7 +7461,7 @@
                 <a:ea typeface="Malgun Gothic"/>
                 <a:cs typeface="Malgun Gothic"/>
               </a:rPr>
-              <a:t>3요인 반복측정 분산분석(ANOVA)·대응 t-검정, Holm·α=0.05</a:t>
+              <a:t>반복측정 분산분석(ANOVA)·대응 t-검정·Holm, α=0.05</a:t>
             </a:r>
           </a:p>
           <a:p xmlns:a="http://schemas.openxmlformats.org/drawingml/2006/main">
@@ -7347,40 +7484,17 @@
                 <a:ea typeface="Malgun Gothic"/>
                 <a:cs typeface="Malgun Gothic"/>
               </a:rPr>
-              <a:t>질의 60개, 품질 S별 H×C / 문자 비율·시간 H×C×S</a:t>
-            </a:r>
-          </a:p>
-          <a:p xmlns:a="http://schemas.openxmlformats.org/drawingml/2006/main">
-            <a:pPr algn="l">
-              <a:defRPr sz="1800" b="1">
-                <a:solidFill>
-                  <a:srgbClr val="24324A"/>
-                </a:solidFill>
-                <a:latin typeface="Malgun Gothic"/>
-                <a:ea typeface="Malgun Gothic"/>
-                <a:cs typeface="Malgun Gothic"/>
-              </a:defRPr>
-            </a:pPr>
-            <a:r>
-              <a:rPr sz="1800" b="1">
-                <a:solidFill>
-                  <a:srgbClr val="24324A"/>
-                </a:solidFill>
-                <a:latin typeface="Malgun Gothic"/>
-                <a:ea typeface="Malgun Gothic"/>
-                <a:cs typeface="Malgun Gothic"/>
-              </a:rPr>
-              <a:t>SCD 120·240쌍은 질의별 평균 차이 60개로 검정</a:t>
+              <a:t>품질 S별 H×C / 문자·시간 H×C×S, SCD 120·240쌍→질의60</a:t>
             </a:r>
           </a:p>
         </p:txBody>
       </p:sp>
       <p:sp>
         <p:nvSpPr>
-          <p:cNvPr id="47" name="">
+          <p:cNvPr id="48" name="">
             <a:extLst xmlns:a="http://schemas.openxmlformats.org/drawingml/2006/main">
               <a:ext uri="{FF2B5EF4-FFF2-40B4-BE49-F238E27FC236}">
-                <a16:creationId xmlns:a16="http://schemas.microsoft.com/office/drawing/2014/main" id="{40C8C176-4CCA-41F3-A201-F320E83D0675}"/>
+                <a16:creationId xmlns:a16="http://schemas.microsoft.com/office/drawing/2014/main" id="{F8CEE9B4-2143-4301-B133-36D58CA50FC8}"/>
               </a:ext>
             </a:extLst>
           </p:cNvPr>
@@ -7408,10 +7522,10 @@
       </p:sp>
       <p:sp>
         <p:nvSpPr>
-          <p:cNvPr id="48" name="05 조합별 결과와 통계 검정">
+          <p:cNvPr id="49" name="05 조합별 결과와 통계 검정">
             <a:extLst xmlns:a="http://schemas.openxmlformats.org/drawingml/2006/main">
               <a:ext uri="{FF2B5EF4-FFF2-40B4-BE49-F238E27FC236}">
-                <a16:creationId xmlns:a16="http://schemas.microsoft.com/office/drawing/2014/main" id="{2AA2D5B0-1C99-408F-8933-6E71054954D5}"/>
+                <a16:creationId xmlns:a16="http://schemas.microsoft.com/office/drawing/2014/main" id="{75E73BFA-1E7B-4493-8A44-26356040C6E9}"/>
               </a:ext>
             </a:extLst>
           </p:cNvPr>
@@ -7476,10 +7590,10 @@
       </p:sp>
       <p:sp>
         <p:nvSpPr>
-          <p:cNvPr id="49" name="HyDE·CAD·SCD 8조합의 품질·한국어 비율·시간 평균(SD)">
+          <p:cNvPr id="50" name="HyDE·CAD·SCD 8조합의 품질·한국어 비율·시간 평균(SD)">
             <a:extLst xmlns:a="http://schemas.openxmlformats.org/drawingml/2006/main">
               <a:ext uri="{FF2B5EF4-FFF2-40B4-BE49-F238E27FC236}">
-                <a16:creationId xmlns:a16="http://schemas.microsoft.com/office/drawing/2014/main" id="{ACF56130-E376-4F8B-8215-D52EAFE6200F}"/>
+                <a16:creationId xmlns:a16="http://schemas.microsoft.com/office/drawing/2014/main" id="{FC457C18-FED2-48C0-AC4D-61DA44DDE2D2}"/>
               </a:ext>
             </a:extLst>
           </p:cNvPr>
@@ -7544,10 +7658,10 @@
       </p:sp>
       <p:graphicFrame>
         <p:nvGraphicFramePr>
-          <p:cNvPr id="50" name="">
+          <p:cNvPr id="51" name="">
             <a:extLst xmlns:a="http://schemas.openxmlformats.org/drawingml/2006/main">
               <a:ext uri="{FF2B5EF4-FFF2-40B4-BE49-F238E27FC236}">
-                <a16:creationId xmlns:a16="http://schemas.microsoft.com/office/drawing/2014/main" id="{18C5C0EA-2652-44CB-B4B4-A33DBCA33A85}"/>
+                <a16:creationId xmlns:a16="http://schemas.microsoft.com/office/drawing/2014/main" id="{09A7DFE8-056D-4FE0-BF9B-762E4A0233E8}"/>
               </a:ext>
             </a:extLst>
           </p:cNvPr>
@@ -10904,10 +11018,10 @@
       </p:graphicFrame>
       <p:sp>
         <p:nvSpPr>
-          <p:cNvPr id="51" name="">
+          <p:cNvPr id="52" name="">
             <a:extLst xmlns:a="http://schemas.openxmlformats.org/drawingml/2006/main">
               <a:ext uri="{FF2B5EF4-FFF2-40B4-BE49-F238E27FC236}">
-                <a16:creationId xmlns:a16="http://schemas.microsoft.com/office/drawing/2014/main" id="{FBEB5C39-5AE7-4E22-B0C3-ACFDAC2E8463}"/>
+                <a16:creationId xmlns:a16="http://schemas.microsoft.com/office/drawing/2014/main" id="{01EC4494-FBB9-4E50-9937-0D99E3F2F648}"/>
               </a:ext>
             </a:extLst>
           </p:cNvPr>
@@ -10935,10 +11049,10 @@
       </p:sp>
       <p:sp>
         <p:nvSpPr>
-          <p:cNvPr id="52" name="S0: 영어 평가 문맥 / S1: 한국어 번역 평가 문맥 충실도 H0C1S0 n=58, H0C0S1 n=57, 나머지">
+          <p:cNvPr id="53" name="S0: 영어 평가 문맥 / S1: 한국어 번역 평가 문맥 충실도 H0C1S0 n=58, H0C0S1 n=57, 나머지">
             <a:extLst xmlns:a="http://schemas.openxmlformats.org/drawingml/2006/main">
               <a:ext uri="{FF2B5EF4-FFF2-40B4-BE49-F238E27FC236}">
-                <a16:creationId xmlns:a16="http://schemas.microsoft.com/office/drawing/2014/main" id="{C51A5B8D-32CE-4FD0-8442-B6A9D7F0BB4C}"/>
+                <a16:creationId xmlns:a16="http://schemas.microsoft.com/office/drawing/2014/main" id="{AFE0D401-8A15-4152-A41A-3760A2132737}"/>
               </a:ext>
             </a:extLst>
           </p:cNvPr>
@@ -11049,10 +11163,10 @@
       </p:sp>
       <p:sp>
         <p:nvSpPr>
-          <p:cNvPr id="53" name="3요인 반복측정 ANOVA  ·  각 효과 df=(1,59)">
+          <p:cNvPr id="54" name="3요인 반복측정 ANOVA  ·  각 효과 df=(1,59)">
             <a:extLst xmlns:a="http://schemas.openxmlformats.org/drawingml/2006/main">
               <a:ext uri="{FF2B5EF4-FFF2-40B4-BE49-F238E27FC236}">
-                <a16:creationId xmlns:a16="http://schemas.microsoft.com/office/drawing/2014/main" id="{F286C0D7-7932-46EC-86F4-DDFBFA77BC5A}"/>
+                <a16:creationId xmlns:a16="http://schemas.microsoft.com/office/drawing/2014/main" id="{7817F849-61CD-428A-8162-44EA13D2519A}"/>
               </a:ext>
             </a:extLst>
           </p:cNvPr>
@@ -11117,10 +11231,10 @@
       </p:sp>
       <p:graphicFrame>
         <p:nvGraphicFramePr>
-          <p:cNvPr id="54" name="">
+          <p:cNvPr id="55" name="">
             <a:extLst xmlns:a="http://schemas.openxmlformats.org/drawingml/2006/main">
               <a:ext uri="{FF2B5EF4-FFF2-40B4-BE49-F238E27FC236}">
-                <a16:creationId xmlns:a16="http://schemas.microsoft.com/office/drawing/2014/main" id="{B4EB41FC-FB60-4D81-9CE9-B108CD7402D9}"/>
+                <a16:creationId xmlns:a16="http://schemas.microsoft.com/office/drawing/2014/main" id="{5452750D-8BAD-44B6-9436-F4B1E1226E8E}"/>
               </a:ext>
             </a:extLst>
           </p:cNvPr>
@@ -12830,10 +12944,10 @@
       </p:graphicFrame>
       <p:sp>
         <p:nvSpPr>
-          <p:cNvPr id="55" name="문자 비율·시간은 각각 7검정에 Holm 보정. RAGAS H×C 검정은 평가 문맥 언어별로 수행했으며, 전체 24검">
+          <p:cNvPr id="56" name="문자 비율·시간은 각각 7검정에 Holm 보정. RAGAS H×C 검정은 평가 문맥 언어별로 수행했으며, 전체 24검">
             <a:extLst xmlns:a="http://schemas.openxmlformats.org/drawingml/2006/main">
               <a:ext uri="{FF2B5EF4-FFF2-40B4-BE49-F238E27FC236}">
-                <a16:creationId xmlns:a16="http://schemas.microsoft.com/office/drawing/2014/main" id="{C10B7B79-3FF2-4E2B-80A6-BCC642900708}"/>
+                <a16:creationId xmlns:a16="http://schemas.microsoft.com/office/drawing/2014/main" id="{511A453B-8A53-4CC4-BD1C-7E19A4CBC0E0}"/>
               </a:ext>
             </a:extLst>
           </p:cNvPr>
@@ -12944,10 +13058,10 @@
       </p:sp>
       <p:sp>
         <p:nvSpPr>
-          <p:cNvPr id="56" name="기법별 대응 비교  ·  질의별 평균 차이, 양측 검정">
+          <p:cNvPr id="57" name="기법별 대응 비교  ·  질의별 평균 차이, 양측 검정">
             <a:extLst xmlns:a="http://schemas.openxmlformats.org/drawingml/2006/main">
               <a:ext uri="{FF2B5EF4-FFF2-40B4-BE49-F238E27FC236}">
-                <a16:creationId xmlns:a16="http://schemas.microsoft.com/office/drawing/2014/main" id="{4689A15E-6183-463B-A8CF-57B562BE3071}"/>
+                <a16:creationId xmlns:a16="http://schemas.microsoft.com/office/drawing/2014/main" id="{558D78C8-6A76-4629-8E1F-F52B6A3BB2A2}"/>
               </a:ext>
             </a:extLst>
           </p:cNvPr>
@@ -13012,10 +13126,10 @@
       </p:sp>
       <p:graphicFrame>
         <p:nvGraphicFramePr>
-          <p:cNvPr id="57" name="">
+          <p:cNvPr id="58" name="">
             <a:extLst xmlns:a="http://schemas.openxmlformats.org/drawingml/2006/main">
               <a:ext uri="{FF2B5EF4-FFF2-40B4-BE49-F238E27FC236}">
-                <a16:creationId xmlns:a16="http://schemas.microsoft.com/office/drawing/2014/main" id="{EBCE8195-3933-4077-A4E0-B94F47BE84C7}"/>
+                <a16:creationId xmlns:a16="http://schemas.microsoft.com/office/drawing/2014/main" id="{246C911D-6624-44C8-A3F4-21854624A143}"/>
               </a:ext>
             </a:extLst>
           </p:cNvPr>
@@ -14053,10 +14167,10 @@
       </p:graphicFrame>
       <p:sp>
         <p:nvSpPr>
-          <p:cNvPr id="58" name="HyDE: C0S0, CAD: H0S0, SCD: H0의 CAD 상태 평균 보정: HyDE·CAD 각 4지표, SCD">
+          <p:cNvPr id="59" name="HyDE: C0S0, CAD: H0S0, SCD: H0의 CAD 상태 평균 보정: HyDE·CAD 각 4지표, SCD">
             <a:extLst xmlns:a="http://schemas.openxmlformats.org/drawingml/2006/main">
               <a:ext uri="{FF2B5EF4-FFF2-40B4-BE49-F238E27FC236}">
-                <a16:creationId xmlns:a16="http://schemas.microsoft.com/office/drawing/2014/main" id="{FE592256-9FEF-486E-8F6F-C721D671F915}"/>
+                <a16:creationId xmlns:a16="http://schemas.microsoft.com/office/drawing/2014/main" id="{7260EA1C-D30E-4F52-B88D-F3EF760CDD5C}"/>
               </a:ext>
             </a:extLst>
           </p:cNvPr>
@@ -14067,8 +14181,8 @@
         </p:nvSpPr>
         <p:spPr>
           <a:xfrm xmlns:a="http://schemas.openxmlformats.org/drawingml/2006/main">
-            <a:off x="10949175" y="21678900"/>
-            <a:ext cx="9729975" cy="904875"/>
+            <a:off x="10949175" y="21564600"/>
+            <a:ext cx="9729975" cy="1143000"/>
           </a:xfrm>
           <a:prstGeom xmlns:a="http://schemas.openxmlformats.org/drawingml/2006/main" prst="rect">
             <a:avLst/>
@@ -14163,14 +14277,37 @@
               <a:t>SCD 차이 +0.218은 한글 비중 +21.8%p에 해당</a:t>
             </a:r>
           </a:p>
+          <a:p xmlns:a="http://schemas.openxmlformats.org/drawingml/2006/main">
+            <a:pPr algn="l">
+              <a:defRPr sz="1800" b="0">
+                <a:solidFill>
+                  <a:srgbClr val="24324A"/>
+                </a:solidFill>
+                <a:latin typeface="Malgun Gothic"/>
+                <a:ea typeface="Malgun Gothic"/>
+                <a:cs typeface="Malgun Gothic"/>
+              </a:defRPr>
+            </a:pPr>
+            <a:r>
+              <a:rPr sz="1800" b="0">
+                <a:solidFill>
+                  <a:srgbClr val="24324A"/>
+                </a:solidFill>
+                <a:latin typeface="Malgun Gothic"/>
+                <a:ea typeface="Malgun Gothic"/>
+                <a:cs typeface="Malgun Gothic"/>
+              </a:rPr>
+              <a:t>평균표 SD는 점수의 산포, 대응표 SD는 ON−OFF 차이의 산포</a:t>
+            </a:r>
+          </a:p>
         </p:txBody>
       </p:sp>
       <p:sp>
         <p:nvSpPr>
-          <p:cNvPr id="59" name="">
+          <p:cNvPr id="60" name="">
             <a:extLst xmlns:a="http://schemas.openxmlformats.org/drawingml/2006/main">
               <a:ext uri="{FF2B5EF4-FFF2-40B4-BE49-F238E27FC236}">
-                <a16:creationId xmlns:a16="http://schemas.microsoft.com/office/drawing/2014/main" id="{783FA76B-B508-4B0E-948A-B4E5AE4E9DC1}"/>
+                <a16:creationId xmlns:a16="http://schemas.microsoft.com/office/drawing/2014/main" id="{912C0399-A0FC-4CD8-B637-706CDF064C9B}"/>
               </a:ext>
             </a:extLst>
           </p:cNvPr>
@@ -14198,10 +14335,10 @@
       </p:sp>
       <p:sp>
         <p:nvSpPr>
-          <p:cNvPr id="60" name="06 결과 해석">
+          <p:cNvPr id="61" name="06 결과 해석">
             <a:extLst xmlns:a="http://schemas.openxmlformats.org/drawingml/2006/main">
               <a:ext uri="{FF2B5EF4-FFF2-40B4-BE49-F238E27FC236}">
-                <a16:creationId xmlns:a16="http://schemas.microsoft.com/office/drawing/2014/main" id="{EBA99112-248E-4BD5-BF3A-4E0C3FB2FA73}"/>
+                <a16:creationId xmlns:a16="http://schemas.microsoft.com/office/drawing/2014/main" id="{6D5EAD38-E571-4DEF-9C1F-AA2877CCE5CD}"/>
               </a:ext>
             </a:extLst>
           </p:cNvPr>
@@ -14266,10 +14403,10 @@
       </p:sp>
       <p:sp>
         <p:nvSpPr>
-          <p:cNvPr id="61" name="HyDE의 양의 관련성 차이는 다중비교 보정 결과와 함께 해석한다. CAD는 질의별 충실도 변동과 추가 실행 시간을 ">
+          <p:cNvPr id="62" name="HyDE의 양의 관련성 차이는 다중비교 보정 결과와 함께 해석한다. CAD는 질의별 충실도 변동과 추가 실행 시간을 ">
             <a:extLst xmlns:a="http://schemas.openxmlformats.org/drawingml/2006/main">
               <a:ext uri="{FF2B5EF4-FFF2-40B4-BE49-F238E27FC236}">
-                <a16:creationId xmlns:a16="http://schemas.microsoft.com/office/drawing/2014/main" id="{CA18B5E5-E0BA-49B3-81AA-C010BAE6B737}"/>
+                <a16:creationId xmlns:a16="http://schemas.microsoft.com/office/drawing/2014/main" id="{9247A825-E4F9-4C2F-9A8F-8F01E04DA36D}"/>
               </a:ext>
             </a:extLst>
           </p:cNvPr>
@@ -14403,10 +14540,10 @@
       </p:sp>
       <p:sp>
         <p:nvSpPr>
-          <p:cNvPr id="62" name="">
+          <p:cNvPr id="63" name="">
             <a:extLst xmlns:a="http://schemas.openxmlformats.org/drawingml/2006/main">
               <a:ext uri="{FF2B5EF4-FFF2-40B4-BE49-F238E27FC236}">
-                <a16:creationId xmlns:a16="http://schemas.microsoft.com/office/drawing/2014/main" id="{1A6884D4-63CA-443C-A900-861751A1763D}"/>
+                <a16:creationId xmlns:a16="http://schemas.microsoft.com/office/drawing/2014/main" id="{46E49CA8-D929-4E6D-B06C-E41762EB53F0}"/>
               </a:ext>
             </a:extLst>
           </p:cNvPr>
@@ -14434,10 +14571,10 @@
       </p:sp>
       <p:sp>
         <p:nvSpPr>
-          <p:cNvPr id="63" name="07 결론">
+          <p:cNvPr id="64" name="07 결론">
             <a:extLst xmlns:a="http://schemas.openxmlformats.org/drawingml/2006/main">
               <a:ext uri="{FF2B5EF4-FFF2-40B4-BE49-F238E27FC236}">
-                <a16:creationId xmlns:a16="http://schemas.microsoft.com/office/drawing/2014/main" id="{2D47D047-7B98-4B89-B0BE-4840EBB284D7}"/>
+                <a16:creationId xmlns:a16="http://schemas.microsoft.com/office/drawing/2014/main" id="{408F19DD-B794-46E2-AF97-2D134E6DC039}"/>
               </a:ext>
             </a:extLst>
           </p:cNvPr>
@@ -14502,10 +14639,10 @@
       </p:sp>
       <p:sp>
         <p:nvSpPr>
-          <p:cNvPr id="64" name="답변 품질은 평균 대응 차이와 보정 검정 결과로 판단한다. 한국어 사용 비중을 높이는 목적에는 SCD 결과를 참고한다">
+          <p:cNvPr id="65" name="답변 품질은 평균 대응 차이와 보정 검정 결과로 판단한다. 한국어 사용 비중을 높이는 목적에는 SCD 결과를 참고한다">
             <a:extLst xmlns:a="http://schemas.openxmlformats.org/drawingml/2006/main">
               <a:ext uri="{FF2B5EF4-FFF2-40B4-BE49-F238E27FC236}">
-                <a16:creationId xmlns:a16="http://schemas.microsoft.com/office/drawing/2014/main" id="{256E70C1-58A4-45EF-AD39-25ABE644EB11}"/>
+                <a16:creationId xmlns:a16="http://schemas.microsoft.com/office/drawing/2014/main" id="{1D2A9F15-0BFE-43C2-A576-F3FE38B5C9E3}"/>
               </a:ext>
             </a:extLst>
           </p:cNvPr>
@@ -14662,10 +14799,10 @@
       </p:sp>
       <p:sp>
         <p:nvSpPr>
-          <p:cNvPr id="65" name="">
+          <p:cNvPr id="66" name="">
             <a:extLst xmlns:a="http://schemas.openxmlformats.org/drawingml/2006/main">
               <a:ext uri="{FF2B5EF4-FFF2-40B4-BE49-F238E27FC236}">
-                <a16:creationId xmlns:a16="http://schemas.microsoft.com/office/drawing/2014/main" id="{699F36F0-008A-486C-9464-90212E23269A}"/>
+                <a16:creationId xmlns:a16="http://schemas.microsoft.com/office/drawing/2014/main" id="{869AB139-A983-45B6-93C8-839DA3D8A153}"/>
               </a:ext>
             </a:extLst>
           </p:cNvPr>
@@ -14693,10 +14830,10 @@
       </p:sp>
       <p:sp>
         <p:nvSpPr>
-          <p:cNvPr id="66" name="08 주요 참고문헌">
+          <p:cNvPr id="67" name="08 주요 참고문헌">
             <a:extLst xmlns:a="http://schemas.openxmlformats.org/drawingml/2006/main">
               <a:ext uri="{FF2B5EF4-FFF2-40B4-BE49-F238E27FC236}">
-                <a16:creationId xmlns:a16="http://schemas.microsoft.com/office/drawing/2014/main" id="{95B1E49D-E49A-4F7F-8889-8CFB7843BF7F}"/>
+                <a16:creationId xmlns:a16="http://schemas.microsoft.com/office/drawing/2014/main" id="{0AF40077-AC3C-49F0-8CA8-FAEA555686BA}"/>
               </a:ext>
             </a:extLst>
           </p:cNvPr>
@@ -14761,10 +14898,10 @@
       </p:sp>
       <p:sp>
         <p:nvSpPr>
-          <p:cNvPr id="67" name="[1] Lewis et al. RAG. NeurIPS, 2020. [2] Gao et al. HyDE. ACL, 20">
+          <p:cNvPr id="68" name="[1] Lewis et al. RAG. NeurIPS, 2020. [2] Gao et al. HyDE. ACL, 20">
             <a:extLst xmlns:a="http://schemas.openxmlformats.org/drawingml/2006/main">
               <a:ext uri="{FF2B5EF4-FFF2-40B4-BE49-F238E27FC236}">
-                <a16:creationId xmlns:a16="http://schemas.microsoft.com/office/drawing/2014/main" id="{5EDDFBC0-7294-47D3-B29B-78AC6D39D854}"/>
+                <a16:creationId xmlns:a16="http://schemas.microsoft.com/office/drawing/2014/main" id="{6B61529D-B497-4654-A433-88F7C72460B2}"/>
               </a:ext>
             </a:extLst>
           </p:cNvPr>
@@ -14875,10 +15012,10 @@
       </p:sp>
       <p:sp>
         <p:nvSpPr>
-          <p:cNvPr id="68" name="[4] Li et al. Language Drift and SCD. AAAI, 2026. [5] Chen et al.">
+          <p:cNvPr id="69" name="[4] Li et al. Language Drift and SCD. AAAI, 2026. [5] Chen et al.">
             <a:extLst xmlns:a="http://schemas.openxmlformats.org/drawingml/2006/main">
               <a:ext uri="{FF2B5EF4-FFF2-40B4-BE49-F238E27FC236}">
-                <a16:creationId xmlns:a16="http://schemas.microsoft.com/office/drawing/2014/main" id="{7787E8CB-0758-47D2-97BE-4288DA5F967C}"/>
+                <a16:creationId xmlns:a16="http://schemas.microsoft.com/office/drawing/2014/main" id="{A5CAC36E-BA61-4F5E-9748-05603C970607}"/>
               </a:ext>
             </a:extLst>
           </p:cNvPr>
@@ -14989,10 +15126,10 @@
       </p:sp>
       <p:sp>
         <p:nvSpPr>
-          <p:cNvPr id="69" name="전체 22편과 통계 상세표·결측·민감도 분석은 동봉 자료에 수록">
+          <p:cNvPr id="70" name="구현 출처  [6] Robertson et al. Okapi at TREC-3. 1994. [7] Cormack et">
             <a:extLst xmlns:a="http://schemas.openxmlformats.org/drawingml/2006/main">
               <a:ext uri="{FF2B5EF4-FFF2-40B4-BE49-F238E27FC236}">
-                <a16:creationId xmlns:a16="http://schemas.microsoft.com/office/drawing/2014/main" id="{F6B3B1A1-E625-4E2E-A892-C40874E07B4C}"/>
+                <a16:creationId xmlns:a16="http://schemas.microsoft.com/office/drawing/2014/main" id="{8F9653C7-6949-43A3-955C-6EDE647B014F}"/>
               </a:ext>
             </a:extLst>
           </p:cNvPr>
@@ -15003,8 +15140,8 @@
         </p:nvSpPr>
         <p:spPr>
           <a:xfrm xmlns:a="http://schemas.openxmlformats.org/drawingml/2006/main">
-            <a:off x="704850" y="28908375"/>
-            <a:ext cx="19974300" cy="304800"/>
+            <a:off x="704850" y="28670250"/>
+            <a:ext cx="9729975" cy="571500"/>
           </a:xfrm>
           <a:prstGeom xmlns:a="http://schemas.openxmlformats.org/drawingml/2006/main" prst="rect">
             <a:avLst/>
@@ -15050,17 +15187,40 @@
                 <a:ea typeface="Malgun Gothic"/>
                 <a:cs typeface="Malgun Gothic"/>
               </a:rPr>
-              <a:t>전체 22편과 통계 상세표·결측·민감도 분석은 동봉 자료에 수록</a:t>
+              <a:t>구현 출처  [6] Robertson et al. Okapi at TREC-3. 1994.</a:t>
+            </a:r>
+          </a:p>
+          <a:p xmlns:a="http://schemas.openxmlformats.org/drawingml/2006/main">
+            <a:pPr algn="l">
+              <a:defRPr sz="1600" b="0">
+                <a:solidFill>
+                  <a:srgbClr val="24324A"/>
+                </a:solidFill>
+                <a:latin typeface="Malgun Gothic"/>
+                <a:ea typeface="Malgun Gothic"/>
+                <a:cs typeface="Malgun Gothic"/>
+              </a:defRPr>
+            </a:pPr>
+            <a:r>
+              <a:rPr sz="1600" b="0">
+                <a:solidFill>
+                  <a:srgbClr val="24324A"/>
+                </a:solidFill>
+                <a:latin typeface="Malgun Gothic"/>
+                <a:ea typeface="Malgun Gothic"/>
+                <a:cs typeface="Malgun Gothic"/>
+              </a:rPr>
+              <a:t>[7] Cormack et al. Reciprocal Rank Fusion. SIGIR, 2009.</a:t>
             </a:r>
           </a:p>
         </p:txBody>
       </p:sp>
       <p:sp>
         <p:nvSpPr>
-          <p:cNvPr id="70" name="영어 문서 4종 · 질의 60개 · 생성 모델 1종 · 질의별 반복측정">
+          <p:cNvPr id="71" name="[8] Nogueira &amp; Cho. Passage Re-ranking with BERT. 2019. [18] Shin">
             <a:extLst xmlns:a="http://schemas.openxmlformats.org/drawingml/2006/main">
               <a:ext uri="{FF2B5EF4-FFF2-40B4-BE49-F238E27FC236}">
-                <a16:creationId xmlns:a16="http://schemas.microsoft.com/office/drawing/2014/main" id="{5FF644E9-4725-449D-BF43-1E2E293850B6}"/>
+                <a16:creationId xmlns:a16="http://schemas.microsoft.com/office/drawing/2014/main" id="{F89FF9B3-8F12-4D59-8F15-62E844814EA4}"/>
               </a:ext>
             </a:extLst>
           </p:cNvPr>
@@ -15071,7 +15231,98 @@
         </p:nvSpPr>
         <p:spPr>
           <a:xfrm xmlns:a="http://schemas.openxmlformats.org/drawingml/2006/main">
-            <a:off x="704850" y="29432250"/>
+            <a:off x="10949175" y="28670250"/>
+            <a:ext cx="9729975" cy="571500"/>
+          </a:xfrm>
+          <a:prstGeom xmlns:a="http://schemas.openxmlformats.org/drawingml/2006/main" prst="rect">
+            <a:avLst/>
+          </a:prstGeom>
+          <a:noFill xmlns:a="http://schemas.openxmlformats.org/drawingml/2006/main"/>
+          <a:ln xmlns:a="http://schemas.openxmlformats.org/drawingml/2006/main" w="0">
+            <a:noFill/>
+          </a:ln>
+        </p:spPr>
+        <p:txBody>
+          <a:bodyPr xmlns:a="http://schemas.openxmlformats.org/drawingml/2006/main" wrap="none" lIns="0" tIns="0" rIns="0" bIns="0" anchor="t">
+            <a:noAutofit/>
+          </a:bodyPr>
+          <a:lstStyle xmlns:a="http://schemas.openxmlformats.org/drawingml/2006/main">
+            <a:defPPr algn="l">
+              <a:defRPr sz="1600" b="0">
+                <a:solidFill>
+                  <a:srgbClr val="24324A"/>
+                </a:solidFill>
+                <a:latin typeface="Malgun Gothic"/>
+                <a:ea typeface="Malgun Gothic"/>
+                <a:cs typeface="Malgun Gothic"/>
+              </a:defRPr>
+            </a:defPPr>
+          </a:lstStyle>
+          <a:p xmlns:a="http://schemas.openxmlformats.org/drawingml/2006/main">
+            <a:pPr algn="l">
+              <a:defRPr sz="1600" b="0">
+                <a:solidFill>
+                  <a:srgbClr val="24324A"/>
+                </a:solidFill>
+                <a:latin typeface="Malgun Gothic"/>
+                <a:ea typeface="Malgun Gothic"/>
+                <a:cs typeface="Malgun Gothic"/>
+              </a:defRPr>
+            </a:pPr>
+            <a:r>
+              <a:rPr sz="1600" b="0">
+                <a:solidFill>
+                  <a:srgbClr val="24324A"/>
+                </a:solidFill>
+                <a:latin typeface="Malgun Gothic"/>
+                <a:ea typeface="Malgun Gothic"/>
+                <a:cs typeface="Malgun Gothic"/>
+              </a:rPr>
+              <a:t>[8] Nogueira &amp; Cho. Passage Re-ranking with BERT. 2019.</a:t>
+            </a:r>
+          </a:p>
+          <a:p xmlns:a="http://schemas.openxmlformats.org/drawingml/2006/main">
+            <a:pPr algn="l">
+              <a:defRPr sz="1600" b="0">
+                <a:solidFill>
+                  <a:srgbClr val="24324A"/>
+                </a:solidFill>
+                <a:latin typeface="Malgun Gothic"/>
+                <a:ea typeface="Malgun Gothic"/>
+                <a:cs typeface="Malgun Gothic"/>
+              </a:defRPr>
+            </a:pPr>
+            <a:r>
+              <a:rPr sz="1600" b="0">
+                <a:solidFill>
+                  <a:srgbClr val="24324A"/>
+                </a:solidFill>
+                <a:latin typeface="Malgun Gothic"/>
+                <a:ea typeface="Malgun Gothic"/>
+                <a:cs typeface="Malgun Gothic"/>
+              </a:rPr>
+              <a:t>[18] Shin et al. Mi:dm 2.0. arXiv:2601.09066, 2026.</a:t>
+            </a:r>
+          </a:p>
+        </p:txBody>
+      </p:sp>
+      <p:sp>
+        <p:nvSpPr>
+          <p:cNvPr id="72" name="전체 22편: 동봉 POSTER_REFERENCES_FULL.md · 통계·결측·민감도 분석: 동봉 상세표">
+            <a:extLst xmlns:a="http://schemas.openxmlformats.org/drawingml/2006/main">
+              <a:ext uri="{FF2B5EF4-FFF2-40B4-BE49-F238E27FC236}">
+                <a16:creationId xmlns:a16="http://schemas.microsoft.com/office/drawing/2014/main" id="{E10EF06E-8B5A-40D3-93F4-6823C640A1B9}"/>
+              </a:ext>
+            </a:extLst>
+          </p:cNvPr>
+          <p:cNvSpPr>
+            <a:spLocks xmlns:a="http://schemas.openxmlformats.org/drawingml/2006/main" noGrp="1"/>
+          </p:cNvSpPr>
+          <p:nvPr/>
+        </p:nvSpPr>
+        <p:spPr>
+          <a:xfrm xmlns:a="http://schemas.openxmlformats.org/drawingml/2006/main">
+            <a:off x="704850" y="29356050"/>
             <a:ext cx="19974300" cy="285750"/>
           </a:xfrm>
           <a:prstGeom xmlns:a="http://schemas.openxmlformats.org/drawingml/2006/main" prst="rect">
@@ -15088,6 +15339,74 @@
           </a:bodyPr>
           <a:lstStyle xmlns:a="http://schemas.openxmlformats.org/drawingml/2006/main">
             <a:defPPr algn="l">
+              <a:defRPr sz="1600" b="0">
+                <a:solidFill>
+                  <a:srgbClr val="24324A"/>
+                </a:solidFill>
+                <a:latin typeface="Malgun Gothic"/>
+                <a:ea typeface="Malgun Gothic"/>
+                <a:cs typeface="Malgun Gothic"/>
+              </a:defRPr>
+            </a:defPPr>
+          </a:lstStyle>
+          <a:p xmlns:a="http://schemas.openxmlformats.org/drawingml/2006/main">
+            <a:pPr algn="l">
+              <a:defRPr sz="1600" b="0">
+                <a:solidFill>
+                  <a:srgbClr val="24324A"/>
+                </a:solidFill>
+                <a:latin typeface="Malgun Gothic"/>
+                <a:ea typeface="Malgun Gothic"/>
+                <a:cs typeface="Malgun Gothic"/>
+              </a:defRPr>
+            </a:pPr>
+            <a:r>
+              <a:rPr sz="1600" b="0">
+                <a:solidFill>
+                  <a:srgbClr val="24324A"/>
+                </a:solidFill>
+                <a:latin typeface="Malgun Gothic"/>
+                <a:ea typeface="Malgun Gothic"/>
+                <a:cs typeface="Malgun Gothic"/>
+              </a:rPr>
+              <a:t>전체 22편: 동봉 POSTER_REFERENCES_FULL.md · 통계·결측·민감도 분석: 동봉 상세표</a:t>
+            </a:r>
+          </a:p>
+        </p:txBody>
+      </p:sp>
+      <p:sp>
+        <p:nvSpPr>
+          <p:cNvPr id="73" name="영어 문서 4종 · 질의 60개 · 생성 모델 1종 · 질의별 반복측정">
+            <a:extLst xmlns:a="http://schemas.openxmlformats.org/drawingml/2006/main">
+              <a:ext uri="{FF2B5EF4-FFF2-40B4-BE49-F238E27FC236}">
+                <a16:creationId xmlns:a16="http://schemas.microsoft.com/office/drawing/2014/main" id="{5C094301-77AF-47E5-8067-094AACC55DD4}"/>
+              </a:ext>
+            </a:extLst>
+          </p:cNvPr>
+          <p:cNvSpPr>
+            <a:spLocks xmlns:a="http://schemas.openxmlformats.org/drawingml/2006/main" noGrp="1"/>
+          </p:cNvSpPr>
+          <p:nvPr/>
+        </p:nvSpPr>
+        <p:spPr>
+          <a:xfrm xmlns:a="http://schemas.openxmlformats.org/drawingml/2006/main">
+            <a:off x="704850" y="29670375"/>
+            <a:ext cx="19974300" cy="247650"/>
+          </a:xfrm>
+          <a:prstGeom xmlns:a="http://schemas.openxmlformats.org/drawingml/2006/main" prst="rect">
+            <a:avLst/>
+          </a:prstGeom>
+          <a:noFill xmlns:a="http://schemas.openxmlformats.org/drawingml/2006/main"/>
+          <a:ln xmlns:a="http://schemas.openxmlformats.org/drawingml/2006/main" w="0">
+            <a:noFill/>
+          </a:ln>
+        </p:spPr>
+        <p:txBody>
+          <a:bodyPr xmlns:a="http://schemas.openxmlformats.org/drawingml/2006/main" wrap="none" lIns="0" tIns="0" rIns="0" bIns="0" anchor="t">
+            <a:noAutofit/>
+          </a:bodyPr>
+          <a:lstStyle xmlns:a="http://schemas.openxmlformats.org/drawingml/2006/main">
+            <a:defPPr algn="l">
               <a:defRPr sz="1400" b="0">
                 <a:solidFill>
                   <a:srgbClr val="695184"/>
@@ -15125,10 +15444,10 @@
       </p:sp>
       <p:sp>
         <p:nvSpPr>
-          <p:cNvPr id="71" name="A1 594 × 841 mm">
+          <p:cNvPr id="74" name="A1 594 × 841 mm">
             <a:extLst xmlns:a="http://schemas.openxmlformats.org/drawingml/2006/main">
               <a:ext uri="{FF2B5EF4-FFF2-40B4-BE49-F238E27FC236}">
-                <a16:creationId xmlns:a16="http://schemas.microsoft.com/office/drawing/2014/main" id="{1B5BD4AF-57A6-4905-BB0B-694E3C210360}"/>
+                <a16:creationId xmlns:a16="http://schemas.microsoft.com/office/drawing/2014/main" id="{ABF2B35B-C050-405C-A66F-449D6B00BE88}"/>
               </a:ext>
             </a:extLst>
           </p:cNvPr>
@@ -15194,7 +15513,7 @@
     </p:spTree>
     <p:extLst>
       <p:ext uri="{BB962C8B-B14F-4D97-AF65-F5344CB8AC3E}">
-        <p14:creationId xmlns:p14="http://schemas.microsoft.com/office/powerpoint/2010/main" val="1438640253"/>
+        <p14:creationId xmlns:p14="http://schemas.microsoft.com/office/powerpoint/2010/main" val="431653367"/>
       </p:ext>
     </p:extLst>
   </p:cSld>

</xml_diff>

<commit_message>
Finalize publication-grounded thesis and poster resubmission
</commit_message>
<xml_diff>
--- a/FINALDOCS/POSTER/A1_FINAL_TITLE_CONFIRMED_20261010/M_RAG_A1_FINAL_EDITABLE.pptx
+++ b/FINALDOCS/POSTER/A1_FINAL_TITLE_CONFIRMED_20261010/M_RAG_A1_FINAL_EDITABLE.pptx
@@ -2,13 +2,13 @@
 <file path=ppt/presentation.xml><?xml version="1.0" encoding="utf-8"?>
 <p:presentation xmlns:p="http://schemas.openxmlformats.org/presentationml/2006/main">
   <p:sldMasterIdLst>
-    <p:sldMasterId xmlns:r="http://schemas.openxmlformats.org/officeDocument/2006/relationships" id="2147483648" r:id="R16a58bf6f0514c86"/>
+    <p:sldMasterId xmlns:r="http://schemas.openxmlformats.org/officeDocument/2006/relationships" id="2147483648" r:id="R1d9eda4321294c62"/>
   </p:sldMasterIdLst>
   <p:notesMasterIdLst>
-    <p:notesMasterId xmlns:r="http://schemas.openxmlformats.org/officeDocument/2006/relationships" r:id="R0c7be1f8abc2443b"/>
+    <p:notesMasterId xmlns:r="http://schemas.openxmlformats.org/officeDocument/2006/relationships" r:id="R183c765c7d9c4233"/>
   </p:notesMasterIdLst>
   <p:sldIdLst>
-    <p:sldId xmlns:r="http://schemas.openxmlformats.org/officeDocument/2006/relationships" id="256" r:id="R2d580b33d23d47bc"/>
+    <p:sldId xmlns:r="http://schemas.openxmlformats.org/officeDocument/2006/relationships" id="256" r:id="R629085d5e3e0476a"/>
   </p:sldIdLst>
   <p:sldSz cx="21384000" cy="30276000"/>
   <p:notesSz cx="6858000" cy="9144000"/>
@@ -442,7 +442,7 @@
           <a:lstStyle xmlns:a="http://schemas.openxmlformats.org/drawingml/2006/main"/>
           <a:p xmlns:a="http://schemas.openxmlformats.org/drawingml/2006/main">
             <a:r>
-              <a:t>Research sources and full statistics: FINALDOCS/DATA/FACTORIAL_STATISTICS_60Q.json; FINALDOCS/MANUSCRIPT/GRADUATION_REPORT_TRANSFER_KO_60Q.md. The exploratory analysis uses query-level repeated measures and Holm-adjusted hypothesis families. Editable tables follow explicit data-type alignment. Reference [4] https://arxiv.org/abs/2511.09984; references follow manuscript numbering.</a:t>
+              <a:t>Research sources and full statistics: FINALDOCS/DATA/FACTORIAL_STATISTICS_60Q.json; FINALDOCS/MANUSCRIPT/GRADUATION_REPORT_TRANSFER_KO_60Q.md. The exploratory analysis uses query-level repeated measures and Holm-adjusted hypothesis families. Editable tables follow explicit data-type alignment. Reference [4] https://ojs.aaai.org/index.php/AAAI/article/view/40417; [8] https://doi.org/10.1145/3331184.3331317 is conceptual ranking background, not the implemented CEDR architecture. [M1] https://huggingface.co/K-intelligence/Midm-2.0-Base-Instruct; [M2] https://huggingface.co/cross-encoder/ms-marco-MiniLM-L6-v2. The English case evidence is a contiguous saved context excerpt (PDF p.9), reference evidence is on PDF p.20. References follow manuscript numbering.</a:t>
             </a:r>
           </a:p>
         </p:txBody>
@@ -489,7 +489,7 @@
           <p:cNvPr id="3" name="Title">
             <a:extLst xmlns:a="http://schemas.openxmlformats.org/drawingml/2006/main">
               <a:ext uri="{FF2B5EF4-FFF2-40B4-BE49-F238E27FC236}">
-                <a16:creationId xmlns:a16="http://schemas.microsoft.com/office/drawing/2014/main" id="{848359CC-4D8E-41DA-B605-F3350540D806}"/>
+                <a16:creationId xmlns:a16="http://schemas.microsoft.com/office/drawing/2014/main" id="{18C2D189-7F74-4993-8549-C9919680D29E}"/>
               </a:ext>
             </a:extLst>
           </p:cNvPr>
@@ -646,7 +646,7 @@
           <p:cNvPr id="2" name="Subtitle">
             <a:extLst xmlns:a="http://schemas.openxmlformats.org/drawingml/2006/main">
               <a:ext uri="{FF2B5EF4-FFF2-40B4-BE49-F238E27FC236}">
-                <a16:creationId xmlns:a16="http://schemas.microsoft.com/office/drawing/2014/main" id="{74BC5F42-0E1F-46A2-9DB6-8C739EE2893B}"/>
+                <a16:creationId xmlns:a16="http://schemas.microsoft.com/office/drawing/2014/main" id="{95258C7D-128B-4FB5-9036-1B1FA2C5D61A}"/>
               </a:ext>
             </a:extLst>
           </p:cNvPr>
@@ -820,7 +820,7 @@
           <p:cNvPr id="2" name="Section title">
             <a:extLst xmlns:a="http://schemas.openxmlformats.org/drawingml/2006/main">
               <a:ext uri="{FF2B5EF4-FFF2-40B4-BE49-F238E27FC236}">
-                <a16:creationId xmlns:a16="http://schemas.microsoft.com/office/drawing/2014/main" id="{2363FC78-7A49-4239-99E6-CC0177D37821}"/>
+                <a16:creationId xmlns:a16="http://schemas.microsoft.com/office/drawing/2014/main" id="{3664E239-E601-43E3-A7E1-4889C93DD8C0}"/>
               </a:ext>
             </a:extLst>
           </p:cNvPr>
@@ -994,7 +994,7 @@
           <p:cNvPr id="3" name="Title">
             <a:extLst xmlns:a="http://schemas.openxmlformats.org/drawingml/2006/main">
               <a:ext uri="{FF2B5EF4-FFF2-40B4-BE49-F238E27FC236}">
-                <a16:creationId xmlns:a16="http://schemas.microsoft.com/office/drawing/2014/main" id="{E00B04E8-BB69-4285-9978-64BE368C77B1}"/>
+                <a16:creationId xmlns:a16="http://schemas.microsoft.com/office/drawing/2014/main" id="{2D40143D-9B87-4255-9D7A-9C933C582688}"/>
               </a:ext>
             </a:extLst>
           </p:cNvPr>
@@ -1151,7 +1151,7 @@
           <p:cNvPr id="2" name="Body">
             <a:extLst xmlns:a="http://schemas.openxmlformats.org/drawingml/2006/main">
               <a:ext uri="{FF2B5EF4-FFF2-40B4-BE49-F238E27FC236}">
-                <a16:creationId xmlns:a16="http://schemas.microsoft.com/office/drawing/2014/main" id="{46821DE3-51DA-48BA-A39F-B87A769B079F}"/>
+                <a16:creationId xmlns:a16="http://schemas.microsoft.com/office/drawing/2014/main" id="{BF3B3B9A-7488-49EE-AE4A-2B44892DA9B8}"/>
               </a:ext>
             </a:extLst>
           </p:cNvPr>
@@ -1325,7 +1325,7 @@
           <p:cNvPr id="4" name="Title">
             <a:extLst xmlns:a="http://schemas.openxmlformats.org/drawingml/2006/main">
               <a:ext uri="{FF2B5EF4-FFF2-40B4-BE49-F238E27FC236}">
-                <a16:creationId xmlns:a16="http://schemas.microsoft.com/office/drawing/2014/main" id="{4417882F-10E4-4CBA-BA7F-927DD5C4EDD7}"/>
+                <a16:creationId xmlns:a16="http://schemas.microsoft.com/office/drawing/2014/main" id="{64E8CCEA-31BC-4362-8B39-988B09536E5B}"/>
               </a:ext>
             </a:extLst>
           </p:cNvPr>
@@ -1482,7 +1482,7 @@
           <p:cNvPr id="2" name="Left column">
             <a:extLst xmlns:a="http://schemas.openxmlformats.org/drawingml/2006/main">
               <a:ext uri="{FF2B5EF4-FFF2-40B4-BE49-F238E27FC236}">
-                <a16:creationId xmlns:a16="http://schemas.microsoft.com/office/drawing/2014/main" id="{38F0C527-7D24-474D-9CD5-E5253C099CCF}"/>
+                <a16:creationId xmlns:a16="http://schemas.microsoft.com/office/drawing/2014/main" id="{06CE0F29-D3E0-4093-AAE3-33BF360204DC}"/>
               </a:ext>
             </a:extLst>
           </p:cNvPr>
@@ -1639,7 +1639,7 @@
           <p:cNvPr id="3" name="Right column">
             <a:extLst xmlns:a="http://schemas.openxmlformats.org/drawingml/2006/main">
               <a:ext uri="{FF2B5EF4-FFF2-40B4-BE49-F238E27FC236}">
-                <a16:creationId xmlns:a16="http://schemas.microsoft.com/office/drawing/2014/main" id="{F7E70C3C-7F85-4165-9203-78C225FC2B3F}"/>
+                <a16:creationId xmlns:a16="http://schemas.microsoft.com/office/drawing/2014/main" id="{D1BC5D0E-465F-4CE6-B2F6-C66255A1358F}"/>
               </a:ext>
             </a:extLst>
           </p:cNvPr>
@@ -1813,7 +1813,7 @@
           <p:cNvPr id="3" name="Title">
             <a:extLst xmlns:a="http://schemas.openxmlformats.org/drawingml/2006/main">
               <a:ext uri="{FF2B5EF4-FFF2-40B4-BE49-F238E27FC236}">
-                <a16:creationId xmlns:a16="http://schemas.microsoft.com/office/drawing/2014/main" id="{F2C5F39C-57B8-42F2-A00D-676970CBB52F}"/>
+                <a16:creationId xmlns:a16="http://schemas.microsoft.com/office/drawing/2014/main" id="{2972B973-4DFE-416E-A383-E21E24C4F17B}"/>
               </a:ext>
             </a:extLst>
           </p:cNvPr>
@@ -1970,7 +1970,7 @@
           <p:cNvPr id="2" name="Left column">
             <a:extLst xmlns:a="http://schemas.openxmlformats.org/drawingml/2006/main">
               <a:ext uri="{FF2B5EF4-FFF2-40B4-BE49-F238E27FC236}">
-                <a16:creationId xmlns:a16="http://schemas.microsoft.com/office/drawing/2014/main" id="{73BAD953-F47A-4175-9BCA-5CE55BF76925}"/>
+                <a16:creationId xmlns:a16="http://schemas.microsoft.com/office/drawing/2014/main" id="{29FA1E36-CF00-45A7-9EE2-17BE27F488F5}"/>
               </a:ext>
             </a:extLst>
           </p:cNvPr>
@@ -2165,12 +2165,12 @@
   </p:cSld>
   <p:clrMap bg1="lt1" tx1="dk1" bg2="lt2" tx2="dk2" accent1="accent1" accent2="accent2" accent3="accent3" accent4="accent4" accent5="accent5" accent6="accent6" hlink="hlink" folHlink="folHlink"/>
   <p:sldLayoutIdLst>
-    <p:sldLayoutId xmlns:r="http://schemas.openxmlformats.org/officeDocument/2006/relationships" id="2147483649" r:id="R80110722d007410e"/>
-    <p:sldLayoutId xmlns:r="http://schemas.openxmlformats.org/officeDocument/2006/relationships" id="2147483650" r:id="Rb335736f41194d7f"/>
-    <p:sldLayoutId xmlns:r="http://schemas.openxmlformats.org/officeDocument/2006/relationships" id="2147483651" r:id="Rdedbe022be4e4e5c"/>
-    <p:sldLayoutId xmlns:r="http://schemas.openxmlformats.org/officeDocument/2006/relationships" id="2147483652" r:id="R9326ff41311e4390"/>
-    <p:sldLayoutId xmlns:r="http://schemas.openxmlformats.org/officeDocument/2006/relationships" id="2147483653" r:id="R0794f6036e83440f"/>
-    <p:sldLayoutId xmlns:r="http://schemas.openxmlformats.org/officeDocument/2006/relationships" id="2147483654" r:id="Rc3cde7c99c9546a3"/>
+    <p:sldLayoutId xmlns:r="http://schemas.openxmlformats.org/officeDocument/2006/relationships" id="2147483649" r:id="Rf857f396295c43c2"/>
+    <p:sldLayoutId xmlns:r="http://schemas.openxmlformats.org/officeDocument/2006/relationships" id="2147483650" r:id="Rc7972f5c0d854c31"/>
+    <p:sldLayoutId xmlns:r="http://schemas.openxmlformats.org/officeDocument/2006/relationships" id="2147483651" r:id="Rdfe4df60e88e4982"/>
+    <p:sldLayoutId xmlns:r="http://schemas.openxmlformats.org/officeDocument/2006/relationships" id="2147483652" r:id="R32f3c1265a244fe4"/>
+    <p:sldLayoutId xmlns:r="http://schemas.openxmlformats.org/officeDocument/2006/relationships" id="2147483653" r:id="R1b1196517acb4894"/>
+    <p:sldLayoutId xmlns:r="http://schemas.openxmlformats.org/officeDocument/2006/relationships" id="2147483654" r:id="R0993f68c06244e85"/>
   </p:sldLayoutIdLst>
   <p:txStyles>
     <p:titleStyle>
@@ -2718,10 +2718,10 @@
       </p:grpSpPr>
       <p:sp>
         <p:nvSpPr>
-          <p:cNvPr id="75" name="">
+          <p:cNvPr id="76" name="">
             <a:extLst xmlns:a="http://schemas.openxmlformats.org/drawingml/2006/main">
               <a:ext uri="{FF2B5EF4-FFF2-40B4-BE49-F238E27FC236}">
-                <a16:creationId xmlns:a16="http://schemas.microsoft.com/office/drawing/2014/main" id="{662205CB-56E8-4729-BFA7-C57BB698F207}"/>
+                <a16:creationId xmlns:a16="http://schemas.microsoft.com/office/drawing/2014/main" id="{307F14FD-D820-4A32-B6F8-DA81B5E23C26}"/>
               </a:ext>
             </a:extLst>
           </p:cNvPr>
@@ -2752,7 +2752,7 @@
           <p:cNvPr id="2" name="한국어 질의로 영어 학술·기술 문서를 검색하는">
             <a:extLst xmlns:a="http://schemas.openxmlformats.org/drawingml/2006/main">
               <a:ext uri="{FF2B5EF4-FFF2-40B4-BE49-F238E27FC236}">
-                <a16:creationId xmlns:a16="http://schemas.microsoft.com/office/drawing/2014/main" id="{7E48507D-2D4A-4296-9D3D-6C6B4369C461}"/>
+                <a16:creationId xmlns:a16="http://schemas.microsoft.com/office/drawing/2014/main" id="{20D8F3DB-04B5-49AD-92E5-BB7609AF52EF}"/>
               </a:ext>
             </a:extLst>
           </p:cNvPr>
@@ -2820,7 +2820,7 @@
           <p:cNvPr id="3" name="RAG에서의 HyDE·CAD·SCD 조합 실험">
             <a:extLst xmlns:a="http://schemas.openxmlformats.org/drawingml/2006/main">
               <a:ext uri="{FF2B5EF4-FFF2-40B4-BE49-F238E27FC236}">
-                <a16:creationId xmlns:a16="http://schemas.microsoft.com/office/drawing/2014/main" id="{DE9E98EE-3B20-40D8-A5F2-0A5C489A4718}"/>
+                <a16:creationId xmlns:a16="http://schemas.microsoft.com/office/drawing/2014/main" id="{7083EE00-123C-4EA6-959F-B4FBDE8FAF6F}"/>
               </a:ext>
             </a:extLst>
           </p:cNvPr>
@@ -2888,7 +2888,7 @@
           <p:cNvPr id="4" name="문종건 · 동국대학교 WISE캠퍼스 컴퓨터공학과 · 지도교수 김진석 · 2026.10.15">
             <a:extLst xmlns:a="http://schemas.openxmlformats.org/drawingml/2006/main">
               <a:ext uri="{FF2B5EF4-FFF2-40B4-BE49-F238E27FC236}">
-                <a16:creationId xmlns:a16="http://schemas.microsoft.com/office/drawing/2014/main" id="{A58E3837-B1B5-4DBC-B883-05FB9CDA6C3C}"/>
+                <a16:creationId xmlns:a16="http://schemas.microsoft.com/office/drawing/2014/main" id="{DB4F0942-9BA0-4154-8754-85691FA8E5E3}"/>
               </a:ext>
             </a:extLst>
           </p:cNvPr>
@@ -2956,7 +2956,7 @@
           <p:cNvPr id="5" name="">
             <a:extLst xmlns:a="http://schemas.openxmlformats.org/drawingml/2006/main">
               <a:ext uri="{FF2B5EF4-FFF2-40B4-BE49-F238E27FC236}">
-                <a16:creationId xmlns:a16="http://schemas.microsoft.com/office/drawing/2014/main" id="{7C80E843-63AE-4D8B-937D-DCFDB40039E9}"/>
+                <a16:creationId xmlns:a16="http://schemas.microsoft.com/office/drawing/2014/main" id="{5FBEE7C2-81E1-458E-BA69-A6A743423CDC}"/>
               </a:ext>
             </a:extLst>
           </p:cNvPr>
@@ -2987,7 +2987,7 @@
           <p:cNvPr id="6" name="01 연구 배경과 목적">
             <a:extLst xmlns:a="http://schemas.openxmlformats.org/drawingml/2006/main">
               <a:ext uri="{FF2B5EF4-FFF2-40B4-BE49-F238E27FC236}">
-                <a16:creationId xmlns:a16="http://schemas.microsoft.com/office/drawing/2014/main" id="{12AD9B65-CF84-4269-BB0F-89D76A16B10F}"/>
+                <a16:creationId xmlns:a16="http://schemas.microsoft.com/office/drawing/2014/main" id="{45E9146F-86D4-47FE-A6C7-F8E25AA605F7}"/>
               </a:ext>
             </a:extLst>
           </p:cNvPr>
@@ -3055,7 +3055,7 @@
           <p:cNvPr id="7" name="검색 증강 생성(Retrieval-Augmented Generation, RAG)은 관련 문서 구간을 검색하고 그 텍">
             <a:extLst xmlns:a="http://schemas.openxmlformats.org/drawingml/2006/main">
               <a:ext uri="{FF2B5EF4-FFF2-40B4-BE49-F238E27FC236}">
-                <a16:creationId xmlns:a16="http://schemas.microsoft.com/office/drawing/2014/main" id="{BFC63E54-7552-448F-B768-4B376ACD3CBC}"/>
+                <a16:creationId xmlns:a16="http://schemas.microsoft.com/office/drawing/2014/main" id="{07AF80D9-A184-4AFC-92E9-410FC0349FD2}"/>
               </a:ext>
             </a:extLst>
           </p:cNvPr>
@@ -3146,7 +3146,7 @@
           <p:cNvPr id="8" name="HyDE: 가상 문서 임베딩(Hypothetical Document Embeddings) 가상 문서 검색 입력 구성[">
             <a:extLst xmlns:a="http://schemas.openxmlformats.org/drawingml/2006/main">
               <a:ext uri="{FF2B5EF4-FFF2-40B4-BE49-F238E27FC236}">
-                <a16:creationId xmlns:a16="http://schemas.microsoft.com/office/drawing/2014/main" id="{2C6D1E42-A1B6-4FC3-8ECF-95944688FB22}"/>
+                <a16:creationId xmlns:a16="http://schemas.microsoft.com/office/drawing/2014/main" id="{BA0DDB7B-38EF-4C53-8B35-4597DAA72049}"/>
               </a:ext>
             </a:extLst>
           </p:cNvPr>
@@ -3326,10 +3326,10 @@
       </p:sp>
       <p:sp>
         <p:nvSpPr>
-          <p:cNvPr id="9" name="한국어 질의와 영어 문서의 표현 차이, 근거의 답변 반영, 출력 언어를 단계별로 평가할 필요가 있다. 본 연구는 동일">
+          <p:cNvPr id="9" name="HyDE는 한국어 등 다국어 검색에서 평가되었다[2]. 본 연구는 한국어 질의–영어 근거의 표현·출력 언어 문제를 동">
             <a:extLst xmlns:a="http://schemas.openxmlformats.org/drawingml/2006/main">
               <a:ext uri="{FF2B5EF4-FFF2-40B4-BE49-F238E27FC236}">
-                <a16:creationId xmlns:a16="http://schemas.microsoft.com/office/drawing/2014/main" id="{5640AC6E-A6B8-4075-A853-035C7FB1D2F5}"/>
+                <a16:creationId xmlns:a16="http://schemas.microsoft.com/office/drawing/2014/main" id="{368ECF16-7A80-4F5D-8924-03128D4B6E30}"/>
               </a:ext>
             </a:extLst>
           </p:cNvPr>
@@ -3387,7 +3387,7 @@
                 <a:ea typeface="Malgun Gothic"/>
                 <a:cs typeface="Malgun Gothic"/>
               </a:rPr>
-              <a:t>한국어 질의와 영어 문서의 표현 차이, 근거의 답변 반영,</a:t>
+              <a:t>HyDE는 한국어 등 다국어 검색에서 평가되었다[2].</a:t>
             </a:r>
           </a:p>
           <a:p xmlns:a="http://schemas.openxmlformats.org/drawingml/2006/main">
@@ -3410,7 +3410,7 @@
                 <a:ea typeface="Malgun Gothic"/>
                 <a:cs typeface="Malgun Gothic"/>
               </a:rPr>
-              <a:t>출력 언어를 단계별로 평가할 필요가 있다. 본 연구는</a:t>
+              <a:t>본 연구는 한국어 질의–영어 근거의 표현·출력 언어 문제를</a:t>
             </a:r>
           </a:p>
           <a:p xmlns:a="http://schemas.openxmlformats.org/drawingml/2006/main">
@@ -3433,7 +3433,7 @@
                 <a:ea typeface="Malgun Gothic"/>
                 <a:cs typeface="Malgun Gothic"/>
               </a:rPr>
-              <a:t>동일 파이프라인에서 세 기법의 개별·조합 효과를 비교한다.</a:t>
+              <a:t>동일 파이프라인에서 세 기법의 개별·조합 효과로 비교한다.</a:t>
             </a:r>
           </a:p>
         </p:txBody>
@@ -3443,7 +3443,7 @@
           <p:cNvPr id="10" name="">
             <a:extLst xmlns:a="http://schemas.openxmlformats.org/drawingml/2006/main">
               <a:ext uri="{FF2B5EF4-FFF2-40B4-BE49-F238E27FC236}">
-                <a16:creationId xmlns:a16="http://schemas.microsoft.com/office/drawing/2014/main" id="{D1666CEC-2BBE-4D35-AA6F-C305A50BB28B}"/>
+                <a16:creationId xmlns:a16="http://schemas.microsoft.com/office/drawing/2014/main" id="{C0816FCC-E820-408B-B85F-75E0A8E0F39F}"/>
               </a:ext>
             </a:extLst>
           </p:cNvPr>
@@ -3474,7 +3474,7 @@
           <p:cNvPr id="11" name="02 Paper-RAG 구조와 기법 적용 위치">
             <a:extLst xmlns:a="http://schemas.openxmlformats.org/drawingml/2006/main">
               <a:ext uri="{FF2B5EF4-FFF2-40B4-BE49-F238E27FC236}">
-                <a16:creationId xmlns:a16="http://schemas.microsoft.com/office/drawing/2014/main" id="{A359DAFF-1DCC-42DF-9631-830EB45CBF2F}"/>
+                <a16:creationId xmlns:a16="http://schemas.microsoft.com/office/drawing/2014/main" id="{ABA491DE-CB5C-4A36-8F7E-0D6058C65509}"/>
               </a:ext>
             </a:extLst>
           </p:cNvPr>
@@ -3542,7 +3542,7 @@
           <p:cNvPr id="12" name="Paper-RAG는 본 연구의 고정 검색·생성 파이프라인이다.">
             <a:extLst xmlns:a="http://schemas.openxmlformats.org/drawingml/2006/main">
               <a:ext uri="{FF2B5EF4-FFF2-40B4-BE49-F238E27FC236}">
-                <a16:creationId xmlns:a16="http://schemas.microsoft.com/office/drawing/2014/main" id="{65CEE761-27C9-46D0-8B8B-E8C8D9B8C5FA}"/>
+                <a16:creationId xmlns:a16="http://schemas.microsoft.com/office/drawing/2014/main" id="{171987F4-43DE-4CA8-95DC-56A870D7326B}"/>
               </a:ext>
             </a:extLst>
           </p:cNvPr>
@@ -3610,7 +3610,7 @@
           <p:cNvPr id="13" name="">
             <a:extLst xmlns:a="http://schemas.openxmlformats.org/drawingml/2006/main">
               <a:ext uri="{FF2B5EF4-FFF2-40B4-BE49-F238E27FC236}">
-                <a16:creationId xmlns:a16="http://schemas.microsoft.com/office/drawing/2014/main" id="{FDEC1F70-A555-4911-84C4-1E7D6F0D97E6}"/>
+                <a16:creationId xmlns:a16="http://schemas.microsoft.com/office/drawing/2014/main" id="{D66388B6-9D9A-4493-BD65-8BF7C53BFDCF}"/>
               </a:ext>
             </a:extLst>
           </p:cNvPr>
@@ -3643,7 +3643,7 @@
           <p:cNvPr id="14" name="한국어 질의 HyDE OFF: 원질의 HyDE ON: 영어 번역·가상 문서">
             <a:extLst xmlns:a="http://schemas.openxmlformats.org/drawingml/2006/main">
               <a:ext uri="{FF2B5EF4-FFF2-40B4-BE49-F238E27FC236}">
-                <a16:creationId xmlns:a16="http://schemas.microsoft.com/office/drawing/2014/main" id="{618FAC3F-A521-42F8-9CD6-066189936BE8}"/>
+                <a16:creationId xmlns:a16="http://schemas.microsoft.com/office/drawing/2014/main" id="{010504EF-242A-472A-AB90-567F4F6F27E5}"/>
               </a:ext>
             </a:extLst>
           </p:cNvPr>
@@ -3757,7 +3757,7 @@
           <p:cNvPr id="15" name="">
             <a:extLst xmlns:a="http://schemas.openxmlformats.org/drawingml/2006/main">
               <a:ext uri="{FF2B5EF4-FFF2-40B4-BE49-F238E27FC236}">
-                <a16:creationId xmlns:a16="http://schemas.microsoft.com/office/drawing/2014/main" id="{31FAE63D-9DB8-416E-88E6-ABF20C78A2AE}"/>
+                <a16:creationId xmlns:a16="http://schemas.microsoft.com/office/drawing/2014/main" id="{57B6A6DD-5D7B-4624-B5D9-9814D3FDF5DC}"/>
               </a:ext>
             </a:extLst>
           </p:cNvPr>
@@ -3790,7 +3790,7 @@
           <p:cNvPr id="16" name="BM25 희소 검색[6] 한국어 원질의 사용">
             <a:extLst xmlns:a="http://schemas.openxmlformats.org/drawingml/2006/main">
               <a:ext uri="{FF2B5EF4-FFF2-40B4-BE49-F238E27FC236}">
-                <a16:creationId xmlns:a16="http://schemas.microsoft.com/office/drawing/2014/main" id="{7A4978EA-8000-42B7-A520-16E123176525}"/>
+                <a16:creationId xmlns:a16="http://schemas.microsoft.com/office/drawing/2014/main" id="{ABBF49ED-CC33-4BF0-93EB-8C2A749C6AA5}"/>
               </a:ext>
             </a:extLst>
           </p:cNvPr>
@@ -3881,7 +3881,7 @@
           <p:cNvPr id="17" name="">
             <a:extLst xmlns:a="http://schemas.openxmlformats.org/drawingml/2006/main">
               <a:ext uri="{FF2B5EF4-FFF2-40B4-BE49-F238E27FC236}">
-                <a16:creationId xmlns:a16="http://schemas.microsoft.com/office/drawing/2014/main" id="{A255968A-A3AF-4E1A-8A39-A96B04DDD5BA}"/>
+                <a16:creationId xmlns:a16="http://schemas.microsoft.com/office/drawing/2014/main" id="{14662856-405F-4C79-AB51-BDE3444C7CC6}"/>
               </a:ext>
             </a:extLst>
           </p:cNvPr>
@@ -3914,7 +3914,7 @@
           <p:cNvPr id="18" name="BGE-M3 밀집 검색[5]">
             <a:extLst xmlns:a="http://schemas.openxmlformats.org/drawingml/2006/main">
               <a:ext uri="{FF2B5EF4-FFF2-40B4-BE49-F238E27FC236}">
-                <a16:creationId xmlns:a16="http://schemas.microsoft.com/office/drawing/2014/main" id="{861CA805-13DA-42D7-83F2-F22FA1AAD0A2}"/>
+                <a16:creationId xmlns:a16="http://schemas.microsoft.com/office/drawing/2014/main" id="{090FAF09-340A-4C07-BB4A-1F3E51851FFC}"/>
               </a:ext>
             </a:extLst>
           </p:cNvPr>
@@ -3982,7 +3982,7 @@
           <p:cNvPr id="19" name="">
             <a:extLst xmlns:a="http://schemas.openxmlformats.org/drawingml/2006/main">
               <a:ext uri="{FF2B5EF4-FFF2-40B4-BE49-F238E27FC236}">
-                <a16:creationId xmlns:a16="http://schemas.microsoft.com/office/drawing/2014/main" id="{F05EAABA-C861-4B00-B54C-CED5A7772525}"/>
+                <a16:creationId xmlns:a16="http://schemas.microsoft.com/office/drawing/2014/main" id="{4B72F661-9B82-4B60-9557-46582FF7446B}"/>
               </a:ext>
             </a:extLst>
           </p:cNvPr>
@@ -4015,7 +4015,7 @@
           <p:cNvPr id="20" name="가중 RRF[7] 0.6 / 0.4, k=60">
             <a:extLst xmlns:a="http://schemas.openxmlformats.org/drawingml/2006/main">
               <a:ext uri="{FF2B5EF4-FFF2-40B4-BE49-F238E27FC236}">
-                <a16:creationId xmlns:a16="http://schemas.microsoft.com/office/drawing/2014/main" id="{D8AFCB13-FB30-44B0-B4CE-00343984AA7E}"/>
+                <a16:creationId xmlns:a16="http://schemas.microsoft.com/office/drawing/2014/main" id="{424BE6AF-0C1B-422C-AB8F-8A55C4999F6F}"/>
               </a:ext>
             </a:extLst>
           </p:cNvPr>
@@ -4106,7 +4106,7 @@
           <p:cNvPr id="21" name="">
             <a:extLst xmlns:a="http://schemas.openxmlformats.org/drawingml/2006/main">
               <a:ext uri="{FF2B5EF4-FFF2-40B4-BE49-F238E27FC236}">
-                <a16:creationId xmlns:a16="http://schemas.microsoft.com/office/drawing/2014/main" id="{6E75C063-180B-46BC-9C20-AF20BE810BCD}"/>
+                <a16:creationId xmlns:a16="http://schemas.microsoft.com/office/drawing/2014/main" id="{C43A4057-0FCA-4D44-8226-15A94E1E42AD}"/>
               </a:ext>
             </a:extLst>
           </p:cNvPr>
@@ -4138,7 +4138,7 @@
           <p:cNvPr id="22" name="">
             <a:extLst xmlns:a="http://schemas.openxmlformats.org/drawingml/2006/main">
               <a:ext uri="{FF2B5EF4-FFF2-40B4-BE49-F238E27FC236}">
-                <a16:creationId xmlns:a16="http://schemas.microsoft.com/office/drawing/2014/main" id="{A3AAAD59-D5F6-4AB8-B76E-8385F8D5ADFA}"/>
+                <a16:creationId xmlns:a16="http://schemas.microsoft.com/office/drawing/2014/main" id="{C90C8D40-5ACD-4ED8-AA51-D7DB4C79396D}"/>
               </a:ext>
             </a:extLst>
           </p:cNvPr>
@@ -4170,7 +4170,7 @@
           <p:cNvPr id="23" name="">
             <a:extLst xmlns:a="http://schemas.openxmlformats.org/drawingml/2006/main">
               <a:ext uri="{FF2B5EF4-FFF2-40B4-BE49-F238E27FC236}">
-                <a16:creationId xmlns:a16="http://schemas.microsoft.com/office/drawing/2014/main" id="{6AEDD4FF-C09C-4596-964A-E360834D7571}"/>
+                <a16:creationId xmlns:a16="http://schemas.microsoft.com/office/drawing/2014/main" id="{8E0C67CE-FD28-49D8-B3AB-212E79663A08}"/>
               </a:ext>
             </a:extLst>
           </p:cNvPr>
@@ -4202,7 +4202,7 @@
           <p:cNvPr id="24" name="">
             <a:extLst xmlns:a="http://schemas.openxmlformats.org/drawingml/2006/main">
               <a:ext uri="{FF2B5EF4-FFF2-40B4-BE49-F238E27FC236}">
-                <a16:creationId xmlns:a16="http://schemas.microsoft.com/office/drawing/2014/main" id="{DE693ADC-3015-4F57-8330-E5354036F23F}"/>
+                <a16:creationId xmlns:a16="http://schemas.microsoft.com/office/drawing/2014/main" id="{0339FDC4-49A8-4CA2-86C8-87BF00790BEB}"/>
               </a:ext>
             </a:extLst>
           </p:cNvPr>
@@ -4232,10 +4232,10 @@
       </p:sp>
       <p:sp>
         <p:nvSpPr>
-          <p:cNvPr id="25" name="원질의 기반 CrossEncoder 재정렬[8] 상위 5개 구간 선택·문맥 길이 관리">
+          <p:cNvPr id="25" name="원질의·구간 쌍 CrossEncoder 재정렬[8][M2] 상위 5개 구간 선택·문맥 길이 관리">
             <a:extLst xmlns:a="http://schemas.openxmlformats.org/drawingml/2006/main">
               <a:ext uri="{FF2B5EF4-FFF2-40B4-BE49-F238E27FC236}">
-                <a16:creationId xmlns:a16="http://schemas.microsoft.com/office/drawing/2014/main" id="{5114DAB0-4999-4624-93DB-3B3EB37ABD3F}"/>
+                <a16:creationId xmlns:a16="http://schemas.microsoft.com/office/drawing/2014/main" id="{1B13E56A-471A-4ECA-901B-39F9B367FA1D}"/>
               </a:ext>
             </a:extLst>
           </p:cNvPr>
@@ -4293,7 +4293,7 @@
                 <a:ea typeface="Malgun Gothic"/>
                 <a:cs typeface="Malgun Gothic"/>
               </a:rPr>
-              <a:t>원질의 기반 CrossEncoder 재정렬[8]</a:t>
+              <a:t>원질의·구간 쌍 CrossEncoder 재정렬[8][M2]</a:t>
             </a:r>
           </a:p>
           <a:p xmlns:a="http://schemas.openxmlformats.org/drawingml/2006/main">
@@ -4326,7 +4326,7 @@
           <p:cNvPr id="26" name="">
             <a:extLst xmlns:a="http://schemas.openxmlformats.org/drawingml/2006/main">
               <a:ext uri="{FF2B5EF4-FFF2-40B4-BE49-F238E27FC236}">
-                <a16:creationId xmlns:a16="http://schemas.microsoft.com/office/drawing/2014/main" id="{D9980D2E-0D33-46F0-B537-E56B9A7EDB14}"/>
+                <a16:creationId xmlns:a16="http://schemas.microsoft.com/office/drawing/2014/main" id="{718F5B70-120D-43B0-9037-555C0C128F6F}"/>
               </a:ext>
             </a:extLst>
           </p:cNvPr>
@@ -4356,10 +4356,10 @@
       </p:sp>
       <p:sp>
         <p:nvSpPr>
-          <p:cNvPr id="27" name="Mi:dm 2.0 Base Instruct[18] CAD 로짓 결합 후 SCD 언어별 조정, 최종 답변 생성">
+          <p:cNvPr id="27" name="Mi:dm 2.0 Base Instruct[M1] CAD 로짓 결합 후 SCD 언어별 조정, 최종 답변 생성">
             <a:extLst xmlns:a="http://schemas.openxmlformats.org/drawingml/2006/main">
               <a:ext uri="{FF2B5EF4-FFF2-40B4-BE49-F238E27FC236}">
-                <a16:creationId xmlns:a16="http://schemas.microsoft.com/office/drawing/2014/main" id="{C5BF05F1-93FA-4260-957B-C4B483540810}"/>
+                <a16:creationId xmlns:a16="http://schemas.microsoft.com/office/drawing/2014/main" id="{068F3D05-F039-4813-B53D-A0EEBD92A59A}"/>
               </a:ext>
             </a:extLst>
           </p:cNvPr>
@@ -4417,7 +4417,7 @@
                 <a:ea typeface="Malgun Gothic"/>
                 <a:cs typeface="Malgun Gothic"/>
               </a:rPr>
-              <a:t>Mi:dm 2.0 Base Instruct[18]</a:t>
+              <a:t>Mi:dm 2.0 Base Instruct[M1]</a:t>
             </a:r>
           </a:p>
           <a:p xmlns:a="http://schemas.openxmlformats.org/drawingml/2006/main">
@@ -4450,7 +4450,7 @@
           <p:cNvPr id="28" name="">
             <a:extLst xmlns:a="http://schemas.openxmlformats.org/drawingml/2006/main">
               <a:ext uri="{FF2B5EF4-FFF2-40B4-BE49-F238E27FC236}">
-                <a16:creationId xmlns:a16="http://schemas.microsoft.com/office/drawing/2014/main" id="{8F48F89E-EF29-42DA-AA6E-5B5FB43D42B5}"/>
+                <a16:creationId xmlns:a16="http://schemas.microsoft.com/office/drawing/2014/main" id="{546EBC49-52FF-4767-8D8B-0B1D3E759A29}"/>
               </a:ext>
             </a:extLst>
           </p:cNvPr>
@@ -4482,7 +4482,7 @@
           <p:cNvPr id="29" name="">
             <a:extLst xmlns:a="http://schemas.openxmlformats.org/drawingml/2006/main">
               <a:ext uri="{FF2B5EF4-FFF2-40B4-BE49-F238E27FC236}">
-                <a16:creationId xmlns:a16="http://schemas.microsoft.com/office/drawing/2014/main" id="{8792B1DD-2037-4653-A37D-E7707BEBAA48}"/>
+                <a16:creationId xmlns:a16="http://schemas.microsoft.com/office/drawing/2014/main" id="{961EA1D3-7005-48E9-86A8-71B377B1C10E}"/>
               </a:ext>
             </a:extLst>
           </p:cNvPr>
@@ -4514,7 +4514,7 @@
           <p:cNvPr id="30" name="">
             <a:extLst xmlns:a="http://schemas.openxmlformats.org/drawingml/2006/main">
               <a:ext uri="{FF2B5EF4-FFF2-40B4-BE49-F238E27FC236}">
-                <a16:creationId xmlns:a16="http://schemas.microsoft.com/office/drawing/2014/main" id="{E1740FB1-CC0B-47DB-937E-60985F7F4FC1}"/>
+                <a16:creationId xmlns:a16="http://schemas.microsoft.com/office/drawing/2014/main" id="{BB8F461A-7AF8-41AD-BE4F-52D92103DA94}"/>
               </a:ext>
             </a:extLst>
           </p:cNvPr>
@@ -4545,7 +4545,7 @@
           <p:cNvPr id="31" name="03 3요인 완전요인 실험 설계">
             <a:extLst xmlns:a="http://schemas.openxmlformats.org/drawingml/2006/main">
               <a:ext uri="{FF2B5EF4-FFF2-40B4-BE49-F238E27FC236}">
-                <a16:creationId xmlns:a16="http://schemas.microsoft.com/office/drawing/2014/main" id="{A87ECBC9-0566-4AF1-A6A6-B495B714053E}"/>
+                <a16:creationId xmlns:a16="http://schemas.microsoft.com/office/drawing/2014/main" id="{06A8580A-BE3F-4FF1-A6B8-D43FFF35A2C2}"/>
               </a:ext>
             </a:extLst>
           </p:cNvPr>
@@ -4613,7 +4613,7 @@
           <p:cNvPr id="32" name="H=HyDE, C=CAD, S=SCD   0=미적용, 1=적용">
             <a:extLst xmlns:a="http://schemas.openxmlformats.org/drawingml/2006/main">
               <a:ext uri="{FF2B5EF4-FFF2-40B4-BE49-F238E27FC236}">
-                <a16:creationId xmlns:a16="http://schemas.microsoft.com/office/drawing/2014/main" id="{9F93F138-42C0-4DF2-BE1A-C4F25E7AAB51}"/>
+                <a16:creationId xmlns:a16="http://schemas.microsoft.com/office/drawing/2014/main" id="{6E658457-7906-4B22-A95B-B56CDF2A9AB1}"/>
               </a:ext>
             </a:extLst>
           </p:cNvPr>
@@ -4681,7 +4681,7 @@
           <p:cNvPr id="33" name="">
             <a:extLst xmlns:a="http://schemas.openxmlformats.org/drawingml/2006/main">
               <a:ext uri="{FF2B5EF4-FFF2-40B4-BE49-F238E27FC236}">
-                <a16:creationId xmlns:a16="http://schemas.microsoft.com/office/drawing/2014/main" id="{C4168366-7139-4AC4-B94A-0B6C1F71BCE1}"/>
+                <a16:creationId xmlns:a16="http://schemas.microsoft.com/office/drawing/2014/main" id="{CB14E32A-5FB3-419C-8228-36C76F28DDC8}"/>
               </a:ext>
             </a:extLst>
           </p:cNvPr>
@@ -6208,10 +6208,10 @@
       </p:graphicFrame>
       <p:sp>
         <p:nvSpPr>
-          <p:cNvPr id="34" name="영어 문서 4종 × 15개 질의 × 8조건 = 480개 생성 기록">
+          <p:cNvPr id="34" name="같은 질의 60개 × 8조건 반복측정 = 480개 생성 기록">
             <a:extLst xmlns:a="http://schemas.openxmlformats.org/drawingml/2006/main">
               <a:ext uri="{FF2B5EF4-FFF2-40B4-BE49-F238E27FC236}">
-                <a16:creationId xmlns:a16="http://schemas.microsoft.com/office/drawing/2014/main" id="{66864D79-5146-44E8-920A-A53838BB732D}"/>
+                <a16:creationId xmlns:a16="http://schemas.microsoft.com/office/drawing/2014/main" id="{C13B4DE2-291F-4C28-806E-AD2A80E1CB53}"/>
               </a:ext>
             </a:extLst>
           </p:cNvPr>
@@ -6269,7 +6269,7 @@
                 <a:ea typeface="Malgun Gothic"/>
                 <a:cs typeface="Malgun Gothic"/>
               </a:rPr>
-              <a:t>영어 문서 4종 × 15개 질의 × 8조건 = 480개 생성 기록</a:t>
+              <a:t>같은 질의 60개 × 8조건 반복측정 = 480개 생성 기록</a:t>
             </a:r>
           </a:p>
         </p:txBody>
@@ -6279,7 +6279,7 @@
           <p:cNvPr id="35" name="생성 512토큰, CAD α=0.5, SCD α=1.1·β=0.9·Tstart=5">
             <a:extLst xmlns:a="http://schemas.openxmlformats.org/drawingml/2006/main">
               <a:ext uri="{FF2B5EF4-FFF2-40B4-BE49-F238E27FC236}">
-                <a16:creationId xmlns:a16="http://schemas.microsoft.com/office/drawing/2014/main" id="{2A888506-9B62-4DFC-A046-71AEC1A91D87}"/>
+                <a16:creationId xmlns:a16="http://schemas.microsoft.com/office/drawing/2014/main" id="{2B114CEE-7C1B-4DC7-9A97-476832105F41}"/>
               </a:ext>
             </a:extLst>
           </p:cNvPr>
@@ -6347,7 +6347,7 @@
           <p:cNvPr id="36" name="문서 요약을 15개 내용 단위로 나누어 질의를 작성하고, 총 60개 질의의 원문 페이지·정답 근거·답변 가능성을 확인">
             <a:extLst xmlns:a="http://schemas.openxmlformats.org/drawingml/2006/main">
               <a:ext uri="{FF2B5EF4-FFF2-40B4-BE49-F238E27FC236}">
-                <a16:creationId xmlns:a16="http://schemas.microsoft.com/office/drawing/2014/main" id="{D676F183-EBA1-4044-9E7D-3DCA6E5475AD}"/>
+                <a16:creationId xmlns:a16="http://schemas.microsoft.com/office/drawing/2014/main" id="{1DB54CE9-20A9-49EC-8861-A0764339B16A}"/>
               </a:ext>
             </a:extLst>
           </p:cNvPr>
@@ -6438,7 +6438,7 @@
           <p:cNvPr id="37" name="">
             <a:extLst xmlns:a="http://schemas.openxmlformats.org/drawingml/2006/main">
               <a:ext uri="{FF2B5EF4-FFF2-40B4-BE49-F238E27FC236}">
-                <a16:creationId xmlns:a16="http://schemas.microsoft.com/office/drawing/2014/main" id="{AC086B2B-56E3-4844-AF51-CABA5AC89075}"/>
+                <a16:creationId xmlns:a16="http://schemas.microsoft.com/office/drawing/2014/main" id="{F62927B6-D60F-4201-B1B1-A68BB0300485}"/>
               </a:ext>
             </a:extLst>
           </p:cNvPr>
@@ -6469,7 +6469,7 @@
           <p:cNvPr id="38" name="04 평가 지표 및 실험·통계 방법">
             <a:extLst xmlns:a="http://schemas.openxmlformats.org/drawingml/2006/main">
               <a:ext uri="{FF2B5EF4-FFF2-40B4-BE49-F238E27FC236}">
-                <a16:creationId xmlns:a16="http://schemas.microsoft.com/office/drawing/2014/main" id="{C6C06BA7-1329-4939-965D-859F5F94A444}"/>
+                <a16:creationId xmlns:a16="http://schemas.microsoft.com/office/drawing/2014/main" id="{A9489E70-B301-48F2-B35A-F97337A797C9}"/>
               </a:ext>
             </a:extLst>
           </p:cNvPr>
@@ -6537,7 +6537,7 @@
           <p:cNvPr id="39" name="근거 충실도: 높을수록 검색 근거가 지지하는 답변 주장 비율이 크다. 답변 관련성: 높을수록 답변 기반 질문과 원질문">
             <a:extLst xmlns:a="http://schemas.openxmlformats.org/drawingml/2006/main">
               <a:ext uri="{FF2B5EF4-FFF2-40B4-BE49-F238E27FC236}">
-                <a16:creationId xmlns:a16="http://schemas.microsoft.com/office/drawing/2014/main" id="{5E7403BF-CFB6-4272-9D80-9510D5D9744F}"/>
+                <a16:creationId xmlns:a16="http://schemas.microsoft.com/office/drawing/2014/main" id="{8B9D0C8B-DE50-4B90-A878-60AFEB0DD8DA}"/>
               </a:ext>
             </a:extLst>
           </p:cNvPr>
@@ -6697,7 +6697,7 @@
           <p:cNvPr id="40" name="품질 관측값은 0~1이다. 관련성 +0.080은 ON−OFF 평균 차이 0.080점이다. SD는 질의별 분포의 표본표">
             <a:extLst xmlns:a="http://schemas.openxmlformats.org/drawingml/2006/main">
               <a:ext uri="{FF2B5EF4-FFF2-40B4-BE49-F238E27FC236}">
-                <a16:creationId xmlns:a16="http://schemas.microsoft.com/office/drawing/2014/main" id="{F22B2673-8C83-4EA0-8AF8-AB950575FE39}"/>
+                <a16:creationId xmlns:a16="http://schemas.microsoft.com/office/drawing/2014/main" id="{5C49F3F4-C621-4158-AA78-3690915A584D}"/>
               </a:ext>
             </a:extLst>
           </p:cNvPr>
@@ -6811,7 +6811,7 @@
           <p:cNvPr id="41" name="평가 예시  ext_raptor_011, H0C0S0">
             <a:extLst xmlns:a="http://schemas.openxmlformats.org/drawingml/2006/main">
               <a:ext uri="{FF2B5EF4-FFF2-40B4-BE49-F238E27FC236}">
-                <a16:creationId xmlns:a16="http://schemas.microsoft.com/office/drawing/2014/main" id="{D7CBEFEC-D542-43E3-A12F-310A3F67EA91}"/>
+                <a16:creationId xmlns:a16="http://schemas.microsoft.com/office/drawing/2014/main" id="{B0B826B3-3EF0-469E-B156-76B43250CC9C}"/>
               </a:ext>
             </a:extLst>
           </p:cNvPr>
@@ -6879,7 +6879,7 @@
           <p:cNvPr id="42" name="질문: Cinderella 사례의 정성 분석에서 RAPTOR의 tree-based retrieval이 DPR보다 주제">
             <a:extLst xmlns:a="http://schemas.openxmlformats.org/drawingml/2006/main">
               <a:ext uri="{FF2B5EF4-FFF2-40B4-BE49-F238E27FC236}">
-                <a16:creationId xmlns:a16="http://schemas.microsoft.com/office/drawing/2014/main" id="{EF383AD0-D560-4E46-B03C-277EBE950E8B}"/>
+                <a16:creationId xmlns:a16="http://schemas.microsoft.com/office/drawing/2014/main" id="{87904639-62A9-4614-B066-40665DEA3566}"/>
               </a:ext>
             </a:extLst>
           </p:cNvPr>
@@ -6891,6 +6891,97 @@
         <p:spPr>
           <a:xfrm xmlns:a="http://schemas.openxmlformats.org/drawingml/2006/main">
             <a:off x="704850" y="22402800"/>
+            <a:ext cx="9729975" cy="571500"/>
+          </a:xfrm>
+          <a:prstGeom xmlns:a="http://schemas.openxmlformats.org/drawingml/2006/main" prst="rect">
+            <a:avLst/>
+          </a:prstGeom>
+          <a:noFill xmlns:a="http://schemas.openxmlformats.org/drawingml/2006/main"/>
+          <a:ln xmlns:a="http://schemas.openxmlformats.org/drawingml/2006/main" w="0">
+            <a:noFill/>
+          </a:ln>
+        </p:spPr>
+        <p:txBody>
+          <a:bodyPr xmlns:a="http://schemas.openxmlformats.org/drawingml/2006/main" wrap="none" lIns="0" tIns="0" rIns="0" bIns="0" anchor="t">
+            <a:noAutofit/>
+          </a:bodyPr>
+          <a:lstStyle xmlns:a="http://schemas.openxmlformats.org/drawingml/2006/main">
+            <a:defPPr algn="l">
+              <a:defRPr sz="1800" b="0">
+                <a:solidFill>
+                  <a:srgbClr val="24324A"/>
+                </a:solidFill>
+                <a:latin typeface="Malgun Gothic"/>
+                <a:ea typeface="Malgun Gothic"/>
+                <a:cs typeface="Malgun Gothic"/>
+              </a:defRPr>
+            </a:defPPr>
+          </a:lstStyle>
+          <a:p xmlns:a="http://schemas.openxmlformats.org/drawingml/2006/main">
+            <a:pPr algn="l">
+              <a:defRPr sz="1800" b="0">
+                <a:solidFill>
+                  <a:srgbClr val="24324A"/>
+                </a:solidFill>
+                <a:latin typeface="Malgun Gothic"/>
+                <a:ea typeface="Malgun Gothic"/>
+                <a:cs typeface="Malgun Gothic"/>
+              </a:defRPr>
+            </a:pPr>
+            <a:r>
+              <a:rPr sz="1800" b="0">
+                <a:solidFill>
+                  <a:srgbClr val="24324A"/>
+                </a:solidFill>
+                <a:latin typeface="Malgun Gothic"/>
+                <a:ea typeface="Malgun Gothic"/>
+                <a:cs typeface="Malgun Gothic"/>
+              </a:rPr>
+              <a:t>질문: Cinderella 사례의 정성 분석에서 RAPTOR의 tree-based</a:t>
+            </a:r>
+          </a:p>
+          <a:p xmlns:a="http://schemas.openxmlformats.org/drawingml/2006/main">
+            <a:pPr algn="l">
+              <a:defRPr sz="1800" b="0">
+                <a:solidFill>
+                  <a:srgbClr val="24324A"/>
+                </a:solidFill>
+                <a:latin typeface="Malgun Gothic"/>
+                <a:ea typeface="Malgun Gothic"/>
+                <a:cs typeface="Malgun Gothic"/>
+              </a:defRPr>
+            </a:pPr>
+            <a:r>
+              <a:rPr sz="1800" b="0">
+                <a:solidFill>
+                  <a:srgbClr val="24324A"/>
+                </a:solidFill>
+                <a:latin typeface="Malgun Gothic"/>
+                <a:ea typeface="Malgun Gothic"/>
+                <a:cs typeface="Malgun Gothic"/>
+              </a:rPr>
+              <a:t>retrieval이 DPR보다 주제형·멀티홉 질문에 유리했던 이유는 무엇입니까?</a:t>
+            </a:r>
+          </a:p>
+        </p:txBody>
+      </p:sp>
+      <p:sp>
+        <p:nvSpPr>
+          <p:cNvPr id="43" name="검색 근거(PDF p.9): “By providing both the original text and higher-l">
+            <a:extLst xmlns:a="http://schemas.openxmlformats.org/drawingml/2006/main">
+              <a:ext uri="{FF2B5EF4-FFF2-40B4-BE49-F238E27FC236}">
+                <a16:creationId xmlns:a16="http://schemas.microsoft.com/office/drawing/2014/main" id="{3B679EB7-B7DC-4A60-A8B9-BA2E9FE038C2}"/>
+              </a:ext>
+            </a:extLst>
+          </p:cNvPr>
+          <p:cNvSpPr>
+            <a:spLocks xmlns:a="http://schemas.openxmlformats.org/drawingml/2006/main" noGrp="1"/>
+          </p:cNvSpPr>
+          <p:nvPr/>
+        </p:nvSpPr>
+        <p:spPr>
+          <a:xfrm xmlns:a="http://schemas.openxmlformats.org/drawingml/2006/main">
+            <a:off x="704850" y="22993350"/>
             <a:ext cx="9729975" cy="857250"/>
           </a:xfrm>
           <a:prstGeom xmlns:a="http://schemas.openxmlformats.org/drawingml/2006/main" prst="rect">
@@ -6937,7 +7028,7 @@
                 <a:ea typeface="Malgun Gothic"/>
                 <a:cs typeface="Malgun Gothic"/>
               </a:rPr>
-              <a:t>질문: Cinderella 사례의 정성 분석에서 RAPTOR의</a:t>
+              <a:t>검색 근거(PDF p.9): “By providing both the original text and higher-level summaries</a:t>
             </a:r>
           </a:p>
           <a:p xmlns:a="http://schemas.openxmlformats.org/drawingml/2006/main">
@@ -6960,7 +7051,7 @@
                 <a:ea typeface="Malgun Gothic"/>
                 <a:cs typeface="Malgun Gothic"/>
               </a:rPr>
-              <a:t>tree-based retrieval이 DPR보다 주제형·멀티홉</a:t>
+              <a:t>for retrieval, RAPTOR can effectively handle a wider range of</a:t>
             </a:r>
           </a:p>
           <a:p xmlns:a="http://schemas.openxmlformats.org/drawingml/2006/main">
@@ -6983,17 +7074,17 @@
                 <a:ea typeface="Malgun Gothic"/>
                 <a:cs typeface="Malgun Gothic"/>
               </a:rPr>
-              <a:t>질문에 유리했던 이유는 무엇입니까?</a:t>
+              <a:t>questions, from higher-order thematic queries to detail-oriented questions.”</a:t>
             </a:r>
           </a:p>
         </p:txBody>
       </p:sp>
       <p:sp>
         <p:nvSpPr>
-          <p:cNvPr id="43" name="참조 답변 요지(원문 p.19): RAPTOR는 이야기의 주요 부분을, DPR은 이야기의 좁은 일부를 자세히 검색한다">
+          <p:cNvPr id="44" name="참조 답변 요지(PDF p.20): RAPTOR는 이야기의 주요 부분을, DPR은 이야기의 좁은 일부를 자세히 검색한">
             <a:extLst xmlns:a="http://schemas.openxmlformats.org/drawingml/2006/main">
               <a:ext uri="{FF2B5EF4-FFF2-40B4-BE49-F238E27FC236}">
-                <a16:creationId xmlns:a16="http://schemas.microsoft.com/office/drawing/2014/main" id="{2AAA700B-49E2-4B20-8E39-0266A247F7C2}"/>
+                <a16:creationId xmlns:a16="http://schemas.microsoft.com/office/drawing/2014/main" id="{DE0059C3-9038-4D15-AD7D-772E14CF57A8}"/>
               </a:ext>
             </a:extLst>
           </p:cNvPr>
@@ -7004,7 +7095,7 @@
         </p:nvSpPr>
         <p:spPr>
           <a:xfrm xmlns:a="http://schemas.openxmlformats.org/drawingml/2006/main">
-            <a:off x="704850" y="23288625"/>
+            <a:off x="704850" y="23879175"/>
             <a:ext cx="9729975" cy="571500"/>
           </a:xfrm>
           <a:prstGeom xmlns:a="http://schemas.openxmlformats.org/drawingml/2006/main" prst="rect">
@@ -7051,7 +7142,7 @@
                 <a:ea typeface="Malgun Gothic"/>
                 <a:cs typeface="Malgun Gothic"/>
               </a:rPr>
-              <a:t>참조 답변 요지(원문 p.19): RAPTOR는 이야기의 주요 부분을,</a:t>
+              <a:t>참조 답변 요지(PDF p.20): RAPTOR는 이야기의 주요 부분을,</a:t>
             </a:r>
           </a:p>
           <a:p xmlns:a="http://schemas.openxmlformats.org/drawingml/2006/main">
@@ -7081,10 +7172,10 @@
       </p:sp>
       <p:sp>
         <p:nvSpPr>
-          <p:cNvPr id="44" name="근거 발췌: “RAPTOR selects nodes from different layers” 생성 답변 발췌: “질문">
+          <p:cNvPr id="45" name="생성 답변 발췌: “질문의 요구사항에 따라 서로 다른 층위(layer)에서 노드를 선택할 수 있습니다.”">
             <a:extLst xmlns:a="http://schemas.openxmlformats.org/drawingml/2006/main">
               <a:ext uri="{FF2B5EF4-FFF2-40B4-BE49-F238E27FC236}">
-                <a16:creationId xmlns:a16="http://schemas.microsoft.com/office/drawing/2014/main" id="{A8337AA5-218A-40ED-AEDA-2E0982324AA5}"/>
+                <a16:creationId xmlns:a16="http://schemas.microsoft.com/office/drawing/2014/main" id="{9D73BECE-FD4F-491D-8ED6-DB58D43259BC}"/>
               </a:ext>
             </a:extLst>
           </p:cNvPr>
@@ -7095,121 +7186,7 @@
         </p:nvSpPr>
         <p:spPr>
           <a:xfrm xmlns:a="http://schemas.openxmlformats.org/drawingml/2006/main">
-            <a:off x="704850" y="23888700"/>
-            <a:ext cx="9729975" cy="857250"/>
-          </a:xfrm>
-          <a:prstGeom xmlns:a="http://schemas.openxmlformats.org/drawingml/2006/main" prst="rect">
-            <a:avLst/>
-          </a:prstGeom>
-          <a:noFill xmlns:a="http://schemas.openxmlformats.org/drawingml/2006/main"/>
-          <a:ln xmlns:a="http://schemas.openxmlformats.org/drawingml/2006/main" w="0">
-            <a:noFill/>
-          </a:ln>
-        </p:spPr>
-        <p:txBody>
-          <a:bodyPr xmlns:a="http://schemas.openxmlformats.org/drawingml/2006/main" wrap="none" lIns="0" tIns="0" rIns="0" bIns="0" anchor="t">
-            <a:noAutofit/>
-          </a:bodyPr>
-          <a:lstStyle xmlns:a="http://schemas.openxmlformats.org/drawingml/2006/main">
-            <a:defPPr algn="l">
-              <a:defRPr sz="1800" b="0">
-                <a:solidFill>
-                  <a:srgbClr val="24324A"/>
-                </a:solidFill>
-                <a:latin typeface="Malgun Gothic"/>
-                <a:ea typeface="Malgun Gothic"/>
-                <a:cs typeface="Malgun Gothic"/>
-              </a:defRPr>
-            </a:defPPr>
-          </a:lstStyle>
-          <a:p xmlns:a="http://schemas.openxmlformats.org/drawingml/2006/main">
-            <a:pPr algn="l">
-              <a:defRPr sz="1800" b="0">
-                <a:solidFill>
-                  <a:srgbClr val="24324A"/>
-                </a:solidFill>
-                <a:latin typeface="Malgun Gothic"/>
-                <a:ea typeface="Malgun Gothic"/>
-                <a:cs typeface="Malgun Gothic"/>
-              </a:defRPr>
-            </a:pPr>
-            <a:r>
-              <a:rPr sz="1800" b="0">
-                <a:solidFill>
-                  <a:srgbClr val="24324A"/>
-                </a:solidFill>
-                <a:latin typeface="Malgun Gothic"/>
-                <a:ea typeface="Malgun Gothic"/>
-                <a:cs typeface="Malgun Gothic"/>
-              </a:rPr>
-              <a:t>근거 발췌: “RAPTOR selects nodes from different layers”</a:t>
-            </a:r>
-          </a:p>
-          <a:p xmlns:a="http://schemas.openxmlformats.org/drawingml/2006/main">
-            <a:pPr algn="l">
-              <a:defRPr sz="1800" b="0">
-                <a:solidFill>
-                  <a:srgbClr val="24324A"/>
-                </a:solidFill>
-                <a:latin typeface="Malgun Gothic"/>
-                <a:ea typeface="Malgun Gothic"/>
-                <a:cs typeface="Malgun Gothic"/>
-              </a:defRPr>
-            </a:pPr>
-            <a:r>
-              <a:rPr sz="1800" b="0">
-                <a:solidFill>
-                  <a:srgbClr val="24324A"/>
-                </a:solidFill>
-                <a:latin typeface="Malgun Gothic"/>
-                <a:ea typeface="Malgun Gothic"/>
-                <a:cs typeface="Malgun Gothic"/>
-              </a:rPr>
-              <a:t>생성 답변 발췌: “질문의 요구사항에 따라 서로 다른</a:t>
-            </a:r>
-          </a:p>
-          <a:p xmlns:a="http://schemas.openxmlformats.org/drawingml/2006/main">
-            <a:pPr algn="l">
-              <a:defRPr sz="1800" b="0">
-                <a:solidFill>
-                  <a:srgbClr val="24324A"/>
-                </a:solidFill>
-                <a:latin typeface="Malgun Gothic"/>
-                <a:ea typeface="Malgun Gothic"/>
-                <a:cs typeface="Malgun Gothic"/>
-              </a:defRPr>
-            </a:pPr>
-            <a:r>
-              <a:rPr sz="1800" b="0">
-                <a:solidFill>
-                  <a:srgbClr val="24324A"/>
-                </a:solidFill>
-                <a:latin typeface="Malgun Gothic"/>
-                <a:ea typeface="Malgun Gothic"/>
-                <a:cs typeface="Malgun Gothic"/>
-              </a:rPr>
-              <a:t>층위(layer)에서 노드를 선택할 수 있습니다.”</a:t>
-            </a:r>
-          </a:p>
-        </p:txBody>
-      </p:sp>
-      <p:sp>
-        <p:nvSpPr>
-          <p:cNvPr id="45" name="충실도 1.000: 추출된 답변 주장을 검색 문맥이 모두 지지 관련성 0.937: 답변 기반 질문과 원질문의 평균 의">
-            <a:extLst xmlns:a="http://schemas.openxmlformats.org/drawingml/2006/main">
-              <a:ext uri="{FF2B5EF4-FFF2-40B4-BE49-F238E27FC236}">
-                <a16:creationId xmlns:a16="http://schemas.microsoft.com/office/drawing/2014/main" id="{C54C3DD1-49C8-44B4-A3A2-B81BE8991EBE}"/>
-              </a:ext>
-            </a:extLst>
-          </p:cNvPr>
-          <p:cNvSpPr>
-            <a:spLocks xmlns:a="http://schemas.openxmlformats.org/drawingml/2006/main" noGrp="1"/>
-          </p:cNvSpPr>
-          <p:nvPr/>
-        </p:nvSpPr>
-        <p:spPr>
-          <a:xfrm xmlns:a="http://schemas.openxmlformats.org/drawingml/2006/main">
-            <a:off x="704850" y="24784050"/>
+            <a:off x="704850" y="24469725"/>
             <a:ext cx="9729975" cy="571500"/>
           </a:xfrm>
           <a:prstGeom xmlns:a="http://schemas.openxmlformats.org/drawingml/2006/main" prst="rect">
@@ -7256,7 +7233,7 @@
                 <a:ea typeface="Malgun Gothic"/>
                 <a:cs typeface="Malgun Gothic"/>
               </a:rPr>
-              <a:t>충실도 1.000: 추출된 답변 주장을 검색 문맥이 모두 지지</a:t>
+              <a:t>생성 답변 발췌: “질문의 요구사항에 따라 서로 다른</a:t>
             </a:r>
           </a:p>
           <a:p xmlns:a="http://schemas.openxmlformats.org/drawingml/2006/main">
@@ -7279,17 +7256,17 @@
                 <a:ea typeface="Malgun Gothic"/>
                 <a:cs typeface="Malgun Gothic"/>
               </a:rPr>
-              <a:t>관련성 0.937: 답변 기반 질문과 원질문의 평균 의미 유사도</a:t>
+              <a:t>층위(layer)에서 노드를 선택할 수 있습니다.”</a:t>
             </a:r>
           </a:p>
         </p:txBody>
       </p:sp>
       <p:sp>
         <p:nvSpPr>
-          <p:cNvPr id="46" name="평가: RAGAS 0.2.15[10], gpt-4o, BGE-M3 임베딩 S0: 영어 문맥 / S1: 한국어 번역 평">
+          <p:cNvPr id="46" name="충실도 1.000: 추출된 답변 주장을 검색 문맥이 모두 지지 관련성 0.937: 답변 기반 질문과 원질문의 평균 의">
             <a:extLst xmlns:a="http://schemas.openxmlformats.org/drawingml/2006/main">
               <a:ext uri="{FF2B5EF4-FFF2-40B4-BE49-F238E27FC236}">
-                <a16:creationId xmlns:a16="http://schemas.microsoft.com/office/drawing/2014/main" id="{922E7EA3-F45C-4B98-97EF-F3326A84E5DC}"/>
+                <a16:creationId xmlns:a16="http://schemas.microsoft.com/office/drawing/2014/main" id="{10339883-484F-49D8-A7C8-F8777F63B8EF}"/>
               </a:ext>
             </a:extLst>
           </p:cNvPr>
@@ -7300,8 +7277,8 @@
         </p:nvSpPr>
         <p:spPr>
           <a:xfrm xmlns:a="http://schemas.openxmlformats.org/drawingml/2006/main">
-            <a:off x="704850" y="25393650"/>
-            <a:ext cx="9729975" cy="857250"/>
+            <a:off x="704850" y="25069800"/>
+            <a:ext cx="9729975" cy="571500"/>
           </a:xfrm>
           <a:prstGeom xmlns:a="http://schemas.openxmlformats.org/drawingml/2006/main" prst="rect">
             <a:avLst/>
@@ -7347,7 +7324,7 @@
                 <a:ea typeface="Malgun Gothic"/>
                 <a:cs typeface="Malgun Gothic"/>
               </a:rPr>
-              <a:t>평가: RAGAS 0.2.15[10], gpt-4o, BGE-M3 임베딩</a:t>
+              <a:t>충실도 1.000: 추출된 답변 주장을 검색 문맥이 모두 지지</a:t>
             </a:r>
           </a:p>
           <a:p xmlns:a="http://schemas.openxmlformats.org/drawingml/2006/main">
@@ -7370,40 +7347,108 @@
                 <a:ea typeface="Malgun Gothic"/>
                 <a:cs typeface="Malgun Gothic"/>
               </a:rPr>
-              <a:t>S0: 영어 문맥 / S1: 한국어 번역 평가 문맥</a:t>
-            </a:r>
-          </a:p>
-          <a:p xmlns:a="http://schemas.openxmlformats.org/drawingml/2006/main">
-            <a:pPr algn="l">
-              <a:defRPr sz="1800" b="0">
-                <a:solidFill>
-                  <a:srgbClr val="24324A"/>
-                </a:solidFill>
-                <a:latin typeface="Malgun Gothic"/>
-                <a:ea typeface="Malgun Gothic"/>
-                <a:cs typeface="Malgun Gothic"/>
-              </a:defRPr>
-            </a:pPr>
-            <a:r>
-              <a:rPr sz="1800" b="0">
-                <a:solidFill>
-                  <a:srgbClr val="24324A"/>
-                </a:solidFill>
-                <a:latin typeface="Malgun Gothic"/>
-                <a:ea typeface="Malgun Gothic"/>
-                <a:cs typeface="Malgun Gothic"/>
-              </a:rPr>
-              <a:t>생성에는 영어 문맥 사용, 저장 답변은 그대로 평가</a:t>
+              <a:t>관련성 0.937: 답변 기반 질문과 원질문의 평균 의미 유사도</a:t>
             </a:r>
           </a:p>
         </p:txBody>
       </p:sp>
       <p:sp>
         <p:nvSpPr>
-          <p:cNvPr id="47" name="반복측정 분산분석(ANOVA)·대응 t-검정·Holm, α=0.05 품질 S별 H×C / 문자·시간 H×C×S, SC">
+          <p:cNvPr id="47" name="평가: RAGAS 0.2.15[10]·gpt-4o·BGE-M3, 저장 답변 평가 S0 영어 / S1 한국어 번역 평가">
             <a:extLst xmlns:a="http://schemas.openxmlformats.org/drawingml/2006/main">
               <a:ext uri="{FF2B5EF4-FFF2-40B4-BE49-F238E27FC236}">
-                <a16:creationId xmlns:a16="http://schemas.microsoft.com/office/drawing/2014/main" id="{E842B2F6-E2E2-44AA-AA30-352B9330298E}"/>
+                <a16:creationId xmlns:a16="http://schemas.microsoft.com/office/drawing/2014/main" id="{4C2F2814-28BF-4FAD-8E2F-938D04745754}"/>
+              </a:ext>
+            </a:extLst>
+          </p:cNvPr>
+          <p:cNvSpPr>
+            <a:spLocks xmlns:a="http://schemas.openxmlformats.org/drawingml/2006/main" noGrp="1"/>
+          </p:cNvSpPr>
+          <p:nvPr/>
+        </p:nvSpPr>
+        <p:spPr>
+          <a:xfrm xmlns:a="http://schemas.openxmlformats.org/drawingml/2006/main">
+            <a:off x="704850" y="25669875"/>
+            <a:ext cx="9729975" cy="571500"/>
+          </a:xfrm>
+          <a:prstGeom xmlns:a="http://schemas.openxmlformats.org/drawingml/2006/main" prst="rect">
+            <a:avLst/>
+          </a:prstGeom>
+          <a:noFill xmlns:a="http://schemas.openxmlformats.org/drawingml/2006/main"/>
+          <a:ln xmlns:a="http://schemas.openxmlformats.org/drawingml/2006/main" w="0">
+            <a:noFill/>
+          </a:ln>
+        </p:spPr>
+        <p:txBody>
+          <a:bodyPr xmlns:a="http://schemas.openxmlformats.org/drawingml/2006/main" wrap="none" lIns="0" tIns="0" rIns="0" bIns="0" anchor="t">
+            <a:noAutofit/>
+          </a:bodyPr>
+          <a:lstStyle xmlns:a="http://schemas.openxmlformats.org/drawingml/2006/main">
+            <a:defPPr algn="l">
+              <a:defRPr sz="1800" b="0">
+                <a:solidFill>
+                  <a:srgbClr val="24324A"/>
+                </a:solidFill>
+                <a:latin typeface="Malgun Gothic"/>
+                <a:ea typeface="Malgun Gothic"/>
+                <a:cs typeface="Malgun Gothic"/>
+              </a:defRPr>
+            </a:defPPr>
+          </a:lstStyle>
+          <a:p xmlns:a="http://schemas.openxmlformats.org/drawingml/2006/main">
+            <a:pPr algn="l">
+              <a:defRPr sz="1800" b="0">
+                <a:solidFill>
+                  <a:srgbClr val="24324A"/>
+                </a:solidFill>
+                <a:latin typeface="Malgun Gothic"/>
+                <a:ea typeface="Malgun Gothic"/>
+                <a:cs typeface="Malgun Gothic"/>
+              </a:defRPr>
+            </a:pPr>
+            <a:r>
+              <a:rPr sz="1800" b="0">
+                <a:solidFill>
+                  <a:srgbClr val="24324A"/>
+                </a:solidFill>
+                <a:latin typeface="Malgun Gothic"/>
+                <a:ea typeface="Malgun Gothic"/>
+                <a:cs typeface="Malgun Gothic"/>
+              </a:rPr>
+              <a:t>평가: RAGAS 0.2.15[10]·gpt-4o·BGE-M3, 저장 답변 평가</a:t>
+            </a:r>
+          </a:p>
+          <a:p xmlns:a="http://schemas.openxmlformats.org/drawingml/2006/main">
+            <a:pPr algn="l">
+              <a:defRPr sz="1800" b="0">
+                <a:solidFill>
+                  <a:srgbClr val="24324A"/>
+                </a:solidFill>
+                <a:latin typeface="Malgun Gothic"/>
+                <a:ea typeface="Malgun Gothic"/>
+                <a:cs typeface="Malgun Gothic"/>
+              </a:defRPr>
+            </a:pPr>
+            <a:r>
+              <a:rPr sz="1800" b="0">
+                <a:solidFill>
+                  <a:srgbClr val="24324A"/>
+                </a:solidFill>
+                <a:latin typeface="Malgun Gothic"/>
+                <a:ea typeface="Malgun Gothic"/>
+                <a:cs typeface="Malgun Gothic"/>
+              </a:rPr>
+              <a:t>S0 영어 / S1 한국어 번역 평가 문맥, 모든 생성 문맥은 영어</a:t>
+            </a:r>
+          </a:p>
+        </p:txBody>
+      </p:sp>
+      <p:sp>
+        <p:nvSpPr>
+          <p:cNvPr id="48" name="반복측정 분산분석(ANOVA)·대응 t-검정·Holm, α=0.05 품질 S별 H×C / 문자·시간 H×C×S, SC">
+            <a:extLst xmlns:a="http://schemas.openxmlformats.org/drawingml/2006/main">
+              <a:ext uri="{FF2B5EF4-FFF2-40B4-BE49-F238E27FC236}">
+                <a16:creationId xmlns:a16="http://schemas.microsoft.com/office/drawing/2014/main" id="{734BF438-2E7D-4C31-86A6-7FCDA4E898BC}"/>
               </a:ext>
             </a:extLst>
           </p:cNvPr>
@@ -7491,10 +7536,10 @@
       </p:sp>
       <p:sp>
         <p:nvSpPr>
-          <p:cNvPr id="48" name="">
+          <p:cNvPr id="49" name="">
             <a:extLst xmlns:a="http://schemas.openxmlformats.org/drawingml/2006/main">
               <a:ext uri="{FF2B5EF4-FFF2-40B4-BE49-F238E27FC236}">
-                <a16:creationId xmlns:a16="http://schemas.microsoft.com/office/drawing/2014/main" id="{F8CEE9B4-2143-4301-B133-36D58CA50FC8}"/>
+                <a16:creationId xmlns:a16="http://schemas.microsoft.com/office/drawing/2014/main" id="{E4F4DA52-820D-49E7-B186-4E0A7462F275}"/>
               </a:ext>
             </a:extLst>
           </p:cNvPr>
@@ -7522,10 +7567,10 @@
       </p:sp>
       <p:sp>
         <p:nvSpPr>
-          <p:cNvPr id="49" name="05 조합별 결과와 통계 검정">
+          <p:cNvPr id="50" name="05 조합별 결과와 통계 검정">
             <a:extLst xmlns:a="http://schemas.openxmlformats.org/drawingml/2006/main">
               <a:ext uri="{FF2B5EF4-FFF2-40B4-BE49-F238E27FC236}">
-                <a16:creationId xmlns:a16="http://schemas.microsoft.com/office/drawing/2014/main" id="{75E73BFA-1E7B-4493-8A44-26356040C6E9}"/>
+                <a16:creationId xmlns:a16="http://schemas.microsoft.com/office/drawing/2014/main" id="{C76AF8FD-FE50-4762-BE8A-5D7CBBD1C539}"/>
               </a:ext>
             </a:extLst>
           </p:cNvPr>
@@ -7590,10 +7635,10 @@
       </p:sp>
       <p:sp>
         <p:nvSpPr>
-          <p:cNvPr id="50" name="HyDE·CAD·SCD 8조합의 품질·한국어 비율·시간 평균(SD)">
+          <p:cNvPr id="51" name="HyDE·CAD·SCD 8조합의 품질·한국어 비율·시간 평균(SD)">
             <a:extLst xmlns:a="http://schemas.openxmlformats.org/drawingml/2006/main">
               <a:ext uri="{FF2B5EF4-FFF2-40B4-BE49-F238E27FC236}">
-                <a16:creationId xmlns:a16="http://schemas.microsoft.com/office/drawing/2014/main" id="{FC457C18-FED2-48C0-AC4D-61DA44DDE2D2}"/>
+                <a16:creationId xmlns:a16="http://schemas.microsoft.com/office/drawing/2014/main" id="{CB9973BD-C0E3-46E0-BB5C-726B7151E099}"/>
               </a:ext>
             </a:extLst>
           </p:cNvPr>
@@ -7658,10 +7703,10 @@
       </p:sp>
       <p:graphicFrame>
         <p:nvGraphicFramePr>
-          <p:cNvPr id="51" name="">
+          <p:cNvPr id="52" name="">
             <a:extLst xmlns:a="http://schemas.openxmlformats.org/drawingml/2006/main">
               <a:ext uri="{FF2B5EF4-FFF2-40B4-BE49-F238E27FC236}">
-                <a16:creationId xmlns:a16="http://schemas.microsoft.com/office/drawing/2014/main" id="{09A7DFE8-056D-4FE0-BF9B-762E4A0233E8}"/>
+                <a16:creationId xmlns:a16="http://schemas.microsoft.com/office/drawing/2014/main" id="{46132889-9852-4B1F-BAD5-9F3C9281BBC8}"/>
               </a:ext>
             </a:extLst>
           </p:cNvPr>
@@ -11018,10 +11063,10 @@
       </p:graphicFrame>
       <p:sp>
         <p:nvSpPr>
-          <p:cNvPr id="52" name="">
+          <p:cNvPr id="53" name="">
             <a:extLst xmlns:a="http://schemas.openxmlformats.org/drawingml/2006/main">
               <a:ext uri="{FF2B5EF4-FFF2-40B4-BE49-F238E27FC236}">
-                <a16:creationId xmlns:a16="http://schemas.microsoft.com/office/drawing/2014/main" id="{01EC4494-FBB9-4E50-9937-0D99E3F2F648}"/>
+                <a16:creationId xmlns:a16="http://schemas.microsoft.com/office/drawing/2014/main" id="{C52C554D-C602-410A-8371-34F0B5FB4AE1}"/>
               </a:ext>
             </a:extLst>
           </p:cNvPr>
@@ -11049,10 +11094,10 @@
       </p:sp>
       <p:sp>
         <p:nvSpPr>
-          <p:cNvPr id="53" name="S0: 영어 평가 문맥 / S1: 한국어 번역 평가 문맥 충실도 H0C1S0 n=58, H0C0S1 n=57, 나머지">
+          <p:cNvPr id="54" name="S0: 영어 평가 문맥 / S1: 한국어 번역 평가 문맥 충실도 H0C1S0 n=58, H0C0S1 n=57, 나머지">
             <a:extLst xmlns:a="http://schemas.openxmlformats.org/drawingml/2006/main">
               <a:ext uri="{FF2B5EF4-FFF2-40B4-BE49-F238E27FC236}">
-                <a16:creationId xmlns:a16="http://schemas.microsoft.com/office/drawing/2014/main" id="{AFE0D401-8A15-4152-A41A-3760A2132737}"/>
+                <a16:creationId xmlns:a16="http://schemas.microsoft.com/office/drawing/2014/main" id="{7BE12E8B-7593-4B72-B74F-B80C1C612C4F}"/>
               </a:ext>
             </a:extLst>
           </p:cNvPr>
@@ -11163,10 +11208,10 @@
       </p:sp>
       <p:sp>
         <p:nvSpPr>
-          <p:cNvPr id="54" name="3요인 반복측정 ANOVA  ·  각 효과 df=(1,59)">
+          <p:cNvPr id="55" name="3요인 반복측정 ANOVA  ·  각 효과 df=(1,59)">
             <a:extLst xmlns:a="http://schemas.openxmlformats.org/drawingml/2006/main">
               <a:ext uri="{FF2B5EF4-FFF2-40B4-BE49-F238E27FC236}">
-                <a16:creationId xmlns:a16="http://schemas.microsoft.com/office/drawing/2014/main" id="{7817F849-61CD-428A-8162-44EA13D2519A}"/>
+                <a16:creationId xmlns:a16="http://schemas.microsoft.com/office/drawing/2014/main" id="{5EC029FB-D198-4410-BF48-B4883A842D6A}"/>
               </a:ext>
             </a:extLst>
           </p:cNvPr>
@@ -11231,10 +11276,10 @@
       </p:sp>
       <p:graphicFrame>
         <p:nvGraphicFramePr>
-          <p:cNvPr id="55" name="">
+          <p:cNvPr id="56" name="">
             <a:extLst xmlns:a="http://schemas.openxmlformats.org/drawingml/2006/main">
               <a:ext uri="{FF2B5EF4-FFF2-40B4-BE49-F238E27FC236}">
-                <a16:creationId xmlns:a16="http://schemas.microsoft.com/office/drawing/2014/main" id="{5452750D-8BAD-44B6-9436-F4B1E1226E8E}"/>
+                <a16:creationId xmlns:a16="http://schemas.microsoft.com/office/drawing/2014/main" id="{145E0A38-A25B-45CF-A80B-F846EB3C0717}"/>
               </a:ext>
             </a:extLst>
           </p:cNvPr>
@@ -12944,10 +12989,10 @@
       </p:graphicFrame>
       <p:sp>
         <p:nvSpPr>
-          <p:cNvPr id="56" name="문자 비율·시간은 각각 7검정에 Holm 보정. RAGAS H×C 검정은 평가 문맥 언어별로 수행했으며, 전체 24검">
+          <p:cNvPr id="57" name="문자 비율·시간은 각각 7검정에 Holm 보정. RAGAS H×C 검정은 평가 문맥 언어별로 수행했으며, 전체 24검">
             <a:extLst xmlns:a="http://schemas.openxmlformats.org/drawingml/2006/main">
               <a:ext uri="{FF2B5EF4-FFF2-40B4-BE49-F238E27FC236}">
-                <a16:creationId xmlns:a16="http://schemas.microsoft.com/office/drawing/2014/main" id="{511A453B-8A53-4CC4-BD1C-7E19A4CBC0E0}"/>
+                <a16:creationId xmlns:a16="http://schemas.microsoft.com/office/drawing/2014/main" id="{87B3D930-A71A-4ECE-A779-BD685224615C}"/>
               </a:ext>
             </a:extLst>
           </p:cNvPr>
@@ -13058,10 +13103,10 @@
       </p:sp>
       <p:sp>
         <p:nvSpPr>
-          <p:cNvPr id="57" name="기법별 대응 비교  ·  질의별 평균 차이, 양측 검정">
+          <p:cNvPr id="58" name="기법별 대응 비교  ·  질의별 평균 차이, 양측 검정">
             <a:extLst xmlns:a="http://schemas.openxmlformats.org/drawingml/2006/main">
               <a:ext uri="{FF2B5EF4-FFF2-40B4-BE49-F238E27FC236}">
-                <a16:creationId xmlns:a16="http://schemas.microsoft.com/office/drawing/2014/main" id="{558D78C8-6A76-4629-8E1F-F52B6A3BB2A2}"/>
+                <a16:creationId xmlns:a16="http://schemas.microsoft.com/office/drawing/2014/main" id="{A6092A1F-E72C-4692-AE2C-D75D0A410C8C}"/>
               </a:ext>
             </a:extLst>
           </p:cNvPr>
@@ -13126,10 +13171,10 @@
       </p:sp>
       <p:graphicFrame>
         <p:nvGraphicFramePr>
-          <p:cNvPr id="58" name="">
+          <p:cNvPr id="59" name="">
             <a:extLst xmlns:a="http://schemas.openxmlformats.org/drawingml/2006/main">
               <a:ext uri="{FF2B5EF4-FFF2-40B4-BE49-F238E27FC236}">
-                <a16:creationId xmlns:a16="http://schemas.microsoft.com/office/drawing/2014/main" id="{246C911D-6624-44C8-A3F4-21854624A143}"/>
+                <a16:creationId xmlns:a16="http://schemas.microsoft.com/office/drawing/2014/main" id="{3CCF2F32-0EA6-429C-A8DC-8844FCB11730}"/>
               </a:ext>
             </a:extLst>
           </p:cNvPr>
@@ -14167,10 +14212,10 @@
       </p:graphicFrame>
       <p:sp>
         <p:nvSpPr>
-          <p:cNvPr id="59" name="HyDE: C0S0, CAD: H0S0, SCD: H0의 CAD 상태 평균 보정: HyDE·CAD 각 4지표, SCD">
+          <p:cNvPr id="60" name="HyDE: C0S0, CAD: H0S0, SCD: H0의 CAD 상태 평균 보정: HyDE·CAD 각 4지표, SCD">
             <a:extLst xmlns:a="http://schemas.openxmlformats.org/drawingml/2006/main">
               <a:ext uri="{FF2B5EF4-FFF2-40B4-BE49-F238E27FC236}">
-                <a16:creationId xmlns:a16="http://schemas.microsoft.com/office/drawing/2014/main" id="{7260EA1C-D30E-4F52-B88D-F3EF760CDD5C}"/>
+                <a16:creationId xmlns:a16="http://schemas.microsoft.com/office/drawing/2014/main" id="{C735DB22-B016-4190-B8C8-4B18C57289F7}"/>
               </a:ext>
             </a:extLst>
           </p:cNvPr>
@@ -14304,10 +14349,10 @@
       </p:sp>
       <p:sp>
         <p:nvSpPr>
-          <p:cNvPr id="60" name="">
+          <p:cNvPr id="61" name="">
             <a:extLst xmlns:a="http://schemas.openxmlformats.org/drawingml/2006/main">
               <a:ext uri="{FF2B5EF4-FFF2-40B4-BE49-F238E27FC236}">
-                <a16:creationId xmlns:a16="http://schemas.microsoft.com/office/drawing/2014/main" id="{912C0399-A0FC-4CD8-B637-706CDF064C9B}"/>
+                <a16:creationId xmlns:a16="http://schemas.microsoft.com/office/drawing/2014/main" id="{36ED8F9F-DEAE-422A-AB18-47EFDC8F2F48}"/>
               </a:ext>
             </a:extLst>
           </p:cNvPr>
@@ -14335,10 +14380,10 @@
       </p:sp>
       <p:sp>
         <p:nvSpPr>
-          <p:cNvPr id="61" name="06 결과 해석">
+          <p:cNvPr id="62" name="06 결과 해석">
             <a:extLst xmlns:a="http://schemas.openxmlformats.org/drawingml/2006/main">
               <a:ext uri="{FF2B5EF4-FFF2-40B4-BE49-F238E27FC236}">
-                <a16:creationId xmlns:a16="http://schemas.microsoft.com/office/drawing/2014/main" id="{6D5EAD38-E571-4DEF-9C1F-AA2877CCE5CD}"/>
+                <a16:creationId xmlns:a16="http://schemas.microsoft.com/office/drawing/2014/main" id="{9A3ACB9E-52AB-41C7-93FE-D17725FD7DCC}"/>
               </a:ext>
             </a:extLst>
           </p:cNvPr>
@@ -14403,10 +14448,10 @@
       </p:sp>
       <p:sp>
         <p:nvSpPr>
-          <p:cNvPr id="62" name="HyDE의 양의 관련성 차이는 다중비교 보정 결과와 함께 해석한다. CAD는 질의별 충실도 변동과 추가 실행 시간을 ">
+          <p:cNvPr id="63" name="HyDE의 양의 관련성 차이는 다중비교 보정 결과와 함께 해석한다. CAD는 질의별 충실도 변동과 추가 실행 시간을 ">
             <a:extLst xmlns:a="http://schemas.openxmlformats.org/drawingml/2006/main">
               <a:ext uri="{FF2B5EF4-FFF2-40B4-BE49-F238E27FC236}">
-                <a16:creationId xmlns:a16="http://schemas.microsoft.com/office/drawing/2014/main" id="{9247A825-E4F9-4C2F-9A8F-8F01E04DA36D}"/>
+                <a16:creationId xmlns:a16="http://schemas.microsoft.com/office/drawing/2014/main" id="{3064354D-CF8D-4207-8EC6-6DB2D62CBF15}"/>
               </a:ext>
             </a:extLst>
           </p:cNvPr>
@@ -14540,10 +14585,10 @@
       </p:sp>
       <p:sp>
         <p:nvSpPr>
-          <p:cNvPr id="63" name="">
+          <p:cNvPr id="64" name="">
             <a:extLst xmlns:a="http://schemas.openxmlformats.org/drawingml/2006/main">
               <a:ext uri="{FF2B5EF4-FFF2-40B4-BE49-F238E27FC236}">
-                <a16:creationId xmlns:a16="http://schemas.microsoft.com/office/drawing/2014/main" id="{46E49CA8-D929-4E6D-B06C-E41762EB53F0}"/>
+                <a16:creationId xmlns:a16="http://schemas.microsoft.com/office/drawing/2014/main" id="{335E4EE7-3A51-44EC-843E-3029AFF737CF}"/>
               </a:ext>
             </a:extLst>
           </p:cNvPr>
@@ -14571,10 +14616,10 @@
       </p:sp>
       <p:sp>
         <p:nvSpPr>
-          <p:cNvPr id="64" name="07 결론">
+          <p:cNvPr id="65" name="07 결론">
             <a:extLst xmlns:a="http://schemas.openxmlformats.org/drawingml/2006/main">
               <a:ext uri="{FF2B5EF4-FFF2-40B4-BE49-F238E27FC236}">
-                <a16:creationId xmlns:a16="http://schemas.microsoft.com/office/drawing/2014/main" id="{408F19DD-B794-46E2-AF97-2D134E6DC039}"/>
+                <a16:creationId xmlns:a16="http://schemas.microsoft.com/office/drawing/2014/main" id="{3E89197A-0FFF-4F28-8AB4-FD0E50C31BF7}"/>
               </a:ext>
             </a:extLst>
           </p:cNvPr>
@@ -14639,10 +14684,10 @@
       </p:sp>
       <p:sp>
         <p:nvSpPr>
-          <p:cNvPr id="65" name="답변 품질은 평균 대응 차이와 보정 검정 결과로 판단한다. 한국어 사용 비중을 높이는 목적에는 SCD 결과를 참고한다">
+          <p:cNvPr id="66" name="답변 품질은 평균 대응 차이와 보정 검정 결과로 판단한다. 한국어 사용 비중을 높이는 목적에는 SCD 결과를 참고한다">
             <a:extLst xmlns:a="http://schemas.openxmlformats.org/drawingml/2006/main">
               <a:ext uri="{FF2B5EF4-FFF2-40B4-BE49-F238E27FC236}">
-                <a16:creationId xmlns:a16="http://schemas.microsoft.com/office/drawing/2014/main" id="{1D2A9F15-0BFE-43C2-A576-F3FE38B5C9E3}"/>
+                <a16:creationId xmlns:a16="http://schemas.microsoft.com/office/drawing/2014/main" id="{AE010BAB-C317-447B-A51E-97D1FA975761}"/>
               </a:ext>
             </a:extLst>
           </p:cNvPr>
@@ -14799,10 +14844,10 @@
       </p:sp>
       <p:sp>
         <p:nvSpPr>
-          <p:cNvPr id="66" name="">
+          <p:cNvPr id="67" name="">
             <a:extLst xmlns:a="http://schemas.openxmlformats.org/drawingml/2006/main">
               <a:ext uri="{FF2B5EF4-FFF2-40B4-BE49-F238E27FC236}">
-                <a16:creationId xmlns:a16="http://schemas.microsoft.com/office/drawing/2014/main" id="{869AB139-A983-45B6-93C8-839DA3D8A153}"/>
+                <a16:creationId xmlns:a16="http://schemas.microsoft.com/office/drawing/2014/main" id="{EA928F77-F2EF-42C7-8912-E723DC9F84AB}"/>
               </a:ext>
             </a:extLst>
           </p:cNvPr>
@@ -14830,10 +14875,10 @@
       </p:sp>
       <p:sp>
         <p:nvSpPr>
-          <p:cNvPr id="67" name="08 주요 참고문헌">
+          <p:cNvPr id="68" name="08 주요 참고문헌">
             <a:extLst xmlns:a="http://schemas.openxmlformats.org/drawingml/2006/main">
               <a:ext uri="{FF2B5EF4-FFF2-40B4-BE49-F238E27FC236}">
-                <a16:creationId xmlns:a16="http://schemas.microsoft.com/office/drawing/2014/main" id="{0AF40077-AC3C-49F0-8CA8-FAEA555686BA}"/>
+                <a16:creationId xmlns:a16="http://schemas.microsoft.com/office/drawing/2014/main" id="{397120A7-6652-4A46-B1DB-C62B417681E0}"/>
               </a:ext>
             </a:extLst>
           </p:cNvPr>
@@ -14898,10 +14943,10 @@
       </p:sp>
       <p:sp>
         <p:nvSpPr>
-          <p:cNvPr id="68" name="[1] Lewis et al. RAG. NeurIPS, 2020. [2] Gao et al. HyDE. ACL, 20">
+          <p:cNvPr id="69" name="[1] Lewis et al. RAG. NeurIPS, 2020. [2] Gao et al. HyDE. ACL, 20">
             <a:extLst xmlns:a="http://schemas.openxmlformats.org/drawingml/2006/main">
               <a:ext uri="{FF2B5EF4-FFF2-40B4-BE49-F238E27FC236}">
-                <a16:creationId xmlns:a16="http://schemas.microsoft.com/office/drawing/2014/main" id="{6B61529D-B497-4654-A433-88F7C72460B2}"/>
+                <a16:creationId xmlns:a16="http://schemas.microsoft.com/office/drawing/2014/main" id="{63179EAE-09ED-447D-A0C7-72C8A7116635}"/>
               </a:ext>
             </a:extLst>
           </p:cNvPr>
@@ -15012,10 +15057,10 @@
       </p:sp>
       <p:sp>
         <p:nvSpPr>
-          <p:cNvPr id="69" name="[4] Li et al. Language Drift and SCD. AAAI, 2026. [5] Chen et al.">
+          <p:cNvPr id="70" name="[4] Li et al. Language Drift and SCD. AAAI, 2026. [5] Chen et al.">
             <a:extLst xmlns:a="http://schemas.openxmlformats.org/drawingml/2006/main">
               <a:ext uri="{FF2B5EF4-FFF2-40B4-BE49-F238E27FC236}">
-                <a16:creationId xmlns:a16="http://schemas.microsoft.com/office/drawing/2014/main" id="{A5CAC36E-BA61-4F5E-9748-05603C970607}"/>
+                <a16:creationId xmlns:a16="http://schemas.microsoft.com/office/drawing/2014/main" id="{E5E7E863-54BB-4C29-BCFA-80F5EE009DAD}"/>
               </a:ext>
             </a:extLst>
           </p:cNvPr>
@@ -15126,10 +15171,10 @@
       </p:sp>
       <p:sp>
         <p:nvSpPr>
-          <p:cNvPr id="70" name="구현 출처  [6] Robertson et al. Okapi at TREC-3. 1994. [7] Cormack et">
+          <p:cNvPr id="71" name="[6] Robertson et al. Okapi at TREC-3. NIST, 1995. [7] Cormack et ">
             <a:extLst xmlns:a="http://schemas.openxmlformats.org/drawingml/2006/main">
               <a:ext uri="{FF2B5EF4-FFF2-40B4-BE49-F238E27FC236}">
-                <a16:creationId xmlns:a16="http://schemas.microsoft.com/office/drawing/2014/main" id="{8F9653C7-6949-43A3-955C-6EDE647B014F}"/>
+                <a16:creationId xmlns:a16="http://schemas.microsoft.com/office/drawing/2014/main" id="{22D781C6-63DB-4A76-836E-7616E1BB7FB1}"/>
               </a:ext>
             </a:extLst>
           </p:cNvPr>
@@ -15187,7 +15232,7 @@
                 <a:ea typeface="Malgun Gothic"/>
                 <a:cs typeface="Malgun Gothic"/>
               </a:rPr>
-              <a:t>구현 출처  [6] Robertson et al. Okapi at TREC-3. 1994.</a:t>
+              <a:t>[6] Robertson et al. Okapi at TREC-3. NIST, 1995.</a:t>
             </a:r>
           </a:p>
           <a:p xmlns:a="http://schemas.openxmlformats.org/drawingml/2006/main">
@@ -15217,10 +15262,10 @@
       </p:sp>
       <p:sp>
         <p:nvSpPr>
-          <p:cNvPr id="71" name="[8] Nogueira &amp; Cho. Passage Re-ranking with BERT. 2019. [18] Shin">
+          <p:cNvPr id="72" name="[8] MacAvaney et al. CEDR. SIGIR, 2019. 공식 모델  [M1] KT Mi:dm 2.0 ">
             <a:extLst xmlns:a="http://schemas.openxmlformats.org/drawingml/2006/main">
               <a:ext uri="{FF2B5EF4-FFF2-40B4-BE49-F238E27FC236}">
-                <a16:creationId xmlns:a16="http://schemas.microsoft.com/office/drawing/2014/main" id="{F89FF9B3-8F12-4D59-8F15-62E844814EA4}"/>
+                <a16:creationId xmlns:a16="http://schemas.microsoft.com/office/drawing/2014/main" id="{23856CA5-4F76-4A97-BCC1-7FFD4E9DFFAE}"/>
               </a:ext>
             </a:extLst>
           </p:cNvPr>
@@ -15278,7 +15323,7 @@
                 <a:ea typeface="Malgun Gothic"/>
                 <a:cs typeface="Malgun Gothic"/>
               </a:rPr>
-              <a:t>[8] Nogueira &amp; Cho. Passage Re-ranking with BERT. 2019.</a:t>
+              <a:t>[8] MacAvaney et al. CEDR. SIGIR, 2019.</a:t>
             </a:r>
           </a:p>
           <a:p xmlns:a="http://schemas.openxmlformats.org/drawingml/2006/main">
@@ -15301,17 +15346,17 @@
                 <a:ea typeface="Malgun Gothic"/>
                 <a:cs typeface="Malgun Gothic"/>
               </a:rPr>
-              <a:t>[18] Shin et al. Mi:dm 2.0. arXiv:2601.09066, 2026.</a:t>
+              <a:t>공식 모델  [M1] KT Mi:dm 2.0 / [M2] MiniLM CrossEncoder</a:t>
             </a:r>
           </a:p>
         </p:txBody>
       </p:sp>
       <p:sp>
         <p:nvSpPr>
-          <p:cNvPr id="72" name="전체 22편: 동봉 POSTER_REFERENCES_FULL.md · 통계·결측·민감도 분석: 동봉 상세표">
+          <p:cNvPr id="73" name="학술 22편·모델·자료 출처: 동봉 POSTER_REFERENCES_FULL.md · 통계·결측·민감도 분석: 동봉 ">
             <a:extLst xmlns:a="http://schemas.openxmlformats.org/drawingml/2006/main">
               <a:ext uri="{FF2B5EF4-FFF2-40B4-BE49-F238E27FC236}">
-                <a16:creationId xmlns:a16="http://schemas.microsoft.com/office/drawing/2014/main" id="{E10EF06E-8B5A-40D3-93F4-6823C640A1B9}"/>
+                <a16:creationId xmlns:a16="http://schemas.microsoft.com/office/drawing/2014/main" id="{A5E2237D-D31E-44E0-8008-6AA4979CDF7D}"/>
               </a:ext>
             </a:extLst>
           </p:cNvPr>
@@ -15369,17 +15414,17 @@
                 <a:ea typeface="Malgun Gothic"/>
                 <a:cs typeface="Malgun Gothic"/>
               </a:rPr>
-              <a:t>전체 22편: 동봉 POSTER_REFERENCES_FULL.md · 통계·결측·민감도 분석: 동봉 상세표</a:t>
+              <a:t>학술 22편·모델·자료 출처: 동봉 POSTER_REFERENCES_FULL.md · 통계·결측·민감도 분석: 동봉 상세표</a:t>
             </a:r>
           </a:p>
         </p:txBody>
       </p:sp>
       <p:sp>
         <p:nvSpPr>
-          <p:cNvPr id="73" name="영어 문서 4종 · 질의 60개 · 생성 모델 1종 · 질의별 반복측정">
+          <p:cNvPr id="74" name="영어 문서 4종 · 질의 60개 · 생성 모델 1종 · 질의별 반복측정">
             <a:extLst xmlns:a="http://schemas.openxmlformats.org/drawingml/2006/main">
               <a:ext uri="{FF2B5EF4-FFF2-40B4-BE49-F238E27FC236}">
-                <a16:creationId xmlns:a16="http://schemas.microsoft.com/office/drawing/2014/main" id="{5C094301-77AF-47E5-8067-094AACC55DD4}"/>
+                <a16:creationId xmlns:a16="http://schemas.microsoft.com/office/drawing/2014/main" id="{14C402B1-41B4-4B19-BCF5-8CC97C5F7CBB}"/>
               </a:ext>
             </a:extLst>
           </p:cNvPr>
@@ -15444,10 +15489,10 @@
       </p:sp>
       <p:sp>
         <p:nvSpPr>
-          <p:cNvPr id="74" name="A1 594 × 841 mm">
+          <p:cNvPr id="75" name="A1 594 × 841 mm">
             <a:extLst xmlns:a="http://schemas.openxmlformats.org/drawingml/2006/main">
               <a:ext uri="{FF2B5EF4-FFF2-40B4-BE49-F238E27FC236}">
-                <a16:creationId xmlns:a16="http://schemas.microsoft.com/office/drawing/2014/main" id="{ABF2B35B-C050-405C-A66F-449D6B00BE88}"/>
+                <a16:creationId xmlns:a16="http://schemas.microsoft.com/office/drawing/2014/main" id="{054E15FE-62B2-4307-9CD2-8E5084005506}"/>
               </a:ext>
             </a:extLst>
           </p:cNvPr>
@@ -15513,7 +15558,7 @@
     </p:spTree>
     <p:extLst>
       <p:ext uri="{BB962C8B-B14F-4D97-AF65-F5344CB8AC3E}">
-        <p14:creationId xmlns:p14="http://schemas.microsoft.com/office/powerpoint/2010/main" val="431653367"/>
+        <p14:creationId xmlns:p14="http://schemas.microsoft.com/office/powerpoint/2010/main" val="1012599631"/>
       </p:ext>
     </p:extLst>
   </p:cSld>

</xml_diff>